<commit_message>
Swapped renter note to TEMP
Co-authored-by: gorgectf <194297338+gorgectf@users.noreply.github.com>
</commit_message>
<xml_diff>
--- a/public/RenterShield_PitchDeck_Revised.pptx
+++ b/public/RenterShield_PitchDeck_Revised.pptx
@@ -9465,7 +9465,7 @@
                 <a:ea typeface="Aptos" pitchFamily="34" charset="-122"/>
                 <a:cs typeface="Aptos" pitchFamily="34" charset="-120"/>
               </a:rPr>
-              <a:t>What testing suggests so far</a:t>
+              <a:t>Renter feedback (temporary)</a:t>
             </a:r>
             <a:endParaRPr lang="en-US" sz="1300" dirty="0"/>
           </a:p>
@@ -9506,58 +9506,7 @@
                 <a:ea typeface="Aptos" pitchFamily="34" charset="-122"/>
                 <a:cs typeface="Aptos" pitchFamily="34" charset="-120"/>
               </a:rPr>
-              <a:t>• 3 renters completed the flow in under 2 minutes</a:t>
-            </a:r>
-            <a:endParaRPr lang="en-US" sz="1100" dirty="0"/>
-          </a:p>
-          <a:p>
-            <a:pPr indent="0" marL="0">
-              <a:buNone/>
-            </a:pPr>
-            <a:r>
-              <a:rPr lang="en-US" sz="1100" dirty="0">
-                <a:solidFill>
-                  <a:srgbClr val="C9D1E0"/>
-                </a:solidFill>
-                <a:latin typeface="Aptos" pitchFamily="34" charset="0"/>
-                <a:ea typeface="Aptos" pitchFamily="34" charset="-122"/>
-                <a:cs typeface="Aptos" pitchFamily="34" charset="-120"/>
-              </a:rPr>
-              <a:t>• Users responded most strongly to concrete next steps</a:t>
-            </a:r>
-            <a:endParaRPr lang="en-US" sz="1100" dirty="0"/>
-          </a:p>
-          <a:p>
-            <a:pPr indent="0" marL="0">
-              <a:buNone/>
-            </a:pPr>
-            <a:r>
-              <a:rPr lang="en-US" sz="1100" dirty="0">
-                <a:solidFill>
-                  <a:srgbClr val="C9D1E0"/>
-                </a:solidFill>
-                <a:latin typeface="Aptos" pitchFamily="34" charset="0"/>
-                <a:ea typeface="Aptos" pitchFamily="34" charset="-122"/>
-                <a:cs typeface="Aptos" pitchFamily="34" charset="-120"/>
-              </a:rPr>
-              <a:t>• Trust improves when legal references and disclaimers are visible</a:t>
-            </a:r>
-            <a:endParaRPr lang="en-US" sz="1100" dirty="0"/>
-          </a:p>
-          <a:p>
-            <a:pPr indent="0" marL="0">
-              <a:buNone/>
-            </a:pPr>
-            <a:r>
-              <a:rPr lang="en-US" sz="1100" dirty="0">
-                <a:solidFill>
-                  <a:srgbClr val="C9D1E0"/>
-                </a:solidFill>
-                <a:latin typeface="Aptos" pitchFamily="34" charset="0"/>
-                <a:ea typeface="Aptos" pitchFamily="34" charset="-122"/>
-                <a:cs typeface="Aptos" pitchFamily="34" charset="-120"/>
-              </a:rPr>
-              <a:t>• Clear next experiment: test with 10–15 more renters</a:t>
+              <a:t>TEMP</a:t>
             </a:r>
             <a:endParaRPr lang="en-US" sz="1100" dirty="0"/>
           </a:p>

</xml_diff>

<commit_message>
Update the pitch deck pptx.
</commit_message>
<xml_diff>
--- a/public/RenterShield_PitchDeck_Revised.pptx
+++ b/public/RenterShield_PitchDeck_Revised.pptx
@@ -4,6 +4,9 @@
   <p:sldMasterIdLst>
     <p:sldMasterId id="2147483648" r:id="rId1"/>
   </p:sldMasterIdLst>
+  <p:notesMasterIdLst>
+    <p:notesMasterId r:id="rId14"/>
+  </p:notesMasterIdLst>
   <p:sldIdLst>
     <p:sldId id="256" r:id="rId2"/>
     <p:sldId id="257" r:id="rId3"/>
@@ -18,9 +21,6 @@
     <p:sldId id="266" r:id="rId12"/>
     <p:sldId id="267" r:id="rId13"/>
   </p:sldIdLst>
-  <p:notesMasterIdLst>
-    <p:notesMasterId r:id="rId14"/>
-  </p:notesMasterIdLst>
   <p:sldSz cx="12192000" cy="6858000"/>
   <p:notesSz cx="6858000" cy="12192000"/>
   <p:defaultTextStyle>
@@ -115,6 +115,11 @@
       </a:defRPr>
     </a:lvl9pPr>
   </p:defaultTextStyle>
+  <p:extLst>
+    <p:ext uri="{EFAFB233-063F-42B5-8137-9DF3F51BA10A}">
+      <p15:sldGuideLst xmlns:p15="http://schemas.microsoft.com/office/powerpoint/2012/main"/>
+    </p:ext>
+  </p:extLst>
 </p:presentation>
 </file>
 
@@ -140,234 +145,10 @@
           <a:chExt cx="0" cy="0"/>
         </a:xfrm>
       </p:grpSpPr>
-      <p:sp>
-        <p:nvSpPr>
-          <p:cNvPr id="2" name="Header Placeholder 1"/>
-          <p:cNvSpPr>
-            <a:spLocks noGrp="1"/>
-          </p:cNvSpPr>
-          <p:nvPr>
-            <p:ph type="hdr" sz="quarter"/>
-          </p:nvPr>
-        </p:nvSpPr>
-        <p:spPr>
-          <a:xfrm>
-            <a:off x="0" y="0"/>
-            <a:ext cx="2971800" cy="458788"/>
-          </a:xfrm>
-          <a:prstGeom prst="rect">
-            <a:avLst/>
-          </a:prstGeom>
-        </p:spPr>
-        <p:txBody>
-          <a:bodyPr vert="horz" lIns="91440" tIns="45720" rIns="91440" bIns="45720" rtlCol="0"/>
-          <a:lstStyle>
-            <a:lvl1pPr algn="l">
-              <a:defRPr sz="1200"/>
-            </a:lvl1pPr>
-          </a:lstStyle>
-          <a:p>
-            <a:endParaRPr lang="en-US"/>
-          </a:p>
-        </p:txBody>
-      </p:sp>
-      <p:sp>
-        <p:nvSpPr>
-          <p:cNvPr id="3" name="Date Placeholder 2"/>
-          <p:cNvSpPr>
-            <a:spLocks noGrp="1"/>
-          </p:cNvSpPr>
-          <p:nvPr>
-            <p:ph type="dt" idx="1"/>
-          </p:nvPr>
-        </p:nvSpPr>
-        <p:spPr>
-          <a:xfrm>
-            <a:off x="3884613" y="0"/>
-            <a:ext cx="2971800" cy="458788"/>
-          </a:xfrm>
-          <a:prstGeom prst="rect">
-            <a:avLst/>
-          </a:prstGeom>
-        </p:spPr>
-        <p:txBody>
-          <a:bodyPr vert="horz" lIns="91440" tIns="45720" rIns="91440" bIns="45720" rtlCol="0"/>
-          <a:lstStyle>
-            <a:lvl1pPr algn="r">
-              <a:defRPr sz="1200"/>
-            </a:lvl1pPr>
-          </a:lstStyle>
-          <a:p>
-            <a:fld id="{5282F153-3F37-0F45-9E97-73ACFA13230C}" type="datetimeFigureOut">
-              <a:rPr lang="en-US"/>
-              <a:t>7/23/19</a:t>
-            </a:fld>
-            <a:endParaRPr lang="en-US"/>
-          </a:p>
-        </p:txBody>
-      </p:sp>
-      <p:sp>
-        <p:nvSpPr>
-          <p:cNvPr id="4" name="Slide Image Placeholder 3"/>
-          <p:cNvSpPr>
-            <a:spLocks noGrp="1" noRot="1" noChangeAspect="1"/>
-          </p:cNvSpPr>
-          <p:nvPr>
-            <p:ph type="sldImg" idx="2"/>
-          </p:nvPr>
-        </p:nvSpPr>
-        <p:spPr>
-          <a:xfrm>
-            <a:off x="685800" y="1143000"/>
-            <a:ext cx="5486400" cy="3086100"/>
-          </a:xfrm>
-          <a:prstGeom prst="rect">
-            <a:avLst/>
-          </a:prstGeom>
-          <a:noFill/>
-          <a:ln w="12700">
-            <a:solidFill>
-              <a:prstClr val="black"/>
-            </a:solidFill>
-          </a:ln>
-        </p:spPr>
-        <p:txBody>
-          <a:bodyPr vert="horz" lIns="91440" tIns="45720" rIns="91440" bIns="45720" rtlCol="0" anchor="ctr"/>
-          <a:lstStyle/>
-          <a:p>
-            <a:endParaRPr lang="en-US"/>
-          </a:p>
-        </p:txBody>
-      </p:sp>
-      <p:sp>
-        <p:nvSpPr>
-          <p:cNvPr id="5" name="Notes Placeholder 4"/>
-          <p:cNvSpPr>
-            <a:spLocks noGrp="1"/>
-          </p:cNvSpPr>
-          <p:nvPr>
-            <p:ph type="body" sz="quarter" idx="3"/>
-          </p:nvPr>
-        </p:nvSpPr>
-        <p:spPr>
-          <a:xfrm>
-            <a:off x="685800" y="4400550"/>
-            <a:ext cx="5486400" cy="3600450"/>
-          </a:xfrm>
-          <a:prstGeom prst="rect">
-            <a:avLst/>
-          </a:prstGeom>
-        </p:spPr>
-        <p:txBody>
-          <a:bodyPr vert="horz" lIns="91440" tIns="45720" rIns="91440" bIns="45720" rtlCol="0"/>
-          <a:lstStyle/>
-          <a:p>
-            <a:pPr lvl="0"/>
-            <a:r>
-              <a:rPr lang="en-US"/>
-              <a:t>Click to edit Master text styles</a:t>
-            </a:r>
-          </a:p>
-          <a:p>
-            <a:pPr lvl="1"/>
-            <a:r>
-              <a:rPr lang="en-US"/>
-              <a:t>Second level</a:t>
-            </a:r>
-          </a:p>
-          <a:p>
-            <a:pPr lvl="2"/>
-            <a:r>
-              <a:rPr lang="en-US"/>
-              <a:t>Third level</a:t>
-            </a:r>
-          </a:p>
-          <a:p>
-            <a:pPr lvl="3"/>
-            <a:r>
-              <a:rPr lang="en-US"/>
-              <a:t>Fourth level</a:t>
-            </a:r>
-          </a:p>
-          <a:p>
-            <a:pPr lvl="4"/>
-            <a:r>
-              <a:rPr lang="en-US"/>
-              <a:t>Fifth level</a:t>
-            </a:r>
-          </a:p>
-        </p:txBody>
-      </p:sp>
-      <p:sp>
-        <p:nvSpPr>
-          <p:cNvPr id="6" name="Footer Placeholder 5"/>
-          <p:cNvSpPr>
-            <a:spLocks noGrp="1"/>
-          </p:cNvSpPr>
-          <p:nvPr>
-            <p:ph type="ftr" sz="quarter" idx="4"/>
-          </p:nvPr>
-        </p:nvSpPr>
-        <p:spPr>
-          <a:xfrm>
-            <a:off x="0" y="8685213"/>
-            <a:ext cx="2971800" cy="458787"/>
-          </a:xfrm>
-          <a:prstGeom prst="rect">
-            <a:avLst/>
-          </a:prstGeom>
-        </p:spPr>
-        <p:txBody>
-          <a:bodyPr vert="horz" lIns="91440" tIns="45720" rIns="91440" bIns="45720" rtlCol="0" anchor="b"/>
-          <a:lstStyle>
-            <a:lvl1pPr algn="l">
-              <a:defRPr sz="1200"/>
-            </a:lvl1pPr>
-          </a:lstStyle>
-          <a:p>
-            <a:endParaRPr lang="en-US"/>
-          </a:p>
-        </p:txBody>
-      </p:sp>
-      <p:sp>
-        <p:nvSpPr>
-          <p:cNvPr id="7" name="Slide Number Placeholder 6"/>
-          <p:cNvSpPr>
-            <a:spLocks noGrp="1"/>
-          </p:cNvSpPr>
-          <p:nvPr>
-            <p:ph type="sldNum" sz="quarter" idx="5"/>
-          </p:nvPr>
-        </p:nvSpPr>
-        <p:spPr>
-          <a:xfrm>
-            <a:off x="3884613" y="8685213"/>
-            <a:ext cx="2971800" cy="458787"/>
-          </a:xfrm>
-          <a:prstGeom prst="rect">
-            <a:avLst/>
-          </a:prstGeom>
-        </p:spPr>
-        <p:txBody>
-          <a:bodyPr vert="horz" lIns="91440" tIns="45720" rIns="91440" bIns="45720" rtlCol="0" anchor="b"/>
-          <a:lstStyle>
-            <a:lvl1pPr algn="r">
-              <a:defRPr sz="1200"/>
-            </a:lvl1pPr>
-          </a:lstStyle>
-          <a:p>
-            <a:fld id="{CE5E9CC1-C706-0F49-92D6-E571CC5EEA8F}" type="slidenum">
-              <a:rPr lang="en-US"/>
-              <a:t>‹#›</a:t>
-            </a:fld>
-            <a:endParaRPr lang="en-US"/>
-          </a:p>
-        </p:txBody>
-      </p:sp>
     </p:spTree>
     <p:extLst>
       <p:ext uri="{BB962C8B-B14F-4D97-AF65-F5344CB8AC3E}">
-        <p14:creationId xmlns:p14="http://schemas.microsoft.com/office/powerpoint/2010/main" val="1024086991"/>
+        <p14:creationId xmlns:p14="http://schemas.microsoft.com/office/powerpoint/2010/main" val="1655606727"/>
       </p:ext>
     </p:extLst>
   </p:cSld>
@@ -511,10 +292,6 @@
           <a:bodyPr/>
           <a:lstStyle/>
           <a:p>
-            <a:r>
-              <a:rPr lang="en-US" dirty="0"/>
-              <a:t/>
-            </a:r>
             <a:endParaRPr lang="en-US" dirty="0"/>
           </a:p>
         </p:txBody>
@@ -599,10 +376,6 @@
           <a:bodyPr/>
           <a:lstStyle/>
           <a:p>
-            <a:r>
-              <a:rPr lang="en-US" dirty="0"/>
-              <a:t/>
-            </a:r>
             <a:endParaRPr lang="en-US" dirty="0"/>
           </a:p>
         </p:txBody>
@@ -687,10 +460,6 @@
           <a:bodyPr/>
           <a:lstStyle/>
           <a:p>
-            <a:r>
-              <a:rPr lang="en-US" dirty="0"/>
-              <a:t/>
-            </a:r>
             <a:endParaRPr lang="en-US" dirty="0"/>
           </a:p>
         </p:txBody>
@@ -775,10 +544,6 @@
           <a:bodyPr/>
           <a:lstStyle/>
           <a:p>
-            <a:r>
-              <a:rPr lang="en-US" dirty="0"/>
-              <a:t/>
-            </a:r>
             <a:endParaRPr lang="en-US" dirty="0"/>
           </a:p>
         </p:txBody>
@@ -863,10 +628,6 @@
           <a:bodyPr/>
           <a:lstStyle/>
           <a:p>
-            <a:r>
-              <a:rPr lang="en-US" dirty="0"/>
-              <a:t/>
-            </a:r>
             <a:endParaRPr lang="en-US" dirty="0"/>
           </a:p>
         </p:txBody>
@@ -951,10 +712,6 @@
           <a:bodyPr/>
           <a:lstStyle/>
           <a:p>
-            <a:r>
-              <a:rPr lang="en-US" dirty="0"/>
-              <a:t/>
-            </a:r>
             <a:endParaRPr lang="en-US" dirty="0"/>
           </a:p>
         </p:txBody>
@@ -1039,10 +796,6 @@
           <a:bodyPr/>
           <a:lstStyle/>
           <a:p>
-            <a:r>
-              <a:rPr lang="en-US" dirty="0"/>
-              <a:t/>
-            </a:r>
             <a:endParaRPr lang="en-US" dirty="0"/>
           </a:p>
         </p:txBody>
@@ -1127,10 +880,6 @@
           <a:bodyPr/>
           <a:lstStyle/>
           <a:p>
-            <a:r>
-              <a:rPr lang="en-US" dirty="0"/>
-              <a:t/>
-            </a:r>
             <a:endParaRPr lang="en-US" dirty="0"/>
           </a:p>
         </p:txBody>
@@ -1215,10 +964,6 @@
           <a:bodyPr/>
           <a:lstStyle/>
           <a:p>
-            <a:r>
-              <a:rPr lang="en-US" dirty="0"/>
-              <a:t/>
-            </a:r>
             <a:endParaRPr lang="en-US" dirty="0"/>
           </a:p>
         </p:txBody>
@@ -1303,10 +1048,6 @@
           <a:bodyPr/>
           <a:lstStyle/>
           <a:p>
-            <a:r>
-              <a:rPr lang="en-US" dirty="0"/>
-              <a:t/>
-            </a:r>
             <a:endParaRPr lang="en-US" dirty="0"/>
           </a:p>
         </p:txBody>
@@ -1391,10 +1132,6 @@
           <a:bodyPr/>
           <a:lstStyle/>
           <a:p>
-            <a:r>
-              <a:rPr lang="en-US" dirty="0"/>
-              <a:t/>
-            </a:r>
             <a:endParaRPr lang="en-US" dirty="0"/>
           </a:p>
         </p:txBody>
@@ -1479,10 +1216,6 @@
           <a:bodyPr/>
           <a:lstStyle/>
           <a:p>
-            <a:r>
-              <a:rPr lang="en-US" dirty="0"/>
-              <a:t/>
-            </a:r>
             <a:endParaRPr lang="en-US" dirty="0"/>
           </a:p>
         </p:txBody>
@@ -1556,6 +1289,11 @@
 <file path=ppt/slideMasters/slideMaster1.xml><?xml version="1.0" encoding="utf-8"?>
 <p:sldMaster xmlns:a="http://schemas.openxmlformats.org/drawingml/2006/main" xmlns:r="http://schemas.openxmlformats.org/officeDocument/2006/relationships" xmlns:p="http://schemas.openxmlformats.org/presentationml/2006/main">
   <p:cSld>
+    <p:bg>
+      <p:bgRef idx="1001">
+        <a:schemeClr val="bg1"/>
+      </p:bgRef>
+    </p:bg>
     <p:spTree>
       <p:nvGrpSpPr>
         <p:cNvPr id="1" name=""/>
@@ -1838,6 +1576,7 @@
         <a:solidFill>
           <a:srgbClr val="0B132B"/>
         </a:solidFill>
+        <a:effectLst/>
       </p:bgPr>
     </p:bg>
     <p:spTree>
@@ -1881,7 +1620,7 @@
           <a:bodyPr wrap="square" rtlCol="0" anchor="ctr"/>
           <a:lstStyle/>
           <a:p>
-            <a:pPr indent="0" marL="0">
+            <a:pPr marL="0" indent="0">
               <a:buNone/>
             </a:pPr>
             <a:endParaRPr lang="en-US" dirty="0"/>
@@ -1909,7 +1648,7 @@
           <a:bodyPr wrap="square" rtlCol="0" anchor="ctr"/>
           <a:lstStyle/>
           <a:p>
-            <a:pPr algn="r" indent="0" marL="0">
+            <a:pPr marL="0" indent="0" algn="r">
               <a:buNone/>
             </a:pPr>
             <a:r>
@@ -1948,7 +1687,7 @@
           <a:bodyPr wrap="square" lIns="0" tIns="0" rIns="0" bIns="0" rtlCol="0" anchor="ctr"/>
           <a:lstStyle/>
           <a:p>
-            <a:pPr indent="0" marL="0">
+            <a:pPr marL="0" indent="0">
               <a:buNone/>
             </a:pPr>
             <a:r>
@@ -1987,7 +1726,7 @@
           <a:bodyPr wrap="square" lIns="0" tIns="0" rIns="0" bIns="0" rtlCol="0" anchor="ctr"/>
           <a:lstStyle/>
           <a:p>
-            <a:pPr indent="0" marL="0">
+            <a:pPr marL="0" indent="0">
               <a:buNone/>
             </a:pPr>
             <a:r>
@@ -2032,7 +1771,7 @@
           <a:bodyPr wrap="square" rtlCol="0" anchor="ctr"/>
           <a:lstStyle/>
           <a:p>
-            <a:pPr indent="0" marL="0">
+            <a:pPr marL="0" indent="0">
               <a:buNone/>
             </a:pPr>
             <a:endParaRPr lang="en-US" dirty="0"/>
@@ -2062,7 +1801,7 @@
           </a:bodyPr>
           <a:lstStyle/>
           <a:p>
-            <a:pPr indent="0" marL="0">
+            <a:pPr marL="0" indent="0">
               <a:buNone/>
             </a:pPr>
             <a:r>
@@ -2103,7 +1842,7 @@
           </a:bodyPr>
           <a:lstStyle/>
           <a:p>
-            <a:pPr indent="0" marL="0">
+            <a:pPr marL="0" indent="0">
               <a:buNone/>
             </a:pPr>
             <a:r>
@@ -2148,7 +1887,7 @@
           <a:bodyPr wrap="square" rtlCol="0" anchor="ctr"/>
           <a:lstStyle/>
           <a:p>
-            <a:pPr indent="0" marL="0">
+            <a:pPr marL="0" indent="0">
               <a:buNone/>
             </a:pPr>
             <a:endParaRPr lang="en-US" dirty="0"/>
@@ -2178,7 +1917,7 @@
           </a:bodyPr>
           <a:lstStyle/>
           <a:p>
-            <a:pPr indent="0" marL="0">
+            <a:pPr marL="0" indent="0">
               <a:buNone/>
             </a:pPr>
             <a:r>
@@ -2219,7 +1958,7 @@
           </a:bodyPr>
           <a:lstStyle/>
           <a:p>
-            <a:pPr indent="0" marL="0">
+            <a:pPr marL="0" indent="0">
               <a:buNone/>
             </a:pPr>
             <a:r>
@@ -2236,13 +1975,13 @@
             <a:endParaRPr lang="en-US" sz="1100" dirty="0"/>
           </a:p>
           <a:p>
-            <a:pPr indent="0" marL="0">
+            <a:pPr marL="0" indent="0">
               <a:buNone/>
             </a:pPr>
             <a:endParaRPr lang="en-US" sz="1100" dirty="0"/>
           </a:p>
           <a:p>
-            <a:pPr indent="0" marL="0">
+            <a:pPr marL="0" indent="0">
               <a:buNone/>
             </a:pPr>
             <a:r>
@@ -2259,7 +1998,7 @@
             <a:endParaRPr lang="en-US" sz="1100" dirty="0"/>
           </a:p>
           <a:p>
-            <a:pPr indent="0" marL="0">
+            <a:pPr marL="0" indent="0">
               <a:buNone/>
             </a:pPr>
             <a:r>
@@ -2276,7 +2015,7 @@
             <a:endParaRPr lang="en-US" sz="1100" dirty="0"/>
           </a:p>
           <a:p>
-            <a:pPr indent="0" marL="0">
+            <a:pPr marL="0" indent="0">
               <a:buNone/>
             </a:pPr>
             <a:r>
@@ -2293,7 +2032,7 @@
             <a:endParaRPr lang="en-US" sz="1100" dirty="0"/>
           </a:p>
           <a:p>
-            <a:pPr indent="0" marL="0">
+            <a:pPr marL="0" indent="0">
               <a:buNone/>
             </a:pPr>
             <a:r>
@@ -2310,7 +2049,7 @@
             <a:endParaRPr lang="en-US" sz="1100" dirty="0"/>
           </a:p>
           <a:p>
-            <a:pPr indent="0" marL="0">
+            <a:pPr marL="0" indent="0">
               <a:buNone/>
             </a:pPr>
             <a:r>
@@ -2349,7 +2088,7 @@
           <a:bodyPr wrap="square" lIns="0" tIns="0" rIns="0" bIns="0" rtlCol="0" anchor="ctr"/>
           <a:lstStyle/>
           <a:p>
-            <a:pPr indent="0" marL="0">
+            <a:pPr marL="0" indent="0">
               <a:buNone/>
             </a:pPr>
             <a:r>
@@ -2383,6 +2122,7 @@
         <a:solidFill>
           <a:srgbClr val="0B132B"/>
         </a:solidFill>
+        <a:effectLst/>
       </p:bgPr>
     </p:bg>
     <p:spTree>
@@ -2426,7 +2166,7 @@
           <a:bodyPr wrap="square" rtlCol="0" anchor="ctr"/>
           <a:lstStyle/>
           <a:p>
-            <a:pPr indent="0" marL="0">
+            <a:pPr marL="0" indent="0">
               <a:buNone/>
             </a:pPr>
             <a:endParaRPr lang="en-US" dirty="0"/>
@@ -2454,7 +2194,7 @@
           <a:bodyPr wrap="square" rtlCol="0" anchor="ctr"/>
           <a:lstStyle/>
           <a:p>
-            <a:pPr algn="r" indent="0" marL="0">
+            <a:pPr marL="0" indent="0" algn="r">
               <a:buNone/>
             </a:pPr>
             <a:r>
@@ -2493,7 +2233,7 @@
           <a:bodyPr wrap="square" rtlCol="0" anchor="ctr"/>
           <a:lstStyle/>
           <a:p>
-            <a:pPr indent="0" marL="0">
+            <a:pPr marL="0" indent="0">
               <a:buNone/>
             </a:pPr>
             <a:r>
@@ -2534,7 +2274,7 @@
           </a:bodyPr>
           <a:lstStyle/>
           <a:p>
-            <a:pPr indent="0" marL="0">
+            <a:pPr marL="0" indent="0">
               <a:buNone/>
             </a:pPr>
             <a:r>
@@ -2579,7 +2319,7 @@
           <a:bodyPr wrap="square" rtlCol="0" anchor="ctr"/>
           <a:lstStyle/>
           <a:p>
-            <a:pPr indent="0" marL="0">
+            <a:pPr marL="0" indent="0">
               <a:buNone/>
             </a:pPr>
             <a:endParaRPr lang="en-US" dirty="0"/>
@@ -2609,7 +2349,7 @@
           </a:bodyPr>
           <a:lstStyle/>
           <a:p>
-            <a:pPr indent="0" marL="0">
+            <a:pPr marL="0" indent="0">
               <a:buNone/>
             </a:pPr>
             <a:r>
@@ -2650,7 +2390,7 @@
           </a:bodyPr>
           <a:lstStyle/>
           <a:p>
-            <a:pPr indent="0" marL="0">
+            <a:pPr marL="0" indent="0">
               <a:buNone/>
             </a:pPr>
             <a:r>
@@ -2667,7 +2407,7 @@
             <a:endParaRPr lang="en-US" sz="1100" dirty="0"/>
           </a:p>
           <a:p>
-            <a:pPr indent="0" marL="0">
+            <a:pPr marL="0" indent="0">
               <a:buNone/>
             </a:pPr>
             <a:r>
@@ -2712,7 +2452,7 @@
           <a:bodyPr wrap="square" rtlCol="0" anchor="ctr"/>
           <a:lstStyle/>
           <a:p>
-            <a:pPr indent="0" marL="0">
+            <a:pPr marL="0" indent="0">
               <a:buNone/>
             </a:pPr>
             <a:endParaRPr lang="en-US" dirty="0"/>
@@ -2742,7 +2482,7 @@
           </a:bodyPr>
           <a:lstStyle/>
           <a:p>
-            <a:pPr indent="0" marL="0">
+            <a:pPr marL="0" indent="0">
               <a:buNone/>
             </a:pPr>
             <a:r>
@@ -2783,7 +2523,7 @@
           </a:bodyPr>
           <a:lstStyle/>
           <a:p>
-            <a:pPr indent="0" marL="0">
+            <a:pPr marL="0" indent="0">
               <a:buNone/>
             </a:pPr>
             <a:r>
@@ -2800,7 +2540,7 @@
             <a:endParaRPr lang="en-US" sz="1100" dirty="0"/>
           </a:p>
           <a:p>
-            <a:pPr indent="0" marL="0">
+            <a:pPr marL="0" indent="0">
               <a:buNone/>
             </a:pPr>
             <a:r>
@@ -2845,7 +2585,7 @@
           <a:bodyPr wrap="square" rtlCol="0" anchor="ctr"/>
           <a:lstStyle/>
           <a:p>
-            <a:pPr indent="0" marL="0">
+            <a:pPr marL="0" indent="0">
               <a:buNone/>
             </a:pPr>
             <a:endParaRPr lang="en-US" dirty="0"/>
@@ -2875,7 +2615,7 @@
           </a:bodyPr>
           <a:lstStyle/>
           <a:p>
-            <a:pPr indent="0" marL="0">
+            <a:pPr marL="0" indent="0">
               <a:buNone/>
             </a:pPr>
             <a:r>
@@ -2916,7 +2656,7 @@
           </a:bodyPr>
           <a:lstStyle/>
           <a:p>
-            <a:pPr indent="0" marL="0">
+            <a:pPr marL="0" indent="0">
               <a:buNone/>
             </a:pPr>
             <a:r>
@@ -2933,7 +2673,7 @@
             <a:endParaRPr lang="en-US" sz="1100" dirty="0"/>
           </a:p>
           <a:p>
-            <a:pPr indent="0" marL="0">
+            <a:pPr marL="0" indent="0">
               <a:buNone/>
             </a:pPr>
             <a:r>
@@ -2978,7 +2718,7 @@
           <a:bodyPr wrap="square" rtlCol="0" anchor="ctr"/>
           <a:lstStyle/>
           <a:p>
-            <a:pPr indent="0" marL="0">
+            <a:pPr marL="0" indent="0">
               <a:buNone/>
             </a:pPr>
             <a:endParaRPr lang="en-US" dirty="0"/>
@@ -3008,7 +2748,7 @@
           </a:bodyPr>
           <a:lstStyle/>
           <a:p>
-            <a:pPr indent="0" marL="0">
+            <a:pPr marL="0" indent="0">
               <a:buNone/>
             </a:pPr>
             <a:r>
@@ -3049,7 +2789,7 @@
           </a:bodyPr>
           <a:lstStyle/>
           <a:p>
-            <a:pPr indent="0" marL="0">
+            <a:pPr marL="0" indent="0">
               <a:buNone/>
             </a:pPr>
             <a:r>
@@ -3066,7 +2806,7 @@
             <a:endParaRPr lang="en-US" sz="1100" dirty="0"/>
           </a:p>
           <a:p>
-            <a:pPr indent="0" marL="0">
+            <a:pPr marL="0" indent="0">
               <a:buNone/>
             </a:pPr>
             <a:r>
@@ -3111,7 +2851,7 @@
           <a:bodyPr wrap="square" rtlCol="0" anchor="ctr"/>
           <a:lstStyle/>
           <a:p>
-            <a:pPr indent="0" marL="0">
+            <a:pPr marL="0" indent="0">
               <a:buNone/>
             </a:pPr>
             <a:endParaRPr lang="en-US" dirty="0"/>
@@ -3141,7 +2881,7 @@
           </a:bodyPr>
           <a:lstStyle/>
           <a:p>
-            <a:pPr indent="0" marL="0">
+            <a:pPr marL="0" indent="0">
               <a:buNone/>
             </a:pPr>
             <a:r>
@@ -3182,7 +2922,7 @@
           </a:bodyPr>
           <a:lstStyle/>
           <a:p>
-            <a:pPr indent="0" marL="0">
+            <a:pPr marL="0" indent="0">
               <a:buNone/>
             </a:pPr>
             <a:r>
@@ -3216,6 +2956,7 @@
         <a:solidFill>
           <a:srgbClr val="0B132B"/>
         </a:solidFill>
+        <a:effectLst/>
       </p:bgPr>
     </p:bg>
     <p:spTree>
@@ -3259,7 +3000,7 @@
           <a:bodyPr wrap="square" rtlCol="0" anchor="ctr"/>
           <a:lstStyle/>
           <a:p>
-            <a:pPr indent="0" marL="0">
+            <a:pPr marL="0" indent="0">
               <a:buNone/>
             </a:pPr>
             <a:endParaRPr lang="en-US" dirty="0"/>
@@ -3287,7 +3028,7 @@
           <a:bodyPr wrap="square" rtlCol="0" anchor="ctr"/>
           <a:lstStyle/>
           <a:p>
-            <a:pPr algn="r" indent="0" marL="0">
+            <a:pPr marL="0" indent="0" algn="r">
               <a:buNone/>
             </a:pPr>
             <a:r>
@@ -3326,7 +3067,7 @@
           <a:bodyPr wrap="square" rtlCol="0" anchor="ctr"/>
           <a:lstStyle/>
           <a:p>
-            <a:pPr indent="0" marL="0">
+            <a:pPr marL="0" indent="0">
               <a:buNone/>
             </a:pPr>
             <a:r>
@@ -3367,7 +3108,7 @@
           </a:bodyPr>
           <a:lstStyle/>
           <a:p>
-            <a:pPr indent="0" marL="0">
+            <a:pPr marL="0" indent="0">
               <a:buNone/>
             </a:pPr>
             <a:r>
@@ -3412,7 +3153,7 @@
           <a:bodyPr wrap="square" rtlCol="0" anchor="ctr"/>
           <a:lstStyle/>
           <a:p>
-            <a:pPr indent="0" marL="0">
+            <a:pPr marL="0" indent="0">
               <a:buNone/>
             </a:pPr>
             <a:endParaRPr lang="en-US" dirty="0"/>
@@ -3442,7 +3183,7 @@
           </a:bodyPr>
           <a:lstStyle/>
           <a:p>
-            <a:pPr indent="0" marL="0">
+            <a:pPr marL="0" indent="0">
               <a:buNone/>
             </a:pPr>
             <a:r>
@@ -3483,7 +3224,7 @@
           </a:bodyPr>
           <a:lstStyle/>
           <a:p>
-            <a:pPr indent="0" marL="0">
+            <a:pPr marL="0" indent="0">
               <a:buNone/>
             </a:pPr>
             <a:r>
@@ -3528,7 +3269,7 @@
           <a:bodyPr wrap="square" rtlCol="0" anchor="ctr"/>
           <a:lstStyle/>
           <a:p>
-            <a:pPr indent="0" marL="0">
+            <a:pPr marL="0" indent="0">
               <a:buNone/>
             </a:pPr>
             <a:endParaRPr lang="en-US" dirty="0"/>
@@ -3558,7 +3299,7 @@
           </a:bodyPr>
           <a:lstStyle/>
           <a:p>
-            <a:pPr indent="0" marL="0">
+            <a:pPr marL="0" indent="0">
               <a:buNone/>
             </a:pPr>
             <a:r>
@@ -3599,7 +3340,7 @@
           </a:bodyPr>
           <a:lstStyle/>
           <a:p>
-            <a:pPr indent="0" marL="0">
+            <a:pPr marL="0" indent="0">
               <a:buNone/>
             </a:pPr>
             <a:r>
@@ -3644,7 +3385,7 @@
           <a:bodyPr wrap="square" rtlCol="0" anchor="ctr"/>
           <a:lstStyle/>
           <a:p>
-            <a:pPr indent="0" marL="0">
+            <a:pPr marL="0" indent="0">
               <a:buNone/>
             </a:pPr>
             <a:endParaRPr lang="en-US" dirty="0"/>
@@ -3674,7 +3415,7 @@
           </a:bodyPr>
           <a:lstStyle/>
           <a:p>
-            <a:pPr indent="0" marL="0">
+            <a:pPr marL="0" indent="0">
               <a:buNone/>
             </a:pPr>
             <a:r>
@@ -3715,7 +3456,7 @@
           </a:bodyPr>
           <a:lstStyle/>
           <a:p>
-            <a:pPr indent="0" marL="0">
+            <a:pPr marL="0" indent="0">
               <a:buNone/>
             </a:pPr>
             <a:r>
@@ -3760,7 +3501,7 @@
           <a:bodyPr wrap="square" rtlCol="0" anchor="ctr"/>
           <a:lstStyle/>
           <a:p>
-            <a:pPr indent="0" marL="0">
+            <a:pPr marL="0" indent="0">
               <a:buNone/>
             </a:pPr>
             <a:endParaRPr lang="en-US" dirty="0"/>
@@ -3790,7 +3531,7 @@
           </a:bodyPr>
           <a:lstStyle/>
           <a:p>
-            <a:pPr indent="0" marL="0">
+            <a:pPr marL="0" indent="0">
               <a:buNone/>
             </a:pPr>
             <a:r>
@@ -3827,11 +3568,11 @@
         </p:spPr>
         <p:txBody>
           <a:bodyPr wrap="square" lIns="0" tIns="0" rIns="0" bIns="0" rtlCol="0" anchor="t">
-            <a:normAutofit/>
+            <a:normAutofit fontScale="92500"/>
           </a:bodyPr>
           <a:lstStyle/>
           <a:p>
-            <a:pPr indent="0" marL="0">
+            <a:pPr marL="0" indent="0">
               <a:buNone/>
             </a:pPr>
             <a:r>
@@ -3865,6 +3606,7 @@
         <a:solidFill>
           <a:srgbClr val="0B132B"/>
         </a:solidFill>
+        <a:effectLst/>
       </p:bgPr>
     </p:bg>
     <p:spTree>
@@ -3908,7 +3650,7 @@
           <a:bodyPr wrap="square" rtlCol="0" anchor="ctr"/>
           <a:lstStyle/>
           <a:p>
-            <a:pPr indent="0" marL="0">
+            <a:pPr marL="0" indent="0">
               <a:buNone/>
             </a:pPr>
             <a:endParaRPr lang="en-US" dirty="0"/>
@@ -3936,7 +3678,7 @@
           <a:bodyPr wrap="square" rtlCol="0" anchor="ctr"/>
           <a:lstStyle/>
           <a:p>
-            <a:pPr algn="r" indent="0" marL="0">
+            <a:pPr marL="0" indent="0" algn="r">
               <a:buNone/>
             </a:pPr>
             <a:r>
@@ -3975,7 +3717,7 @@
           <a:bodyPr wrap="square" rtlCol="0" anchor="ctr"/>
           <a:lstStyle/>
           <a:p>
-            <a:pPr indent="0" marL="0">
+            <a:pPr marL="0" indent="0">
               <a:buNone/>
             </a:pPr>
             <a:r>
@@ -4016,7 +3758,7 @@
           </a:bodyPr>
           <a:lstStyle/>
           <a:p>
-            <a:pPr indent="0" marL="0">
+            <a:pPr marL="0" indent="0">
               <a:buNone/>
             </a:pPr>
             <a:r>
@@ -4061,7 +3803,7 @@
           <a:bodyPr wrap="square" rtlCol="0" anchor="ctr"/>
           <a:lstStyle/>
           <a:p>
-            <a:pPr indent="0" marL="0">
+            <a:pPr marL="0" indent="0">
               <a:buNone/>
             </a:pPr>
             <a:endParaRPr lang="en-US" dirty="0"/>
@@ -4091,7 +3833,7 @@
           </a:bodyPr>
           <a:lstStyle/>
           <a:p>
-            <a:pPr indent="0" marL="0">
+            <a:pPr marL="0" indent="0">
               <a:buNone/>
             </a:pPr>
             <a:r>
@@ -4132,7 +3874,7 @@
           </a:bodyPr>
           <a:lstStyle/>
           <a:p>
-            <a:pPr indent="0" marL="0">
+            <a:pPr marL="0" indent="0">
               <a:buNone/>
             </a:pPr>
             <a:r>
@@ -4177,7 +3919,7 @@
           <a:bodyPr wrap="square" rtlCol="0" anchor="ctr"/>
           <a:lstStyle/>
           <a:p>
-            <a:pPr indent="0" marL="0">
+            <a:pPr marL="0" indent="0">
               <a:buNone/>
             </a:pPr>
             <a:endParaRPr lang="en-US" dirty="0"/>
@@ -4207,7 +3949,7 @@
           </a:bodyPr>
           <a:lstStyle/>
           <a:p>
-            <a:pPr indent="0" marL="0">
+            <a:pPr marL="0" indent="0">
               <a:buNone/>
             </a:pPr>
             <a:r>
@@ -4248,7 +3990,7 @@
           </a:bodyPr>
           <a:lstStyle/>
           <a:p>
-            <a:pPr indent="0" marL="0">
+            <a:pPr marL="0" indent="0">
               <a:buNone/>
             </a:pPr>
             <a:r>
@@ -4293,7 +4035,7 @@
           <a:bodyPr wrap="square" rtlCol="0" anchor="ctr"/>
           <a:lstStyle/>
           <a:p>
-            <a:pPr indent="0" marL="0">
+            <a:pPr marL="0" indent="0">
               <a:buNone/>
             </a:pPr>
             <a:endParaRPr lang="en-US" dirty="0"/>
@@ -4323,7 +4065,7 @@
           </a:bodyPr>
           <a:lstStyle/>
           <a:p>
-            <a:pPr indent="0" marL="0">
+            <a:pPr marL="0" indent="0">
               <a:buNone/>
             </a:pPr>
             <a:r>
@@ -4364,7 +4106,7 @@
           </a:bodyPr>
           <a:lstStyle/>
           <a:p>
-            <a:pPr indent="0" marL="0">
+            <a:pPr marL="0" indent="0">
               <a:buNone/>
             </a:pPr>
             <a:r>
@@ -4409,7 +4151,7 @@
           <a:bodyPr wrap="square" rtlCol="0" anchor="ctr"/>
           <a:lstStyle/>
           <a:p>
-            <a:pPr indent="0" marL="0">
+            <a:pPr marL="0" indent="0">
               <a:buNone/>
             </a:pPr>
             <a:endParaRPr lang="en-US" dirty="0"/>
@@ -4439,7 +4181,7 @@
           </a:bodyPr>
           <a:lstStyle/>
           <a:p>
-            <a:pPr indent="0" marL="0">
+            <a:pPr marL="0" indent="0">
               <a:buNone/>
             </a:pPr>
             <a:r>
@@ -4480,7 +4222,7 @@
           </a:bodyPr>
           <a:lstStyle/>
           <a:p>
-            <a:pPr indent="0" marL="0">
+            <a:pPr marL="0" indent="0">
               <a:buNone/>
             </a:pPr>
             <a:r>
@@ -4514,6 +4256,7 @@
         <a:solidFill>
           <a:srgbClr val="0B132B"/>
         </a:solidFill>
+        <a:effectLst/>
       </p:bgPr>
     </p:bg>
     <p:spTree>
@@ -4557,7 +4300,7 @@
           <a:bodyPr wrap="square" rtlCol="0" anchor="ctr"/>
           <a:lstStyle/>
           <a:p>
-            <a:pPr indent="0" marL="0">
+            <a:pPr marL="0" indent="0">
               <a:buNone/>
             </a:pPr>
             <a:endParaRPr lang="en-US" dirty="0"/>
@@ -4585,7 +4328,7 @@
           <a:bodyPr wrap="square" rtlCol="0" anchor="ctr"/>
           <a:lstStyle/>
           <a:p>
-            <a:pPr algn="r" indent="0" marL="0">
+            <a:pPr marL="0" indent="0" algn="r">
               <a:buNone/>
             </a:pPr>
             <a:r>
@@ -4624,7 +4367,7 @@
           <a:bodyPr wrap="square" rtlCol="0" anchor="ctr"/>
           <a:lstStyle/>
           <a:p>
-            <a:pPr indent="0" marL="0">
+            <a:pPr marL="0" indent="0">
               <a:buNone/>
             </a:pPr>
             <a:r>
@@ -4665,7 +4408,7 @@
           </a:bodyPr>
           <a:lstStyle/>
           <a:p>
-            <a:pPr indent="0" marL="0">
+            <a:pPr marL="0" indent="0">
               <a:buNone/>
             </a:pPr>
             <a:r>
@@ -4710,7 +4453,7 @@
           <a:bodyPr wrap="square" rtlCol="0" anchor="ctr"/>
           <a:lstStyle/>
           <a:p>
-            <a:pPr indent="0" marL="0">
+            <a:pPr marL="0" indent="0">
               <a:buNone/>
             </a:pPr>
             <a:endParaRPr lang="en-US" dirty="0"/>
@@ -4738,7 +4481,7 @@
           <a:bodyPr wrap="square" lIns="0" tIns="0" rIns="0" bIns="0" rtlCol="0" anchor="ctr"/>
           <a:lstStyle/>
           <a:p>
-            <a:pPr indent="0" marL="0">
+            <a:pPr marL="0" indent="0">
               <a:buNone/>
             </a:pPr>
             <a:r>
@@ -4779,7 +4522,7 @@
           </a:bodyPr>
           <a:lstStyle/>
           <a:p>
-            <a:pPr indent="0" marL="0">
+            <a:pPr marL="0" indent="0">
               <a:buNone/>
             </a:pPr>
             <a:r>
@@ -4824,7 +4567,7 @@
           <a:bodyPr wrap="square" rtlCol="0" anchor="ctr"/>
           <a:lstStyle/>
           <a:p>
-            <a:pPr indent="0" marL="0">
+            <a:pPr marL="0" indent="0">
               <a:buNone/>
             </a:pPr>
             <a:endParaRPr lang="en-US" dirty="0"/>
@@ -4852,7 +4595,7 @@
           <a:bodyPr wrap="square" lIns="0" tIns="0" rIns="0" bIns="0" rtlCol="0" anchor="ctr"/>
           <a:lstStyle/>
           <a:p>
-            <a:pPr indent="0" marL="0">
+            <a:pPr marL="0" indent="0">
               <a:buNone/>
             </a:pPr>
             <a:r>
@@ -4889,11 +4632,11 @@
         </p:spPr>
         <p:txBody>
           <a:bodyPr wrap="square" lIns="0" tIns="0" rIns="0" bIns="0" rtlCol="0" anchor="ctr">
-            <a:normAutofit/>
+            <a:normAutofit fontScale="92500"/>
           </a:bodyPr>
           <a:lstStyle/>
           <a:p>
-            <a:pPr indent="0" marL="0">
+            <a:pPr marL="0" indent="0">
               <a:buNone/>
             </a:pPr>
             <a:r>
@@ -4938,7 +4681,7 @@
           <a:bodyPr wrap="square" rtlCol="0" anchor="ctr"/>
           <a:lstStyle/>
           <a:p>
-            <a:pPr indent="0" marL="0">
+            <a:pPr marL="0" indent="0">
               <a:buNone/>
             </a:pPr>
             <a:endParaRPr lang="en-US" dirty="0"/>
@@ -4966,7 +4709,7 @@
           <a:bodyPr wrap="square" lIns="0" tIns="0" rIns="0" bIns="0" rtlCol="0" anchor="ctr"/>
           <a:lstStyle/>
           <a:p>
-            <a:pPr indent="0" marL="0">
+            <a:pPr marL="0" indent="0">
               <a:buNone/>
             </a:pPr>
             <a:r>
@@ -5003,11 +4746,11 @@
         </p:spPr>
         <p:txBody>
           <a:bodyPr wrap="square" lIns="0" tIns="0" rIns="0" bIns="0" rtlCol="0" anchor="ctr">
-            <a:normAutofit/>
+            <a:normAutofit fontScale="92500" lnSpcReduction="20000"/>
           </a:bodyPr>
           <a:lstStyle/>
           <a:p>
-            <a:pPr indent="0" marL="0">
+            <a:pPr marL="0" indent="0">
               <a:buNone/>
             </a:pPr>
             <a:r>
@@ -5052,7 +4795,7 @@
           <a:bodyPr wrap="square" rtlCol="0" anchor="ctr"/>
           <a:lstStyle/>
           <a:p>
-            <a:pPr indent="0" marL="0">
+            <a:pPr marL="0" indent="0">
               <a:buNone/>
             </a:pPr>
             <a:endParaRPr lang="en-US" dirty="0"/>
@@ -5082,7 +4825,7 @@
           </a:bodyPr>
           <a:lstStyle/>
           <a:p>
-            <a:pPr indent="0" marL="0">
+            <a:pPr marL="0" indent="0">
               <a:buNone/>
             </a:pPr>
             <a:r>
@@ -5123,7 +4866,7 @@
           </a:bodyPr>
           <a:lstStyle/>
           <a:p>
-            <a:pPr indent="0" marL="0">
+            <a:pPr marL="0" indent="0">
               <a:buNone/>
             </a:pPr>
             <a:r>
@@ -5168,7 +4911,7 @@
           <a:bodyPr wrap="square" rtlCol="0" anchor="ctr"/>
           <a:lstStyle/>
           <a:p>
-            <a:pPr indent="0" marL="0">
+            <a:pPr marL="0" indent="0">
               <a:buNone/>
             </a:pPr>
             <a:endParaRPr lang="en-US" dirty="0"/>
@@ -5198,7 +4941,7 @@
           </a:bodyPr>
           <a:lstStyle/>
           <a:p>
-            <a:pPr indent="0" marL="0">
+            <a:pPr marL="0" indent="0">
               <a:buNone/>
             </a:pPr>
             <a:r>
@@ -5239,7 +4982,7 @@
           </a:bodyPr>
           <a:lstStyle/>
           <a:p>
-            <a:pPr indent="0" marL="0">
+            <a:pPr marL="0" indent="0">
               <a:buNone/>
             </a:pPr>
             <a:r>
@@ -5273,6 +5016,7 @@
         <a:solidFill>
           <a:srgbClr val="0B132B"/>
         </a:solidFill>
+        <a:effectLst/>
       </p:bgPr>
     </p:bg>
     <p:spTree>
@@ -5316,7 +5060,7 @@
           <a:bodyPr wrap="square" rtlCol="0" anchor="ctr"/>
           <a:lstStyle/>
           <a:p>
-            <a:pPr indent="0" marL="0">
+            <a:pPr marL="0" indent="0">
               <a:buNone/>
             </a:pPr>
             <a:endParaRPr lang="en-US" dirty="0"/>
@@ -5344,7 +5088,7 @@
           <a:bodyPr wrap="square" rtlCol="0" anchor="ctr"/>
           <a:lstStyle/>
           <a:p>
-            <a:pPr algn="r" indent="0" marL="0">
+            <a:pPr marL="0" indent="0" algn="r">
               <a:buNone/>
             </a:pPr>
             <a:r>
@@ -5383,7 +5127,7 @@
           <a:bodyPr wrap="square" rtlCol="0" anchor="ctr"/>
           <a:lstStyle/>
           <a:p>
-            <a:pPr indent="0" marL="0">
+            <a:pPr marL="0" indent="0">
               <a:buNone/>
             </a:pPr>
             <a:r>
@@ -5424,7 +5168,7 @@
           </a:bodyPr>
           <a:lstStyle/>
           <a:p>
-            <a:pPr indent="0" marL="0">
+            <a:pPr marL="0" indent="0">
               <a:buNone/>
             </a:pPr>
             <a:r>
@@ -5469,7 +5213,7 @@
           <a:bodyPr wrap="square" rtlCol="0" anchor="ctr"/>
           <a:lstStyle/>
           <a:p>
-            <a:pPr indent="0" marL="0">
+            <a:pPr marL="0" indent="0">
               <a:buNone/>
             </a:pPr>
             <a:endParaRPr lang="en-US" dirty="0"/>
@@ -5499,7 +5243,7 @@
           </a:bodyPr>
           <a:lstStyle/>
           <a:p>
-            <a:pPr indent="0" marL="0">
+            <a:pPr marL="0" indent="0">
               <a:buNone/>
             </a:pPr>
             <a:r>
@@ -5540,7 +5284,7 @@
           </a:bodyPr>
           <a:lstStyle/>
           <a:p>
-            <a:pPr indent="0" marL="0">
+            <a:pPr marL="0" indent="0">
               <a:buNone/>
             </a:pPr>
             <a:r>
@@ -5585,7 +5329,7 @@
           <a:bodyPr wrap="square" rtlCol="0" anchor="ctr"/>
           <a:lstStyle/>
           <a:p>
-            <a:pPr indent="0" marL="0">
+            <a:pPr marL="0" indent="0">
               <a:buNone/>
             </a:pPr>
             <a:endParaRPr lang="en-US" dirty="0"/>
@@ -5615,7 +5359,7 @@
           </a:bodyPr>
           <a:lstStyle/>
           <a:p>
-            <a:pPr indent="0" marL="0">
+            <a:pPr marL="0" indent="0">
               <a:buNone/>
             </a:pPr>
             <a:r>
@@ -5656,7 +5400,7 @@
           </a:bodyPr>
           <a:lstStyle/>
           <a:p>
-            <a:pPr indent="0" marL="0">
+            <a:pPr marL="0" indent="0">
               <a:buNone/>
             </a:pPr>
             <a:r>
@@ -5701,7 +5445,7 @@
           <a:bodyPr wrap="square" rtlCol="0" anchor="ctr"/>
           <a:lstStyle/>
           <a:p>
-            <a:pPr indent="0" marL="0">
+            <a:pPr marL="0" indent="0">
               <a:buNone/>
             </a:pPr>
             <a:endParaRPr lang="en-US" dirty="0"/>
@@ -5731,7 +5475,7 @@
           </a:bodyPr>
           <a:lstStyle/>
           <a:p>
-            <a:pPr indent="0" marL="0">
+            <a:pPr marL="0" indent="0">
               <a:buNone/>
             </a:pPr>
             <a:r>
@@ -5772,7 +5516,7 @@
           </a:bodyPr>
           <a:lstStyle/>
           <a:p>
-            <a:pPr indent="0" marL="0">
+            <a:pPr marL="0" indent="0">
               <a:buNone/>
             </a:pPr>
             <a:r>
@@ -5813,7 +5557,7 @@
           </a:bodyPr>
           <a:lstStyle/>
           <a:p>
-            <a:pPr indent="0" marL="0">
+            <a:pPr marL="0" indent="0">
               <a:buNone/>
             </a:pPr>
             <a:r>
@@ -5830,7 +5574,7 @@
             <a:endParaRPr lang="en-US" sz="1200" dirty="0"/>
           </a:p>
           <a:p>
-            <a:pPr indent="0" marL="0">
+            <a:pPr marL="0" indent="0">
               <a:buNone/>
             </a:pPr>
             <a:r>
@@ -5847,7 +5591,7 @@
             <a:endParaRPr lang="en-US" sz="1200" dirty="0"/>
           </a:p>
           <a:p>
-            <a:pPr indent="0" marL="0">
+            <a:pPr marL="0" indent="0">
               <a:buNone/>
             </a:pPr>
             <a:r>
@@ -5892,7 +5636,7 @@
           <a:bodyPr wrap="square" rtlCol="0" anchor="ctr"/>
           <a:lstStyle/>
           <a:p>
-            <a:pPr indent="0" marL="0">
+            <a:pPr marL="0" indent="0">
               <a:buNone/>
             </a:pPr>
             <a:endParaRPr lang="en-US" dirty="0"/>
@@ -5922,7 +5666,7 @@
           </a:bodyPr>
           <a:lstStyle/>
           <a:p>
-            <a:pPr indent="0" marL="0">
+            <a:pPr marL="0" indent="0">
               <a:buNone/>
             </a:pPr>
             <a:r>
@@ -5963,7 +5707,7 @@
           </a:bodyPr>
           <a:lstStyle/>
           <a:p>
-            <a:pPr indent="0" marL="0">
+            <a:pPr marL="0" indent="0">
               <a:buNone/>
             </a:pPr>
             <a:r>
@@ -5997,6 +5741,7 @@
         <a:solidFill>
           <a:srgbClr val="0B132B"/>
         </a:solidFill>
+        <a:effectLst/>
       </p:bgPr>
     </p:bg>
     <p:spTree>
@@ -6040,7 +5785,7 @@
           <a:bodyPr wrap="square" rtlCol="0" anchor="ctr"/>
           <a:lstStyle/>
           <a:p>
-            <a:pPr indent="0" marL="0">
+            <a:pPr marL="0" indent="0">
               <a:buNone/>
             </a:pPr>
             <a:endParaRPr lang="en-US" dirty="0"/>
@@ -6068,7 +5813,7 @@
           <a:bodyPr wrap="square" rtlCol="0" anchor="ctr"/>
           <a:lstStyle/>
           <a:p>
-            <a:pPr algn="r" indent="0" marL="0">
+            <a:pPr marL="0" indent="0" algn="r">
               <a:buNone/>
             </a:pPr>
             <a:r>
@@ -6107,7 +5852,7 @@
           <a:bodyPr wrap="square" rtlCol="0" anchor="ctr"/>
           <a:lstStyle/>
           <a:p>
-            <a:pPr indent="0" marL="0">
+            <a:pPr marL="0" indent="0">
               <a:buNone/>
             </a:pPr>
             <a:r>
@@ -6148,7 +5893,7 @@
           </a:bodyPr>
           <a:lstStyle/>
           <a:p>
-            <a:pPr indent="0" marL="0">
+            <a:pPr marL="0" indent="0">
               <a:buNone/>
             </a:pPr>
             <a:r>
@@ -6193,7 +5938,7 @@
           <a:bodyPr wrap="square" rtlCol="0" anchor="ctr"/>
           <a:lstStyle/>
           <a:p>
-            <a:pPr indent="0" marL="0">
+            <a:pPr marL="0" indent="0">
               <a:buNone/>
             </a:pPr>
             <a:endParaRPr lang="en-US" dirty="0"/>
@@ -6223,7 +5968,7 @@
           </a:bodyPr>
           <a:lstStyle/>
           <a:p>
-            <a:pPr indent="0" marL="0">
+            <a:pPr marL="0" indent="0">
               <a:buNone/>
             </a:pPr>
             <a:r>
@@ -6264,7 +6009,7 @@
           </a:bodyPr>
           <a:lstStyle/>
           <a:p>
-            <a:pPr indent="0" marL="0">
+            <a:pPr marL="0" indent="0">
               <a:buNone/>
             </a:pPr>
             <a:r>
@@ -6281,7 +6026,7 @@
             <a:endParaRPr lang="en-US" sz="1100" dirty="0"/>
           </a:p>
           <a:p>
-            <a:pPr indent="0" marL="0">
+            <a:pPr marL="0" indent="0">
               <a:buNone/>
             </a:pPr>
             <a:r>
@@ -6326,7 +6071,7 @@
           <a:bodyPr wrap="square" rtlCol="0" anchor="ctr"/>
           <a:lstStyle/>
           <a:p>
-            <a:pPr indent="0" marL="0">
+            <a:pPr marL="0" indent="0">
               <a:buNone/>
             </a:pPr>
             <a:endParaRPr lang="en-US" dirty="0"/>
@@ -6356,7 +6101,7 @@
           </a:bodyPr>
           <a:lstStyle/>
           <a:p>
-            <a:pPr indent="0" marL="0">
+            <a:pPr marL="0" indent="0">
               <a:buNone/>
             </a:pPr>
             <a:r>
@@ -6397,7 +6142,7 @@
           </a:bodyPr>
           <a:lstStyle/>
           <a:p>
-            <a:pPr indent="0" marL="0">
+            <a:pPr marL="0" indent="0">
               <a:buNone/>
             </a:pPr>
             <a:r>
@@ -6414,7 +6159,7 @@
             <a:endParaRPr lang="en-US" sz="1100" dirty="0"/>
           </a:p>
           <a:p>
-            <a:pPr indent="0" marL="0">
+            <a:pPr marL="0" indent="0">
               <a:buNone/>
             </a:pPr>
             <a:r>
@@ -6459,7 +6204,7 @@
           <a:bodyPr wrap="square" rtlCol="0" anchor="ctr"/>
           <a:lstStyle/>
           <a:p>
-            <a:pPr indent="0" marL="0">
+            <a:pPr marL="0" indent="0">
               <a:buNone/>
             </a:pPr>
             <a:endParaRPr lang="en-US" dirty="0"/>
@@ -6489,7 +6234,7 @@
           </a:bodyPr>
           <a:lstStyle/>
           <a:p>
-            <a:pPr indent="0" marL="0">
+            <a:pPr marL="0" indent="0">
               <a:buNone/>
             </a:pPr>
             <a:r>
@@ -6530,7 +6275,7 @@
           </a:bodyPr>
           <a:lstStyle/>
           <a:p>
-            <a:pPr indent="0" marL="0">
+            <a:pPr marL="0" indent="0">
               <a:buNone/>
             </a:pPr>
             <a:r>
@@ -6547,7 +6292,7 @@
             <a:endParaRPr lang="en-US" sz="1100" dirty="0"/>
           </a:p>
           <a:p>
-            <a:pPr indent="0" marL="0">
+            <a:pPr marL="0" indent="0">
               <a:buNone/>
             </a:pPr>
             <a:r>
@@ -6592,7 +6337,7 @@
           <a:bodyPr wrap="square" rtlCol="0" anchor="ctr"/>
           <a:lstStyle/>
           <a:p>
-            <a:pPr indent="0" marL="0">
+            <a:pPr marL="0" indent="0">
               <a:buNone/>
             </a:pPr>
             <a:endParaRPr lang="en-US" dirty="0"/>
@@ -6622,7 +6367,7 @@
           </a:bodyPr>
           <a:lstStyle/>
           <a:p>
-            <a:pPr indent="0" marL="0">
+            <a:pPr marL="0" indent="0">
               <a:buNone/>
             </a:pPr>
             <a:r>
@@ -6663,7 +6408,7 @@
           </a:bodyPr>
           <a:lstStyle/>
           <a:p>
-            <a:pPr indent="0" marL="0">
+            <a:pPr marL="0" indent="0">
               <a:buNone/>
             </a:pPr>
             <a:r>
@@ -6708,7 +6453,7 @@
           <a:bodyPr wrap="square" rtlCol="0" anchor="ctr"/>
           <a:lstStyle/>
           <a:p>
-            <a:pPr indent="0" marL="0">
+            <a:pPr marL="0" indent="0">
               <a:buNone/>
             </a:pPr>
             <a:endParaRPr lang="en-US" dirty="0"/>
@@ -6738,7 +6483,7 @@
           </a:bodyPr>
           <a:lstStyle/>
           <a:p>
-            <a:pPr indent="0" marL="0">
+            <a:pPr marL="0" indent="0">
               <a:buNone/>
             </a:pPr>
             <a:r>
@@ -6779,7 +6524,7 @@
           </a:bodyPr>
           <a:lstStyle/>
           <a:p>
-            <a:pPr indent="0" marL="0">
+            <a:pPr marL="0" indent="0">
               <a:buNone/>
             </a:pPr>
             <a:r>
@@ -6813,6 +6558,7 @@
         <a:solidFill>
           <a:srgbClr val="0B132B"/>
         </a:solidFill>
+        <a:effectLst/>
       </p:bgPr>
     </p:bg>
     <p:spTree>
@@ -6856,7 +6602,7 @@
           <a:bodyPr wrap="square" rtlCol="0" anchor="ctr"/>
           <a:lstStyle/>
           <a:p>
-            <a:pPr indent="0" marL="0">
+            <a:pPr marL="0" indent="0">
               <a:buNone/>
             </a:pPr>
             <a:endParaRPr lang="en-US" dirty="0"/>
@@ -6884,7 +6630,7 @@
           <a:bodyPr wrap="square" rtlCol="0" anchor="ctr"/>
           <a:lstStyle/>
           <a:p>
-            <a:pPr algn="r" indent="0" marL="0">
+            <a:pPr marL="0" indent="0" algn="r">
               <a:buNone/>
             </a:pPr>
             <a:r>
@@ -6923,7 +6669,7 @@
           <a:bodyPr wrap="square" rtlCol="0" anchor="ctr"/>
           <a:lstStyle/>
           <a:p>
-            <a:pPr indent="0" marL="0">
+            <a:pPr marL="0" indent="0">
               <a:buNone/>
             </a:pPr>
             <a:r>
@@ -6964,7 +6710,7 @@
           </a:bodyPr>
           <a:lstStyle/>
           <a:p>
-            <a:pPr indent="0" marL="0">
+            <a:pPr marL="0" indent="0">
               <a:buNone/>
             </a:pPr>
             <a:r>
@@ -7009,7 +6755,7 @@
           <a:bodyPr wrap="square" rtlCol="0" anchor="ctr"/>
           <a:lstStyle/>
           <a:p>
-            <a:pPr indent="0" marL="0">
+            <a:pPr marL="0" indent="0">
               <a:buNone/>
             </a:pPr>
             <a:endParaRPr lang="en-US" dirty="0"/>
@@ -7039,7 +6785,7 @@
           </a:bodyPr>
           <a:lstStyle/>
           <a:p>
-            <a:pPr indent="0" marL="0">
+            <a:pPr marL="0" indent="0">
               <a:buNone/>
             </a:pPr>
             <a:r>
@@ -7080,7 +6826,7 @@
           </a:bodyPr>
           <a:lstStyle/>
           <a:p>
-            <a:pPr indent="0" marL="0">
+            <a:pPr marL="0" indent="0">
               <a:buNone/>
             </a:pPr>
             <a:r>
@@ -7125,7 +6871,7 @@
           <a:bodyPr wrap="square" rtlCol="0" anchor="ctr"/>
           <a:lstStyle/>
           <a:p>
-            <a:pPr indent="0" marL="0">
+            <a:pPr marL="0" indent="0">
               <a:buNone/>
             </a:pPr>
             <a:endParaRPr lang="en-US" dirty="0"/>
@@ -7155,7 +6901,7 @@
           </a:bodyPr>
           <a:lstStyle/>
           <a:p>
-            <a:pPr indent="0" marL="0">
+            <a:pPr marL="0" indent="0">
               <a:buNone/>
             </a:pPr>
             <a:r>
@@ -7196,7 +6942,7 @@
           </a:bodyPr>
           <a:lstStyle/>
           <a:p>
-            <a:pPr indent="0" marL="0">
+            <a:pPr marL="0" indent="0">
               <a:buNone/>
             </a:pPr>
             <a:r>
@@ -7241,7 +6987,7 @@
           <a:bodyPr wrap="square" rtlCol="0" anchor="ctr"/>
           <a:lstStyle/>
           <a:p>
-            <a:pPr indent="0" marL="0">
+            <a:pPr marL="0" indent="0">
               <a:buNone/>
             </a:pPr>
             <a:endParaRPr lang="en-US" dirty="0"/>
@@ -7271,7 +7017,7 @@
           </a:bodyPr>
           <a:lstStyle/>
           <a:p>
-            <a:pPr indent="0" marL="0">
+            <a:pPr marL="0" indent="0">
               <a:buNone/>
             </a:pPr>
             <a:r>
@@ -7312,7 +7058,7 @@
           </a:bodyPr>
           <a:lstStyle/>
           <a:p>
-            <a:pPr indent="0" marL="0">
+            <a:pPr marL="0" indent="0">
               <a:buNone/>
             </a:pPr>
             <a:r>
@@ -7357,7 +7103,7 @@
           <a:bodyPr wrap="square" rtlCol="0" anchor="ctr"/>
           <a:lstStyle/>
           <a:p>
-            <a:pPr indent="0" marL="0">
+            <a:pPr marL="0" indent="0">
               <a:buNone/>
             </a:pPr>
             <a:endParaRPr lang="en-US" dirty="0"/>
@@ -7387,7 +7133,7 @@
           </a:bodyPr>
           <a:lstStyle/>
           <a:p>
-            <a:pPr indent="0" marL="0">
+            <a:pPr marL="0" indent="0">
               <a:buNone/>
             </a:pPr>
             <a:r>
@@ -7428,7 +7174,7 @@
           </a:bodyPr>
           <a:lstStyle/>
           <a:p>
-            <a:pPr indent="0" marL="0">
+            <a:pPr marL="0" indent="0">
               <a:buNone/>
             </a:pPr>
             <a:r>
@@ -7462,6 +7208,7 @@
         <a:solidFill>
           <a:srgbClr val="0B132B"/>
         </a:solidFill>
+        <a:effectLst/>
       </p:bgPr>
     </p:bg>
     <p:spTree>
@@ -7505,7 +7252,7 @@
           <a:bodyPr wrap="square" rtlCol="0" anchor="ctr"/>
           <a:lstStyle/>
           <a:p>
-            <a:pPr indent="0" marL="0">
+            <a:pPr marL="0" indent="0">
               <a:buNone/>
             </a:pPr>
             <a:endParaRPr lang="en-US" dirty="0"/>
@@ -7533,7 +7280,7 @@
           <a:bodyPr wrap="square" rtlCol="0" anchor="ctr"/>
           <a:lstStyle/>
           <a:p>
-            <a:pPr algn="r" indent="0" marL="0">
+            <a:pPr marL="0" indent="0" algn="r">
               <a:buNone/>
             </a:pPr>
             <a:r>
@@ -7572,7 +7319,7 @@
           <a:bodyPr wrap="square" rtlCol="0" anchor="ctr"/>
           <a:lstStyle/>
           <a:p>
-            <a:pPr indent="0" marL="0">
+            <a:pPr marL="0" indent="0">
               <a:buNone/>
             </a:pPr>
             <a:r>
@@ -7613,7 +7360,7 @@
           </a:bodyPr>
           <a:lstStyle/>
           <a:p>
-            <a:pPr indent="0" marL="0">
+            <a:pPr marL="0" indent="0">
               <a:buNone/>
             </a:pPr>
             <a:r>
@@ -7658,7 +7405,7 @@
           <a:bodyPr wrap="square" rtlCol="0" anchor="ctr"/>
           <a:lstStyle/>
           <a:p>
-            <a:pPr indent="0" marL="0">
+            <a:pPr marL="0" indent="0">
               <a:buNone/>
             </a:pPr>
             <a:endParaRPr lang="en-US" dirty="0"/>
@@ -7688,7 +7435,7 @@
           </a:bodyPr>
           <a:lstStyle/>
           <a:p>
-            <a:pPr indent="0" marL="0">
+            <a:pPr marL="0" indent="0">
               <a:buNone/>
             </a:pPr>
             <a:r>
@@ -7729,7 +7476,7 @@
           </a:bodyPr>
           <a:lstStyle/>
           <a:p>
-            <a:pPr indent="0" marL="0">
+            <a:pPr marL="0" indent="0">
               <a:buNone/>
             </a:pPr>
             <a:r>
@@ -7774,7 +7521,7 @@
           <a:bodyPr wrap="square" rtlCol="0" anchor="ctr"/>
           <a:lstStyle/>
           <a:p>
-            <a:pPr indent="0" marL="0">
+            <a:pPr marL="0" indent="0">
               <a:buNone/>
             </a:pPr>
             <a:endParaRPr lang="en-US" dirty="0"/>
@@ -7804,7 +7551,7 @@
           </a:bodyPr>
           <a:lstStyle/>
           <a:p>
-            <a:pPr indent="0" marL="0">
+            <a:pPr marL="0" indent="0">
               <a:buNone/>
             </a:pPr>
             <a:r>
@@ -7845,7 +7592,7 @@
           </a:bodyPr>
           <a:lstStyle/>
           <a:p>
-            <a:pPr indent="0" marL="0">
+            <a:pPr marL="0" indent="0">
               <a:buNone/>
             </a:pPr>
             <a:r>
@@ -7890,7 +7637,7 @@
           <a:bodyPr wrap="square" rtlCol="0" anchor="ctr"/>
           <a:lstStyle/>
           <a:p>
-            <a:pPr indent="0" marL="0">
+            <a:pPr marL="0" indent="0">
               <a:buNone/>
             </a:pPr>
             <a:endParaRPr lang="en-US" dirty="0"/>
@@ -7920,7 +7667,7 @@
           </a:bodyPr>
           <a:lstStyle/>
           <a:p>
-            <a:pPr indent="0" marL="0">
+            <a:pPr marL="0" indent="0">
               <a:buNone/>
             </a:pPr>
             <a:r>
@@ -7961,7 +7708,7 @@
           </a:bodyPr>
           <a:lstStyle/>
           <a:p>
-            <a:pPr indent="0" marL="0">
+            <a:pPr marL="0" indent="0">
               <a:buNone/>
             </a:pPr>
             <a:r>
@@ -8006,7 +7753,7 @@
           <a:bodyPr wrap="square" rtlCol="0" anchor="ctr"/>
           <a:lstStyle/>
           <a:p>
-            <a:pPr indent="0" marL="0">
+            <a:pPr marL="0" indent="0">
               <a:buNone/>
             </a:pPr>
             <a:endParaRPr lang="en-US" dirty="0"/>
@@ -8036,7 +7783,7 @@
           </a:bodyPr>
           <a:lstStyle/>
           <a:p>
-            <a:pPr indent="0" marL="0">
+            <a:pPr marL="0" indent="0">
               <a:buNone/>
             </a:pPr>
             <a:r>
@@ -8077,7 +7824,7 @@
           </a:bodyPr>
           <a:lstStyle/>
           <a:p>
-            <a:pPr indent="0" marL="0">
+            <a:pPr marL="0" indent="0">
               <a:buNone/>
             </a:pPr>
             <a:r>
@@ -8122,7 +7869,7 @@
           <a:bodyPr wrap="square" rtlCol="0" anchor="ctr"/>
           <a:lstStyle/>
           <a:p>
-            <a:pPr indent="0" marL="0">
+            <a:pPr marL="0" indent="0">
               <a:buNone/>
             </a:pPr>
             <a:endParaRPr lang="en-US" dirty="0"/>
@@ -8152,7 +7899,7 @@
           </a:bodyPr>
           <a:lstStyle/>
           <a:p>
-            <a:pPr indent="0" marL="0">
+            <a:pPr marL="0" indent="0">
               <a:buNone/>
             </a:pPr>
             <a:r>
@@ -8193,7 +7940,7 @@
           </a:bodyPr>
           <a:lstStyle/>
           <a:p>
-            <a:pPr indent="0" marL="0">
+            <a:pPr marL="0" indent="0">
               <a:buNone/>
             </a:pPr>
             <a:r>
@@ -8227,6 +7974,7 @@
         <a:solidFill>
           <a:srgbClr val="0B132B"/>
         </a:solidFill>
+        <a:effectLst/>
       </p:bgPr>
     </p:bg>
     <p:spTree>
@@ -8270,7 +8018,7 @@
           <a:bodyPr wrap="square" rtlCol="0" anchor="ctr"/>
           <a:lstStyle/>
           <a:p>
-            <a:pPr indent="0" marL="0">
+            <a:pPr marL="0" indent="0">
               <a:buNone/>
             </a:pPr>
             <a:endParaRPr lang="en-US" dirty="0"/>
@@ -8298,7 +8046,7 @@
           <a:bodyPr wrap="square" rtlCol="0" anchor="ctr"/>
           <a:lstStyle/>
           <a:p>
-            <a:pPr algn="r" indent="0" marL="0">
+            <a:pPr marL="0" indent="0" algn="r">
               <a:buNone/>
             </a:pPr>
             <a:r>
@@ -8337,7 +8085,7 @@
           <a:bodyPr wrap="square" rtlCol="0" anchor="ctr"/>
           <a:lstStyle/>
           <a:p>
-            <a:pPr indent="0" marL="0">
+            <a:pPr marL="0" indent="0">
               <a:buNone/>
             </a:pPr>
             <a:r>
@@ -8378,7 +8126,7 @@
           </a:bodyPr>
           <a:lstStyle/>
           <a:p>
-            <a:pPr indent="0" marL="0">
+            <a:pPr marL="0" indent="0">
               <a:buNone/>
             </a:pPr>
             <a:r>
@@ -8423,7 +8171,7 @@
           <a:bodyPr wrap="square" rtlCol="0" anchor="ctr"/>
           <a:lstStyle/>
           <a:p>
-            <a:pPr indent="0" marL="0">
+            <a:pPr marL="0" indent="0">
               <a:buNone/>
             </a:pPr>
             <a:endParaRPr lang="en-US" dirty="0"/>
@@ -8453,7 +8201,7 @@
           </a:bodyPr>
           <a:lstStyle/>
           <a:p>
-            <a:pPr indent="0" marL="0">
+            <a:pPr marL="0" indent="0">
               <a:buNone/>
             </a:pPr>
             <a:r>
@@ -8494,7 +8242,7 @@
           </a:bodyPr>
           <a:lstStyle/>
           <a:p>
-            <a:pPr indent="0" marL="0">
+            <a:pPr marL="0" indent="0">
               <a:buNone/>
             </a:pPr>
             <a:r>
@@ -8539,7 +8287,7 @@
           <a:bodyPr wrap="square" rtlCol="0" anchor="ctr"/>
           <a:lstStyle/>
           <a:p>
-            <a:pPr indent="0" marL="0">
+            <a:pPr marL="0" indent="0">
               <a:buNone/>
             </a:pPr>
             <a:endParaRPr lang="en-US" dirty="0"/>
@@ -8569,7 +8317,7 @@
           </a:bodyPr>
           <a:lstStyle/>
           <a:p>
-            <a:pPr indent="0" marL="0">
+            <a:pPr marL="0" indent="0">
               <a:buNone/>
             </a:pPr>
             <a:r>
@@ -8610,7 +8358,7 @@
           </a:bodyPr>
           <a:lstStyle/>
           <a:p>
-            <a:pPr indent="0" marL="0">
+            <a:pPr marL="0" indent="0">
               <a:buNone/>
             </a:pPr>
             <a:r>
@@ -8655,7 +8403,7 @@
           <a:bodyPr wrap="square" rtlCol="0" anchor="ctr"/>
           <a:lstStyle/>
           <a:p>
-            <a:pPr indent="0" marL="0">
+            <a:pPr marL="0" indent="0">
               <a:buNone/>
             </a:pPr>
             <a:endParaRPr lang="en-US" dirty="0"/>
@@ -8685,7 +8433,7 @@
           </a:bodyPr>
           <a:lstStyle/>
           <a:p>
-            <a:pPr indent="0" marL="0">
+            <a:pPr marL="0" indent="0">
               <a:buNone/>
             </a:pPr>
             <a:r>
@@ -8726,7 +8474,7 @@
           </a:bodyPr>
           <a:lstStyle/>
           <a:p>
-            <a:pPr indent="0" marL="0">
+            <a:pPr marL="0" indent="0">
               <a:buNone/>
             </a:pPr>
             <a:r>
@@ -8771,7 +8519,7 @@
           <a:bodyPr wrap="square" rtlCol="0" anchor="ctr"/>
           <a:lstStyle/>
           <a:p>
-            <a:pPr indent="0" marL="0">
+            <a:pPr marL="0" indent="0">
               <a:buNone/>
             </a:pPr>
             <a:endParaRPr lang="en-US" dirty="0"/>
@@ -8801,7 +8549,7 @@
           </a:bodyPr>
           <a:lstStyle/>
           <a:p>
-            <a:pPr indent="0" marL="0">
+            <a:pPr marL="0" indent="0">
               <a:buNone/>
             </a:pPr>
             <a:r>
@@ -8842,7 +8590,7 @@
           </a:bodyPr>
           <a:lstStyle/>
           <a:p>
-            <a:pPr indent="0" marL="0">
+            <a:pPr marL="0" indent="0">
               <a:buNone/>
             </a:pPr>
             <a:r>
@@ -8876,6 +8624,7 @@
         <a:solidFill>
           <a:srgbClr val="0B132B"/>
         </a:solidFill>
+        <a:effectLst/>
       </p:bgPr>
     </p:bg>
     <p:spTree>
@@ -8919,7 +8668,7 @@
           <a:bodyPr wrap="square" rtlCol="0" anchor="ctr"/>
           <a:lstStyle/>
           <a:p>
-            <a:pPr indent="0" marL="0">
+            <a:pPr marL="0" indent="0">
               <a:buNone/>
             </a:pPr>
             <a:endParaRPr lang="en-US" dirty="0"/>
@@ -8947,7 +8696,7 @@
           <a:bodyPr wrap="square" rtlCol="0" anchor="ctr"/>
           <a:lstStyle/>
           <a:p>
-            <a:pPr algn="r" indent="0" marL="0">
+            <a:pPr marL="0" indent="0" algn="r">
               <a:buNone/>
             </a:pPr>
             <a:r>
@@ -8986,7 +8735,7 @@
           <a:bodyPr wrap="square" rtlCol="0" anchor="ctr"/>
           <a:lstStyle/>
           <a:p>
-            <a:pPr indent="0" marL="0">
+            <a:pPr marL="0" indent="0">
               <a:buNone/>
             </a:pPr>
             <a:r>
@@ -9027,7 +8776,7 @@
           </a:bodyPr>
           <a:lstStyle/>
           <a:p>
-            <a:pPr indent="0" marL="0">
+            <a:pPr marL="0" indent="0">
               <a:buNone/>
             </a:pPr>
             <a:r>
@@ -9072,7 +8821,7 @@
           <a:bodyPr wrap="square" rtlCol="0" anchor="ctr"/>
           <a:lstStyle/>
           <a:p>
-            <a:pPr indent="0" marL="0">
+            <a:pPr marL="0" indent="0">
               <a:buNone/>
             </a:pPr>
             <a:endParaRPr lang="en-US" dirty="0"/>
@@ -9102,7 +8851,7 @@
           </a:bodyPr>
           <a:lstStyle/>
           <a:p>
-            <a:pPr indent="0" marL="0">
+            <a:pPr marL="0" indent="0">
               <a:buNone/>
             </a:pPr>
             <a:r>
@@ -9143,7 +8892,7 @@
           </a:bodyPr>
           <a:lstStyle/>
           <a:p>
-            <a:pPr indent="0" marL="0">
+            <a:pPr marL="0" indent="0">
               <a:buNone/>
             </a:pPr>
             <a:r>
@@ -9160,7 +8909,7 @@
             <a:endParaRPr lang="en-US" sz="1100" dirty="0"/>
           </a:p>
           <a:p>
-            <a:pPr indent="0" marL="0">
+            <a:pPr marL="0" indent="0">
               <a:buNone/>
             </a:pPr>
             <a:r>
@@ -9177,7 +8926,7 @@
             <a:endParaRPr lang="en-US" sz="1100" dirty="0"/>
           </a:p>
           <a:p>
-            <a:pPr indent="0" marL="0">
+            <a:pPr marL="0" indent="0">
               <a:buNone/>
             </a:pPr>
             <a:r>
@@ -9194,7 +8943,7 @@
             <a:endParaRPr lang="en-US" sz="1100" dirty="0"/>
           </a:p>
           <a:p>
-            <a:pPr indent="0" marL="0">
+            <a:pPr marL="0" indent="0">
               <a:buNone/>
             </a:pPr>
             <a:r>
@@ -9211,7 +8960,7 @@
             <a:endParaRPr lang="en-US" sz="1100" dirty="0"/>
           </a:p>
           <a:p>
-            <a:pPr indent="0" marL="0">
+            <a:pPr marL="0" indent="0">
               <a:buNone/>
             </a:pPr>
             <a:r>
@@ -9256,7 +9005,7 @@
           <a:bodyPr wrap="square" rtlCol="0" anchor="ctr"/>
           <a:lstStyle/>
           <a:p>
-            <a:pPr indent="0" marL="0">
+            <a:pPr marL="0" indent="0">
               <a:buNone/>
             </a:pPr>
             <a:endParaRPr lang="en-US" dirty="0"/>
@@ -9286,7 +9035,7 @@
           </a:bodyPr>
           <a:lstStyle/>
           <a:p>
-            <a:pPr indent="0" marL="0">
+            <a:pPr marL="0" indent="0">
               <a:buNone/>
             </a:pPr>
             <a:r>
@@ -9327,7 +9076,7 @@
           </a:bodyPr>
           <a:lstStyle/>
           <a:p>
-            <a:pPr indent="0" marL="0">
+            <a:pPr marL="0" indent="0">
               <a:buNone/>
             </a:pPr>
             <a:r>
@@ -9344,7 +9093,7 @@
             <a:endParaRPr lang="en-US" sz="1100" dirty="0"/>
           </a:p>
           <a:p>
-            <a:pPr indent="0" marL="0">
+            <a:pPr marL="0" indent="0">
               <a:buNone/>
             </a:pPr>
             <a:r>
@@ -9361,7 +9110,7 @@
             <a:endParaRPr lang="en-US" sz="1100" dirty="0"/>
           </a:p>
           <a:p>
-            <a:pPr indent="0" marL="0">
+            <a:pPr marL="0" indent="0">
               <a:buNone/>
             </a:pPr>
             <a:r>
@@ -9378,7 +9127,7 @@
             <a:endParaRPr lang="en-US" sz="1100" dirty="0"/>
           </a:p>
           <a:p>
-            <a:pPr indent="0" marL="0">
+            <a:pPr marL="0" indent="0">
               <a:buNone/>
             </a:pPr>
             <a:r>
@@ -9423,7 +9172,7 @@
           <a:bodyPr wrap="square" rtlCol="0" anchor="ctr"/>
           <a:lstStyle/>
           <a:p>
-            <a:pPr indent="0" marL="0">
+            <a:pPr marL="0" indent="0">
               <a:buNone/>
             </a:pPr>
             <a:endParaRPr lang="en-US" dirty="0"/>
@@ -9453,7 +9202,7 @@
           </a:bodyPr>
           <a:lstStyle/>
           <a:p>
-            <a:pPr indent="0" marL="0">
+            <a:pPr marL="0" indent="0">
               <a:buNone/>
             </a:pPr>
             <a:r>
@@ -9465,7 +9214,7 @@
                 <a:ea typeface="Aptos" pitchFamily="34" charset="-122"/>
                 <a:cs typeface="Aptos" pitchFamily="34" charset="-120"/>
               </a:rPr>
-              <a:t>Renter feedback (temporary)</a:t>
+              <a:t>Renter feedback</a:t>
             </a:r>
             <a:endParaRPr lang="en-US" sz="1300" dirty="0"/>
           </a:p>
@@ -9490,12 +9239,13 @@
         </p:spPr>
         <p:txBody>
           <a:bodyPr wrap="square" lIns="0" tIns="0" rIns="0" bIns="0" rtlCol="0" anchor="t">
-            <a:normAutofit/>
+            <a:normAutofit fontScale="92500"/>
           </a:bodyPr>
           <a:lstStyle/>
           <a:p>
-            <a:pPr indent="0" marL="0">
-              <a:buNone/>
+            <a:pPr marL="171450" indent="-171450">
+              <a:buFontTx/>
+              <a:buChar char="-"/>
             </a:pPr>
             <a:r>
               <a:rPr lang="en-US" sz="1100" dirty="0">
@@ -9503,12 +9253,39 @@
                   <a:srgbClr val="C9D1E0"/>
                 </a:solidFill>
                 <a:latin typeface="Aptos" pitchFamily="34" charset="0"/>
-                <a:ea typeface="Aptos" pitchFamily="34" charset="-122"/>
-                <a:cs typeface="Aptos" pitchFamily="34" charset="-120"/>
-              </a:rPr>
-              <a:t>TEMP</a:t>
-            </a:r>
-            <a:endParaRPr lang="en-US" sz="1100" dirty="0"/>
+              </a:rPr>
+              <a:t>Close friends of mine in their twenties have dealt with unsafe conditions and slow or ignored responses when they raised serious maintenance concerns.</a:t>
+            </a:r>
+          </a:p>
+          <a:p>
+            <a:pPr marL="171450" indent="-171450">
+              <a:buFontTx/>
+              <a:buChar char="-"/>
+            </a:pPr>
+            <a:r>
+              <a:rPr lang="en-US" sz="1100" dirty="0">
+                <a:solidFill>
+                  <a:srgbClr val="C9D1E0"/>
+                </a:solidFill>
+                <a:latin typeface="Aptos" pitchFamily="34" charset="0"/>
+              </a:rPr>
+              <a:t>They have also experienced poor communication, with key issues around inspections, repairs, and tenancy expectations handled unclearly or inconsistently.</a:t>
+            </a:r>
+          </a:p>
+          <a:p>
+            <a:pPr marL="171450" indent="-171450">
+              <a:buFontTx/>
+              <a:buChar char="-"/>
+            </a:pPr>
+            <a:r>
+              <a:rPr lang="en-US" sz="1100" dirty="0">
+                <a:solidFill>
+                  <a:srgbClr val="C9D1E0"/>
+                </a:solidFill>
+                <a:latin typeface="Aptos" pitchFamily="34" charset="0"/>
+              </a:rPr>
+              <a:t>These experiences left them feeling stressed and unsupported during a period when stable housing should have been straightforward and secure.</a:t>
+            </a:r>
           </a:p>
         </p:txBody>
       </p:sp>
@@ -9539,7 +9316,7 @@
           <a:bodyPr wrap="square" rtlCol="0" anchor="ctr"/>
           <a:lstStyle/>
           <a:p>
-            <a:pPr indent="0" marL="0">
+            <a:pPr marL="0" indent="0">
               <a:buNone/>
             </a:pPr>
             <a:endParaRPr lang="en-US" dirty="0"/>
@@ -9569,7 +9346,7 @@
           </a:bodyPr>
           <a:lstStyle/>
           <a:p>
-            <a:pPr indent="0" marL="0">
+            <a:pPr marL="0" indent="0">
               <a:buNone/>
             </a:pPr>
             <a:r>
@@ -9606,11 +9383,11 @@
         </p:spPr>
         <p:txBody>
           <a:bodyPr wrap="square" lIns="0" tIns="0" rIns="0" bIns="0" rtlCol="0" anchor="t">
-            <a:normAutofit/>
+            <a:normAutofit lnSpcReduction="10000"/>
           </a:bodyPr>
           <a:lstStyle/>
           <a:p>
-            <a:pPr indent="0" marL="0">
+            <a:pPr marL="0" indent="0">
               <a:buNone/>
             </a:pPr>
             <a:r>
@@ -9644,6 +9421,7 @@
         <a:solidFill>
           <a:srgbClr val="0B132B"/>
         </a:solidFill>
+        <a:effectLst/>
       </p:bgPr>
     </p:bg>
     <p:spTree>
@@ -9687,7 +9465,7 @@
           <a:bodyPr wrap="square" rtlCol="0" anchor="ctr"/>
           <a:lstStyle/>
           <a:p>
-            <a:pPr indent="0" marL="0">
+            <a:pPr marL="0" indent="0">
               <a:buNone/>
             </a:pPr>
             <a:endParaRPr lang="en-US" dirty="0"/>
@@ -9715,7 +9493,7 @@
           <a:bodyPr wrap="square" rtlCol="0" anchor="ctr"/>
           <a:lstStyle/>
           <a:p>
-            <a:pPr algn="r" indent="0" marL="0">
+            <a:pPr marL="0" indent="0" algn="r">
               <a:buNone/>
             </a:pPr>
             <a:r>
@@ -9754,7 +9532,7 @@
           <a:bodyPr wrap="square" rtlCol="0" anchor="ctr"/>
           <a:lstStyle/>
           <a:p>
-            <a:pPr indent="0" marL="0">
+            <a:pPr marL="0" indent="0">
               <a:buNone/>
             </a:pPr>
             <a:r>
@@ -9795,7 +9573,7 @@
           </a:bodyPr>
           <a:lstStyle/>
           <a:p>
-            <a:pPr indent="0" marL="0">
+            <a:pPr marL="0" indent="0">
               <a:buNone/>
             </a:pPr>
             <a:r>
@@ -9840,7 +9618,7 @@
           <a:bodyPr wrap="square" rtlCol="0" anchor="ctr"/>
           <a:lstStyle/>
           <a:p>
-            <a:pPr indent="0" marL="0">
+            <a:pPr marL="0" indent="0">
               <a:buNone/>
             </a:pPr>
             <a:endParaRPr lang="en-US" dirty="0"/>
@@ -9870,7 +9648,7 @@
           </a:bodyPr>
           <a:lstStyle/>
           <a:p>
-            <a:pPr indent="0" marL="0">
+            <a:pPr marL="0" indent="0">
               <a:buNone/>
             </a:pPr>
             <a:r>
@@ -9911,7 +9689,7 @@
           </a:bodyPr>
           <a:lstStyle/>
           <a:p>
-            <a:pPr indent="0" marL="0">
+            <a:pPr marL="0" indent="0">
               <a:buNone/>
             </a:pPr>
             <a:r>
@@ -9928,13 +9706,13 @@
             <a:endParaRPr lang="en-US" sz="1100" dirty="0"/>
           </a:p>
           <a:p>
-            <a:pPr indent="0" marL="0">
+            <a:pPr marL="0" indent="0">
               <a:buNone/>
             </a:pPr>
             <a:endParaRPr lang="en-US" sz="1100" dirty="0"/>
           </a:p>
           <a:p>
-            <a:pPr indent="0" marL="0">
+            <a:pPr marL="0" indent="0">
               <a:buNone/>
             </a:pPr>
             <a:r>
@@ -9979,7 +9757,7 @@
           <a:bodyPr wrap="square" rtlCol="0" anchor="ctr"/>
           <a:lstStyle/>
           <a:p>
-            <a:pPr indent="0" marL="0">
+            <a:pPr marL="0" indent="0">
               <a:buNone/>
             </a:pPr>
             <a:endParaRPr lang="en-US" dirty="0"/>
@@ -10009,7 +9787,7 @@
           </a:bodyPr>
           <a:lstStyle/>
           <a:p>
-            <a:pPr indent="0" marL="0">
+            <a:pPr marL="0" indent="0">
               <a:buNone/>
             </a:pPr>
             <a:r>
@@ -10050,7 +9828,7 @@
           </a:bodyPr>
           <a:lstStyle/>
           <a:p>
-            <a:pPr indent="0" marL="0">
+            <a:pPr marL="0" indent="0">
               <a:buNone/>
             </a:pPr>
             <a:r>
@@ -10067,7 +9845,7 @@
             <a:endParaRPr lang="en-US" sz="1100" dirty="0"/>
           </a:p>
           <a:p>
-            <a:pPr indent="0" marL="0">
+            <a:pPr marL="0" indent="0">
               <a:buNone/>
             </a:pPr>
             <a:r>
@@ -10084,7 +9862,7 @@
             <a:endParaRPr lang="en-US" sz="1100" dirty="0"/>
           </a:p>
           <a:p>
-            <a:pPr indent="0" marL="0">
+            <a:pPr marL="0" indent="0">
               <a:buNone/>
             </a:pPr>
             <a:r>
@@ -10101,7 +9879,7 @@
             <a:endParaRPr lang="en-US" sz="1100" dirty="0"/>
           </a:p>
           <a:p>
-            <a:pPr indent="0" marL="0">
+            <a:pPr marL="0" indent="0">
               <a:buNone/>
             </a:pPr>
             <a:r>
@@ -10140,7 +9918,7 @@
           <a:bodyPr wrap="square" lIns="0" tIns="0" rIns="0" bIns="0" rtlCol="0" anchor="ctr"/>
           <a:lstStyle/>
           <a:p>
-            <a:pPr indent="0" marL="0">
+            <a:pPr marL="0" indent="0">
               <a:buNone/>
             </a:pPr>
             <a:r>
@@ -10459,4 +10237,319 @@
     </a:ext>
   </a:extLst>
 </a:theme>
+</file>
+
+<file path=ppt/theme/theme2.xml><?xml version="1.0" encoding="utf-8"?>
+<a:theme xmlns:a="http://schemas.openxmlformats.org/drawingml/2006/main" name="Office Theme">
+  <a:themeElements>
+    <a:clrScheme name="Office">
+      <a:dk1>
+        <a:sysClr val="windowText" lastClr="000000"/>
+      </a:dk1>
+      <a:lt1>
+        <a:sysClr val="window" lastClr="FFFFFF"/>
+      </a:lt1>
+      <a:dk2>
+        <a:srgbClr val="0E2841"/>
+      </a:dk2>
+      <a:lt2>
+        <a:srgbClr val="E8E8E8"/>
+      </a:lt2>
+      <a:accent1>
+        <a:srgbClr val="156082"/>
+      </a:accent1>
+      <a:accent2>
+        <a:srgbClr val="E97132"/>
+      </a:accent2>
+      <a:accent3>
+        <a:srgbClr val="196B24"/>
+      </a:accent3>
+      <a:accent4>
+        <a:srgbClr val="0F9ED5"/>
+      </a:accent4>
+      <a:accent5>
+        <a:srgbClr val="A02B93"/>
+      </a:accent5>
+      <a:accent6>
+        <a:srgbClr val="4EA72E"/>
+      </a:accent6>
+      <a:hlink>
+        <a:srgbClr val="467886"/>
+      </a:hlink>
+      <a:folHlink>
+        <a:srgbClr val="96607D"/>
+      </a:folHlink>
+    </a:clrScheme>
+    <a:fontScheme name="Office">
+      <a:majorFont>
+        <a:latin typeface="Aptos Display" panose="02110004020202020204"/>
+        <a:ea typeface=""/>
+        <a:cs typeface=""/>
+        <a:font script="Jpan" typeface="游ゴシック Light"/>
+        <a:font script="Hang" typeface="맑은 고딕"/>
+        <a:font script="Hans" typeface="等线 Light"/>
+        <a:font script="Hant" typeface="新細明體"/>
+        <a:font script="Arab" typeface="Times New Roman"/>
+        <a:font script="Hebr" typeface="Times New Roman"/>
+        <a:font script="Thai" typeface="Angsana New"/>
+        <a:font script="Ethi" typeface="Nyala"/>
+        <a:font script="Beng" typeface="Vrinda"/>
+        <a:font script="Gujr" typeface="Shruti"/>
+        <a:font script="Khmr" typeface="MoolBoran"/>
+        <a:font script="Knda" typeface="Tunga"/>
+        <a:font script="Guru" typeface="Raavi"/>
+        <a:font script="Cans" typeface="Euphemia"/>
+        <a:font script="Cher" typeface="Plantagenet Cherokee"/>
+        <a:font script="Yiii" typeface="Microsoft Yi Baiti"/>
+        <a:font script="Tibt" typeface="Microsoft Himalaya"/>
+        <a:font script="Thaa" typeface="MV Boli"/>
+        <a:font script="Deva" typeface="Mangal"/>
+        <a:font script="Telu" typeface="Gautami"/>
+        <a:font script="Taml" typeface="Latha"/>
+        <a:font script="Syrc" typeface="Estrangelo Edessa"/>
+        <a:font script="Orya" typeface="Kalinga"/>
+        <a:font script="Mlym" typeface="Kartika"/>
+        <a:font script="Laoo" typeface="DokChampa"/>
+        <a:font script="Sinh" typeface="Iskoola Pota"/>
+        <a:font script="Mong" typeface="Mongolian Baiti"/>
+        <a:font script="Viet" typeface="Times New Roman"/>
+        <a:font script="Uigh" typeface="Microsoft Uighur"/>
+        <a:font script="Geor" typeface="Sylfaen"/>
+        <a:font script="Armn" typeface="Arial"/>
+        <a:font script="Bugi" typeface="Leelawadee UI"/>
+        <a:font script="Bopo" typeface="Microsoft JhengHei"/>
+        <a:font script="Java" typeface="Javanese Text"/>
+        <a:font script="Lisu" typeface="Segoe UI"/>
+        <a:font script="Mymr" typeface="Myanmar Text"/>
+        <a:font script="Nkoo" typeface="Ebrima"/>
+        <a:font script="Olck" typeface="Nirmala UI"/>
+        <a:font script="Osma" typeface="Ebrima"/>
+        <a:font script="Phag" typeface="Phagspa"/>
+        <a:font script="Syrn" typeface="Estrangelo Edessa"/>
+        <a:font script="Syrj" typeface="Estrangelo Edessa"/>
+        <a:font script="Syre" typeface="Estrangelo Edessa"/>
+        <a:font script="Sora" typeface="Nirmala UI"/>
+        <a:font script="Tale" typeface="Microsoft Tai Le"/>
+        <a:font script="Talu" typeface="Microsoft New Tai Lue"/>
+        <a:font script="Tfng" typeface="Ebrima"/>
+      </a:majorFont>
+      <a:minorFont>
+        <a:latin typeface="Aptos" panose="02110004020202020204"/>
+        <a:ea typeface=""/>
+        <a:cs typeface=""/>
+        <a:font script="Jpan" typeface="游ゴシック"/>
+        <a:font script="Hang" typeface="맑은 고딕"/>
+        <a:font script="Hans" typeface="等线"/>
+        <a:font script="Hant" typeface="新細明體"/>
+        <a:font script="Arab" typeface="Arial"/>
+        <a:font script="Hebr" typeface="Arial"/>
+        <a:font script="Thai" typeface="Cordia New"/>
+        <a:font script="Ethi" typeface="Nyala"/>
+        <a:font script="Beng" typeface="Vrinda"/>
+        <a:font script="Gujr" typeface="Shruti"/>
+        <a:font script="Khmr" typeface="DaunPenh"/>
+        <a:font script="Knda" typeface="Tunga"/>
+        <a:font script="Guru" typeface="Raavi"/>
+        <a:font script="Cans" typeface="Euphemia"/>
+        <a:font script="Cher" typeface="Plantagenet Cherokee"/>
+        <a:font script="Yiii" typeface="Microsoft Yi Baiti"/>
+        <a:font script="Tibt" typeface="Microsoft Himalaya"/>
+        <a:font script="Thaa" typeface="MV Boli"/>
+        <a:font script="Deva" typeface="Mangal"/>
+        <a:font script="Telu" typeface="Gautami"/>
+        <a:font script="Taml" typeface="Latha"/>
+        <a:font script="Syrc" typeface="Estrangelo Edessa"/>
+        <a:font script="Orya" typeface="Kalinga"/>
+        <a:font script="Mlym" typeface="Kartika"/>
+        <a:font script="Laoo" typeface="DokChampa"/>
+        <a:font script="Sinh" typeface="Iskoola Pota"/>
+        <a:font script="Mong" typeface="Mongolian Baiti"/>
+        <a:font script="Viet" typeface="Arial"/>
+        <a:font script="Uigh" typeface="Microsoft Uighur"/>
+        <a:font script="Geor" typeface="Sylfaen"/>
+        <a:font script="Armn" typeface="Arial"/>
+        <a:font script="Bugi" typeface="Leelawadee UI"/>
+        <a:font script="Bopo" typeface="Microsoft JhengHei"/>
+        <a:font script="Java" typeface="Javanese Text"/>
+        <a:font script="Lisu" typeface="Segoe UI"/>
+        <a:font script="Mymr" typeface="Myanmar Text"/>
+        <a:font script="Nkoo" typeface="Ebrima"/>
+        <a:font script="Olck" typeface="Nirmala UI"/>
+        <a:font script="Osma" typeface="Ebrima"/>
+        <a:font script="Phag" typeface="Phagspa"/>
+        <a:font script="Syrn" typeface="Estrangelo Edessa"/>
+        <a:font script="Syrj" typeface="Estrangelo Edessa"/>
+        <a:font script="Syre" typeface="Estrangelo Edessa"/>
+        <a:font script="Sora" typeface="Nirmala UI"/>
+        <a:font script="Tale" typeface="Microsoft Tai Le"/>
+        <a:font script="Talu" typeface="Microsoft New Tai Lue"/>
+        <a:font script="Tfng" typeface="Ebrima"/>
+      </a:minorFont>
+    </a:fontScheme>
+    <a:fmtScheme name="Office">
+      <a:fillStyleLst>
+        <a:solidFill>
+          <a:schemeClr val="phClr"/>
+        </a:solidFill>
+        <a:gradFill rotWithShape="1">
+          <a:gsLst>
+            <a:gs pos="0">
+              <a:schemeClr val="phClr">
+                <a:lumMod val="110000"/>
+                <a:satMod val="105000"/>
+                <a:tint val="67000"/>
+              </a:schemeClr>
+            </a:gs>
+            <a:gs pos="50000">
+              <a:schemeClr val="phClr">
+                <a:lumMod val="105000"/>
+                <a:satMod val="103000"/>
+                <a:tint val="73000"/>
+              </a:schemeClr>
+            </a:gs>
+            <a:gs pos="100000">
+              <a:schemeClr val="phClr">
+                <a:lumMod val="105000"/>
+                <a:satMod val="109000"/>
+                <a:tint val="81000"/>
+              </a:schemeClr>
+            </a:gs>
+          </a:gsLst>
+          <a:lin ang="5400000" scaled="0"/>
+        </a:gradFill>
+        <a:gradFill rotWithShape="1">
+          <a:gsLst>
+            <a:gs pos="0">
+              <a:schemeClr val="phClr">
+                <a:satMod val="103000"/>
+                <a:lumMod val="102000"/>
+                <a:tint val="94000"/>
+              </a:schemeClr>
+            </a:gs>
+            <a:gs pos="50000">
+              <a:schemeClr val="phClr">
+                <a:satMod val="110000"/>
+                <a:lumMod val="100000"/>
+                <a:shade val="100000"/>
+              </a:schemeClr>
+            </a:gs>
+            <a:gs pos="100000">
+              <a:schemeClr val="phClr">
+                <a:lumMod val="99000"/>
+                <a:satMod val="120000"/>
+                <a:shade val="78000"/>
+              </a:schemeClr>
+            </a:gs>
+          </a:gsLst>
+          <a:lin ang="5400000" scaled="0"/>
+        </a:gradFill>
+      </a:fillStyleLst>
+      <a:lnStyleLst>
+        <a:ln w="12700" cap="flat" cmpd="sng" algn="ctr">
+          <a:solidFill>
+            <a:schemeClr val="phClr"/>
+          </a:solidFill>
+          <a:prstDash val="solid"/>
+          <a:miter lim="800000"/>
+        </a:ln>
+        <a:ln w="19050" cap="flat" cmpd="sng" algn="ctr">
+          <a:solidFill>
+            <a:schemeClr val="phClr"/>
+          </a:solidFill>
+          <a:prstDash val="solid"/>
+          <a:miter lim="800000"/>
+        </a:ln>
+        <a:ln w="25400" cap="flat" cmpd="sng" algn="ctr">
+          <a:solidFill>
+            <a:schemeClr val="phClr"/>
+          </a:solidFill>
+          <a:prstDash val="solid"/>
+          <a:miter lim="800000"/>
+        </a:ln>
+      </a:lnStyleLst>
+      <a:effectStyleLst>
+        <a:effectStyle>
+          <a:effectLst/>
+        </a:effectStyle>
+        <a:effectStyle>
+          <a:effectLst/>
+        </a:effectStyle>
+        <a:effectStyle>
+          <a:effectLst>
+            <a:outerShdw blurRad="57150" dist="19050" dir="5400000" algn="ctr" rotWithShape="0">
+              <a:srgbClr val="000000">
+                <a:alpha val="63000"/>
+              </a:srgbClr>
+            </a:outerShdw>
+          </a:effectLst>
+        </a:effectStyle>
+      </a:effectStyleLst>
+      <a:bgFillStyleLst>
+        <a:solidFill>
+          <a:schemeClr val="phClr"/>
+        </a:solidFill>
+        <a:solidFill>
+          <a:schemeClr val="phClr">
+            <a:tint val="95000"/>
+            <a:satMod val="170000"/>
+          </a:schemeClr>
+        </a:solidFill>
+        <a:gradFill rotWithShape="1">
+          <a:gsLst>
+            <a:gs pos="0">
+              <a:schemeClr val="phClr">
+                <a:tint val="93000"/>
+                <a:satMod val="150000"/>
+                <a:shade val="98000"/>
+                <a:lumMod val="102000"/>
+              </a:schemeClr>
+            </a:gs>
+            <a:gs pos="50000">
+              <a:schemeClr val="phClr">
+                <a:tint val="98000"/>
+                <a:satMod val="130000"/>
+                <a:shade val="90000"/>
+                <a:lumMod val="103000"/>
+              </a:schemeClr>
+            </a:gs>
+            <a:gs pos="100000">
+              <a:schemeClr val="phClr">
+                <a:shade val="63000"/>
+                <a:satMod val="120000"/>
+              </a:schemeClr>
+            </a:gs>
+          </a:gsLst>
+          <a:lin ang="5400000" scaled="0"/>
+        </a:gradFill>
+      </a:bgFillStyleLst>
+    </a:fmtScheme>
+  </a:themeElements>
+  <a:objectDefaults>
+    <a:lnDef>
+      <a:spPr/>
+      <a:bodyPr/>
+      <a:lstStyle/>
+      <a:style>
+        <a:lnRef idx="2">
+          <a:schemeClr val="accent1"/>
+        </a:lnRef>
+        <a:fillRef idx="0">
+          <a:schemeClr val="accent1"/>
+        </a:fillRef>
+        <a:effectRef idx="1">
+          <a:schemeClr val="accent1"/>
+        </a:effectRef>
+        <a:fontRef idx="minor">
+          <a:schemeClr val="tx1"/>
+        </a:fontRef>
+      </a:style>
+    </a:lnDef>
+  </a:objectDefaults>
+  <a:extraClrSchemeLst/>
+  <a:extLst>
+    <a:ext uri="{05A4C25C-085E-4340-85A3-A5531E510DB2}">
+      <thm15:themeFamily xmlns:thm15="http://schemas.microsoft.com/office/thememl/2012/main" name="Office Theme" id="{2E142A2C-CD16-42D6-873A-C26D2A0506FA}" vid="{1BDDFF52-6CD6-40A5-AB3C-68EB2F1E4D0A}"/>
+    </a:ext>
+  </a:extLst>
+</a:theme>
 </file>
</xml_diff>

<commit_message>
Update deck with host feedback
Co-authored-by: gorgectf <194297338+gorgectf@users.noreply.github.com>
</commit_message>
<xml_diff>
--- a/public/RenterShield_PitchDeck_Revised.pptx
+++ b/public/RenterShield_PitchDeck_Revised.pptx
@@ -4,9 +4,6 @@
   <p:sldMasterIdLst>
     <p:sldMasterId id="2147483648" r:id="rId1"/>
   </p:sldMasterIdLst>
-  <p:notesMasterIdLst>
-    <p:notesMasterId r:id="rId14"/>
-  </p:notesMasterIdLst>
   <p:sldIdLst>
     <p:sldId id="256" r:id="rId2"/>
     <p:sldId id="257" r:id="rId3"/>
@@ -21,6 +18,9 @@
     <p:sldId id="266" r:id="rId12"/>
     <p:sldId id="267" r:id="rId13"/>
   </p:sldIdLst>
+  <p:notesMasterIdLst>
+    <p:notesMasterId r:id="rId14"/>
+  </p:notesMasterIdLst>
   <p:sldSz cx="12192000" cy="6858000"/>
   <p:notesSz cx="6858000" cy="12192000"/>
   <p:defaultTextStyle>
@@ -115,11 +115,6 @@
       </a:defRPr>
     </a:lvl9pPr>
   </p:defaultTextStyle>
-  <p:extLst>
-    <p:ext uri="{EFAFB233-063F-42B5-8137-9DF3F51BA10A}">
-      <p15:sldGuideLst xmlns:p15="http://schemas.microsoft.com/office/powerpoint/2012/main"/>
-    </p:ext>
-  </p:extLst>
 </p:presentation>
 </file>
 
@@ -145,10 +140,234 @@
           <a:chExt cx="0" cy="0"/>
         </a:xfrm>
       </p:grpSpPr>
+      <p:sp>
+        <p:nvSpPr>
+          <p:cNvPr id="2" name="Header Placeholder 1"/>
+          <p:cNvSpPr>
+            <a:spLocks noGrp="1"/>
+          </p:cNvSpPr>
+          <p:nvPr>
+            <p:ph type="hdr" sz="quarter"/>
+          </p:nvPr>
+        </p:nvSpPr>
+        <p:spPr>
+          <a:xfrm>
+            <a:off x="0" y="0"/>
+            <a:ext cx="2971800" cy="458788"/>
+          </a:xfrm>
+          <a:prstGeom prst="rect">
+            <a:avLst/>
+          </a:prstGeom>
+        </p:spPr>
+        <p:txBody>
+          <a:bodyPr vert="horz" lIns="91440" tIns="45720" rIns="91440" bIns="45720" rtlCol="0"/>
+          <a:lstStyle>
+            <a:lvl1pPr algn="l">
+              <a:defRPr sz="1200"/>
+            </a:lvl1pPr>
+          </a:lstStyle>
+          <a:p>
+            <a:endParaRPr lang="en-US"/>
+          </a:p>
+        </p:txBody>
+      </p:sp>
+      <p:sp>
+        <p:nvSpPr>
+          <p:cNvPr id="3" name="Date Placeholder 2"/>
+          <p:cNvSpPr>
+            <a:spLocks noGrp="1"/>
+          </p:cNvSpPr>
+          <p:nvPr>
+            <p:ph type="dt" idx="1"/>
+          </p:nvPr>
+        </p:nvSpPr>
+        <p:spPr>
+          <a:xfrm>
+            <a:off x="3884613" y="0"/>
+            <a:ext cx="2971800" cy="458788"/>
+          </a:xfrm>
+          <a:prstGeom prst="rect">
+            <a:avLst/>
+          </a:prstGeom>
+        </p:spPr>
+        <p:txBody>
+          <a:bodyPr vert="horz" lIns="91440" tIns="45720" rIns="91440" bIns="45720" rtlCol="0"/>
+          <a:lstStyle>
+            <a:lvl1pPr algn="r">
+              <a:defRPr sz="1200"/>
+            </a:lvl1pPr>
+          </a:lstStyle>
+          <a:p>
+            <a:fld id="{5282F153-3F37-0F45-9E97-73ACFA13230C}" type="datetimeFigureOut">
+              <a:rPr lang="en-US"/>
+              <a:t>7/23/19</a:t>
+            </a:fld>
+            <a:endParaRPr lang="en-US"/>
+          </a:p>
+        </p:txBody>
+      </p:sp>
+      <p:sp>
+        <p:nvSpPr>
+          <p:cNvPr id="4" name="Slide Image Placeholder 3"/>
+          <p:cNvSpPr>
+            <a:spLocks noGrp="1" noRot="1" noChangeAspect="1"/>
+          </p:cNvSpPr>
+          <p:nvPr>
+            <p:ph type="sldImg" idx="2"/>
+          </p:nvPr>
+        </p:nvSpPr>
+        <p:spPr>
+          <a:xfrm>
+            <a:off x="685800" y="1143000"/>
+            <a:ext cx="5486400" cy="3086100"/>
+          </a:xfrm>
+          <a:prstGeom prst="rect">
+            <a:avLst/>
+          </a:prstGeom>
+          <a:noFill/>
+          <a:ln w="12700">
+            <a:solidFill>
+              <a:prstClr val="black"/>
+            </a:solidFill>
+          </a:ln>
+        </p:spPr>
+        <p:txBody>
+          <a:bodyPr vert="horz" lIns="91440" tIns="45720" rIns="91440" bIns="45720" rtlCol="0" anchor="ctr"/>
+          <a:lstStyle/>
+          <a:p>
+            <a:endParaRPr lang="en-US"/>
+          </a:p>
+        </p:txBody>
+      </p:sp>
+      <p:sp>
+        <p:nvSpPr>
+          <p:cNvPr id="5" name="Notes Placeholder 4"/>
+          <p:cNvSpPr>
+            <a:spLocks noGrp="1"/>
+          </p:cNvSpPr>
+          <p:nvPr>
+            <p:ph type="body" sz="quarter" idx="3"/>
+          </p:nvPr>
+        </p:nvSpPr>
+        <p:spPr>
+          <a:xfrm>
+            <a:off x="685800" y="4400550"/>
+            <a:ext cx="5486400" cy="3600450"/>
+          </a:xfrm>
+          <a:prstGeom prst="rect">
+            <a:avLst/>
+          </a:prstGeom>
+        </p:spPr>
+        <p:txBody>
+          <a:bodyPr vert="horz" lIns="91440" tIns="45720" rIns="91440" bIns="45720" rtlCol="0"/>
+          <a:lstStyle/>
+          <a:p>
+            <a:pPr lvl="0"/>
+            <a:r>
+              <a:rPr lang="en-US"/>
+              <a:t>Click to edit Master text styles</a:t>
+            </a:r>
+          </a:p>
+          <a:p>
+            <a:pPr lvl="1"/>
+            <a:r>
+              <a:rPr lang="en-US"/>
+              <a:t>Second level</a:t>
+            </a:r>
+          </a:p>
+          <a:p>
+            <a:pPr lvl="2"/>
+            <a:r>
+              <a:rPr lang="en-US"/>
+              <a:t>Third level</a:t>
+            </a:r>
+          </a:p>
+          <a:p>
+            <a:pPr lvl="3"/>
+            <a:r>
+              <a:rPr lang="en-US"/>
+              <a:t>Fourth level</a:t>
+            </a:r>
+          </a:p>
+          <a:p>
+            <a:pPr lvl="4"/>
+            <a:r>
+              <a:rPr lang="en-US"/>
+              <a:t>Fifth level</a:t>
+            </a:r>
+          </a:p>
+        </p:txBody>
+      </p:sp>
+      <p:sp>
+        <p:nvSpPr>
+          <p:cNvPr id="6" name="Footer Placeholder 5"/>
+          <p:cNvSpPr>
+            <a:spLocks noGrp="1"/>
+          </p:cNvSpPr>
+          <p:nvPr>
+            <p:ph type="ftr" sz="quarter" idx="4"/>
+          </p:nvPr>
+        </p:nvSpPr>
+        <p:spPr>
+          <a:xfrm>
+            <a:off x="0" y="8685213"/>
+            <a:ext cx="2971800" cy="458787"/>
+          </a:xfrm>
+          <a:prstGeom prst="rect">
+            <a:avLst/>
+          </a:prstGeom>
+        </p:spPr>
+        <p:txBody>
+          <a:bodyPr vert="horz" lIns="91440" tIns="45720" rIns="91440" bIns="45720" rtlCol="0" anchor="b"/>
+          <a:lstStyle>
+            <a:lvl1pPr algn="l">
+              <a:defRPr sz="1200"/>
+            </a:lvl1pPr>
+          </a:lstStyle>
+          <a:p>
+            <a:endParaRPr lang="en-US"/>
+          </a:p>
+        </p:txBody>
+      </p:sp>
+      <p:sp>
+        <p:nvSpPr>
+          <p:cNvPr id="7" name="Slide Number Placeholder 6"/>
+          <p:cNvSpPr>
+            <a:spLocks noGrp="1"/>
+          </p:cNvSpPr>
+          <p:nvPr>
+            <p:ph type="sldNum" sz="quarter" idx="5"/>
+          </p:nvPr>
+        </p:nvSpPr>
+        <p:spPr>
+          <a:xfrm>
+            <a:off x="3884613" y="8685213"/>
+            <a:ext cx="2971800" cy="458787"/>
+          </a:xfrm>
+          <a:prstGeom prst="rect">
+            <a:avLst/>
+          </a:prstGeom>
+        </p:spPr>
+        <p:txBody>
+          <a:bodyPr vert="horz" lIns="91440" tIns="45720" rIns="91440" bIns="45720" rtlCol="0" anchor="b"/>
+          <a:lstStyle>
+            <a:lvl1pPr algn="r">
+              <a:defRPr sz="1200"/>
+            </a:lvl1pPr>
+          </a:lstStyle>
+          <a:p>
+            <a:fld id="{CE5E9CC1-C706-0F49-92D6-E571CC5EEA8F}" type="slidenum">
+              <a:rPr lang="en-US"/>
+              <a:t>‹#›</a:t>
+            </a:fld>
+            <a:endParaRPr lang="en-US"/>
+          </a:p>
+        </p:txBody>
+      </p:sp>
     </p:spTree>
     <p:extLst>
       <p:ext uri="{BB962C8B-B14F-4D97-AF65-F5344CB8AC3E}">
-        <p14:creationId xmlns:p14="http://schemas.microsoft.com/office/powerpoint/2010/main" val="1655606727"/>
+        <p14:creationId xmlns:p14="http://schemas.microsoft.com/office/powerpoint/2010/main" val="1024086991"/>
       </p:ext>
     </p:extLst>
   </p:cSld>
@@ -292,6 +511,10 @@
           <a:bodyPr/>
           <a:lstStyle/>
           <a:p>
+            <a:r>
+              <a:rPr lang="en-US" dirty="0"/>
+              <a:t/>
+            </a:r>
             <a:endParaRPr lang="en-US" dirty="0"/>
           </a:p>
         </p:txBody>
@@ -376,6 +599,10 @@
           <a:bodyPr/>
           <a:lstStyle/>
           <a:p>
+            <a:r>
+              <a:rPr lang="en-US" dirty="0"/>
+              <a:t/>
+            </a:r>
             <a:endParaRPr lang="en-US" dirty="0"/>
           </a:p>
         </p:txBody>
@@ -460,6 +687,10 @@
           <a:bodyPr/>
           <a:lstStyle/>
           <a:p>
+            <a:r>
+              <a:rPr lang="en-US" dirty="0"/>
+              <a:t/>
+            </a:r>
             <a:endParaRPr lang="en-US" dirty="0"/>
           </a:p>
         </p:txBody>
@@ -544,6 +775,10 @@
           <a:bodyPr/>
           <a:lstStyle/>
           <a:p>
+            <a:r>
+              <a:rPr lang="en-US" dirty="0"/>
+              <a:t/>
+            </a:r>
             <a:endParaRPr lang="en-US" dirty="0"/>
           </a:p>
         </p:txBody>
@@ -628,6 +863,10 @@
           <a:bodyPr/>
           <a:lstStyle/>
           <a:p>
+            <a:r>
+              <a:rPr lang="en-US" dirty="0"/>
+              <a:t/>
+            </a:r>
             <a:endParaRPr lang="en-US" dirty="0"/>
           </a:p>
         </p:txBody>
@@ -712,6 +951,10 @@
           <a:bodyPr/>
           <a:lstStyle/>
           <a:p>
+            <a:r>
+              <a:rPr lang="en-US" dirty="0"/>
+              <a:t/>
+            </a:r>
             <a:endParaRPr lang="en-US" dirty="0"/>
           </a:p>
         </p:txBody>
@@ -796,6 +1039,10 @@
           <a:bodyPr/>
           <a:lstStyle/>
           <a:p>
+            <a:r>
+              <a:rPr lang="en-US" dirty="0"/>
+              <a:t/>
+            </a:r>
             <a:endParaRPr lang="en-US" dirty="0"/>
           </a:p>
         </p:txBody>
@@ -880,6 +1127,10 @@
           <a:bodyPr/>
           <a:lstStyle/>
           <a:p>
+            <a:r>
+              <a:rPr lang="en-US" dirty="0"/>
+              <a:t/>
+            </a:r>
             <a:endParaRPr lang="en-US" dirty="0"/>
           </a:p>
         </p:txBody>
@@ -964,6 +1215,10 @@
           <a:bodyPr/>
           <a:lstStyle/>
           <a:p>
+            <a:r>
+              <a:rPr lang="en-US" dirty="0"/>
+              <a:t/>
+            </a:r>
             <a:endParaRPr lang="en-US" dirty="0"/>
           </a:p>
         </p:txBody>
@@ -1048,6 +1303,10 @@
           <a:bodyPr/>
           <a:lstStyle/>
           <a:p>
+            <a:r>
+              <a:rPr lang="en-US" dirty="0"/>
+              <a:t/>
+            </a:r>
             <a:endParaRPr lang="en-US" dirty="0"/>
           </a:p>
         </p:txBody>
@@ -1132,6 +1391,10 @@
           <a:bodyPr/>
           <a:lstStyle/>
           <a:p>
+            <a:r>
+              <a:rPr lang="en-US" dirty="0"/>
+              <a:t/>
+            </a:r>
             <a:endParaRPr lang="en-US" dirty="0"/>
           </a:p>
         </p:txBody>
@@ -1216,6 +1479,10 @@
           <a:bodyPr/>
           <a:lstStyle/>
           <a:p>
+            <a:r>
+              <a:rPr lang="en-US" dirty="0"/>
+              <a:t/>
+            </a:r>
             <a:endParaRPr lang="en-US" dirty="0"/>
           </a:p>
         </p:txBody>
@@ -1289,11 +1556,6 @@
 <file path=ppt/slideMasters/slideMaster1.xml><?xml version="1.0" encoding="utf-8"?>
 <p:sldMaster xmlns:a="http://schemas.openxmlformats.org/drawingml/2006/main" xmlns:r="http://schemas.openxmlformats.org/officeDocument/2006/relationships" xmlns:p="http://schemas.openxmlformats.org/presentationml/2006/main">
   <p:cSld>
-    <p:bg>
-      <p:bgRef idx="1001">
-        <a:schemeClr val="bg1"/>
-      </p:bgRef>
-    </p:bg>
     <p:spTree>
       <p:nvGrpSpPr>
         <p:cNvPr id="1" name=""/>
@@ -1576,7 +1838,6 @@
         <a:solidFill>
           <a:srgbClr val="0B132B"/>
         </a:solidFill>
-        <a:effectLst/>
       </p:bgPr>
     </p:bg>
     <p:spTree>
@@ -1620,7 +1881,7 @@
           <a:bodyPr wrap="square" rtlCol="0" anchor="ctr"/>
           <a:lstStyle/>
           <a:p>
-            <a:pPr marL="0" indent="0">
+            <a:pPr indent="0" marL="0">
               <a:buNone/>
             </a:pPr>
             <a:endParaRPr lang="en-US" dirty="0"/>
@@ -1648,7 +1909,7 @@
           <a:bodyPr wrap="square" rtlCol="0" anchor="ctr"/>
           <a:lstStyle/>
           <a:p>
-            <a:pPr marL="0" indent="0" algn="r">
+            <a:pPr algn="r" indent="0" marL="0">
               <a:buNone/>
             </a:pPr>
             <a:r>
@@ -1687,7 +1948,7 @@
           <a:bodyPr wrap="square" lIns="0" tIns="0" rIns="0" bIns="0" rtlCol="0" anchor="ctr"/>
           <a:lstStyle/>
           <a:p>
-            <a:pPr marL="0" indent="0">
+            <a:pPr indent="0" marL="0">
               <a:buNone/>
             </a:pPr>
             <a:r>
@@ -1726,7 +1987,7 @@
           <a:bodyPr wrap="square" lIns="0" tIns="0" rIns="0" bIns="0" rtlCol="0" anchor="ctr"/>
           <a:lstStyle/>
           <a:p>
-            <a:pPr marL="0" indent="0">
+            <a:pPr indent="0" marL="0">
               <a:buNone/>
             </a:pPr>
             <a:r>
@@ -1771,7 +2032,7 @@
           <a:bodyPr wrap="square" rtlCol="0" anchor="ctr"/>
           <a:lstStyle/>
           <a:p>
-            <a:pPr marL="0" indent="0">
+            <a:pPr indent="0" marL="0">
               <a:buNone/>
             </a:pPr>
             <a:endParaRPr lang="en-US" dirty="0"/>
@@ -1801,7 +2062,7 @@
           </a:bodyPr>
           <a:lstStyle/>
           <a:p>
-            <a:pPr marL="0" indent="0">
+            <a:pPr indent="0" marL="0">
               <a:buNone/>
             </a:pPr>
             <a:r>
@@ -1842,7 +2103,7 @@
           </a:bodyPr>
           <a:lstStyle/>
           <a:p>
-            <a:pPr marL="0" indent="0">
+            <a:pPr indent="0" marL="0">
               <a:buNone/>
             </a:pPr>
             <a:r>
@@ -1887,7 +2148,7 @@
           <a:bodyPr wrap="square" rtlCol="0" anchor="ctr"/>
           <a:lstStyle/>
           <a:p>
-            <a:pPr marL="0" indent="0">
+            <a:pPr indent="0" marL="0">
               <a:buNone/>
             </a:pPr>
             <a:endParaRPr lang="en-US" dirty="0"/>
@@ -1917,7 +2178,7 @@
           </a:bodyPr>
           <a:lstStyle/>
           <a:p>
-            <a:pPr marL="0" indent="0">
+            <a:pPr indent="0" marL="0">
               <a:buNone/>
             </a:pPr>
             <a:r>
@@ -1958,7 +2219,7 @@
           </a:bodyPr>
           <a:lstStyle/>
           <a:p>
-            <a:pPr marL="0" indent="0">
+            <a:pPr indent="0" marL="0">
               <a:buNone/>
             </a:pPr>
             <a:r>
@@ -1975,13 +2236,13 @@
             <a:endParaRPr lang="en-US" sz="1100" dirty="0"/>
           </a:p>
           <a:p>
-            <a:pPr marL="0" indent="0">
+            <a:pPr indent="0" marL="0">
               <a:buNone/>
             </a:pPr>
             <a:endParaRPr lang="en-US" sz="1100" dirty="0"/>
           </a:p>
           <a:p>
-            <a:pPr marL="0" indent="0">
+            <a:pPr indent="0" marL="0">
               <a:buNone/>
             </a:pPr>
             <a:r>
@@ -1998,7 +2259,7 @@
             <a:endParaRPr lang="en-US" sz="1100" dirty="0"/>
           </a:p>
           <a:p>
-            <a:pPr marL="0" indent="0">
+            <a:pPr indent="0" marL="0">
               <a:buNone/>
             </a:pPr>
             <a:r>
@@ -2015,7 +2276,7 @@
             <a:endParaRPr lang="en-US" sz="1100" dirty="0"/>
           </a:p>
           <a:p>
-            <a:pPr marL="0" indent="0">
+            <a:pPr indent="0" marL="0">
               <a:buNone/>
             </a:pPr>
             <a:r>
@@ -2032,7 +2293,7 @@
             <a:endParaRPr lang="en-US" sz="1100" dirty="0"/>
           </a:p>
           <a:p>
-            <a:pPr marL="0" indent="0">
+            <a:pPr indent="0" marL="0">
               <a:buNone/>
             </a:pPr>
             <a:r>
@@ -2049,7 +2310,7 @@
             <a:endParaRPr lang="en-US" sz="1100" dirty="0"/>
           </a:p>
           <a:p>
-            <a:pPr marL="0" indent="0">
+            <a:pPr indent="0" marL="0">
               <a:buNone/>
             </a:pPr>
             <a:r>
@@ -2088,7 +2349,7 @@
           <a:bodyPr wrap="square" lIns="0" tIns="0" rIns="0" bIns="0" rtlCol="0" anchor="ctr"/>
           <a:lstStyle/>
           <a:p>
-            <a:pPr marL="0" indent="0">
+            <a:pPr indent="0" marL="0">
               <a:buNone/>
             </a:pPr>
             <a:r>
@@ -2122,7 +2383,6 @@
         <a:solidFill>
           <a:srgbClr val="0B132B"/>
         </a:solidFill>
-        <a:effectLst/>
       </p:bgPr>
     </p:bg>
     <p:spTree>
@@ -2166,7 +2426,7 @@
           <a:bodyPr wrap="square" rtlCol="0" anchor="ctr"/>
           <a:lstStyle/>
           <a:p>
-            <a:pPr marL="0" indent="0">
+            <a:pPr indent="0" marL="0">
               <a:buNone/>
             </a:pPr>
             <a:endParaRPr lang="en-US" dirty="0"/>
@@ -2194,7 +2454,7 @@
           <a:bodyPr wrap="square" rtlCol="0" anchor="ctr"/>
           <a:lstStyle/>
           <a:p>
-            <a:pPr marL="0" indent="0" algn="r">
+            <a:pPr algn="r" indent="0" marL="0">
               <a:buNone/>
             </a:pPr>
             <a:r>
@@ -2233,7 +2493,7 @@
           <a:bodyPr wrap="square" rtlCol="0" anchor="ctr"/>
           <a:lstStyle/>
           <a:p>
-            <a:pPr marL="0" indent="0">
+            <a:pPr indent="0" marL="0">
               <a:buNone/>
             </a:pPr>
             <a:r>
@@ -2274,7 +2534,7 @@
           </a:bodyPr>
           <a:lstStyle/>
           <a:p>
-            <a:pPr marL="0" indent="0">
+            <a:pPr indent="0" marL="0">
               <a:buNone/>
             </a:pPr>
             <a:r>
@@ -2319,7 +2579,7 @@
           <a:bodyPr wrap="square" rtlCol="0" anchor="ctr"/>
           <a:lstStyle/>
           <a:p>
-            <a:pPr marL="0" indent="0">
+            <a:pPr indent="0" marL="0">
               <a:buNone/>
             </a:pPr>
             <a:endParaRPr lang="en-US" dirty="0"/>
@@ -2349,7 +2609,7 @@
           </a:bodyPr>
           <a:lstStyle/>
           <a:p>
-            <a:pPr marL="0" indent="0">
+            <a:pPr indent="0" marL="0">
               <a:buNone/>
             </a:pPr>
             <a:r>
@@ -2390,7 +2650,7 @@
           </a:bodyPr>
           <a:lstStyle/>
           <a:p>
-            <a:pPr marL="0" indent="0">
+            <a:pPr indent="0" marL="0">
               <a:buNone/>
             </a:pPr>
             <a:r>
@@ -2407,7 +2667,7 @@
             <a:endParaRPr lang="en-US" sz="1100" dirty="0"/>
           </a:p>
           <a:p>
-            <a:pPr marL="0" indent="0">
+            <a:pPr indent="0" marL="0">
               <a:buNone/>
             </a:pPr>
             <a:r>
@@ -2452,7 +2712,7 @@
           <a:bodyPr wrap="square" rtlCol="0" anchor="ctr"/>
           <a:lstStyle/>
           <a:p>
-            <a:pPr marL="0" indent="0">
+            <a:pPr indent="0" marL="0">
               <a:buNone/>
             </a:pPr>
             <a:endParaRPr lang="en-US" dirty="0"/>
@@ -2482,7 +2742,7 @@
           </a:bodyPr>
           <a:lstStyle/>
           <a:p>
-            <a:pPr marL="0" indent="0">
+            <a:pPr indent="0" marL="0">
               <a:buNone/>
             </a:pPr>
             <a:r>
@@ -2523,7 +2783,7 @@
           </a:bodyPr>
           <a:lstStyle/>
           <a:p>
-            <a:pPr marL="0" indent="0">
+            <a:pPr indent="0" marL="0">
               <a:buNone/>
             </a:pPr>
             <a:r>
@@ -2540,7 +2800,7 @@
             <a:endParaRPr lang="en-US" sz="1100" dirty="0"/>
           </a:p>
           <a:p>
-            <a:pPr marL="0" indent="0">
+            <a:pPr indent="0" marL="0">
               <a:buNone/>
             </a:pPr>
             <a:r>
@@ -2585,7 +2845,7 @@
           <a:bodyPr wrap="square" rtlCol="0" anchor="ctr"/>
           <a:lstStyle/>
           <a:p>
-            <a:pPr marL="0" indent="0">
+            <a:pPr indent="0" marL="0">
               <a:buNone/>
             </a:pPr>
             <a:endParaRPr lang="en-US" dirty="0"/>
@@ -2615,7 +2875,7 @@
           </a:bodyPr>
           <a:lstStyle/>
           <a:p>
-            <a:pPr marL="0" indent="0">
+            <a:pPr indent="0" marL="0">
               <a:buNone/>
             </a:pPr>
             <a:r>
@@ -2656,7 +2916,7 @@
           </a:bodyPr>
           <a:lstStyle/>
           <a:p>
-            <a:pPr marL="0" indent="0">
+            <a:pPr indent="0" marL="0">
               <a:buNone/>
             </a:pPr>
             <a:r>
@@ -2673,7 +2933,7 @@
             <a:endParaRPr lang="en-US" sz="1100" dirty="0"/>
           </a:p>
           <a:p>
-            <a:pPr marL="0" indent="0">
+            <a:pPr indent="0" marL="0">
               <a:buNone/>
             </a:pPr>
             <a:r>
@@ -2718,7 +2978,7 @@
           <a:bodyPr wrap="square" rtlCol="0" anchor="ctr"/>
           <a:lstStyle/>
           <a:p>
-            <a:pPr marL="0" indent="0">
+            <a:pPr indent="0" marL="0">
               <a:buNone/>
             </a:pPr>
             <a:endParaRPr lang="en-US" dirty="0"/>
@@ -2748,7 +3008,7 @@
           </a:bodyPr>
           <a:lstStyle/>
           <a:p>
-            <a:pPr marL="0" indent="0">
+            <a:pPr indent="0" marL="0">
               <a:buNone/>
             </a:pPr>
             <a:r>
@@ -2789,7 +3049,7 @@
           </a:bodyPr>
           <a:lstStyle/>
           <a:p>
-            <a:pPr marL="0" indent="0">
+            <a:pPr indent="0" marL="0">
               <a:buNone/>
             </a:pPr>
             <a:r>
@@ -2806,7 +3066,7 @@
             <a:endParaRPr lang="en-US" sz="1100" dirty="0"/>
           </a:p>
           <a:p>
-            <a:pPr marL="0" indent="0">
+            <a:pPr indent="0" marL="0">
               <a:buNone/>
             </a:pPr>
             <a:r>
@@ -2851,7 +3111,7 @@
           <a:bodyPr wrap="square" rtlCol="0" anchor="ctr"/>
           <a:lstStyle/>
           <a:p>
-            <a:pPr marL="0" indent="0">
+            <a:pPr indent="0" marL="0">
               <a:buNone/>
             </a:pPr>
             <a:endParaRPr lang="en-US" dirty="0"/>
@@ -2881,7 +3141,7 @@
           </a:bodyPr>
           <a:lstStyle/>
           <a:p>
-            <a:pPr marL="0" indent="0">
+            <a:pPr indent="0" marL="0">
               <a:buNone/>
             </a:pPr>
             <a:r>
@@ -2922,7 +3182,7 @@
           </a:bodyPr>
           <a:lstStyle/>
           <a:p>
-            <a:pPr marL="0" indent="0">
+            <a:pPr indent="0" marL="0">
               <a:buNone/>
             </a:pPr>
             <a:r>
@@ -2956,7 +3216,6 @@
         <a:solidFill>
           <a:srgbClr val="0B132B"/>
         </a:solidFill>
-        <a:effectLst/>
       </p:bgPr>
     </p:bg>
     <p:spTree>
@@ -3000,7 +3259,7 @@
           <a:bodyPr wrap="square" rtlCol="0" anchor="ctr"/>
           <a:lstStyle/>
           <a:p>
-            <a:pPr marL="0" indent="0">
+            <a:pPr indent="0" marL="0">
               <a:buNone/>
             </a:pPr>
             <a:endParaRPr lang="en-US" dirty="0"/>
@@ -3028,7 +3287,7 @@
           <a:bodyPr wrap="square" rtlCol="0" anchor="ctr"/>
           <a:lstStyle/>
           <a:p>
-            <a:pPr marL="0" indent="0" algn="r">
+            <a:pPr algn="r" indent="0" marL="0">
               <a:buNone/>
             </a:pPr>
             <a:r>
@@ -3067,7 +3326,7 @@
           <a:bodyPr wrap="square" rtlCol="0" anchor="ctr"/>
           <a:lstStyle/>
           <a:p>
-            <a:pPr marL="0" indent="0">
+            <a:pPr indent="0" marL="0">
               <a:buNone/>
             </a:pPr>
             <a:r>
@@ -3108,7 +3367,7 @@
           </a:bodyPr>
           <a:lstStyle/>
           <a:p>
-            <a:pPr marL="0" indent="0">
+            <a:pPr indent="0" marL="0">
               <a:buNone/>
             </a:pPr>
             <a:r>
@@ -3153,7 +3412,7 @@
           <a:bodyPr wrap="square" rtlCol="0" anchor="ctr"/>
           <a:lstStyle/>
           <a:p>
-            <a:pPr marL="0" indent="0">
+            <a:pPr indent="0" marL="0">
               <a:buNone/>
             </a:pPr>
             <a:endParaRPr lang="en-US" dirty="0"/>
@@ -3183,7 +3442,7 @@
           </a:bodyPr>
           <a:lstStyle/>
           <a:p>
-            <a:pPr marL="0" indent="0">
+            <a:pPr indent="0" marL="0">
               <a:buNone/>
             </a:pPr>
             <a:r>
@@ -3224,7 +3483,7 @@
           </a:bodyPr>
           <a:lstStyle/>
           <a:p>
-            <a:pPr marL="0" indent="0">
+            <a:pPr indent="0" marL="0">
               <a:buNone/>
             </a:pPr>
             <a:r>
@@ -3269,7 +3528,7 @@
           <a:bodyPr wrap="square" rtlCol="0" anchor="ctr"/>
           <a:lstStyle/>
           <a:p>
-            <a:pPr marL="0" indent="0">
+            <a:pPr indent="0" marL="0">
               <a:buNone/>
             </a:pPr>
             <a:endParaRPr lang="en-US" dirty="0"/>
@@ -3299,7 +3558,7 @@
           </a:bodyPr>
           <a:lstStyle/>
           <a:p>
-            <a:pPr marL="0" indent="0">
+            <a:pPr indent="0" marL="0">
               <a:buNone/>
             </a:pPr>
             <a:r>
@@ -3340,7 +3599,7 @@
           </a:bodyPr>
           <a:lstStyle/>
           <a:p>
-            <a:pPr marL="0" indent="0">
+            <a:pPr indent="0" marL="0">
               <a:buNone/>
             </a:pPr>
             <a:r>
@@ -3385,7 +3644,7 @@
           <a:bodyPr wrap="square" rtlCol="0" anchor="ctr"/>
           <a:lstStyle/>
           <a:p>
-            <a:pPr marL="0" indent="0">
+            <a:pPr indent="0" marL="0">
               <a:buNone/>
             </a:pPr>
             <a:endParaRPr lang="en-US" dirty="0"/>
@@ -3415,7 +3674,7 @@
           </a:bodyPr>
           <a:lstStyle/>
           <a:p>
-            <a:pPr marL="0" indent="0">
+            <a:pPr indent="0" marL="0">
               <a:buNone/>
             </a:pPr>
             <a:r>
@@ -3456,7 +3715,7 @@
           </a:bodyPr>
           <a:lstStyle/>
           <a:p>
-            <a:pPr marL="0" indent="0">
+            <a:pPr indent="0" marL="0">
               <a:buNone/>
             </a:pPr>
             <a:r>
@@ -3501,7 +3760,7 @@
           <a:bodyPr wrap="square" rtlCol="0" anchor="ctr"/>
           <a:lstStyle/>
           <a:p>
-            <a:pPr marL="0" indent="0">
+            <a:pPr indent="0" marL="0">
               <a:buNone/>
             </a:pPr>
             <a:endParaRPr lang="en-US" dirty="0"/>
@@ -3531,7 +3790,7 @@
           </a:bodyPr>
           <a:lstStyle/>
           <a:p>
-            <a:pPr marL="0" indent="0">
+            <a:pPr indent="0" marL="0">
               <a:buNone/>
             </a:pPr>
             <a:r>
@@ -3568,11 +3827,11 @@
         </p:spPr>
         <p:txBody>
           <a:bodyPr wrap="square" lIns="0" tIns="0" rIns="0" bIns="0" rtlCol="0" anchor="t">
-            <a:normAutofit fontScale="92500"/>
+            <a:normAutofit/>
           </a:bodyPr>
           <a:lstStyle/>
           <a:p>
-            <a:pPr marL="0" indent="0">
+            <a:pPr indent="0" marL="0">
               <a:buNone/>
             </a:pPr>
             <a:r>
@@ -3606,7 +3865,6 @@
         <a:solidFill>
           <a:srgbClr val="0B132B"/>
         </a:solidFill>
-        <a:effectLst/>
       </p:bgPr>
     </p:bg>
     <p:spTree>
@@ -3650,7 +3908,7 @@
           <a:bodyPr wrap="square" rtlCol="0" anchor="ctr"/>
           <a:lstStyle/>
           <a:p>
-            <a:pPr marL="0" indent="0">
+            <a:pPr indent="0" marL="0">
               <a:buNone/>
             </a:pPr>
             <a:endParaRPr lang="en-US" dirty="0"/>
@@ -3678,7 +3936,7 @@
           <a:bodyPr wrap="square" rtlCol="0" anchor="ctr"/>
           <a:lstStyle/>
           <a:p>
-            <a:pPr marL="0" indent="0" algn="r">
+            <a:pPr algn="r" indent="0" marL="0">
               <a:buNone/>
             </a:pPr>
             <a:r>
@@ -3717,7 +3975,7 @@
           <a:bodyPr wrap="square" rtlCol="0" anchor="ctr"/>
           <a:lstStyle/>
           <a:p>
-            <a:pPr marL="0" indent="0">
+            <a:pPr indent="0" marL="0">
               <a:buNone/>
             </a:pPr>
             <a:r>
@@ -3758,7 +4016,7 @@
           </a:bodyPr>
           <a:lstStyle/>
           <a:p>
-            <a:pPr marL="0" indent="0">
+            <a:pPr indent="0" marL="0">
               <a:buNone/>
             </a:pPr>
             <a:r>
@@ -3803,7 +4061,7 @@
           <a:bodyPr wrap="square" rtlCol="0" anchor="ctr"/>
           <a:lstStyle/>
           <a:p>
-            <a:pPr marL="0" indent="0">
+            <a:pPr indent="0" marL="0">
               <a:buNone/>
             </a:pPr>
             <a:endParaRPr lang="en-US" dirty="0"/>
@@ -3833,7 +4091,7 @@
           </a:bodyPr>
           <a:lstStyle/>
           <a:p>
-            <a:pPr marL="0" indent="0">
+            <a:pPr indent="0" marL="0">
               <a:buNone/>
             </a:pPr>
             <a:r>
@@ -3874,7 +4132,7 @@
           </a:bodyPr>
           <a:lstStyle/>
           <a:p>
-            <a:pPr marL="0" indent="0">
+            <a:pPr indent="0" marL="0">
               <a:buNone/>
             </a:pPr>
             <a:r>
@@ -3919,7 +4177,7 @@
           <a:bodyPr wrap="square" rtlCol="0" anchor="ctr"/>
           <a:lstStyle/>
           <a:p>
-            <a:pPr marL="0" indent="0">
+            <a:pPr indent="0" marL="0">
               <a:buNone/>
             </a:pPr>
             <a:endParaRPr lang="en-US" dirty="0"/>
@@ -3949,7 +4207,7 @@
           </a:bodyPr>
           <a:lstStyle/>
           <a:p>
-            <a:pPr marL="0" indent="0">
+            <a:pPr indent="0" marL="0">
               <a:buNone/>
             </a:pPr>
             <a:r>
@@ -3990,7 +4248,7 @@
           </a:bodyPr>
           <a:lstStyle/>
           <a:p>
-            <a:pPr marL="0" indent="0">
+            <a:pPr indent="0" marL="0">
               <a:buNone/>
             </a:pPr>
             <a:r>
@@ -4035,7 +4293,7 @@
           <a:bodyPr wrap="square" rtlCol="0" anchor="ctr"/>
           <a:lstStyle/>
           <a:p>
-            <a:pPr marL="0" indent="0">
+            <a:pPr indent="0" marL="0">
               <a:buNone/>
             </a:pPr>
             <a:endParaRPr lang="en-US" dirty="0"/>
@@ -4065,7 +4323,7 @@
           </a:bodyPr>
           <a:lstStyle/>
           <a:p>
-            <a:pPr marL="0" indent="0">
+            <a:pPr indent="0" marL="0">
               <a:buNone/>
             </a:pPr>
             <a:r>
@@ -4106,7 +4364,7 @@
           </a:bodyPr>
           <a:lstStyle/>
           <a:p>
-            <a:pPr marL="0" indent="0">
+            <a:pPr indent="0" marL="0">
               <a:buNone/>
             </a:pPr>
             <a:r>
@@ -4151,7 +4409,7 @@
           <a:bodyPr wrap="square" rtlCol="0" anchor="ctr"/>
           <a:lstStyle/>
           <a:p>
-            <a:pPr marL="0" indent="0">
+            <a:pPr indent="0" marL="0">
               <a:buNone/>
             </a:pPr>
             <a:endParaRPr lang="en-US" dirty="0"/>
@@ -4181,7 +4439,7 @@
           </a:bodyPr>
           <a:lstStyle/>
           <a:p>
-            <a:pPr marL="0" indent="0">
+            <a:pPr indent="0" marL="0">
               <a:buNone/>
             </a:pPr>
             <a:r>
@@ -4222,7 +4480,7 @@
           </a:bodyPr>
           <a:lstStyle/>
           <a:p>
-            <a:pPr marL="0" indent="0">
+            <a:pPr indent="0" marL="0">
               <a:buNone/>
             </a:pPr>
             <a:r>
@@ -4256,7 +4514,6 @@
         <a:solidFill>
           <a:srgbClr val="0B132B"/>
         </a:solidFill>
-        <a:effectLst/>
       </p:bgPr>
     </p:bg>
     <p:spTree>
@@ -4300,7 +4557,7 @@
           <a:bodyPr wrap="square" rtlCol="0" anchor="ctr"/>
           <a:lstStyle/>
           <a:p>
-            <a:pPr marL="0" indent="0">
+            <a:pPr indent="0" marL="0">
               <a:buNone/>
             </a:pPr>
             <a:endParaRPr lang="en-US" dirty="0"/>
@@ -4328,7 +4585,7 @@
           <a:bodyPr wrap="square" rtlCol="0" anchor="ctr"/>
           <a:lstStyle/>
           <a:p>
-            <a:pPr marL="0" indent="0" algn="r">
+            <a:pPr algn="r" indent="0" marL="0">
               <a:buNone/>
             </a:pPr>
             <a:r>
@@ -4367,7 +4624,7 @@
           <a:bodyPr wrap="square" rtlCol="0" anchor="ctr"/>
           <a:lstStyle/>
           <a:p>
-            <a:pPr marL="0" indent="0">
+            <a:pPr indent="0" marL="0">
               <a:buNone/>
             </a:pPr>
             <a:r>
@@ -4408,7 +4665,7 @@
           </a:bodyPr>
           <a:lstStyle/>
           <a:p>
-            <a:pPr marL="0" indent="0">
+            <a:pPr indent="0" marL="0">
               <a:buNone/>
             </a:pPr>
             <a:r>
@@ -4453,7 +4710,7 @@
           <a:bodyPr wrap="square" rtlCol="0" anchor="ctr"/>
           <a:lstStyle/>
           <a:p>
-            <a:pPr marL="0" indent="0">
+            <a:pPr indent="0" marL="0">
               <a:buNone/>
             </a:pPr>
             <a:endParaRPr lang="en-US" dirty="0"/>
@@ -4481,7 +4738,7 @@
           <a:bodyPr wrap="square" lIns="0" tIns="0" rIns="0" bIns="0" rtlCol="0" anchor="ctr"/>
           <a:lstStyle/>
           <a:p>
-            <a:pPr marL="0" indent="0">
+            <a:pPr indent="0" marL="0">
               <a:buNone/>
             </a:pPr>
             <a:r>
@@ -4522,7 +4779,7 @@
           </a:bodyPr>
           <a:lstStyle/>
           <a:p>
-            <a:pPr marL="0" indent="0">
+            <a:pPr indent="0" marL="0">
               <a:buNone/>
             </a:pPr>
             <a:r>
@@ -4567,7 +4824,7 @@
           <a:bodyPr wrap="square" rtlCol="0" anchor="ctr"/>
           <a:lstStyle/>
           <a:p>
-            <a:pPr marL="0" indent="0">
+            <a:pPr indent="0" marL="0">
               <a:buNone/>
             </a:pPr>
             <a:endParaRPr lang="en-US" dirty="0"/>
@@ -4595,7 +4852,7 @@
           <a:bodyPr wrap="square" lIns="0" tIns="0" rIns="0" bIns="0" rtlCol="0" anchor="ctr"/>
           <a:lstStyle/>
           <a:p>
-            <a:pPr marL="0" indent="0">
+            <a:pPr indent="0" marL="0">
               <a:buNone/>
             </a:pPr>
             <a:r>
@@ -4632,11 +4889,11 @@
         </p:spPr>
         <p:txBody>
           <a:bodyPr wrap="square" lIns="0" tIns="0" rIns="0" bIns="0" rtlCol="0" anchor="ctr">
-            <a:normAutofit fontScale="92500"/>
+            <a:normAutofit/>
           </a:bodyPr>
           <a:lstStyle/>
           <a:p>
-            <a:pPr marL="0" indent="0">
+            <a:pPr indent="0" marL="0">
               <a:buNone/>
             </a:pPr>
             <a:r>
@@ -4681,7 +4938,7 @@
           <a:bodyPr wrap="square" rtlCol="0" anchor="ctr"/>
           <a:lstStyle/>
           <a:p>
-            <a:pPr marL="0" indent="0">
+            <a:pPr indent="0" marL="0">
               <a:buNone/>
             </a:pPr>
             <a:endParaRPr lang="en-US" dirty="0"/>
@@ -4709,7 +4966,7 @@
           <a:bodyPr wrap="square" lIns="0" tIns="0" rIns="0" bIns="0" rtlCol="0" anchor="ctr"/>
           <a:lstStyle/>
           <a:p>
-            <a:pPr marL="0" indent="0">
+            <a:pPr indent="0" marL="0">
               <a:buNone/>
             </a:pPr>
             <a:r>
@@ -4746,11 +5003,11 @@
         </p:spPr>
         <p:txBody>
           <a:bodyPr wrap="square" lIns="0" tIns="0" rIns="0" bIns="0" rtlCol="0" anchor="ctr">
-            <a:normAutofit fontScale="92500" lnSpcReduction="20000"/>
+            <a:normAutofit/>
           </a:bodyPr>
           <a:lstStyle/>
           <a:p>
-            <a:pPr marL="0" indent="0">
+            <a:pPr indent="0" marL="0">
               <a:buNone/>
             </a:pPr>
             <a:r>
@@ -4795,7 +5052,7 @@
           <a:bodyPr wrap="square" rtlCol="0" anchor="ctr"/>
           <a:lstStyle/>
           <a:p>
-            <a:pPr marL="0" indent="0">
+            <a:pPr indent="0" marL="0">
               <a:buNone/>
             </a:pPr>
             <a:endParaRPr lang="en-US" dirty="0"/>
@@ -4825,7 +5082,7 @@
           </a:bodyPr>
           <a:lstStyle/>
           <a:p>
-            <a:pPr marL="0" indent="0">
+            <a:pPr indent="0" marL="0">
               <a:buNone/>
             </a:pPr>
             <a:r>
@@ -4866,7 +5123,7 @@
           </a:bodyPr>
           <a:lstStyle/>
           <a:p>
-            <a:pPr marL="0" indent="0">
+            <a:pPr indent="0" marL="0">
               <a:buNone/>
             </a:pPr>
             <a:r>
@@ -4911,7 +5168,7 @@
           <a:bodyPr wrap="square" rtlCol="0" anchor="ctr"/>
           <a:lstStyle/>
           <a:p>
-            <a:pPr marL="0" indent="0">
+            <a:pPr indent="0" marL="0">
               <a:buNone/>
             </a:pPr>
             <a:endParaRPr lang="en-US" dirty="0"/>
@@ -4941,7 +5198,7 @@
           </a:bodyPr>
           <a:lstStyle/>
           <a:p>
-            <a:pPr marL="0" indent="0">
+            <a:pPr indent="0" marL="0">
               <a:buNone/>
             </a:pPr>
             <a:r>
@@ -4982,7 +5239,7 @@
           </a:bodyPr>
           <a:lstStyle/>
           <a:p>
-            <a:pPr marL="0" indent="0">
+            <a:pPr indent="0" marL="0">
               <a:buNone/>
             </a:pPr>
             <a:r>
@@ -5016,7 +5273,6 @@
         <a:solidFill>
           <a:srgbClr val="0B132B"/>
         </a:solidFill>
-        <a:effectLst/>
       </p:bgPr>
     </p:bg>
     <p:spTree>
@@ -5060,7 +5316,7 @@
           <a:bodyPr wrap="square" rtlCol="0" anchor="ctr"/>
           <a:lstStyle/>
           <a:p>
-            <a:pPr marL="0" indent="0">
+            <a:pPr indent="0" marL="0">
               <a:buNone/>
             </a:pPr>
             <a:endParaRPr lang="en-US" dirty="0"/>
@@ -5088,7 +5344,7 @@
           <a:bodyPr wrap="square" rtlCol="0" anchor="ctr"/>
           <a:lstStyle/>
           <a:p>
-            <a:pPr marL="0" indent="0" algn="r">
+            <a:pPr algn="r" indent="0" marL="0">
               <a:buNone/>
             </a:pPr>
             <a:r>
@@ -5127,7 +5383,7 @@
           <a:bodyPr wrap="square" rtlCol="0" anchor="ctr"/>
           <a:lstStyle/>
           <a:p>
-            <a:pPr marL="0" indent="0">
+            <a:pPr indent="0" marL="0">
               <a:buNone/>
             </a:pPr>
             <a:r>
@@ -5168,7 +5424,7 @@
           </a:bodyPr>
           <a:lstStyle/>
           <a:p>
-            <a:pPr marL="0" indent="0">
+            <a:pPr indent="0" marL="0">
               <a:buNone/>
             </a:pPr>
             <a:r>
@@ -5213,7 +5469,7 @@
           <a:bodyPr wrap="square" rtlCol="0" anchor="ctr"/>
           <a:lstStyle/>
           <a:p>
-            <a:pPr marL="0" indent="0">
+            <a:pPr indent="0" marL="0">
               <a:buNone/>
             </a:pPr>
             <a:endParaRPr lang="en-US" dirty="0"/>
@@ -5243,7 +5499,7 @@
           </a:bodyPr>
           <a:lstStyle/>
           <a:p>
-            <a:pPr marL="0" indent="0">
+            <a:pPr indent="0" marL="0">
               <a:buNone/>
             </a:pPr>
             <a:r>
@@ -5284,7 +5540,7 @@
           </a:bodyPr>
           <a:lstStyle/>
           <a:p>
-            <a:pPr marL="0" indent="0">
+            <a:pPr indent="0" marL="0">
               <a:buNone/>
             </a:pPr>
             <a:r>
@@ -5329,7 +5585,7 @@
           <a:bodyPr wrap="square" rtlCol="0" anchor="ctr"/>
           <a:lstStyle/>
           <a:p>
-            <a:pPr marL="0" indent="0">
+            <a:pPr indent="0" marL="0">
               <a:buNone/>
             </a:pPr>
             <a:endParaRPr lang="en-US" dirty="0"/>
@@ -5359,7 +5615,7 @@
           </a:bodyPr>
           <a:lstStyle/>
           <a:p>
-            <a:pPr marL="0" indent="0">
+            <a:pPr indent="0" marL="0">
               <a:buNone/>
             </a:pPr>
             <a:r>
@@ -5400,7 +5656,7 @@
           </a:bodyPr>
           <a:lstStyle/>
           <a:p>
-            <a:pPr marL="0" indent="0">
+            <a:pPr indent="0" marL="0">
               <a:buNone/>
             </a:pPr>
             <a:r>
@@ -5445,7 +5701,7 @@
           <a:bodyPr wrap="square" rtlCol="0" anchor="ctr"/>
           <a:lstStyle/>
           <a:p>
-            <a:pPr marL="0" indent="0">
+            <a:pPr indent="0" marL="0">
               <a:buNone/>
             </a:pPr>
             <a:endParaRPr lang="en-US" dirty="0"/>
@@ -5475,7 +5731,7 @@
           </a:bodyPr>
           <a:lstStyle/>
           <a:p>
-            <a:pPr marL="0" indent="0">
+            <a:pPr indent="0" marL="0">
               <a:buNone/>
             </a:pPr>
             <a:r>
@@ -5516,7 +5772,7 @@
           </a:bodyPr>
           <a:lstStyle/>
           <a:p>
-            <a:pPr marL="0" indent="0">
+            <a:pPr indent="0" marL="0">
               <a:buNone/>
             </a:pPr>
             <a:r>
@@ -5557,7 +5813,7 @@
           </a:bodyPr>
           <a:lstStyle/>
           <a:p>
-            <a:pPr marL="0" indent="0">
+            <a:pPr indent="0" marL="0">
               <a:buNone/>
             </a:pPr>
             <a:r>
@@ -5574,7 +5830,7 @@
             <a:endParaRPr lang="en-US" sz="1200" dirty="0"/>
           </a:p>
           <a:p>
-            <a:pPr marL="0" indent="0">
+            <a:pPr indent="0" marL="0">
               <a:buNone/>
             </a:pPr>
             <a:r>
@@ -5591,7 +5847,7 @@
             <a:endParaRPr lang="en-US" sz="1200" dirty="0"/>
           </a:p>
           <a:p>
-            <a:pPr marL="0" indent="0">
+            <a:pPr indent="0" marL="0">
               <a:buNone/>
             </a:pPr>
             <a:r>
@@ -5636,7 +5892,7 @@
           <a:bodyPr wrap="square" rtlCol="0" anchor="ctr"/>
           <a:lstStyle/>
           <a:p>
-            <a:pPr marL="0" indent="0">
+            <a:pPr indent="0" marL="0">
               <a:buNone/>
             </a:pPr>
             <a:endParaRPr lang="en-US" dirty="0"/>
@@ -5666,7 +5922,7 @@
           </a:bodyPr>
           <a:lstStyle/>
           <a:p>
-            <a:pPr marL="0" indent="0">
+            <a:pPr indent="0" marL="0">
               <a:buNone/>
             </a:pPr>
             <a:r>
@@ -5707,7 +5963,7 @@
           </a:bodyPr>
           <a:lstStyle/>
           <a:p>
-            <a:pPr marL="0" indent="0">
+            <a:pPr indent="0" marL="0">
               <a:buNone/>
             </a:pPr>
             <a:r>
@@ -5741,7 +5997,6 @@
         <a:solidFill>
           <a:srgbClr val="0B132B"/>
         </a:solidFill>
-        <a:effectLst/>
       </p:bgPr>
     </p:bg>
     <p:spTree>
@@ -5785,7 +6040,7 @@
           <a:bodyPr wrap="square" rtlCol="0" anchor="ctr"/>
           <a:lstStyle/>
           <a:p>
-            <a:pPr marL="0" indent="0">
+            <a:pPr indent="0" marL="0">
               <a:buNone/>
             </a:pPr>
             <a:endParaRPr lang="en-US" dirty="0"/>
@@ -5813,7 +6068,7 @@
           <a:bodyPr wrap="square" rtlCol="0" anchor="ctr"/>
           <a:lstStyle/>
           <a:p>
-            <a:pPr marL="0" indent="0" algn="r">
+            <a:pPr algn="r" indent="0" marL="0">
               <a:buNone/>
             </a:pPr>
             <a:r>
@@ -5852,7 +6107,7 @@
           <a:bodyPr wrap="square" rtlCol="0" anchor="ctr"/>
           <a:lstStyle/>
           <a:p>
-            <a:pPr marL="0" indent="0">
+            <a:pPr indent="0" marL="0">
               <a:buNone/>
             </a:pPr>
             <a:r>
@@ -5864,7 +6119,7 @@
                 <a:ea typeface="Aptos" pitchFamily="34" charset="-122"/>
                 <a:cs typeface="Aptos" pitchFamily="34" charset="-120"/>
               </a:rPr>
-              <a:t>MARKET POTENTIAL</a:t>
+              <a:t>MARKET OPPORTUNITY</a:t>
             </a:r>
             <a:endParaRPr lang="en-US" sz="1200" dirty="0"/>
           </a:p>
@@ -5893,7 +6148,7 @@
           </a:bodyPr>
           <a:lstStyle/>
           <a:p>
-            <a:pPr marL="0" indent="0">
+            <a:pPr indent="0" marL="0">
               <a:buNone/>
             </a:pPr>
             <a:r>
@@ -5905,7 +6160,7 @@
                 <a:ea typeface="Aptos Display" pitchFamily="34" charset="-122"/>
                 <a:cs typeface="Aptos Display" pitchFamily="34" charset="-120"/>
               </a:rPr>
-              <a:t>Large market, but the near-term opportunity is a focused self-serve wedge.</a:t>
+              <a:t>Big category, but the first wedge is a specific renter segment with a clearer path to revenue.</a:t>
             </a:r>
             <a:endParaRPr lang="en-US" sz="2400" dirty="0"/>
           </a:p>
@@ -5938,7 +6193,7 @@
           <a:bodyPr wrap="square" rtlCol="0" anchor="ctr"/>
           <a:lstStyle/>
           <a:p>
-            <a:pPr marL="0" indent="0">
+            <a:pPr indent="0" marL="0">
               <a:buNone/>
             </a:pPr>
             <a:endParaRPr lang="en-US" dirty="0"/>
@@ -5968,7 +6223,7 @@
           </a:bodyPr>
           <a:lstStyle/>
           <a:p>
-            <a:pPr marL="0" indent="0">
+            <a:pPr indent="0" marL="0">
               <a:buNone/>
             </a:pPr>
             <a:r>
@@ -6009,7 +6264,7 @@
           </a:bodyPr>
           <a:lstStyle/>
           <a:p>
-            <a:pPr marL="0" indent="0">
+            <a:pPr indent="0" marL="0">
               <a:buNone/>
             </a:pPr>
             <a:r>
@@ -6026,7 +6281,7 @@
             <a:endParaRPr lang="en-US" sz="1100" dirty="0"/>
           </a:p>
           <a:p>
-            <a:pPr marL="0" indent="0">
+            <a:pPr indent="0" marL="0">
               <a:buNone/>
             </a:pPr>
             <a:r>
@@ -6071,7 +6326,7 @@
           <a:bodyPr wrap="square" rtlCol="0" anchor="ctr"/>
           <a:lstStyle/>
           <a:p>
-            <a:pPr marL="0" indent="0">
+            <a:pPr indent="0" marL="0">
               <a:buNone/>
             </a:pPr>
             <a:endParaRPr lang="en-US" dirty="0"/>
@@ -6101,7 +6356,7 @@
           </a:bodyPr>
           <a:lstStyle/>
           <a:p>
-            <a:pPr marL="0" indent="0">
+            <a:pPr indent="0" marL="0">
               <a:buNone/>
             </a:pPr>
             <a:r>
@@ -6142,7 +6397,7 @@
           </a:bodyPr>
           <a:lstStyle/>
           <a:p>
-            <a:pPr marL="0" indent="0">
+            <a:pPr indent="0" marL="0">
               <a:buNone/>
             </a:pPr>
             <a:r>
@@ -6159,7 +6414,7 @@
             <a:endParaRPr lang="en-US" sz="1100" dirty="0"/>
           </a:p>
           <a:p>
-            <a:pPr marL="0" indent="0">
+            <a:pPr indent="0" marL="0">
               <a:buNone/>
             </a:pPr>
             <a:r>
@@ -6171,7 +6426,7 @@
                 <a:ea typeface="Aptos" pitchFamily="34" charset="-122"/>
                 <a:cs typeface="Aptos" pitchFamily="34" charset="-120"/>
               </a:rPr>
-              <a:t>Self-serve tools and digital guidance for private renters with legal or tenancy problems.</a:t>
+              <a:t>Digitally delivered guidance and workflow support for private renters facing deposit, repairs, eviction, or rent disputes.</a:t>
             </a:r>
             <a:endParaRPr lang="en-US" sz="1100" dirty="0"/>
           </a:p>
@@ -6204,7 +6459,7 @@
           <a:bodyPr wrap="square" rtlCol="0" anchor="ctr"/>
           <a:lstStyle/>
           <a:p>
-            <a:pPr marL="0" indent="0">
+            <a:pPr indent="0" marL="0">
               <a:buNone/>
             </a:pPr>
             <a:endParaRPr lang="en-US" dirty="0"/>
@@ -6234,7 +6489,7 @@
           </a:bodyPr>
           <a:lstStyle/>
           <a:p>
-            <a:pPr marL="0" indent="0">
+            <a:pPr indent="0" marL="0">
               <a:buNone/>
             </a:pPr>
             <a:r>
@@ -6275,7 +6530,7 @@
           </a:bodyPr>
           <a:lstStyle/>
           <a:p>
-            <a:pPr marL="0" indent="0">
+            <a:pPr indent="0" marL="0">
               <a:buNone/>
             </a:pPr>
             <a:r>
@@ -6292,7 +6547,7 @@
             <a:endParaRPr lang="en-US" sz="1100" dirty="0"/>
           </a:p>
           <a:p>
-            <a:pPr marL="0" indent="0">
+            <a:pPr indent="0" marL="0">
               <a:buNone/>
             </a:pPr>
             <a:r>
@@ -6304,7 +6559,7 @@
                 <a:ea typeface="Aptos" pitchFamily="34" charset="-122"/>
                 <a:cs typeface="Aptos" pitchFamily="34" charset="-120"/>
               </a:rPr>
-              <a:t>Illustrative first wedge: 5,000 premium users at £14/month after initial traction and iteration.</a:t>
+              <a:t>Illustrative first wedge: 5,000 paying users at £14/month after winning a narrow, high-intent segment.</a:t>
             </a:r>
             <a:endParaRPr lang="en-US" sz="1100" dirty="0"/>
           </a:p>
@@ -6337,7 +6592,7 @@
           <a:bodyPr wrap="square" rtlCol="0" anchor="ctr"/>
           <a:lstStyle/>
           <a:p>
-            <a:pPr marL="0" indent="0">
+            <a:pPr indent="0" marL="0">
               <a:buNone/>
             </a:pPr>
             <a:endParaRPr lang="en-US" dirty="0"/>
@@ -6367,7 +6622,7 @@
           </a:bodyPr>
           <a:lstStyle/>
           <a:p>
-            <a:pPr marL="0" indent="0">
+            <a:pPr indent="0" marL="0">
               <a:buNone/>
             </a:pPr>
             <a:r>
@@ -6379,7 +6634,7 @@
                 <a:ea typeface="Aptos" pitchFamily="34" charset="-122"/>
                 <a:cs typeface="Aptos" pitchFamily="34" charset="-120"/>
               </a:rPr>
-              <a:t>Why this version is more credible</a:t>
+              <a:t>Initial wedge to win first</a:t>
             </a:r>
             <a:endParaRPr lang="en-US" sz="1300" dirty="0"/>
           </a:p>
@@ -6408,7 +6663,7 @@
           </a:bodyPr>
           <a:lstStyle/>
           <a:p>
-            <a:pPr marL="0" indent="0">
+            <a:pPr indent="0" marL="0">
               <a:buNone/>
             </a:pPr>
             <a:r>
@@ -6420,7 +6675,7 @@
                 <a:ea typeface="Aptos" pitchFamily="34" charset="-122"/>
                 <a:cs typeface="Aptos" pitchFamily="34" charset="-120"/>
               </a:rPr>
-              <a:t>The original deck’s first-year SOM was ambitious. This revised framing keeps the same market logic but uses a smaller, more believable obtainable target that is easier to defend in front of judges.</a:t>
+              <a:t>Start with students and young professionals in private rentals: digitally native renters, high search intent, limited legal confidence, and strong need for fast self-serve support.</a:t>
             </a:r>
             <a:endParaRPr lang="en-US" sz="1100" dirty="0"/>
           </a:p>
@@ -6453,7 +6708,7 @@
           <a:bodyPr wrap="square" rtlCol="0" anchor="ctr"/>
           <a:lstStyle/>
           <a:p>
-            <a:pPr marL="0" indent="0">
+            <a:pPr indent="0" marL="0">
               <a:buNone/>
             </a:pPr>
             <a:endParaRPr lang="en-US" dirty="0"/>
@@ -6483,7 +6738,7 @@
           </a:bodyPr>
           <a:lstStyle/>
           <a:p>
-            <a:pPr marL="0" indent="0">
+            <a:pPr indent="0" marL="0">
               <a:buNone/>
             </a:pPr>
             <a:r>
@@ -6495,7 +6750,7 @@
                 <a:ea typeface="Aptos" pitchFamily="34" charset="-122"/>
                 <a:cs typeface="Aptos" pitchFamily="34" charset="-120"/>
               </a:rPr>
-              <a:t>Source base</a:t>
+              <a:t>Research to cite</a:t>
             </a:r>
             <a:endParaRPr lang="en-US" sz="1300" dirty="0"/>
           </a:p>
@@ -6524,7 +6779,7 @@
           </a:bodyPr>
           <a:lstStyle/>
           <a:p>
-            <a:pPr marL="0" indent="0">
+            <a:pPr indent="0" marL="0">
               <a:buNone/>
             </a:pPr>
             <a:r>
@@ -6536,7 +6791,7 @@
                 <a:ea typeface="Aptos" pitchFamily="34" charset="-122"/>
                 <a:cs typeface="Aptos" pitchFamily="34" charset="-120"/>
               </a:rPr>
-              <a:t>English Housing Survey, Shelter reporting, and legal services market data can support the top-down story. Keep appendix notes handy for verbal Q&amp;A.</a:t>
+              <a:t>Support the story with English Housing Survey data, tenancy deposit dispute volumes, Shelter reporting, and UK private renter population figures.</a:t>
             </a:r>
             <a:endParaRPr lang="en-US" sz="1100" dirty="0"/>
           </a:p>
@@ -6558,7 +6813,6 @@
         <a:solidFill>
           <a:srgbClr val="0B132B"/>
         </a:solidFill>
-        <a:effectLst/>
       </p:bgPr>
     </p:bg>
     <p:spTree>
@@ -6602,7 +6856,7 @@
           <a:bodyPr wrap="square" rtlCol="0" anchor="ctr"/>
           <a:lstStyle/>
           <a:p>
-            <a:pPr marL="0" indent="0">
+            <a:pPr indent="0" marL="0">
               <a:buNone/>
             </a:pPr>
             <a:endParaRPr lang="en-US" dirty="0"/>
@@ -6630,7 +6884,7 @@
           <a:bodyPr wrap="square" rtlCol="0" anchor="ctr"/>
           <a:lstStyle/>
           <a:p>
-            <a:pPr marL="0" indent="0" algn="r">
+            <a:pPr algn="r" indent="0" marL="0">
               <a:buNone/>
             </a:pPr>
             <a:r>
@@ -6669,7 +6923,7 @@
           <a:bodyPr wrap="square" rtlCol="0" anchor="ctr"/>
           <a:lstStyle/>
           <a:p>
-            <a:pPr marL="0" indent="0">
+            <a:pPr indent="0" marL="0">
               <a:buNone/>
             </a:pPr>
             <a:r>
@@ -6710,7 +6964,7 @@
           </a:bodyPr>
           <a:lstStyle/>
           <a:p>
-            <a:pPr marL="0" indent="0">
+            <a:pPr indent="0" marL="0">
               <a:buNone/>
             </a:pPr>
             <a:r>
@@ -6755,7 +7009,7 @@
           <a:bodyPr wrap="square" rtlCol="0" anchor="ctr"/>
           <a:lstStyle/>
           <a:p>
-            <a:pPr marL="0" indent="0">
+            <a:pPr indent="0" marL="0">
               <a:buNone/>
             </a:pPr>
             <a:endParaRPr lang="en-US" dirty="0"/>
@@ -6785,7 +7039,7 @@
           </a:bodyPr>
           <a:lstStyle/>
           <a:p>
-            <a:pPr marL="0" indent="0">
+            <a:pPr indent="0" marL="0">
               <a:buNone/>
             </a:pPr>
             <a:r>
@@ -6826,7 +7080,7 @@
           </a:bodyPr>
           <a:lstStyle/>
           <a:p>
-            <a:pPr marL="0" indent="0">
+            <a:pPr indent="0" marL="0">
               <a:buNone/>
             </a:pPr>
             <a:r>
@@ -6871,7 +7125,7 @@
           <a:bodyPr wrap="square" rtlCol="0" anchor="ctr"/>
           <a:lstStyle/>
           <a:p>
-            <a:pPr marL="0" indent="0">
+            <a:pPr indent="0" marL="0">
               <a:buNone/>
             </a:pPr>
             <a:endParaRPr lang="en-US" dirty="0"/>
@@ -6901,7 +7155,7 @@
           </a:bodyPr>
           <a:lstStyle/>
           <a:p>
-            <a:pPr marL="0" indent="0">
+            <a:pPr indent="0" marL="0">
               <a:buNone/>
             </a:pPr>
             <a:r>
@@ -6942,7 +7196,7 @@
           </a:bodyPr>
           <a:lstStyle/>
           <a:p>
-            <a:pPr marL="0" indent="0">
+            <a:pPr indent="0" marL="0">
               <a:buNone/>
             </a:pPr>
             <a:r>
@@ -6987,7 +7241,7 @@
           <a:bodyPr wrap="square" rtlCol="0" anchor="ctr"/>
           <a:lstStyle/>
           <a:p>
-            <a:pPr marL="0" indent="0">
+            <a:pPr indent="0" marL="0">
               <a:buNone/>
             </a:pPr>
             <a:endParaRPr lang="en-US" dirty="0"/>
@@ -7017,7 +7271,7 @@
           </a:bodyPr>
           <a:lstStyle/>
           <a:p>
-            <a:pPr marL="0" indent="0">
+            <a:pPr indent="0" marL="0">
               <a:buNone/>
             </a:pPr>
             <a:r>
@@ -7058,7 +7312,7 @@
           </a:bodyPr>
           <a:lstStyle/>
           <a:p>
-            <a:pPr marL="0" indent="0">
+            <a:pPr indent="0" marL="0">
               <a:buNone/>
             </a:pPr>
             <a:r>
@@ -7103,7 +7357,7 @@
           <a:bodyPr wrap="square" rtlCol="0" anchor="ctr"/>
           <a:lstStyle/>
           <a:p>
-            <a:pPr marL="0" indent="0">
+            <a:pPr indent="0" marL="0">
               <a:buNone/>
             </a:pPr>
             <a:endParaRPr lang="en-US" dirty="0"/>
@@ -7133,7 +7387,7 @@
           </a:bodyPr>
           <a:lstStyle/>
           <a:p>
-            <a:pPr marL="0" indent="0">
+            <a:pPr indent="0" marL="0">
               <a:buNone/>
             </a:pPr>
             <a:r>
@@ -7174,7 +7428,7 @@
           </a:bodyPr>
           <a:lstStyle/>
           <a:p>
-            <a:pPr marL="0" indent="0">
+            <a:pPr indent="0" marL="0">
               <a:buNone/>
             </a:pPr>
             <a:r>
@@ -7208,7 +7462,6 @@
         <a:solidFill>
           <a:srgbClr val="0B132B"/>
         </a:solidFill>
-        <a:effectLst/>
       </p:bgPr>
     </p:bg>
     <p:spTree>
@@ -7252,7 +7505,7 @@
           <a:bodyPr wrap="square" rtlCol="0" anchor="ctr"/>
           <a:lstStyle/>
           <a:p>
-            <a:pPr marL="0" indent="0">
+            <a:pPr indent="0" marL="0">
               <a:buNone/>
             </a:pPr>
             <a:endParaRPr lang="en-US" dirty="0"/>
@@ -7280,7 +7533,7 @@
           <a:bodyPr wrap="square" rtlCol="0" anchor="ctr"/>
           <a:lstStyle/>
           <a:p>
-            <a:pPr marL="0" indent="0" algn="r">
+            <a:pPr algn="r" indent="0" marL="0">
               <a:buNone/>
             </a:pPr>
             <a:r>
@@ -7319,7 +7572,7 @@
           <a:bodyPr wrap="square" rtlCol="0" anchor="ctr"/>
           <a:lstStyle/>
           <a:p>
-            <a:pPr marL="0" indent="0">
+            <a:pPr indent="0" marL="0">
               <a:buNone/>
             </a:pPr>
             <a:r>
@@ -7360,7 +7613,7 @@
           </a:bodyPr>
           <a:lstStyle/>
           <a:p>
-            <a:pPr marL="0" indent="0">
+            <a:pPr indent="0" marL="0">
               <a:buNone/>
             </a:pPr>
             <a:r>
@@ -7372,7 +7625,7 @@
                 <a:ea typeface="Aptos Display" pitchFamily="34" charset="-122"/>
                 <a:cs typeface="Aptos Display" pitchFamily="34" charset="-120"/>
               </a:rPr>
-              <a:t>Free guidance builds trust; paid workflow tools unlock monetisation once urgency and complexity increase.</a:t>
+              <a:t>The end user is broad, but the first paying customers are renters in high-stress disputes and B2B pilot partners.</a:t>
             </a:r>
             <a:endParaRPr lang="en-US" sz="2400" dirty="0"/>
           </a:p>
@@ -7405,7 +7658,7 @@
           <a:bodyPr wrap="square" rtlCol="0" anchor="ctr"/>
           <a:lstStyle/>
           <a:p>
-            <a:pPr marL="0" indent="0">
+            <a:pPr indent="0" marL="0">
               <a:buNone/>
             </a:pPr>
             <a:endParaRPr lang="en-US" dirty="0"/>
@@ -7435,7 +7688,7 @@
           </a:bodyPr>
           <a:lstStyle/>
           <a:p>
-            <a:pPr marL="0" indent="0">
+            <a:pPr indent="0" marL="0">
               <a:buNone/>
             </a:pPr>
             <a:r>
@@ -7476,7 +7729,7 @@
           </a:bodyPr>
           <a:lstStyle/>
           <a:p>
-            <a:pPr marL="0" indent="0">
+            <a:pPr indent="0" marL="0">
               <a:buNone/>
             </a:pPr>
             <a:r>
@@ -7521,7 +7774,7 @@
           <a:bodyPr wrap="square" rtlCol="0" anchor="ctr"/>
           <a:lstStyle/>
           <a:p>
-            <a:pPr marL="0" indent="0">
+            <a:pPr indent="0" marL="0">
               <a:buNone/>
             </a:pPr>
             <a:endParaRPr lang="en-US" dirty="0"/>
@@ -7551,7 +7804,7 @@
           </a:bodyPr>
           <a:lstStyle/>
           <a:p>
-            <a:pPr marL="0" indent="0">
+            <a:pPr indent="0" marL="0">
               <a:buNone/>
             </a:pPr>
             <a:r>
@@ -7563,7 +7816,7 @@
                 <a:ea typeface="Aptos" pitchFamily="34" charset="-122"/>
                 <a:cs typeface="Aptos" pitchFamily="34" charset="-120"/>
               </a:rPr>
-              <a:t>Premium tier (£14/month)</a:t>
+              <a:t>Premium renter plan (£14/month)</a:t>
             </a:r>
             <a:endParaRPr lang="en-US" sz="1300" dirty="0"/>
           </a:p>
@@ -7592,7 +7845,7 @@
           </a:bodyPr>
           <a:lstStyle/>
           <a:p>
-            <a:pPr marL="0" indent="0">
+            <a:pPr indent="0" marL="0">
               <a:buNone/>
             </a:pPr>
             <a:r>
@@ -7604,7 +7857,7 @@
                 <a:ea typeface="Aptos" pitchFamily="34" charset="-122"/>
                 <a:cs typeface="Aptos" pitchFamily="34" charset="-120"/>
               </a:rPr>
-              <a:t>AI-assisted letter drafting, deadline tracking, evidence logging, and a landlord communication timeline for high-stakes or ongoing cases.</a:t>
+              <a:t>AI-assisted letter drafting, deadline tracking, evidence logging, and a landlord communication timeline for urgent or ongoing disputes.</a:t>
             </a:r>
             <a:endParaRPr lang="en-US" sz="1100" dirty="0"/>
           </a:p>
@@ -7637,7 +7890,7 @@
           <a:bodyPr wrap="square" rtlCol="0" anchor="ctr"/>
           <a:lstStyle/>
           <a:p>
-            <a:pPr marL="0" indent="0">
+            <a:pPr indent="0" marL="0">
               <a:buNone/>
             </a:pPr>
             <a:endParaRPr lang="en-US" dirty="0"/>
@@ -7667,7 +7920,7 @@
           </a:bodyPr>
           <a:lstStyle/>
           <a:p>
-            <a:pPr marL="0" indent="0">
+            <a:pPr indent="0" marL="0">
               <a:buNone/>
             </a:pPr>
             <a:r>
@@ -7679,7 +7932,7 @@
                 <a:ea typeface="Aptos" pitchFamily="34" charset="-122"/>
                 <a:cs typeface="Aptos" pitchFamily="34" charset="-120"/>
               </a:rPr>
-              <a:t>B2B / pilot path</a:t>
+              <a:t>Institutional buyer path</a:t>
             </a:r>
             <a:endParaRPr lang="en-US" sz="1300" dirty="0"/>
           </a:p>
@@ -7708,7 +7961,7 @@
           </a:bodyPr>
           <a:lstStyle/>
           <a:p>
-            <a:pPr marL="0" indent="0">
+            <a:pPr indent="0" marL="0">
               <a:buNone/>
             </a:pPr>
             <a:r>
@@ -7720,7 +7973,7 @@
                 <a:ea typeface="Aptos" pitchFamily="34" charset="-122"/>
                 <a:cs typeface="Aptos" pitchFamily="34" charset="-120"/>
               </a:rPr>
-              <a:t>Housing associations, student housing teams, councils, or advice services that want a self-serve triage layer.</a:t>
+              <a:t>University housing teams, student unions, councils, or advice organisations that want a self-serve triage layer before 1:1 support.</a:t>
             </a:r>
             <a:endParaRPr lang="en-US" sz="1100" dirty="0"/>
           </a:p>
@@ -7753,7 +8006,7 @@
           <a:bodyPr wrap="square" rtlCol="0" anchor="ctr"/>
           <a:lstStyle/>
           <a:p>
-            <a:pPr marL="0" indent="0">
+            <a:pPr indent="0" marL="0">
               <a:buNone/>
             </a:pPr>
             <a:endParaRPr lang="en-US" dirty="0"/>
@@ -7783,7 +8036,7 @@
           </a:bodyPr>
           <a:lstStyle/>
           <a:p>
-            <a:pPr marL="0" indent="0">
+            <a:pPr indent="0" marL="0">
               <a:buNone/>
             </a:pPr>
             <a:r>
@@ -7795,7 +8048,7 @@
                 <a:ea typeface="Aptos" pitchFamily="34" charset="-122"/>
                 <a:cs typeface="Aptos" pitchFamily="34" charset="-120"/>
               </a:rPr>
-              <a:t>Conversion trigger</a:t>
+              <a:t>Who pays first</a:t>
             </a:r>
             <a:endParaRPr lang="en-US" sz="1300" dirty="0"/>
           </a:p>
@@ -7824,7 +8077,7 @@
           </a:bodyPr>
           <a:lstStyle/>
           <a:p>
-            <a:pPr marL="0" indent="0">
+            <a:pPr indent="0" marL="0">
               <a:buNone/>
             </a:pPr>
             <a:r>
@@ -7836,7 +8089,7 @@
                 <a:ea typeface="Aptos" pitchFamily="34" charset="-122"/>
                 <a:cs typeface="Aptos" pitchFamily="34" charset="-120"/>
               </a:rPr>
-              <a:t>Users are most likely to pay when their issue is time-sensitive, evidence-heavy, or emotionally draining.</a:t>
+              <a:t>Likely early payer: renters with time-sensitive, evidence-heavy issues such as deposits, repairs escalation, or eviction pressure.</a:t>
             </a:r>
             <a:endParaRPr lang="en-US" sz="1100" dirty="0"/>
           </a:p>
@@ -7869,7 +8122,7 @@
           <a:bodyPr wrap="square" rtlCol="0" anchor="ctr"/>
           <a:lstStyle/>
           <a:p>
-            <a:pPr marL="0" indent="0">
+            <a:pPr indent="0" marL="0">
               <a:buNone/>
             </a:pPr>
             <a:endParaRPr lang="en-US" dirty="0"/>
@@ -7899,7 +8152,7 @@
           </a:bodyPr>
           <a:lstStyle/>
           <a:p>
-            <a:pPr marL="0" indent="0">
+            <a:pPr indent="0" marL="0">
               <a:buNone/>
             </a:pPr>
             <a:r>
@@ -7911,7 +8164,7 @@
                 <a:ea typeface="Aptos" pitchFamily="34" charset="-122"/>
                 <a:cs typeface="Aptos" pitchFamily="34" charset="-120"/>
               </a:rPr>
-              <a:t>What to say if challenged</a:t>
+              <a:t>How to explain monetisation</a:t>
             </a:r>
             <a:endParaRPr lang="en-US" sz="1300" dirty="0"/>
           </a:p>
@@ -7940,7 +8193,7 @@
           </a:bodyPr>
           <a:lstStyle/>
           <a:p>
-            <a:pPr marL="0" indent="0">
+            <a:pPr indent="0" marL="0">
               <a:buNone/>
             </a:pPr>
             <a:r>
@@ -7952,7 +8205,7 @@
                 <a:ea typeface="Aptos" pitchFamily="34" charset="-122"/>
                 <a:cs typeface="Aptos" pitchFamily="34" charset="-120"/>
               </a:rPr>
-              <a:t>Premium is not 'pay for rights' — it is pay for organisation, drafting support, reminders, and confidence during stressful disputes.</a:t>
+              <a:t>Users do not pay for rights information; they pay for speed, structure, drafting support, and confidence during stressful cases.</a:t>
             </a:r>
             <a:endParaRPr lang="en-US" sz="1100" dirty="0"/>
           </a:p>
@@ -7974,7 +8227,6 @@
         <a:solidFill>
           <a:srgbClr val="0B132B"/>
         </a:solidFill>
-        <a:effectLst/>
       </p:bgPr>
     </p:bg>
     <p:spTree>
@@ -8018,7 +8270,7 @@
           <a:bodyPr wrap="square" rtlCol="0" anchor="ctr"/>
           <a:lstStyle/>
           <a:p>
-            <a:pPr marL="0" indent="0">
+            <a:pPr indent="0" marL="0">
               <a:buNone/>
             </a:pPr>
             <a:endParaRPr lang="en-US" dirty="0"/>
@@ -8046,7 +8298,7 @@
           <a:bodyPr wrap="square" rtlCol="0" anchor="ctr"/>
           <a:lstStyle/>
           <a:p>
-            <a:pPr marL="0" indent="0" algn="r">
+            <a:pPr algn="r" indent="0" marL="0">
               <a:buNone/>
             </a:pPr>
             <a:r>
@@ -8085,7 +8337,7 @@
           <a:bodyPr wrap="square" rtlCol="0" anchor="ctr"/>
           <a:lstStyle/>
           <a:p>
-            <a:pPr marL="0" indent="0">
+            <a:pPr indent="0" marL="0">
               <a:buNone/>
             </a:pPr>
             <a:r>
@@ -8126,7 +8378,7 @@
           </a:bodyPr>
           <a:lstStyle/>
           <a:p>
-            <a:pPr marL="0" indent="0">
+            <a:pPr indent="0" marL="0">
               <a:buNone/>
             </a:pPr>
             <a:r>
@@ -8138,7 +8390,7 @@
                 <a:ea typeface="Aptos Display" pitchFamily="34" charset="-122"/>
                 <a:cs typeface="Aptos Display" pitchFamily="34" charset="-120"/>
               </a:rPr>
-              <a:t>Start where renters already ask for help, then layer in trust and referrals.</a:t>
+              <a:t>Market to one renter segment first, prove trust there, then expand to adjacent users and organisations.</a:t>
             </a:r>
             <a:endParaRPr lang="en-US" sz="2400" dirty="0"/>
           </a:p>
@@ -8171,7 +8423,7 @@
           <a:bodyPr wrap="square" rtlCol="0" anchor="ctr"/>
           <a:lstStyle/>
           <a:p>
-            <a:pPr marL="0" indent="0">
+            <a:pPr indent="0" marL="0">
               <a:buNone/>
             </a:pPr>
             <a:endParaRPr lang="en-US" dirty="0"/>
@@ -8201,7 +8453,7 @@
           </a:bodyPr>
           <a:lstStyle/>
           <a:p>
-            <a:pPr marL="0" indent="0">
+            <a:pPr indent="0" marL="0">
               <a:buNone/>
             </a:pPr>
             <a:r>
@@ -8213,7 +8465,7 @@
                 <a:ea typeface="Aptos" pitchFamily="34" charset="-122"/>
                 <a:cs typeface="Aptos" pitchFamily="34" charset="-120"/>
               </a:rPr>
-              <a:t>1. Communities</a:t>
+              <a:t>1. Young renter channels</a:t>
             </a:r>
             <a:endParaRPr lang="en-US" sz="1300" dirty="0"/>
           </a:p>
@@ -8242,7 +8494,7 @@
           </a:bodyPr>
           <a:lstStyle/>
           <a:p>
-            <a:pPr marL="0" indent="0">
+            <a:pPr indent="0" marL="0">
               <a:buNone/>
             </a:pPr>
             <a:r>
@@ -8254,7 +8506,7 @@
                 <a:ea typeface="Aptos" pitchFamily="34" charset="-122"/>
                 <a:cs typeface="Aptos" pitchFamily="34" charset="-120"/>
               </a:rPr>
-              <a:t>Reddit, MoneySavingExpert, tenant forums, and student housing groups. Answer real questions and direct users to the tool when relevant.</a:t>
+              <a:t>Student housing groups, Reddit, MoneySavingExpert, tenant forums, and university communities where renters already share urgent problems.</a:t>
             </a:r>
             <a:endParaRPr lang="en-US" sz="1100" dirty="0"/>
           </a:p>
@@ -8287,7 +8539,7 @@
           <a:bodyPr wrap="square" rtlCol="0" anchor="ctr"/>
           <a:lstStyle/>
           <a:p>
-            <a:pPr marL="0" indent="0">
+            <a:pPr indent="0" marL="0">
               <a:buNone/>
             </a:pPr>
             <a:endParaRPr lang="en-US" dirty="0"/>
@@ -8317,7 +8569,7 @@
           </a:bodyPr>
           <a:lstStyle/>
           <a:p>
-            <a:pPr marL="0" indent="0">
+            <a:pPr indent="0" marL="0">
               <a:buNone/>
             </a:pPr>
             <a:r>
@@ -8329,7 +8581,7 @@
                 <a:ea typeface="Aptos" pitchFamily="34" charset="-122"/>
                 <a:cs typeface="Aptos" pitchFamily="34" charset="-120"/>
               </a:rPr>
-              <a:t>2. Content + SEO</a:t>
+              <a:t>2. High-intent SEO</a:t>
             </a:r>
             <a:endParaRPr lang="en-US" sz="1300" dirty="0"/>
           </a:p>
@@ -8358,7 +8610,7 @@
           </a:bodyPr>
           <a:lstStyle/>
           <a:p>
-            <a:pPr marL="0" indent="0">
+            <a:pPr indent="0" marL="0">
               <a:buNone/>
             </a:pPr>
             <a:r>
@@ -8370,7 +8622,7 @@
                 <a:ea typeface="Aptos" pitchFamily="34" charset="-122"/>
                 <a:cs typeface="Aptos" pitchFamily="34" charset="-120"/>
               </a:rPr>
-              <a:t>Target high-intent searches like 'landlord won’t return deposit' or 'how long to fix damp'. Publish pages that convert into guided flows.</a:t>
+              <a:t>Target searches like 'landlord won’t return deposit' and 'how long to fix damp' with pages that convert readers into guided flows.</a:t>
             </a:r>
             <a:endParaRPr lang="en-US" sz="1100" dirty="0"/>
           </a:p>
@@ -8403,7 +8655,7 @@
           <a:bodyPr wrap="square" rtlCol="0" anchor="ctr"/>
           <a:lstStyle/>
           <a:p>
-            <a:pPr marL="0" indent="0">
+            <a:pPr indent="0" marL="0">
               <a:buNone/>
             </a:pPr>
             <a:endParaRPr lang="en-US" dirty="0"/>
@@ -8433,7 +8685,7 @@
           </a:bodyPr>
           <a:lstStyle/>
           <a:p>
-            <a:pPr marL="0" indent="0">
+            <a:pPr indent="0" marL="0">
               <a:buNone/>
             </a:pPr>
             <a:r>
@@ -8445,7 +8697,7 @@
                 <a:ea typeface="Aptos" pitchFamily="34" charset="-122"/>
                 <a:cs typeface="Aptos" pitchFamily="34" charset="-120"/>
               </a:rPr>
-              <a:t>3. Pilot conversations</a:t>
+              <a:t>3. Pilot buyers</a:t>
             </a:r>
             <a:endParaRPr lang="en-US" sz="1300" dirty="0"/>
           </a:p>
@@ -8474,7 +8726,7 @@
           </a:bodyPr>
           <a:lstStyle/>
           <a:p>
-            <a:pPr marL="0" indent="0">
+            <a:pPr indent="0" marL="0">
               <a:buNone/>
             </a:pPr>
             <a:r>
@@ -8486,7 +8738,7 @@
                 <a:ea typeface="Aptos" pitchFamily="34" charset="-122"/>
                 <a:cs typeface="Aptos" pitchFamily="34" charset="-120"/>
               </a:rPr>
-              <a:t>Approach charities, unions, university housing teams, and local support organisations with a lightweight self-serve pilot.</a:t>
+              <a:t>Approach university housing teams, tenant unions, councils, and advice services with a lightweight self-serve pilot.</a:t>
             </a:r>
             <a:endParaRPr lang="en-US" sz="1100" dirty="0"/>
           </a:p>
@@ -8519,7 +8771,7 @@
           <a:bodyPr wrap="square" rtlCol="0" anchor="ctr"/>
           <a:lstStyle/>
           <a:p>
-            <a:pPr marL="0" indent="0">
+            <a:pPr indent="0" marL="0">
               <a:buNone/>
             </a:pPr>
             <a:endParaRPr lang="en-US" dirty="0"/>
@@ -8549,7 +8801,7 @@
           </a:bodyPr>
           <a:lstStyle/>
           <a:p>
-            <a:pPr marL="0" indent="0">
+            <a:pPr indent="0" marL="0">
               <a:buNone/>
             </a:pPr>
             <a:r>
@@ -8561,7 +8813,7 @@
                 <a:ea typeface="Aptos" pitchFamily="34" charset="-122"/>
                 <a:cs typeface="Aptos" pitchFamily="34" charset="-120"/>
               </a:rPr>
-              <a:t>Important correction from the feedback</a:t>
+              <a:t>Messaging discipline</a:t>
             </a:r>
             <a:endParaRPr lang="en-US" sz="1300" dirty="0"/>
           </a:p>
@@ -8590,7 +8842,7 @@
           </a:bodyPr>
           <a:lstStyle/>
           <a:p>
-            <a:pPr marL="0" indent="0">
+            <a:pPr indent="0" marL="0">
               <a:buNone/>
             </a:pPr>
             <a:r>
@@ -8602,7 +8854,7 @@
                 <a:ea typeface="Aptos" pitchFamily="34" charset="-122"/>
                 <a:cs typeface="Aptos" pitchFamily="34" charset="-120"/>
               </a:rPr>
-              <a:t>Do not imply formal partnerships with Shelter or Citizens Advice unless they already exist. Frame this as pilot exploration, not confirmed distribution.</a:t>
+              <a:t>Be explicit: the core user is the renter, and the first paying customer is either a renter in a premium moment or an organisation buying triage capacity.</a:t>
             </a:r>
             <a:endParaRPr lang="en-US" sz="1100" dirty="0"/>
           </a:p>
@@ -8624,7 +8876,6 @@
         <a:solidFill>
           <a:srgbClr val="0B132B"/>
         </a:solidFill>
-        <a:effectLst/>
       </p:bgPr>
     </p:bg>
     <p:spTree>
@@ -8668,7 +8919,7 @@
           <a:bodyPr wrap="square" rtlCol="0" anchor="ctr"/>
           <a:lstStyle/>
           <a:p>
-            <a:pPr marL="0" indent="0">
+            <a:pPr indent="0" marL="0">
               <a:buNone/>
             </a:pPr>
             <a:endParaRPr lang="en-US" dirty="0"/>
@@ -8696,7 +8947,7 @@
           <a:bodyPr wrap="square" rtlCol="0" anchor="ctr"/>
           <a:lstStyle/>
           <a:p>
-            <a:pPr marL="0" indent="0" algn="r">
+            <a:pPr algn="r" indent="0" marL="0">
               <a:buNone/>
             </a:pPr>
             <a:r>
@@ -8735,7 +8986,7 @@
           <a:bodyPr wrap="square" rtlCol="0" anchor="ctr"/>
           <a:lstStyle/>
           <a:p>
-            <a:pPr marL="0" indent="0">
+            <a:pPr indent="0" marL="0">
               <a:buNone/>
             </a:pPr>
             <a:r>
@@ -8776,7 +9027,7 @@
           </a:bodyPr>
           <a:lstStyle/>
           <a:p>
-            <a:pPr marL="0" indent="0">
+            <a:pPr indent="0" marL="0">
               <a:buNone/>
             </a:pPr>
             <a:r>
@@ -8788,7 +9039,7 @@
                 <a:ea typeface="Aptos Display" pitchFamily="34" charset="-122"/>
                 <a:cs typeface="Aptos Display" pitchFamily="34" charset="-120"/>
               </a:rPr>
-              <a:t>The prototype already proves usability; the next step is stronger evidence and trust-building.</a:t>
+              <a:t>The prototype proves usability; next validation should focus on trust, willingness to pay, and the best first segment.</a:t>
             </a:r>
             <a:endParaRPr lang="en-US" sz="2400" dirty="0"/>
           </a:p>
@@ -8821,7 +9072,7 @@
           <a:bodyPr wrap="square" rtlCol="0" anchor="ctr"/>
           <a:lstStyle/>
           <a:p>
-            <a:pPr marL="0" indent="0">
+            <a:pPr indent="0" marL="0">
               <a:buNone/>
             </a:pPr>
             <a:endParaRPr lang="en-US" dirty="0"/>
@@ -8851,7 +9102,7 @@
           </a:bodyPr>
           <a:lstStyle/>
           <a:p>
-            <a:pPr marL="0" indent="0">
+            <a:pPr indent="0" marL="0">
               <a:buNone/>
             </a:pPr>
             <a:r>
@@ -8892,7 +9143,7 @@
           </a:bodyPr>
           <a:lstStyle/>
           <a:p>
-            <a:pPr marL="0" indent="0">
+            <a:pPr indent="0" marL="0">
               <a:buNone/>
             </a:pPr>
             <a:r>
@@ -8909,7 +9160,7 @@
             <a:endParaRPr lang="en-US" sz="1100" dirty="0"/>
           </a:p>
           <a:p>
-            <a:pPr marL="0" indent="0">
+            <a:pPr indent="0" marL="0">
               <a:buNone/>
             </a:pPr>
             <a:r>
@@ -8926,7 +9177,7 @@
             <a:endParaRPr lang="en-US" sz="1100" dirty="0"/>
           </a:p>
           <a:p>
-            <a:pPr marL="0" indent="0">
+            <a:pPr indent="0" marL="0">
               <a:buNone/>
             </a:pPr>
             <a:r>
@@ -8943,7 +9194,7 @@
             <a:endParaRPr lang="en-US" sz="1100" dirty="0"/>
           </a:p>
           <a:p>
-            <a:pPr marL="0" indent="0">
+            <a:pPr indent="0" marL="0">
               <a:buNone/>
             </a:pPr>
             <a:r>
@@ -8960,7 +9211,7 @@
             <a:endParaRPr lang="en-US" sz="1100" dirty="0"/>
           </a:p>
           <a:p>
-            <a:pPr marL="0" indent="0">
+            <a:pPr indent="0" marL="0">
               <a:buNone/>
             </a:pPr>
             <a:r>
@@ -9005,7 +9256,7 @@
           <a:bodyPr wrap="square" rtlCol="0" anchor="ctr"/>
           <a:lstStyle/>
           <a:p>
-            <a:pPr marL="0" indent="0">
+            <a:pPr indent="0" marL="0">
               <a:buNone/>
             </a:pPr>
             <a:endParaRPr lang="en-US" dirty="0"/>
@@ -9035,7 +9286,7 @@
           </a:bodyPr>
           <a:lstStyle/>
           <a:p>
-            <a:pPr marL="0" indent="0">
+            <a:pPr indent="0" marL="0">
               <a:buNone/>
             </a:pPr>
             <a:r>
@@ -9076,7 +9327,7 @@
           </a:bodyPr>
           <a:lstStyle/>
           <a:p>
-            <a:pPr marL="0" indent="0">
+            <a:pPr indent="0" marL="0">
               <a:buNone/>
             </a:pPr>
             <a:r>
@@ -9093,7 +9344,7 @@
             <a:endParaRPr lang="en-US" sz="1100" dirty="0"/>
           </a:p>
           <a:p>
-            <a:pPr marL="0" indent="0">
+            <a:pPr indent="0" marL="0">
               <a:buNone/>
             </a:pPr>
             <a:r>
@@ -9105,12 +9356,12 @@
                 <a:ea typeface="Aptos" pitchFamily="34" charset="-122"/>
                 <a:cs typeface="Aptos" pitchFamily="34" charset="-120"/>
               </a:rPr>
-              <a:t>• Template letters feel trustworthy enough to use</a:t>
+              <a:t>• Users trust the outputs enough to act</a:t>
             </a:r>
             <a:endParaRPr lang="en-US" sz="1100" dirty="0"/>
           </a:p>
           <a:p>
-            <a:pPr marL="0" indent="0">
+            <a:pPr indent="0" marL="0">
               <a:buNone/>
             </a:pPr>
             <a:r>
@@ -9122,12 +9373,12 @@
                 <a:ea typeface="Aptos" pitchFamily="34" charset="-122"/>
                 <a:cs typeface="Aptos" pitchFamily="34" charset="-120"/>
               </a:rPr>
-              <a:t>• Users understand this is guidance, not legal advice</a:t>
+              <a:t>• Students and young professionals are the easiest wedge to acquire first</a:t>
             </a:r>
             <a:endParaRPr lang="en-US" sz="1100" dirty="0"/>
           </a:p>
           <a:p>
-            <a:pPr marL="0" indent="0">
+            <a:pPr indent="0" marL="0">
               <a:buNone/>
             </a:pPr>
             <a:r>
@@ -9172,7 +9423,7 @@
           <a:bodyPr wrap="square" rtlCol="0" anchor="ctr"/>
           <a:lstStyle/>
           <a:p>
-            <a:pPr marL="0" indent="0">
+            <a:pPr indent="0" marL="0">
               <a:buNone/>
             </a:pPr>
             <a:endParaRPr lang="en-US" dirty="0"/>
@@ -9202,7 +9453,7 @@
           </a:bodyPr>
           <a:lstStyle/>
           <a:p>
-            <a:pPr marL="0" indent="0">
+            <a:pPr indent="0" marL="0">
               <a:buNone/>
             </a:pPr>
             <a:r>
@@ -9214,7 +9465,7 @@
                 <a:ea typeface="Aptos" pitchFamily="34" charset="-122"/>
                 <a:cs typeface="Aptos" pitchFamily="34" charset="-120"/>
               </a:rPr>
-              <a:t>Renter feedback</a:t>
+              <a:t>Renter feedback (temporary)</a:t>
             </a:r>
             <a:endParaRPr lang="en-US" sz="1300" dirty="0"/>
           </a:p>
@@ -9239,13 +9490,12 @@
         </p:spPr>
         <p:txBody>
           <a:bodyPr wrap="square" lIns="0" tIns="0" rIns="0" bIns="0" rtlCol="0" anchor="t">
-            <a:normAutofit fontScale="92500"/>
+            <a:normAutofit/>
           </a:bodyPr>
           <a:lstStyle/>
           <a:p>
-            <a:pPr marL="171450" indent="-171450">
-              <a:buFontTx/>
-              <a:buChar char="-"/>
+            <a:pPr indent="0" marL="0">
+              <a:buNone/>
             </a:pPr>
             <a:r>
               <a:rPr lang="en-US" sz="1100" dirty="0">
@@ -9253,39 +9503,12 @@
                   <a:srgbClr val="C9D1E0"/>
                 </a:solidFill>
                 <a:latin typeface="Aptos" pitchFamily="34" charset="0"/>
-              </a:rPr>
-              <a:t>Close friends of mine in their twenties have dealt with unsafe conditions and slow or ignored responses when they raised serious maintenance concerns.</a:t>
-            </a:r>
-          </a:p>
-          <a:p>
-            <a:pPr marL="171450" indent="-171450">
-              <a:buFontTx/>
-              <a:buChar char="-"/>
-            </a:pPr>
-            <a:r>
-              <a:rPr lang="en-US" sz="1100" dirty="0">
-                <a:solidFill>
-                  <a:srgbClr val="C9D1E0"/>
-                </a:solidFill>
-                <a:latin typeface="Aptos" pitchFamily="34" charset="0"/>
-              </a:rPr>
-              <a:t>They have also experienced poor communication, with key issues around inspections, repairs, and tenancy expectations handled unclearly or inconsistently.</a:t>
-            </a:r>
-          </a:p>
-          <a:p>
-            <a:pPr marL="171450" indent="-171450">
-              <a:buFontTx/>
-              <a:buChar char="-"/>
-            </a:pPr>
-            <a:r>
-              <a:rPr lang="en-US" sz="1100" dirty="0">
-                <a:solidFill>
-                  <a:srgbClr val="C9D1E0"/>
-                </a:solidFill>
-                <a:latin typeface="Aptos" pitchFamily="34" charset="0"/>
-              </a:rPr>
-              <a:t>These experiences left them feeling stressed and unsupported during a period when stable housing should have been straightforward and secure.</a:t>
-            </a:r>
+                <a:ea typeface="Aptos" pitchFamily="34" charset="-122"/>
+                <a:cs typeface="Aptos" pitchFamily="34" charset="-120"/>
+              </a:rPr>
+              <a:t>TEMP — Add 3–5 renter quotes showing whether users trusted the guidance, understood the disclaimer, and would pay for drafting, reminders, or evidence tracking in stressful disputes.</a:t>
+            </a:r>
+            <a:endParaRPr lang="en-US" sz="1100" dirty="0"/>
           </a:p>
         </p:txBody>
       </p:sp>
@@ -9316,7 +9539,7 @@
           <a:bodyPr wrap="square" rtlCol="0" anchor="ctr"/>
           <a:lstStyle/>
           <a:p>
-            <a:pPr marL="0" indent="0">
+            <a:pPr indent="0" marL="0">
               <a:buNone/>
             </a:pPr>
             <a:endParaRPr lang="en-US" dirty="0"/>
@@ -9346,7 +9569,7 @@
           </a:bodyPr>
           <a:lstStyle/>
           <a:p>
-            <a:pPr marL="0" indent="0">
+            <a:pPr indent="0" marL="0">
               <a:buNone/>
             </a:pPr>
             <a:r>
@@ -9383,11 +9606,11 @@
         </p:spPr>
         <p:txBody>
           <a:bodyPr wrap="square" lIns="0" tIns="0" rIns="0" bIns="0" rtlCol="0" anchor="t">
-            <a:normAutofit lnSpcReduction="10000"/>
+            <a:normAutofit/>
           </a:bodyPr>
           <a:lstStyle/>
           <a:p>
-            <a:pPr marL="0" indent="0">
+            <a:pPr indent="0" marL="0">
               <a:buNone/>
             </a:pPr>
             <a:r>
@@ -9399,7 +9622,7 @@
                 <a:ea typeface="Aptos" pitchFamily="34" charset="-122"/>
                 <a:cs typeface="Aptos" pitchFamily="34" charset="-120"/>
               </a:rPr>
-              <a:t>This is strongest when positioned as a confidence and action tool, not a generic legal information site.</a:t>
+              <a:t>This is strongest when framed as a renter action tool with a narrow first segment and clear premium moments — not a general legal information site.</a:t>
             </a:r>
             <a:endParaRPr lang="en-US" sz="1100" dirty="0"/>
           </a:p>
@@ -9421,7 +9644,6 @@
         <a:solidFill>
           <a:srgbClr val="0B132B"/>
         </a:solidFill>
-        <a:effectLst/>
       </p:bgPr>
     </p:bg>
     <p:spTree>
@@ -9465,7 +9687,7 @@
           <a:bodyPr wrap="square" rtlCol="0" anchor="ctr"/>
           <a:lstStyle/>
           <a:p>
-            <a:pPr marL="0" indent="0">
+            <a:pPr indent="0" marL="0">
               <a:buNone/>
             </a:pPr>
             <a:endParaRPr lang="en-US" dirty="0"/>
@@ -9493,7 +9715,7 @@
           <a:bodyPr wrap="square" rtlCol="0" anchor="ctr"/>
           <a:lstStyle/>
           <a:p>
-            <a:pPr marL="0" indent="0" algn="r">
+            <a:pPr algn="r" indent="0" marL="0">
               <a:buNone/>
             </a:pPr>
             <a:r>
@@ -9532,7 +9754,7 @@
           <a:bodyPr wrap="square" rtlCol="0" anchor="ctr"/>
           <a:lstStyle/>
           <a:p>
-            <a:pPr marL="0" indent="0">
+            <a:pPr indent="0" marL="0">
               <a:buNone/>
             </a:pPr>
             <a:r>
@@ -9573,7 +9795,7 @@
           </a:bodyPr>
           <a:lstStyle/>
           <a:p>
-            <a:pPr marL="0" indent="0">
+            <a:pPr indent="0" marL="0">
               <a:buNone/>
             </a:pPr>
             <a:r>
@@ -9618,7 +9840,7 @@
           <a:bodyPr wrap="square" rtlCol="0" anchor="ctr"/>
           <a:lstStyle/>
           <a:p>
-            <a:pPr marL="0" indent="0">
+            <a:pPr indent="0" marL="0">
               <a:buNone/>
             </a:pPr>
             <a:endParaRPr lang="en-US" dirty="0"/>
@@ -9648,7 +9870,7 @@
           </a:bodyPr>
           <a:lstStyle/>
           <a:p>
-            <a:pPr marL="0" indent="0">
+            <a:pPr indent="0" marL="0">
               <a:buNone/>
             </a:pPr>
             <a:r>
@@ -9689,7 +9911,7 @@
           </a:bodyPr>
           <a:lstStyle/>
           <a:p>
-            <a:pPr marL="0" indent="0">
+            <a:pPr indent="0" marL="0">
               <a:buNone/>
             </a:pPr>
             <a:r>
@@ -9706,13 +9928,13 @@
             <a:endParaRPr lang="en-US" sz="1100" dirty="0"/>
           </a:p>
           <a:p>
-            <a:pPr marL="0" indent="0">
+            <a:pPr indent="0" marL="0">
               <a:buNone/>
             </a:pPr>
             <a:endParaRPr lang="en-US" sz="1100" dirty="0"/>
           </a:p>
           <a:p>
-            <a:pPr marL="0" indent="0">
+            <a:pPr indent="0" marL="0">
               <a:buNone/>
             </a:pPr>
             <a:r>
@@ -9757,7 +9979,7 @@
           <a:bodyPr wrap="square" rtlCol="0" anchor="ctr"/>
           <a:lstStyle/>
           <a:p>
-            <a:pPr marL="0" indent="0">
+            <a:pPr indent="0" marL="0">
               <a:buNone/>
             </a:pPr>
             <a:endParaRPr lang="en-US" dirty="0"/>
@@ -9787,7 +10009,7 @@
           </a:bodyPr>
           <a:lstStyle/>
           <a:p>
-            <a:pPr marL="0" indent="0">
+            <a:pPr indent="0" marL="0">
               <a:buNone/>
             </a:pPr>
             <a:r>
@@ -9828,7 +10050,7 @@
           </a:bodyPr>
           <a:lstStyle/>
           <a:p>
-            <a:pPr marL="0" indent="0">
+            <a:pPr indent="0" marL="0">
               <a:buNone/>
             </a:pPr>
             <a:r>
@@ -9845,7 +10067,7 @@
             <a:endParaRPr lang="en-US" sz="1100" dirty="0"/>
           </a:p>
           <a:p>
-            <a:pPr marL="0" indent="0">
+            <a:pPr indent="0" marL="0">
               <a:buNone/>
             </a:pPr>
             <a:r>
@@ -9862,7 +10084,7 @@
             <a:endParaRPr lang="en-US" sz="1100" dirty="0"/>
           </a:p>
           <a:p>
-            <a:pPr marL="0" indent="0">
+            <a:pPr indent="0" marL="0">
               <a:buNone/>
             </a:pPr>
             <a:r>
@@ -9879,7 +10101,7 @@
             <a:endParaRPr lang="en-US" sz="1100" dirty="0"/>
           </a:p>
           <a:p>
-            <a:pPr marL="0" indent="0">
+            <a:pPr indent="0" marL="0">
               <a:buNone/>
             </a:pPr>
             <a:r>
@@ -9918,7 +10140,7 @@
           <a:bodyPr wrap="square" lIns="0" tIns="0" rIns="0" bIns="0" rtlCol="0" anchor="ctr"/>
           <a:lstStyle/>
           <a:p>
-            <a:pPr marL="0" indent="0">
+            <a:pPr indent="0" marL="0">
               <a:buNone/>
             </a:pPr>
             <a:r>
@@ -10237,319 +10459,4 @@
     </a:ext>
   </a:extLst>
 </a:theme>
-</file>
-
-<file path=ppt/theme/theme2.xml><?xml version="1.0" encoding="utf-8"?>
-<a:theme xmlns:a="http://schemas.openxmlformats.org/drawingml/2006/main" name="Office Theme">
-  <a:themeElements>
-    <a:clrScheme name="Office">
-      <a:dk1>
-        <a:sysClr val="windowText" lastClr="000000"/>
-      </a:dk1>
-      <a:lt1>
-        <a:sysClr val="window" lastClr="FFFFFF"/>
-      </a:lt1>
-      <a:dk2>
-        <a:srgbClr val="0E2841"/>
-      </a:dk2>
-      <a:lt2>
-        <a:srgbClr val="E8E8E8"/>
-      </a:lt2>
-      <a:accent1>
-        <a:srgbClr val="156082"/>
-      </a:accent1>
-      <a:accent2>
-        <a:srgbClr val="E97132"/>
-      </a:accent2>
-      <a:accent3>
-        <a:srgbClr val="196B24"/>
-      </a:accent3>
-      <a:accent4>
-        <a:srgbClr val="0F9ED5"/>
-      </a:accent4>
-      <a:accent5>
-        <a:srgbClr val="A02B93"/>
-      </a:accent5>
-      <a:accent6>
-        <a:srgbClr val="4EA72E"/>
-      </a:accent6>
-      <a:hlink>
-        <a:srgbClr val="467886"/>
-      </a:hlink>
-      <a:folHlink>
-        <a:srgbClr val="96607D"/>
-      </a:folHlink>
-    </a:clrScheme>
-    <a:fontScheme name="Office">
-      <a:majorFont>
-        <a:latin typeface="Aptos Display" panose="02110004020202020204"/>
-        <a:ea typeface=""/>
-        <a:cs typeface=""/>
-        <a:font script="Jpan" typeface="游ゴシック Light"/>
-        <a:font script="Hang" typeface="맑은 고딕"/>
-        <a:font script="Hans" typeface="等线 Light"/>
-        <a:font script="Hant" typeface="新細明體"/>
-        <a:font script="Arab" typeface="Times New Roman"/>
-        <a:font script="Hebr" typeface="Times New Roman"/>
-        <a:font script="Thai" typeface="Angsana New"/>
-        <a:font script="Ethi" typeface="Nyala"/>
-        <a:font script="Beng" typeface="Vrinda"/>
-        <a:font script="Gujr" typeface="Shruti"/>
-        <a:font script="Khmr" typeface="MoolBoran"/>
-        <a:font script="Knda" typeface="Tunga"/>
-        <a:font script="Guru" typeface="Raavi"/>
-        <a:font script="Cans" typeface="Euphemia"/>
-        <a:font script="Cher" typeface="Plantagenet Cherokee"/>
-        <a:font script="Yiii" typeface="Microsoft Yi Baiti"/>
-        <a:font script="Tibt" typeface="Microsoft Himalaya"/>
-        <a:font script="Thaa" typeface="MV Boli"/>
-        <a:font script="Deva" typeface="Mangal"/>
-        <a:font script="Telu" typeface="Gautami"/>
-        <a:font script="Taml" typeface="Latha"/>
-        <a:font script="Syrc" typeface="Estrangelo Edessa"/>
-        <a:font script="Orya" typeface="Kalinga"/>
-        <a:font script="Mlym" typeface="Kartika"/>
-        <a:font script="Laoo" typeface="DokChampa"/>
-        <a:font script="Sinh" typeface="Iskoola Pota"/>
-        <a:font script="Mong" typeface="Mongolian Baiti"/>
-        <a:font script="Viet" typeface="Times New Roman"/>
-        <a:font script="Uigh" typeface="Microsoft Uighur"/>
-        <a:font script="Geor" typeface="Sylfaen"/>
-        <a:font script="Armn" typeface="Arial"/>
-        <a:font script="Bugi" typeface="Leelawadee UI"/>
-        <a:font script="Bopo" typeface="Microsoft JhengHei"/>
-        <a:font script="Java" typeface="Javanese Text"/>
-        <a:font script="Lisu" typeface="Segoe UI"/>
-        <a:font script="Mymr" typeface="Myanmar Text"/>
-        <a:font script="Nkoo" typeface="Ebrima"/>
-        <a:font script="Olck" typeface="Nirmala UI"/>
-        <a:font script="Osma" typeface="Ebrima"/>
-        <a:font script="Phag" typeface="Phagspa"/>
-        <a:font script="Syrn" typeface="Estrangelo Edessa"/>
-        <a:font script="Syrj" typeface="Estrangelo Edessa"/>
-        <a:font script="Syre" typeface="Estrangelo Edessa"/>
-        <a:font script="Sora" typeface="Nirmala UI"/>
-        <a:font script="Tale" typeface="Microsoft Tai Le"/>
-        <a:font script="Talu" typeface="Microsoft New Tai Lue"/>
-        <a:font script="Tfng" typeface="Ebrima"/>
-      </a:majorFont>
-      <a:minorFont>
-        <a:latin typeface="Aptos" panose="02110004020202020204"/>
-        <a:ea typeface=""/>
-        <a:cs typeface=""/>
-        <a:font script="Jpan" typeface="游ゴシック"/>
-        <a:font script="Hang" typeface="맑은 고딕"/>
-        <a:font script="Hans" typeface="等线"/>
-        <a:font script="Hant" typeface="新細明體"/>
-        <a:font script="Arab" typeface="Arial"/>
-        <a:font script="Hebr" typeface="Arial"/>
-        <a:font script="Thai" typeface="Cordia New"/>
-        <a:font script="Ethi" typeface="Nyala"/>
-        <a:font script="Beng" typeface="Vrinda"/>
-        <a:font script="Gujr" typeface="Shruti"/>
-        <a:font script="Khmr" typeface="DaunPenh"/>
-        <a:font script="Knda" typeface="Tunga"/>
-        <a:font script="Guru" typeface="Raavi"/>
-        <a:font script="Cans" typeface="Euphemia"/>
-        <a:font script="Cher" typeface="Plantagenet Cherokee"/>
-        <a:font script="Yiii" typeface="Microsoft Yi Baiti"/>
-        <a:font script="Tibt" typeface="Microsoft Himalaya"/>
-        <a:font script="Thaa" typeface="MV Boli"/>
-        <a:font script="Deva" typeface="Mangal"/>
-        <a:font script="Telu" typeface="Gautami"/>
-        <a:font script="Taml" typeface="Latha"/>
-        <a:font script="Syrc" typeface="Estrangelo Edessa"/>
-        <a:font script="Orya" typeface="Kalinga"/>
-        <a:font script="Mlym" typeface="Kartika"/>
-        <a:font script="Laoo" typeface="DokChampa"/>
-        <a:font script="Sinh" typeface="Iskoola Pota"/>
-        <a:font script="Mong" typeface="Mongolian Baiti"/>
-        <a:font script="Viet" typeface="Arial"/>
-        <a:font script="Uigh" typeface="Microsoft Uighur"/>
-        <a:font script="Geor" typeface="Sylfaen"/>
-        <a:font script="Armn" typeface="Arial"/>
-        <a:font script="Bugi" typeface="Leelawadee UI"/>
-        <a:font script="Bopo" typeface="Microsoft JhengHei"/>
-        <a:font script="Java" typeface="Javanese Text"/>
-        <a:font script="Lisu" typeface="Segoe UI"/>
-        <a:font script="Mymr" typeface="Myanmar Text"/>
-        <a:font script="Nkoo" typeface="Ebrima"/>
-        <a:font script="Olck" typeface="Nirmala UI"/>
-        <a:font script="Osma" typeface="Ebrima"/>
-        <a:font script="Phag" typeface="Phagspa"/>
-        <a:font script="Syrn" typeface="Estrangelo Edessa"/>
-        <a:font script="Syrj" typeface="Estrangelo Edessa"/>
-        <a:font script="Syre" typeface="Estrangelo Edessa"/>
-        <a:font script="Sora" typeface="Nirmala UI"/>
-        <a:font script="Tale" typeface="Microsoft Tai Le"/>
-        <a:font script="Talu" typeface="Microsoft New Tai Lue"/>
-        <a:font script="Tfng" typeface="Ebrima"/>
-      </a:minorFont>
-    </a:fontScheme>
-    <a:fmtScheme name="Office">
-      <a:fillStyleLst>
-        <a:solidFill>
-          <a:schemeClr val="phClr"/>
-        </a:solidFill>
-        <a:gradFill rotWithShape="1">
-          <a:gsLst>
-            <a:gs pos="0">
-              <a:schemeClr val="phClr">
-                <a:lumMod val="110000"/>
-                <a:satMod val="105000"/>
-                <a:tint val="67000"/>
-              </a:schemeClr>
-            </a:gs>
-            <a:gs pos="50000">
-              <a:schemeClr val="phClr">
-                <a:lumMod val="105000"/>
-                <a:satMod val="103000"/>
-                <a:tint val="73000"/>
-              </a:schemeClr>
-            </a:gs>
-            <a:gs pos="100000">
-              <a:schemeClr val="phClr">
-                <a:lumMod val="105000"/>
-                <a:satMod val="109000"/>
-                <a:tint val="81000"/>
-              </a:schemeClr>
-            </a:gs>
-          </a:gsLst>
-          <a:lin ang="5400000" scaled="0"/>
-        </a:gradFill>
-        <a:gradFill rotWithShape="1">
-          <a:gsLst>
-            <a:gs pos="0">
-              <a:schemeClr val="phClr">
-                <a:satMod val="103000"/>
-                <a:lumMod val="102000"/>
-                <a:tint val="94000"/>
-              </a:schemeClr>
-            </a:gs>
-            <a:gs pos="50000">
-              <a:schemeClr val="phClr">
-                <a:satMod val="110000"/>
-                <a:lumMod val="100000"/>
-                <a:shade val="100000"/>
-              </a:schemeClr>
-            </a:gs>
-            <a:gs pos="100000">
-              <a:schemeClr val="phClr">
-                <a:lumMod val="99000"/>
-                <a:satMod val="120000"/>
-                <a:shade val="78000"/>
-              </a:schemeClr>
-            </a:gs>
-          </a:gsLst>
-          <a:lin ang="5400000" scaled="0"/>
-        </a:gradFill>
-      </a:fillStyleLst>
-      <a:lnStyleLst>
-        <a:ln w="12700" cap="flat" cmpd="sng" algn="ctr">
-          <a:solidFill>
-            <a:schemeClr val="phClr"/>
-          </a:solidFill>
-          <a:prstDash val="solid"/>
-          <a:miter lim="800000"/>
-        </a:ln>
-        <a:ln w="19050" cap="flat" cmpd="sng" algn="ctr">
-          <a:solidFill>
-            <a:schemeClr val="phClr"/>
-          </a:solidFill>
-          <a:prstDash val="solid"/>
-          <a:miter lim="800000"/>
-        </a:ln>
-        <a:ln w="25400" cap="flat" cmpd="sng" algn="ctr">
-          <a:solidFill>
-            <a:schemeClr val="phClr"/>
-          </a:solidFill>
-          <a:prstDash val="solid"/>
-          <a:miter lim="800000"/>
-        </a:ln>
-      </a:lnStyleLst>
-      <a:effectStyleLst>
-        <a:effectStyle>
-          <a:effectLst/>
-        </a:effectStyle>
-        <a:effectStyle>
-          <a:effectLst/>
-        </a:effectStyle>
-        <a:effectStyle>
-          <a:effectLst>
-            <a:outerShdw blurRad="57150" dist="19050" dir="5400000" algn="ctr" rotWithShape="0">
-              <a:srgbClr val="000000">
-                <a:alpha val="63000"/>
-              </a:srgbClr>
-            </a:outerShdw>
-          </a:effectLst>
-        </a:effectStyle>
-      </a:effectStyleLst>
-      <a:bgFillStyleLst>
-        <a:solidFill>
-          <a:schemeClr val="phClr"/>
-        </a:solidFill>
-        <a:solidFill>
-          <a:schemeClr val="phClr">
-            <a:tint val="95000"/>
-            <a:satMod val="170000"/>
-          </a:schemeClr>
-        </a:solidFill>
-        <a:gradFill rotWithShape="1">
-          <a:gsLst>
-            <a:gs pos="0">
-              <a:schemeClr val="phClr">
-                <a:tint val="93000"/>
-                <a:satMod val="150000"/>
-                <a:shade val="98000"/>
-                <a:lumMod val="102000"/>
-              </a:schemeClr>
-            </a:gs>
-            <a:gs pos="50000">
-              <a:schemeClr val="phClr">
-                <a:tint val="98000"/>
-                <a:satMod val="130000"/>
-                <a:shade val="90000"/>
-                <a:lumMod val="103000"/>
-              </a:schemeClr>
-            </a:gs>
-            <a:gs pos="100000">
-              <a:schemeClr val="phClr">
-                <a:shade val="63000"/>
-                <a:satMod val="120000"/>
-              </a:schemeClr>
-            </a:gs>
-          </a:gsLst>
-          <a:lin ang="5400000" scaled="0"/>
-        </a:gradFill>
-      </a:bgFillStyleLst>
-    </a:fmtScheme>
-  </a:themeElements>
-  <a:objectDefaults>
-    <a:lnDef>
-      <a:spPr/>
-      <a:bodyPr/>
-      <a:lstStyle/>
-      <a:style>
-        <a:lnRef idx="2">
-          <a:schemeClr val="accent1"/>
-        </a:lnRef>
-        <a:fillRef idx="0">
-          <a:schemeClr val="accent1"/>
-        </a:fillRef>
-        <a:effectRef idx="1">
-          <a:schemeClr val="accent1"/>
-        </a:effectRef>
-        <a:fontRef idx="minor">
-          <a:schemeClr val="tx1"/>
-        </a:fontRef>
-      </a:style>
-    </a:lnDef>
-  </a:objectDefaults>
-  <a:extraClrSchemeLst/>
-  <a:extLst>
-    <a:ext uri="{05A4C25C-085E-4340-85A3-A5531E510DB2}">
-      <thm15:themeFamily xmlns:thm15="http://schemas.microsoft.com/office/thememl/2012/main" name="Office Theme" id="{2E142A2C-CD16-42D6-873A-C26D2A0506FA}" vid="{1BDDFF52-6CD6-40A5-AB3C-68EB2F1E4D0A}"/>
-    </a:ext>
-  </a:extLst>
-</a:theme>
 </file>
</xml_diff>

<commit_message>
Update to pitch deck.
</commit_message>
<xml_diff>
--- a/public/RenterShield_PitchDeck_Revised.pptx
+++ b/public/RenterShield_PitchDeck_Revised.pptx
@@ -4,6 +4,9 @@
   <p:sldMasterIdLst>
     <p:sldMasterId id="2147483648" r:id="rId1"/>
   </p:sldMasterIdLst>
+  <p:notesMasterIdLst>
+    <p:notesMasterId r:id="rId14"/>
+  </p:notesMasterIdLst>
   <p:sldIdLst>
     <p:sldId id="256" r:id="rId2"/>
     <p:sldId id="257" r:id="rId3"/>
@@ -18,9 +21,6 @@
     <p:sldId id="266" r:id="rId12"/>
     <p:sldId id="267" r:id="rId13"/>
   </p:sldIdLst>
-  <p:notesMasterIdLst>
-    <p:notesMasterId r:id="rId14"/>
-  </p:notesMasterIdLst>
   <p:sldSz cx="12192000" cy="6858000"/>
   <p:notesSz cx="6858000" cy="12192000"/>
   <p:defaultTextStyle>
@@ -115,6 +115,11 @@
       </a:defRPr>
     </a:lvl9pPr>
   </p:defaultTextStyle>
+  <p:extLst>
+    <p:ext uri="{EFAFB233-063F-42B5-8137-9DF3F51BA10A}">
+      <p15:sldGuideLst xmlns:p15="http://schemas.microsoft.com/office/powerpoint/2012/main"/>
+    </p:ext>
+  </p:extLst>
 </p:presentation>
 </file>
 
@@ -140,234 +145,10 @@
           <a:chExt cx="0" cy="0"/>
         </a:xfrm>
       </p:grpSpPr>
-      <p:sp>
-        <p:nvSpPr>
-          <p:cNvPr id="2" name="Header Placeholder 1"/>
-          <p:cNvSpPr>
-            <a:spLocks noGrp="1"/>
-          </p:cNvSpPr>
-          <p:nvPr>
-            <p:ph type="hdr" sz="quarter"/>
-          </p:nvPr>
-        </p:nvSpPr>
-        <p:spPr>
-          <a:xfrm>
-            <a:off x="0" y="0"/>
-            <a:ext cx="2971800" cy="458788"/>
-          </a:xfrm>
-          <a:prstGeom prst="rect">
-            <a:avLst/>
-          </a:prstGeom>
-        </p:spPr>
-        <p:txBody>
-          <a:bodyPr vert="horz" lIns="91440" tIns="45720" rIns="91440" bIns="45720" rtlCol="0"/>
-          <a:lstStyle>
-            <a:lvl1pPr algn="l">
-              <a:defRPr sz="1200"/>
-            </a:lvl1pPr>
-          </a:lstStyle>
-          <a:p>
-            <a:endParaRPr lang="en-US"/>
-          </a:p>
-        </p:txBody>
-      </p:sp>
-      <p:sp>
-        <p:nvSpPr>
-          <p:cNvPr id="3" name="Date Placeholder 2"/>
-          <p:cNvSpPr>
-            <a:spLocks noGrp="1"/>
-          </p:cNvSpPr>
-          <p:nvPr>
-            <p:ph type="dt" idx="1"/>
-          </p:nvPr>
-        </p:nvSpPr>
-        <p:spPr>
-          <a:xfrm>
-            <a:off x="3884613" y="0"/>
-            <a:ext cx="2971800" cy="458788"/>
-          </a:xfrm>
-          <a:prstGeom prst="rect">
-            <a:avLst/>
-          </a:prstGeom>
-        </p:spPr>
-        <p:txBody>
-          <a:bodyPr vert="horz" lIns="91440" tIns="45720" rIns="91440" bIns="45720" rtlCol="0"/>
-          <a:lstStyle>
-            <a:lvl1pPr algn="r">
-              <a:defRPr sz="1200"/>
-            </a:lvl1pPr>
-          </a:lstStyle>
-          <a:p>
-            <a:fld id="{5282F153-3F37-0F45-9E97-73ACFA13230C}" type="datetimeFigureOut">
-              <a:rPr lang="en-US"/>
-              <a:t>7/23/19</a:t>
-            </a:fld>
-            <a:endParaRPr lang="en-US"/>
-          </a:p>
-        </p:txBody>
-      </p:sp>
-      <p:sp>
-        <p:nvSpPr>
-          <p:cNvPr id="4" name="Slide Image Placeholder 3"/>
-          <p:cNvSpPr>
-            <a:spLocks noGrp="1" noRot="1" noChangeAspect="1"/>
-          </p:cNvSpPr>
-          <p:nvPr>
-            <p:ph type="sldImg" idx="2"/>
-          </p:nvPr>
-        </p:nvSpPr>
-        <p:spPr>
-          <a:xfrm>
-            <a:off x="685800" y="1143000"/>
-            <a:ext cx="5486400" cy="3086100"/>
-          </a:xfrm>
-          <a:prstGeom prst="rect">
-            <a:avLst/>
-          </a:prstGeom>
-          <a:noFill/>
-          <a:ln w="12700">
-            <a:solidFill>
-              <a:prstClr val="black"/>
-            </a:solidFill>
-          </a:ln>
-        </p:spPr>
-        <p:txBody>
-          <a:bodyPr vert="horz" lIns="91440" tIns="45720" rIns="91440" bIns="45720" rtlCol="0" anchor="ctr"/>
-          <a:lstStyle/>
-          <a:p>
-            <a:endParaRPr lang="en-US"/>
-          </a:p>
-        </p:txBody>
-      </p:sp>
-      <p:sp>
-        <p:nvSpPr>
-          <p:cNvPr id="5" name="Notes Placeholder 4"/>
-          <p:cNvSpPr>
-            <a:spLocks noGrp="1"/>
-          </p:cNvSpPr>
-          <p:nvPr>
-            <p:ph type="body" sz="quarter" idx="3"/>
-          </p:nvPr>
-        </p:nvSpPr>
-        <p:spPr>
-          <a:xfrm>
-            <a:off x="685800" y="4400550"/>
-            <a:ext cx="5486400" cy="3600450"/>
-          </a:xfrm>
-          <a:prstGeom prst="rect">
-            <a:avLst/>
-          </a:prstGeom>
-        </p:spPr>
-        <p:txBody>
-          <a:bodyPr vert="horz" lIns="91440" tIns="45720" rIns="91440" bIns="45720" rtlCol="0"/>
-          <a:lstStyle/>
-          <a:p>
-            <a:pPr lvl="0"/>
-            <a:r>
-              <a:rPr lang="en-US"/>
-              <a:t>Click to edit Master text styles</a:t>
-            </a:r>
-          </a:p>
-          <a:p>
-            <a:pPr lvl="1"/>
-            <a:r>
-              <a:rPr lang="en-US"/>
-              <a:t>Second level</a:t>
-            </a:r>
-          </a:p>
-          <a:p>
-            <a:pPr lvl="2"/>
-            <a:r>
-              <a:rPr lang="en-US"/>
-              <a:t>Third level</a:t>
-            </a:r>
-          </a:p>
-          <a:p>
-            <a:pPr lvl="3"/>
-            <a:r>
-              <a:rPr lang="en-US"/>
-              <a:t>Fourth level</a:t>
-            </a:r>
-          </a:p>
-          <a:p>
-            <a:pPr lvl="4"/>
-            <a:r>
-              <a:rPr lang="en-US"/>
-              <a:t>Fifth level</a:t>
-            </a:r>
-          </a:p>
-        </p:txBody>
-      </p:sp>
-      <p:sp>
-        <p:nvSpPr>
-          <p:cNvPr id="6" name="Footer Placeholder 5"/>
-          <p:cNvSpPr>
-            <a:spLocks noGrp="1"/>
-          </p:cNvSpPr>
-          <p:nvPr>
-            <p:ph type="ftr" sz="quarter" idx="4"/>
-          </p:nvPr>
-        </p:nvSpPr>
-        <p:spPr>
-          <a:xfrm>
-            <a:off x="0" y="8685213"/>
-            <a:ext cx="2971800" cy="458787"/>
-          </a:xfrm>
-          <a:prstGeom prst="rect">
-            <a:avLst/>
-          </a:prstGeom>
-        </p:spPr>
-        <p:txBody>
-          <a:bodyPr vert="horz" lIns="91440" tIns="45720" rIns="91440" bIns="45720" rtlCol="0" anchor="b"/>
-          <a:lstStyle>
-            <a:lvl1pPr algn="l">
-              <a:defRPr sz="1200"/>
-            </a:lvl1pPr>
-          </a:lstStyle>
-          <a:p>
-            <a:endParaRPr lang="en-US"/>
-          </a:p>
-        </p:txBody>
-      </p:sp>
-      <p:sp>
-        <p:nvSpPr>
-          <p:cNvPr id="7" name="Slide Number Placeholder 6"/>
-          <p:cNvSpPr>
-            <a:spLocks noGrp="1"/>
-          </p:cNvSpPr>
-          <p:nvPr>
-            <p:ph type="sldNum" sz="quarter" idx="5"/>
-          </p:nvPr>
-        </p:nvSpPr>
-        <p:spPr>
-          <a:xfrm>
-            <a:off x="3884613" y="8685213"/>
-            <a:ext cx="2971800" cy="458787"/>
-          </a:xfrm>
-          <a:prstGeom prst="rect">
-            <a:avLst/>
-          </a:prstGeom>
-        </p:spPr>
-        <p:txBody>
-          <a:bodyPr vert="horz" lIns="91440" tIns="45720" rIns="91440" bIns="45720" rtlCol="0" anchor="b"/>
-          <a:lstStyle>
-            <a:lvl1pPr algn="r">
-              <a:defRPr sz="1200"/>
-            </a:lvl1pPr>
-          </a:lstStyle>
-          <a:p>
-            <a:fld id="{CE5E9CC1-C706-0F49-92D6-E571CC5EEA8F}" type="slidenum">
-              <a:rPr lang="en-US"/>
-              <a:t>‹#›</a:t>
-            </a:fld>
-            <a:endParaRPr lang="en-US"/>
-          </a:p>
-        </p:txBody>
-      </p:sp>
     </p:spTree>
     <p:extLst>
       <p:ext uri="{BB962C8B-B14F-4D97-AF65-F5344CB8AC3E}">
-        <p14:creationId xmlns:p14="http://schemas.microsoft.com/office/powerpoint/2010/main" val="1024086991"/>
+        <p14:creationId xmlns:p14="http://schemas.microsoft.com/office/powerpoint/2010/main" val="4055006679"/>
       </p:ext>
     </p:extLst>
   </p:cSld>
@@ -511,10 +292,6 @@
           <a:bodyPr/>
           <a:lstStyle/>
           <a:p>
-            <a:r>
-              <a:rPr lang="en-US" dirty="0"/>
-              <a:t/>
-            </a:r>
             <a:endParaRPr lang="en-US" dirty="0"/>
           </a:p>
         </p:txBody>
@@ -599,10 +376,6 @@
           <a:bodyPr/>
           <a:lstStyle/>
           <a:p>
-            <a:r>
-              <a:rPr lang="en-US" dirty="0"/>
-              <a:t/>
-            </a:r>
             <a:endParaRPr lang="en-US" dirty="0"/>
           </a:p>
         </p:txBody>
@@ -687,10 +460,6 @@
           <a:bodyPr/>
           <a:lstStyle/>
           <a:p>
-            <a:r>
-              <a:rPr lang="en-US" dirty="0"/>
-              <a:t/>
-            </a:r>
             <a:endParaRPr lang="en-US" dirty="0"/>
           </a:p>
         </p:txBody>
@@ -775,10 +544,6 @@
           <a:bodyPr/>
           <a:lstStyle/>
           <a:p>
-            <a:r>
-              <a:rPr lang="en-US" dirty="0"/>
-              <a:t/>
-            </a:r>
             <a:endParaRPr lang="en-US" dirty="0"/>
           </a:p>
         </p:txBody>
@@ -863,10 +628,6 @@
           <a:bodyPr/>
           <a:lstStyle/>
           <a:p>
-            <a:r>
-              <a:rPr lang="en-US" dirty="0"/>
-              <a:t/>
-            </a:r>
             <a:endParaRPr lang="en-US" dirty="0"/>
           </a:p>
         </p:txBody>
@@ -951,10 +712,6 @@
           <a:bodyPr/>
           <a:lstStyle/>
           <a:p>
-            <a:r>
-              <a:rPr lang="en-US" dirty="0"/>
-              <a:t/>
-            </a:r>
             <a:endParaRPr lang="en-US" dirty="0"/>
           </a:p>
         </p:txBody>
@@ -1039,10 +796,6 @@
           <a:bodyPr/>
           <a:lstStyle/>
           <a:p>
-            <a:r>
-              <a:rPr lang="en-US" dirty="0"/>
-              <a:t/>
-            </a:r>
             <a:endParaRPr lang="en-US" dirty="0"/>
           </a:p>
         </p:txBody>
@@ -1127,10 +880,6 @@
           <a:bodyPr/>
           <a:lstStyle/>
           <a:p>
-            <a:r>
-              <a:rPr lang="en-US" dirty="0"/>
-              <a:t/>
-            </a:r>
             <a:endParaRPr lang="en-US" dirty="0"/>
           </a:p>
         </p:txBody>
@@ -1215,10 +964,6 @@
           <a:bodyPr/>
           <a:lstStyle/>
           <a:p>
-            <a:r>
-              <a:rPr lang="en-US" dirty="0"/>
-              <a:t/>
-            </a:r>
             <a:endParaRPr lang="en-US" dirty="0"/>
           </a:p>
         </p:txBody>
@@ -1303,10 +1048,6 @@
           <a:bodyPr/>
           <a:lstStyle/>
           <a:p>
-            <a:r>
-              <a:rPr lang="en-US" dirty="0"/>
-              <a:t/>
-            </a:r>
             <a:endParaRPr lang="en-US" dirty="0"/>
           </a:p>
         </p:txBody>
@@ -1391,10 +1132,6 @@
           <a:bodyPr/>
           <a:lstStyle/>
           <a:p>
-            <a:r>
-              <a:rPr lang="en-US" dirty="0"/>
-              <a:t/>
-            </a:r>
             <a:endParaRPr lang="en-US" dirty="0"/>
           </a:p>
         </p:txBody>
@@ -1479,10 +1216,6 @@
           <a:bodyPr/>
           <a:lstStyle/>
           <a:p>
-            <a:r>
-              <a:rPr lang="en-US" dirty="0"/>
-              <a:t/>
-            </a:r>
             <a:endParaRPr lang="en-US" dirty="0"/>
           </a:p>
         </p:txBody>
@@ -1556,6 +1289,11 @@
 <file path=ppt/slideMasters/slideMaster1.xml><?xml version="1.0" encoding="utf-8"?>
 <p:sldMaster xmlns:a="http://schemas.openxmlformats.org/drawingml/2006/main" xmlns:r="http://schemas.openxmlformats.org/officeDocument/2006/relationships" xmlns:p="http://schemas.openxmlformats.org/presentationml/2006/main">
   <p:cSld>
+    <p:bg>
+      <p:bgRef idx="1001">
+        <a:schemeClr val="bg1"/>
+      </p:bgRef>
+    </p:bg>
     <p:spTree>
       <p:nvGrpSpPr>
         <p:cNvPr id="1" name=""/>
@@ -1838,6 +1576,7 @@
         <a:solidFill>
           <a:srgbClr val="0B132B"/>
         </a:solidFill>
+        <a:effectLst/>
       </p:bgPr>
     </p:bg>
     <p:spTree>
@@ -1881,7 +1620,7 @@
           <a:bodyPr wrap="square" rtlCol="0" anchor="ctr"/>
           <a:lstStyle/>
           <a:p>
-            <a:pPr indent="0" marL="0">
+            <a:pPr marL="0" indent="0">
               <a:buNone/>
             </a:pPr>
             <a:endParaRPr lang="en-US" dirty="0"/>
@@ -1909,7 +1648,7 @@
           <a:bodyPr wrap="square" rtlCol="0" anchor="ctr"/>
           <a:lstStyle/>
           <a:p>
-            <a:pPr algn="r" indent="0" marL="0">
+            <a:pPr marL="0" indent="0" algn="r">
               <a:buNone/>
             </a:pPr>
             <a:r>
@@ -1948,7 +1687,7 @@
           <a:bodyPr wrap="square" lIns="0" tIns="0" rIns="0" bIns="0" rtlCol="0" anchor="ctr"/>
           <a:lstStyle/>
           <a:p>
-            <a:pPr indent="0" marL="0">
+            <a:pPr marL="0" indent="0">
               <a:buNone/>
             </a:pPr>
             <a:r>
@@ -1987,7 +1726,7 @@
           <a:bodyPr wrap="square" lIns="0" tIns="0" rIns="0" bIns="0" rtlCol="0" anchor="ctr"/>
           <a:lstStyle/>
           <a:p>
-            <a:pPr indent="0" marL="0">
+            <a:pPr marL="0" indent="0">
               <a:buNone/>
             </a:pPr>
             <a:r>
@@ -2007,130 +1746,14 @@
       </p:sp>
       <p:sp>
         <p:nvSpPr>
-          <p:cNvPr id="6" name="Text 4"/>
-          <p:cNvSpPr/>
-          <p:nvPr/>
-        </p:nvSpPr>
-        <p:spPr>
-          <a:xfrm>
-            <a:off x="658368" y="2788920"/>
-            <a:ext cx="5669280" cy="1920240"/>
-          </a:xfrm>
-          <a:prstGeom prst="rect">
-            <a:avLst/>
-          </a:prstGeom>
-          <a:solidFill>
-            <a:srgbClr val="1C2541"/>
-          </a:solidFill>
-          <a:ln>
-            <a:solidFill>
-              <a:srgbClr val="314167"/>
-            </a:solidFill>
-          </a:ln>
-        </p:spPr>
-        <p:txBody>
-          <a:bodyPr wrap="square" rtlCol="0" anchor="ctr"/>
-          <a:lstStyle/>
-          <a:p>
-            <a:pPr indent="0" marL="0">
-              <a:buNone/>
-            </a:pPr>
-            <a:endParaRPr lang="en-US" dirty="0"/>
-          </a:p>
-        </p:txBody>
-      </p:sp>
-      <p:sp>
-        <p:nvSpPr>
-          <p:cNvPr id="7" name="Text 5"/>
-          <p:cNvSpPr/>
-          <p:nvPr/>
-        </p:nvSpPr>
-        <p:spPr>
-          <a:xfrm>
-            <a:off x="859536" y="2953512"/>
-            <a:ext cx="5266944" cy="274320"/>
-          </a:xfrm>
-          <a:prstGeom prst="rect">
-            <a:avLst/>
-          </a:prstGeom>
-          <a:noFill/>
-          <a:ln/>
-        </p:spPr>
-        <p:txBody>
-          <a:bodyPr wrap="square" lIns="0" tIns="0" rIns="0" bIns="0" rtlCol="0" anchor="ctr">
-            <a:normAutofit/>
-          </a:bodyPr>
-          <a:lstStyle/>
-          <a:p>
-            <a:pPr indent="0" marL="0">
-              <a:buNone/>
-            </a:pPr>
-            <a:r>
-              <a:rPr lang="en-US" sz="1300" b="1" dirty="0">
-                <a:solidFill>
-                  <a:srgbClr val="F8FAFC"/>
-                </a:solidFill>
-                <a:latin typeface="Aptos" pitchFamily="34" charset="0"/>
-                <a:ea typeface="Aptos" pitchFamily="34" charset="-122"/>
-                <a:cs typeface="Aptos" pitchFamily="34" charset="-120"/>
-              </a:rPr>
-              <a:t>What this deck now does better</a:t>
-            </a:r>
-            <a:endParaRPr lang="en-US" sz="1300" dirty="0"/>
-          </a:p>
-        </p:txBody>
-      </p:sp>
-      <p:sp>
-        <p:nvSpPr>
-          <p:cNvPr id="8" name="Text 6"/>
-          <p:cNvSpPr/>
-          <p:nvPr/>
-        </p:nvSpPr>
-        <p:spPr>
-          <a:xfrm>
-            <a:off x="859536" y="3291840"/>
-            <a:ext cx="5266944" cy="1261872"/>
-          </a:xfrm>
-          <a:prstGeom prst="rect">
-            <a:avLst/>
-          </a:prstGeom>
-          <a:noFill/>
-          <a:ln/>
-        </p:spPr>
-        <p:txBody>
-          <a:bodyPr wrap="square" lIns="0" tIns="0" rIns="0" bIns="0" rtlCol="0" anchor="t">
-            <a:normAutofit/>
-          </a:bodyPr>
-          <a:lstStyle/>
-          <a:p>
-            <a:pPr indent="0" marL="0">
-              <a:buNone/>
-            </a:pPr>
-            <a:r>
-              <a:rPr lang="en-US" sz="1100" dirty="0">
-                <a:solidFill>
-                  <a:srgbClr val="C9D1E0"/>
-                </a:solidFill>
-                <a:latin typeface="Aptos" pitchFamily="34" charset="0"/>
-                <a:ea typeface="Aptos" pitchFamily="34" charset="-122"/>
-                <a:cs typeface="Aptos" pitchFamily="34" charset="-120"/>
-              </a:rPr>
-              <a:t>Sharpens the problem, de-risks bold claims, shows what the prototype already proves, and frames RenterShield as a credible early-stage venture rather than just a useful project.</a:t>
-            </a:r>
-            <a:endParaRPr lang="en-US" sz="1100" dirty="0"/>
-          </a:p>
-        </p:txBody>
-      </p:sp>
-      <p:sp>
-        <p:nvSpPr>
           <p:cNvPr id="9" name="Text 7"/>
           <p:cNvSpPr/>
           <p:nvPr/>
         </p:nvSpPr>
         <p:spPr>
           <a:xfrm>
-            <a:off x="6720840" y="987552"/>
-            <a:ext cx="4754880" cy="3721608"/>
+            <a:off x="658368" y="2363820"/>
+            <a:ext cx="10817352" cy="2345339"/>
           </a:xfrm>
           <a:prstGeom prst="rect">
             <a:avLst/>
@@ -2148,7 +1771,7 @@
           <a:bodyPr wrap="square" rtlCol="0" anchor="ctr"/>
           <a:lstStyle/>
           <a:p>
-            <a:pPr indent="0" marL="0">
+            <a:pPr marL="0" indent="0">
               <a:buNone/>
             </a:pPr>
             <a:endParaRPr lang="en-US" dirty="0"/>
@@ -2163,7 +1786,7 @@
         </p:nvSpPr>
         <p:spPr>
           <a:xfrm>
-            <a:off x="6922008" y="1152144"/>
+            <a:off x="871403" y="2521798"/>
             <a:ext cx="4352544" cy="274320"/>
           </a:xfrm>
           <a:prstGeom prst="rect">
@@ -2178,7 +1801,7 @@
           </a:bodyPr>
           <a:lstStyle/>
           <a:p>
-            <a:pPr indent="0" marL="0">
+            <a:pPr marL="0" indent="0">
               <a:buNone/>
             </a:pPr>
             <a:r>
@@ -2204,7 +1827,7 @@
         </p:nvSpPr>
         <p:spPr>
           <a:xfrm>
-            <a:off x="6922008" y="1490472"/>
+            <a:off x="871403" y="2860126"/>
             <a:ext cx="4352544" cy="3063240"/>
           </a:xfrm>
           <a:prstGeom prst="rect">
@@ -2219,7 +1842,7 @@
           </a:bodyPr>
           <a:lstStyle/>
           <a:p>
-            <a:pPr indent="0" marL="0">
+            <a:pPr marL="0" indent="0">
               <a:buNone/>
             </a:pPr>
             <a:r>
@@ -2236,13 +1859,13 @@
             <a:endParaRPr lang="en-US" sz="1100" dirty="0"/>
           </a:p>
           <a:p>
-            <a:pPr indent="0" marL="0">
+            <a:pPr marL="0" indent="0">
               <a:buNone/>
             </a:pPr>
             <a:endParaRPr lang="en-US" sz="1100" dirty="0"/>
           </a:p>
           <a:p>
-            <a:pPr indent="0" marL="0">
+            <a:pPr marL="0" indent="0">
               <a:buNone/>
             </a:pPr>
             <a:r>
@@ -2259,7 +1882,7 @@
             <a:endParaRPr lang="en-US" sz="1100" dirty="0"/>
           </a:p>
           <a:p>
-            <a:pPr indent="0" marL="0">
+            <a:pPr marL="0" indent="0">
               <a:buNone/>
             </a:pPr>
             <a:r>
@@ -2276,7 +1899,7 @@
             <a:endParaRPr lang="en-US" sz="1100" dirty="0"/>
           </a:p>
           <a:p>
-            <a:pPr indent="0" marL="0">
+            <a:pPr marL="0" indent="0">
               <a:buNone/>
             </a:pPr>
             <a:r>
@@ -2293,7 +1916,7 @@
             <a:endParaRPr lang="en-US" sz="1100" dirty="0"/>
           </a:p>
           <a:p>
-            <a:pPr indent="0" marL="0">
+            <a:pPr marL="0" indent="0">
               <a:buNone/>
             </a:pPr>
             <a:r>
@@ -2310,7 +1933,7 @@
             <a:endParaRPr lang="en-US" sz="1100" dirty="0"/>
           </a:p>
           <a:p>
-            <a:pPr indent="0" marL="0">
+            <a:pPr marL="0" indent="0">
               <a:buNone/>
             </a:pPr>
             <a:r>
@@ -2349,7 +1972,7 @@
           <a:bodyPr wrap="square" lIns="0" tIns="0" rIns="0" bIns="0" rtlCol="0" anchor="ctr"/>
           <a:lstStyle/>
           <a:p>
-            <a:pPr indent="0" marL="0">
+            <a:pPr marL="0" indent="0">
               <a:buNone/>
             </a:pPr>
             <a:r>
@@ -2383,6 +2006,7 @@
         <a:solidFill>
           <a:srgbClr val="0B132B"/>
         </a:solidFill>
+        <a:effectLst/>
       </p:bgPr>
     </p:bg>
     <p:spTree>
@@ -2426,7 +2050,7 @@
           <a:bodyPr wrap="square" rtlCol="0" anchor="ctr"/>
           <a:lstStyle/>
           <a:p>
-            <a:pPr indent="0" marL="0">
+            <a:pPr marL="0" indent="0">
               <a:buNone/>
             </a:pPr>
             <a:endParaRPr lang="en-US" dirty="0"/>
@@ -2454,7 +2078,7 @@
           <a:bodyPr wrap="square" rtlCol="0" anchor="ctr"/>
           <a:lstStyle/>
           <a:p>
-            <a:pPr algn="r" indent="0" marL="0">
+            <a:pPr marL="0" indent="0" algn="r">
               <a:buNone/>
             </a:pPr>
             <a:r>
@@ -2493,7 +2117,7 @@
           <a:bodyPr wrap="square" rtlCol="0" anchor="ctr"/>
           <a:lstStyle/>
           <a:p>
-            <a:pPr indent="0" marL="0">
+            <a:pPr marL="0" indent="0">
               <a:buNone/>
             </a:pPr>
             <a:r>
@@ -2534,7 +2158,7 @@
           </a:bodyPr>
           <a:lstStyle/>
           <a:p>
-            <a:pPr indent="0" marL="0">
+            <a:pPr marL="0" indent="0">
               <a:buNone/>
             </a:pPr>
             <a:r>
@@ -2579,7 +2203,7 @@
           <a:bodyPr wrap="square" rtlCol="0" anchor="ctr"/>
           <a:lstStyle/>
           <a:p>
-            <a:pPr indent="0" marL="0">
+            <a:pPr marL="0" indent="0">
               <a:buNone/>
             </a:pPr>
             <a:endParaRPr lang="en-US" dirty="0"/>
@@ -2609,7 +2233,7 @@
           </a:bodyPr>
           <a:lstStyle/>
           <a:p>
-            <a:pPr indent="0" marL="0">
+            <a:pPr marL="0" indent="0">
               <a:buNone/>
             </a:pPr>
             <a:r>
@@ -2650,7 +2274,7 @@
           </a:bodyPr>
           <a:lstStyle/>
           <a:p>
-            <a:pPr indent="0" marL="0">
+            <a:pPr marL="0" indent="0">
               <a:buNone/>
             </a:pPr>
             <a:r>
@@ -2667,7 +2291,7 @@
             <a:endParaRPr lang="en-US" sz="1100" dirty="0"/>
           </a:p>
           <a:p>
-            <a:pPr indent="0" marL="0">
+            <a:pPr marL="0" indent="0">
               <a:buNone/>
             </a:pPr>
             <a:r>
@@ -2712,7 +2336,7 @@
           <a:bodyPr wrap="square" rtlCol="0" anchor="ctr"/>
           <a:lstStyle/>
           <a:p>
-            <a:pPr indent="0" marL="0">
+            <a:pPr marL="0" indent="0">
               <a:buNone/>
             </a:pPr>
             <a:endParaRPr lang="en-US" dirty="0"/>
@@ -2742,7 +2366,7 @@
           </a:bodyPr>
           <a:lstStyle/>
           <a:p>
-            <a:pPr indent="0" marL="0">
+            <a:pPr marL="0" indent="0">
               <a:buNone/>
             </a:pPr>
             <a:r>
@@ -2783,7 +2407,7 @@
           </a:bodyPr>
           <a:lstStyle/>
           <a:p>
-            <a:pPr indent="0" marL="0">
+            <a:pPr marL="0" indent="0">
               <a:buNone/>
             </a:pPr>
             <a:r>
@@ -2800,7 +2424,7 @@
             <a:endParaRPr lang="en-US" sz="1100" dirty="0"/>
           </a:p>
           <a:p>
-            <a:pPr indent="0" marL="0">
+            <a:pPr marL="0" indent="0">
               <a:buNone/>
             </a:pPr>
             <a:r>
@@ -2845,7 +2469,7 @@
           <a:bodyPr wrap="square" rtlCol="0" anchor="ctr"/>
           <a:lstStyle/>
           <a:p>
-            <a:pPr indent="0" marL="0">
+            <a:pPr marL="0" indent="0">
               <a:buNone/>
             </a:pPr>
             <a:endParaRPr lang="en-US" dirty="0"/>
@@ -2875,7 +2499,7 @@
           </a:bodyPr>
           <a:lstStyle/>
           <a:p>
-            <a:pPr indent="0" marL="0">
+            <a:pPr marL="0" indent="0">
               <a:buNone/>
             </a:pPr>
             <a:r>
@@ -2916,7 +2540,7 @@
           </a:bodyPr>
           <a:lstStyle/>
           <a:p>
-            <a:pPr indent="0" marL="0">
+            <a:pPr marL="0" indent="0">
               <a:buNone/>
             </a:pPr>
             <a:r>
@@ -2933,7 +2557,7 @@
             <a:endParaRPr lang="en-US" sz="1100" dirty="0"/>
           </a:p>
           <a:p>
-            <a:pPr indent="0" marL="0">
+            <a:pPr marL="0" indent="0">
               <a:buNone/>
             </a:pPr>
             <a:r>
@@ -2978,7 +2602,7 @@
           <a:bodyPr wrap="square" rtlCol="0" anchor="ctr"/>
           <a:lstStyle/>
           <a:p>
-            <a:pPr indent="0" marL="0">
+            <a:pPr marL="0" indent="0">
               <a:buNone/>
             </a:pPr>
             <a:endParaRPr lang="en-US" dirty="0"/>
@@ -3008,7 +2632,7 @@
           </a:bodyPr>
           <a:lstStyle/>
           <a:p>
-            <a:pPr indent="0" marL="0">
+            <a:pPr marL="0" indent="0">
               <a:buNone/>
             </a:pPr>
             <a:r>
@@ -3049,7 +2673,7 @@
           </a:bodyPr>
           <a:lstStyle/>
           <a:p>
-            <a:pPr indent="0" marL="0">
+            <a:pPr marL="0" indent="0">
               <a:buNone/>
             </a:pPr>
             <a:r>
@@ -3066,7 +2690,7 @@
             <a:endParaRPr lang="en-US" sz="1100" dirty="0"/>
           </a:p>
           <a:p>
-            <a:pPr indent="0" marL="0">
+            <a:pPr marL="0" indent="0">
               <a:buNone/>
             </a:pPr>
             <a:r>
@@ -3111,7 +2735,7 @@
           <a:bodyPr wrap="square" rtlCol="0" anchor="ctr"/>
           <a:lstStyle/>
           <a:p>
-            <a:pPr indent="0" marL="0">
+            <a:pPr marL="0" indent="0">
               <a:buNone/>
             </a:pPr>
             <a:endParaRPr lang="en-US" dirty="0"/>
@@ -3141,7 +2765,7 @@
           </a:bodyPr>
           <a:lstStyle/>
           <a:p>
-            <a:pPr indent="0" marL="0">
+            <a:pPr marL="0" indent="0">
               <a:buNone/>
             </a:pPr>
             <a:r>
@@ -3182,7 +2806,7 @@
           </a:bodyPr>
           <a:lstStyle/>
           <a:p>
-            <a:pPr indent="0" marL="0">
+            <a:pPr marL="0" indent="0">
               <a:buNone/>
             </a:pPr>
             <a:r>
@@ -3216,6 +2840,7 @@
         <a:solidFill>
           <a:srgbClr val="0B132B"/>
         </a:solidFill>
+        <a:effectLst/>
       </p:bgPr>
     </p:bg>
     <p:spTree>
@@ -3259,7 +2884,7 @@
           <a:bodyPr wrap="square" rtlCol="0" anchor="ctr"/>
           <a:lstStyle/>
           <a:p>
-            <a:pPr indent="0" marL="0">
+            <a:pPr marL="0" indent="0">
               <a:buNone/>
             </a:pPr>
             <a:endParaRPr lang="en-US" dirty="0"/>
@@ -3287,7 +2912,7 @@
           <a:bodyPr wrap="square" rtlCol="0" anchor="ctr"/>
           <a:lstStyle/>
           <a:p>
-            <a:pPr algn="r" indent="0" marL="0">
+            <a:pPr marL="0" indent="0" algn="r">
               <a:buNone/>
             </a:pPr>
             <a:r>
@@ -3326,7 +2951,7 @@
           <a:bodyPr wrap="square" rtlCol="0" anchor="ctr"/>
           <a:lstStyle/>
           <a:p>
-            <a:pPr indent="0" marL="0">
+            <a:pPr marL="0" indent="0">
               <a:buNone/>
             </a:pPr>
             <a:r>
@@ -3367,7 +2992,7 @@
           </a:bodyPr>
           <a:lstStyle/>
           <a:p>
-            <a:pPr indent="0" marL="0">
+            <a:pPr marL="0" indent="0">
               <a:buNone/>
             </a:pPr>
             <a:r>
@@ -3412,7 +3037,7 @@
           <a:bodyPr wrap="square" rtlCol="0" anchor="ctr"/>
           <a:lstStyle/>
           <a:p>
-            <a:pPr indent="0" marL="0">
+            <a:pPr marL="0" indent="0">
               <a:buNone/>
             </a:pPr>
             <a:endParaRPr lang="en-US" dirty="0"/>
@@ -3442,7 +3067,7 @@
           </a:bodyPr>
           <a:lstStyle/>
           <a:p>
-            <a:pPr indent="0" marL="0">
+            <a:pPr marL="0" indent="0">
               <a:buNone/>
             </a:pPr>
             <a:r>
@@ -3483,7 +3108,7 @@
           </a:bodyPr>
           <a:lstStyle/>
           <a:p>
-            <a:pPr indent="0" marL="0">
+            <a:pPr marL="0" indent="0">
               <a:buNone/>
             </a:pPr>
             <a:r>
@@ -3528,7 +3153,7 @@
           <a:bodyPr wrap="square" rtlCol="0" anchor="ctr"/>
           <a:lstStyle/>
           <a:p>
-            <a:pPr indent="0" marL="0">
+            <a:pPr marL="0" indent="0">
               <a:buNone/>
             </a:pPr>
             <a:endParaRPr lang="en-US" dirty="0"/>
@@ -3558,7 +3183,7 @@
           </a:bodyPr>
           <a:lstStyle/>
           <a:p>
-            <a:pPr indent="0" marL="0">
+            <a:pPr marL="0" indent="0">
               <a:buNone/>
             </a:pPr>
             <a:r>
@@ -3599,7 +3224,7 @@
           </a:bodyPr>
           <a:lstStyle/>
           <a:p>
-            <a:pPr indent="0" marL="0">
+            <a:pPr marL="0" indent="0">
               <a:buNone/>
             </a:pPr>
             <a:r>
@@ -3644,7 +3269,7 @@
           <a:bodyPr wrap="square" rtlCol="0" anchor="ctr"/>
           <a:lstStyle/>
           <a:p>
-            <a:pPr indent="0" marL="0">
+            <a:pPr marL="0" indent="0">
               <a:buNone/>
             </a:pPr>
             <a:endParaRPr lang="en-US" dirty="0"/>
@@ -3674,7 +3299,7 @@
           </a:bodyPr>
           <a:lstStyle/>
           <a:p>
-            <a:pPr indent="0" marL="0">
+            <a:pPr marL="0" indent="0">
               <a:buNone/>
             </a:pPr>
             <a:r>
@@ -3715,7 +3340,7 @@
           </a:bodyPr>
           <a:lstStyle/>
           <a:p>
-            <a:pPr indent="0" marL="0">
+            <a:pPr marL="0" indent="0">
               <a:buNone/>
             </a:pPr>
             <a:r>
@@ -3760,7 +3385,7 @@
           <a:bodyPr wrap="square" rtlCol="0" anchor="ctr"/>
           <a:lstStyle/>
           <a:p>
-            <a:pPr indent="0" marL="0">
+            <a:pPr marL="0" indent="0">
               <a:buNone/>
             </a:pPr>
             <a:endParaRPr lang="en-US" dirty="0"/>
@@ -3790,7 +3415,7 @@
           </a:bodyPr>
           <a:lstStyle/>
           <a:p>
-            <a:pPr indent="0" marL="0">
+            <a:pPr marL="0" indent="0">
               <a:buNone/>
             </a:pPr>
             <a:r>
@@ -3831,7 +3456,7 @@
           </a:bodyPr>
           <a:lstStyle/>
           <a:p>
-            <a:pPr indent="0" marL="0">
+            <a:pPr marL="0" indent="0">
               <a:buNone/>
             </a:pPr>
             <a:r>
@@ -3865,6 +3490,7 @@
         <a:solidFill>
           <a:srgbClr val="0B132B"/>
         </a:solidFill>
+        <a:effectLst/>
       </p:bgPr>
     </p:bg>
     <p:spTree>
@@ -3908,7 +3534,7 @@
           <a:bodyPr wrap="square" rtlCol="0" anchor="ctr"/>
           <a:lstStyle/>
           <a:p>
-            <a:pPr indent="0" marL="0">
+            <a:pPr marL="0" indent="0">
               <a:buNone/>
             </a:pPr>
             <a:endParaRPr lang="en-US" dirty="0"/>
@@ -3936,7 +3562,7 @@
           <a:bodyPr wrap="square" rtlCol="0" anchor="ctr"/>
           <a:lstStyle/>
           <a:p>
-            <a:pPr algn="r" indent="0" marL="0">
+            <a:pPr marL="0" indent="0" algn="r">
               <a:buNone/>
             </a:pPr>
             <a:r>
@@ -3975,7 +3601,7 @@
           <a:bodyPr wrap="square" rtlCol="0" anchor="ctr"/>
           <a:lstStyle/>
           <a:p>
-            <a:pPr indent="0" marL="0">
+            <a:pPr marL="0" indent="0">
               <a:buNone/>
             </a:pPr>
             <a:r>
@@ -4016,7 +3642,7 @@
           </a:bodyPr>
           <a:lstStyle/>
           <a:p>
-            <a:pPr indent="0" marL="0">
+            <a:pPr marL="0" indent="0">
               <a:buNone/>
             </a:pPr>
             <a:r>
@@ -4061,7 +3687,7 @@
           <a:bodyPr wrap="square" rtlCol="0" anchor="ctr"/>
           <a:lstStyle/>
           <a:p>
-            <a:pPr indent="0" marL="0">
+            <a:pPr marL="0" indent="0">
               <a:buNone/>
             </a:pPr>
             <a:endParaRPr lang="en-US" dirty="0"/>
@@ -4091,7 +3717,7 @@
           </a:bodyPr>
           <a:lstStyle/>
           <a:p>
-            <a:pPr indent="0" marL="0">
+            <a:pPr marL="0" indent="0">
               <a:buNone/>
             </a:pPr>
             <a:r>
@@ -4132,7 +3758,7 @@
           </a:bodyPr>
           <a:lstStyle/>
           <a:p>
-            <a:pPr indent="0" marL="0">
+            <a:pPr marL="0" indent="0">
               <a:buNone/>
             </a:pPr>
             <a:r>
@@ -4177,7 +3803,7 @@
           <a:bodyPr wrap="square" rtlCol="0" anchor="ctr"/>
           <a:lstStyle/>
           <a:p>
-            <a:pPr indent="0" marL="0">
+            <a:pPr marL="0" indent="0">
               <a:buNone/>
             </a:pPr>
             <a:endParaRPr lang="en-US" dirty="0"/>
@@ -4207,7 +3833,7 @@
           </a:bodyPr>
           <a:lstStyle/>
           <a:p>
-            <a:pPr indent="0" marL="0">
+            <a:pPr marL="0" indent="0">
               <a:buNone/>
             </a:pPr>
             <a:r>
@@ -4248,7 +3874,7 @@
           </a:bodyPr>
           <a:lstStyle/>
           <a:p>
-            <a:pPr indent="0" marL="0">
+            <a:pPr marL="0" indent="0">
               <a:buNone/>
             </a:pPr>
             <a:r>
@@ -4293,7 +3919,7 @@
           <a:bodyPr wrap="square" rtlCol="0" anchor="ctr"/>
           <a:lstStyle/>
           <a:p>
-            <a:pPr indent="0" marL="0">
+            <a:pPr marL="0" indent="0">
               <a:buNone/>
             </a:pPr>
             <a:endParaRPr lang="en-US" dirty="0"/>
@@ -4323,7 +3949,7 @@
           </a:bodyPr>
           <a:lstStyle/>
           <a:p>
-            <a:pPr indent="0" marL="0">
+            <a:pPr marL="0" indent="0">
               <a:buNone/>
             </a:pPr>
             <a:r>
@@ -4364,7 +3990,7 @@
           </a:bodyPr>
           <a:lstStyle/>
           <a:p>
-            <a:pPr indent="0" marL="0">
+            <a:pPr marL="0" indent="0">
               <a:buNone/>
             </a:pPr>
             <a:r>
@@ -4390,7 +4016,7 @@
         </p:nvSpPr>
         <p:spPr>
           <a:xfrm>
-            <a:off x="658368" y="4480560"/>
+            <a:off x="572104" y="4448556"/>
             <a:ext cx="10881360" cy="841248"/>
           </a:xfrm>
           <a:prstGeom prst="rect">
@@ -4409,7 +4035,7 @@
           <a:bodyPr wrap="square" rtlCol="0" anchor="ctr"/>
           <a:lstStyle/>
           <a:p>
-            <a:pPr indent="0" marL="0">
+            <a:pPr marL="0" indent="0">
               <a:buNone/>
             </a:pPr>
             <a:endParaRPr lang="en-US" dirty="0"/>
@@ -4439,7 +4065,7 @@
           </a:bodyPr>
           <a:lstStyle/>
           <a:p>
-            <a:pPr indent="0" marL="0">
+            <a:pPr marL="0" indent="0">
               <a:buNone/>
             </a:pPr>
             <a:r>
@@ -4480,7 +4106,7 @@
           </a:bodyPr>
           <a:lstStyle/>
           <a:p>
-            <a:pPr indent="0" marL="0">
+            <a:pPr marL="0" indent="0">
               <a:buNone/>
             </a:pPr>
             <a:r>
@@ -4514,6 +4140,7 @@
         <a:solidFill>
           <a:srgbClr val="0B132B"/>
         </a:solidFill>
+        <a:effectLst/>
       </p:bgPr>
     </p:bg>
     <p:spTree>
@@ -4557,7 +4184,7 @@
           <a:bodyPr wrap="square" rtlCol="0" anchor="ctr"/>
           <a:lstStyle/>
           <a:p>
-            <a:pPr indent="0" marL="0">
+            <a:pPr marL="0" indent="0">
               <a:buNone/>
             </a:pPr>
             <a:endParaRPr lang="en-US" dirty="0"/>
@@ -4585,7 +4212,7 @@
           <a:bodyPr wrap="square" rtlCol="0" anchor="ctr"/>
           <a:lstStyle/>
           <a:p>
-            <a:pPr algn="r" indent="0" marL="0">
+            <a:pPr marL="0" indent="0" algn="r">
               <a:buNone/>
             </a:pPr>
             <a:r>
@@ -4624,7 +4251,7 @@
           <a:bodyPr wrap="square" rtlCol="0" anchor="ctr"/>
           <a:lstStyle/>
           <a:p>
-            <a:pPr indent="0" marL="0">
+            <a:pPr marL="0" indent="0">
               <a:buNone/>
             </a:pPr>
             <a:r>
@@ -4665,7 +4292,7 @@
           </a:bodyPr>
           <a:lstStyle/>
           <a:p>
-            <a:pPr indent="0" marL="0">
+            <a:pPr marL="0" indent="0">
               <a:buNone/>
             </a:pPr>
             <a:r>
@@ -4710,7 +4337,7 @@
           <a:bodyPr wrap="square" rtlCol="0" anchor="ctr"/>
           <a:lstStyle/>
           <a:p>
-            <a:pPr indent="0" marL="0">
+            <a:pPr marL="0" indent="0">
               <a:buNone/>
             </a:pPr>
             <a:endParaRPr lang="en-US" dirty="0"/>
@@ -4738,7 +4365,7 @@
           <a:bodyPr wrap="square" lIns="0" tIns="0" rIns="0" bIns="0" rtlCol="0" anchor="ctr"/>
           <a:lstStyle/>
           <a:p>
-            <a:pPr indent="0" marL="0">
+            <a:pPr marL="0" indent="0">
               <a:buNone/>
             </a:pPr>
             <a:r>
@@ -4779,7 +4406,7 @@
           </a:bodyPr>
           <a:lstStyle/>
           <a:p>
-            <a:pPr indent="0" marL="0">
+            <a:pPr marL="0" indent="0">
               <a:buNone/>
             </a:pPr>
             <a:r>
@@ -4824,7 +4451,7 @@
           <a:bodyPr wrap="square" rtlCol="0" anchor="ctr"/>
           <a:lstStyle/>
           <a:p>
-            <a:pPr indent="0" marL="0">
+            <a:pPr marL="0" indent="0">
               <a:buNone/>
             </a:pPr>
             <a:endParaRPr lang="en-US" dirty="0"/>
@@ -4852,7 +4479,7 @@
           <a:bodyPr wrap="square" lIns="0" tIns="0" rIns="0" bIns="0" rtlCol="0" anchor="ctr"/>
           <a:lstStyle/>
           <a:p>
-            <a:pPr indent="0" marL="0">
+            <a:pPr marL="0" indent="0">
               <a:buNone/>
             </a:pPr>
             <a:r>
@@ -4893,7 +4520,7 @@
           </a:bodyPr>
           <a:lstStyle/>
           <a:p>
-            <a:pPr indent="0" marL="0">
+            <a:pPr marL="0" indent="0">
               <a:buNone/>
             </a:pPr>
             <a:r>
@@ -4938,7 +4565,7 @@
           <a:bodyPr wrap="square" rtlCol="0" anchor="ctr"/>
           <a:lstStyle/>
           <a:p>
-            <a:pPr indent="0" marL="0">
+            <a:pPr marL="0" indent="0">
               <a:buNone/>
             </a:pPr>
             <a:endParaRPr lang="en-US" dirty="0"/>
@@ -4966,7 +4593,7 @@
           <a:bodyPr wrap="square" lIns="0" tIns="0" rIns="0" bIns="0" rtlCol="0" anchor="ctr"/>
           <a:lstStyle/>
           <a:p>
-            <a:pPr indent="0" marL="0">
+            <a:pPr marL="0" indent="0">
               <a:buNone/>
             </a:pPr>
             <a:r>
@@ -5007,7 +4634,7 @@
           </a:bodyPr>
           <a:lstStyle/>
           <a:p>
-            <a:pPr indent="0" marL="0">
+            <a:pPr marL="0" indent="0">
               <a:buNone/>
             </a:pPr>
             <a:r>
@@ -5052,7 +4679,7 @@
           <a:bodyPr wrap="square" rtlCol="0" anchor="ctr"/>
           <a:lstStyle/>
           <a:p>
-            <a:pPr indent="0" marL="0">
+            <a:pPr marL="0" indent="0">
               <a:buNone/>
             </a:pPr>
             <a:endParaRPr lang="en-US" dirty="0"/>
@@ -5082,7 +4709,7 @@
           </a:bodyPr>
           <a:lstStyle/>
           <a:p>
-            <a:pPr indent="0" marL="0">
+            <a:pPr marL="0" indent="0">
               <a:buNone/>
             </a:pPr>
             <a:r>
@@ -5123,7 +4750,7 @@
           </a:bodyPr>
           <a:lstStyle/>
           <a:p>
-            <a:pPr indent="0" marL="0">
+            <a:pPr marL="0" indent="0">
               <a:buNone/>
             </a:pPr>
             <a:r>
@@ -5168,7 +4795,7 @@
           <a:bodyPr wrap="square" rtlCol="0" anchor="ctr"/>
           <a:lstStyle/>
           <a:p>
-            <a:pPr indent="0" marL="0">
+            <a:pPr marL="0" indent="0">
               <a:buNone/>
             </a:pPr>
             <a:endParaRPr lang="en-US" dirty="0"/>
@@ -5198,7 +4825,7 @@
           </a:bodyPr>
           <a:lstStyle/>
           <a:p>
-            <a:pPr indent="0" marL="0">
+            <a:pPr marL="0" indent="0">
               <a:buNone/>
             </a:pPr>
             <a:r>
@@ -5239,7 +4866,7 @@
           </a:bodyPr>
           <a:lstStyle/>
           <a:p>
-            <a:pPr indent="0" marL="0">
+            <a:pPr marL="0" indent="0">
               <a:buNone/>
             </a:pPr>
             <a:r>
@@ -5273,6 +4900,7 @@
         <a:solidFill>
           <a:srgbClr val="0B132B"/>
         </a:solidFill>
+        <a:effectLst/>
       </p:bgPr>
     </p:bg>
     <p:spTree>
@@ -5316,7 +4944,7 @@
           <a:bodyPr wrap="square" rtlCol="0" anchor="ctr"/>
           <a:lstStyle/>
           <a:p>
-            <a:pPr indent="0" marL="0">
+            <a:pPr marL="0" indent="0">
               <a:buNone/>
             </a:pPr>
             <a:endParaRPr lang="en-US" dirty="0"/>
@@ -5344,7 +4972,7 @@
           <a:bodyPr wrap="square" rtlCol="0" anchor="ctr"/>
           <a:lstStyle/>
           <a:p>
-            <a:pPr algn="r" indent="0" marL="0">
+            <a:pPr marL="0" indent="0" algn="r">
               <a:buNone/>
             </a:pPr>
             <a:r>
@@ -5383,7 +5011,7 @@
           <a:bodyPr wrap="square" rtlCol="0" anchor="ctr"/>
           <a:lstStyle/>
           <a:p>
-            <a:pPr indent="0" marL="0">
+            <a:pPr marL="0" indent="0">
               <a:buNone/>
             </a:pPr>
             <a:r>
@@ -5424,7 +5052,7 @@
           </a:bodyPr>
           <a:lstStyle/>
           <a:p>
-            <a:pPr indent="0" marL="0">
+            <a:pPr marL="0" indent="0">
               <a:buNone/>
             </a:pPr>
             <a:r>
@@ -5469,7 +5097,7 @@
           <a:bodyPr wrap="square" rtlCol="0" anchor="ctr"/>
           <a:lstStyle/>
           <a:p>
-            <a:pPr indent="0" marL="0">
+            <a:pPr marL="0" indent="0">
               <a:buNone/>
             </a:pPr>
             <a:endParaRPr lang="en-US" dirty="0"/>
@@ -5499,7 +5127,7 @@
           </a:bodyPr>
           <a:lstStyle/>
           <a:p>
-            <a:pPr indent="0" marL="0">
+            <a:pPr marL="0" indent="0">
               <a:buNone/>
             </a:pPr>
             <a:r>
@@ -5540,7 +5168,7 @@
           </a:bodyPr>
           <a:lstStyle/>
           <a:p>
-            <a:pPr indent="0" marL="0">
+            <a:pPr marL="0" indent="0">
               <a:buNone/>
             </a:pPr>
             <a:r>
@@ -5585,7 +5213,7 @@
           <a:bodyPr wrap="square" rtlCol="0" anchor="ctr"/>
           <a:lstStyle/>
           <a:p>
-            <a:pPr indent="0" marL="0">
+            <a:pPr marL="0" indent="0">
               <a:buNone/>
             </a:pPr>
             <a:endParaRPr lang="en-US" dirty="0"/>
@@ -5615,7 +5243,7 @@
           </a:bodyPr>
           <a:lstStyle/>
           <a:p>
-            <a:pPr indent="0" marL="0">
+            <a:pPr marL="0" indent="0">
               <a:buNone/>
             </a:pPr>
             <a:r>
@@ -5656,7 +5284,7 @@
           </a:bodyPr>
           <a:lstStyle/>
           <a:p>
-            <a:pPr indent="0" marL="0">
+            <a:pPr marL="0" indent="0">
               <a:buNone/>
             </a:pPr>
             <a:r>
@@ -5701,7 +5329,7 @@
           <a:bodyPr wrap="square" rtlCol="0" anchor="ctr"/>
           <a:lstStyle/>
           <a:p>
-            <a:pPr indent="0" marL="0">
+            <a:pPr marL="0" indent="0">
               <a:buNone/>
             </a:pPr>
             <a:endParaRPr lang="en-US" dirty="0"/>
@@ -5731,7 +5359,7 @@
           </a:bodyPr>
           <a:lstStyle/>
           <a:p>
-            <a:pPr indent="0" marL="0">
+            <a:pPr marL="0" indent="0">
               <a:buNone/>
             </a:pPr>
             <a:r>
@@ -5772,7 +5400,7 @@
           </a:bodyPr>
           <a:lstStyle/>
           <a:p>
-            <a:pPr indent="0" marL="0">
+            <a:pPr marL="0" indent="0">
               <a:buNone/>
             </a:pPr>
             <a:r>
@@ -5813,7 +5441,7 @@
           </a:bodyPr>
           <a:lstStyle/>
           <a:p>
-            <a:pPr indent="0" marL="0">
+            <a:pPr marL="0" indent="0">
               <a:buNone/>
             </a:pPr>
             <a:r>
@@ -5830,7 +5458,7 @@
             <a:endParaRPr lang="en-US" sz="1200" dirty="0"/>
           </a:p>
           <a:p>
-            <a:pPr indent="0" marL="0">
+            <a:pPr marL="0" indent="0">
               <a:buNone/>
             </a:pPr>
             <a:r>
@@ -5847,7 +5475,7 @@
             <a:endParaRPr lang="en-US" sz="1200" dirty="0"/>
           </a:p>
           <a:p>
-            <a:pPr indent="0" marL="0">
+            <a:pPr marL="0" indent="0">
               <a:buNone/>
             </a:pPr>
             <a:r>
@@ -5892,7 +5520,7 @@
           <a:bodyPr wrap="square" rtlCol="0" anchor="ctr"/>
           <a:lstStyle/>
           <a:p>
-            <a:pPr indent="0" marL="0">
+            <a:pPr marL="0" indent="0">
               <a:buNone/>
             </a:pPr>
             <a:endParaRPr lang="en-US" dirty="0"/>
@@ -5922,7 +5550,7 @@
           </a:bodyPr>
           <a:lstStyle/>
           <a:p>
-            <a:pPr indent="0" marL="0">
+            <a:pPr marL="0" indent="0">
               <a:buNone/>
             </a:pPr>
             <a:r>
@@ -5963,7 +5591,7 @@
           </a:bodyPr>
           <a:lstStyle/>
           <a:p>
-            <a:pPr indent="0" marL="0">
+            <a:pPr marL="0" indent="0">
               <a:buNone/>
             </a:pPr>
             <a:r>
@@ -5997,6 +5625,7 @@
         <a:solidFill>
           <a:srgbClr val="0B132B"/>
         </a:solidFill>
+        <a:effectLst/>
       </p:bgPr>
     </p:bg>
     <p:spTree>
@@ -6040,7 +5669,7 @@
           <a:bodyPr wrap="square" rtlCol="0" anchor="ctr"/>
           <a:lstStyle/>
           <a:p>
-            <a:pPr indent="0" marL="0">
+            <a:pPr marL="0" indent="0">
               <a:buNone/>
             </a:pPr>
             <a:endParaRPr lang="en-US" dirty="0"/>
@@ -6068,7 +5697,7 @@
           <a:bodyPr wrap="square" rtlCol="0" anchor="ctr"/>
           <a:lstStyle/>
           <a:p>
-            <a:pPr algn="r" indent="0" marL="0">
+            <a:pPr marL="0" indent="0" algn="r">
               <a:buNone/>
             </a:pPr>
             <a:r>
@@ -6107,7 +5736,7 @@
           <a:bodyPr wrap="square" rtlCol="0" anchor="ctr"/>
           <a:lstStyle/>
           <a:p>
-            <a:pPr indent="0" marL="0">
+            <a:pPr marL="0" indent="0">
               <a:buNone/>
             </a:pPr>
             <a:r>
@@ -6148,7 +5777,7 @@
           </a:bodyPr>
           <a:lstStyle/>
           <a:p>
-            <a:pPr indent="0" marL="0">
+            <a:pPr marL="0" indent="0">
               <a:buNone/>
             </a:pPr>
             <a:r>
@@ -6193,7 +5822,7 @@
           <a:bodyPr wrap="square" rtlCol="0" anchor="ctr"/>
           <a:lstStyle/>
           <a:p>
-            <a:pPr indent="0" marL="0">
+            <a:pPr marL="0" indent="0">
               <a:buNone/>
             </a:pPr>
             <a:endParaRPr lang="en-US" dirty="0"/>
@@ -6223,7 +5852,7 @@
           </a:bodyPr>
           <a:lstStyle/>
           <a:p>
-            <a:pPr indent="0" marL="0">
+            <a:pPr marL="0" indent="0">
               <a:buNone/>
             </a:pPr>
             <a:r>
@@ -6264,7 +5893,7 @@
           </a:bodyPr>
           <a:lstStyle/>
           <a:p>
-            <a:pPr indent="0" marL="0">
+            <a:pPr marL="0" indent="0">
               <a:buNone/>
             </a:pPr>
             <a:r>
@@ -6281,7 +5910,7 @@
             <a:endParaRPr lang="en-US" sz="1100" dirty="0"/>
           </a:p>
           <a:p>
-            <a:pPr indent="0" marL="0">
+            <a:pPr marL="0" indent="0">
               <a:buNone/>
             </a:pPr>
             <a:r>
@@ -6326,7 +5955,7 @@
           <a:bodyPr wrap="square" rtlCol="0" anchor="ctr"/>
           <a:lstStyle/>
           <a:p>
-            <a:pPr indent="0" marL="0">
+            <a:pPr marL="0" indent="0">
               <a:buNone/>
             </a:pPr>
             <a:endParaRPr lang="en-US" dirty="0"/>
@@ -6356,7 +5985,7 @@
           </a:bodyPr>
           <a:lstStyle/>
           <a:p>
-            <a:pPr indent="0" marL="0">
+            <a:pPr marL="0" indent="0">
               <a:buNone/>
             </a:pPr>
             <a:r>
@@ -6397,7 +6026,7 @@
           </a:bodyPr>
           <a:lstStyle/>
           <a:p>
-            <a:pPr indent="0" marL="0">
+            <a:pPr marL="0" indent="0">
               <a:buNone/>
             </a:pPr>
             <a:r>
@@ -6414,7 +6043,7 @@
             <a:endParaRPr lang="en-US" sz="1100" dirty="0"/>
           </a:p>
           <a:p>
-            <a:pPr indent="0" marL="0">
+            <a:pPr marL="0" indent="0">
               <a:buNone/>
             </a:pPr>
             <a:r>
@@ -6459,7 +6088,7 @@
           <a:bodyPr wrap="square" rtlCol="0" anchor="ctr"/>
           <a:lstStyle/>
           <a:p>
-            <a:pPr indent="0" marL="0">
+            <a:pPr marL="0" indent="0">
               <a:buNone/>
             </a:pPr>
             <a:endParaRPr lang="en-US" dirty="0"/>
@@ -6489,7 +6118,7 @@
           </a:bodyPr>
           <a:lstStyle/>
           <a:p>
-            <a:pPr indent="0" marL="0">
+            <a:pPr marL="0" indent="0">
               <a:buNone/>
             </a:pPr>
             <a:r>
@@ -6530,7 +6159,7 @@
           </a:bodyPr>
           <a:lstStyle/>
           <a:p>
-            <a:pPr indent="0" marL="0">
+            <a:pPr marL="0" indent="0">
               <a:buNone/>
             </a:pPr>
             <a:r>
@@ -6547,7 +6176,7 @@
             <a:endParaRPr lang="en-US" sz="1100" dirty="0"/>
           </a:p>
           <a:p>
-            <a:pPr indent="0" marL="0">
+            <a:pPr marL="0" indent="0">
               <a:buNone/>
             </a:pPr>
             <a:r>
@@ -6592,7 +6221,7 @@
           <a:bodyPr wrap="square" rtlCol="0" anchor="ctr"/>
           <a:lstStyle/>
           <a:p>
-            <a:pPr indent="0" marL="0">
+            <a:pPr marL="0" indent="0">
               <a:buNone/>
             </a:pPr>
             <a:endParaRPr lang="en-US" dirty="0"/>
@@ -6622,7 +6251,7 @@
           </a:bodyPr>
           <a:lstStyle/>
           <a:p>
-            <a:pPr indent="0" marL="0">
+            <a:pPr marL="0" indent="0">
               <a:buNone/>
             </a:pPr>
             <a:r>
@@ -6663,7 +6292,7 @@
           </a:bodyPr>
           <a:lstStyle/>
           <a:p>
-            <a:pPr indent="0" marL="0">
+            <a:pPr marL="0" indent="0">
               <a:buNone/>
             </a:pPr>
             <a:r>
@@ -6708,7 +6337,7 @@
           <a:bodyPr wrap="square" rtlCol="0" anchor="ctr"/>
           <a:lstStyle/>
           <a:p>
-            <a:pPr indent="0" marL="0">
+            <a:pPr marL="0" indent="0">
               <a:buNone/>
             </a:pPr>
             <a:endParaRPr lang="en-US" dirty="0"/>
@@ -6738,7 +6367,7 @@
           </a:bodyPr>
           <a:lstStyle/>
           <a:p>
-            <a:pPr indent="0" marL="0">
+            <a:pPr marL="0" indent="0">
               <a:buNone/>
             </a:pPr>
             <a:r>
@@ -6779,7 +6408,7 @@
           </a:bodyPr>
           <a:lstStyle/>
           <a:p>
-            <a:pPr indent="0" marL="0">
+            <a:pPr marL="0" indent="0">
               <a:buNone/>
             </a:pPr>
             <a:r>
@@ -6813,6 +6442,7 @@
         <a:solidFill>
           <a:srgbClr val="0B132B"/>
         </a:solidFill>
+        <a:effectLst/>
       </p:bgPr>
     </p:bg>
     <p:spTree>
@@ -6856,7 +6486,7 @@
           <a:bodyPr wrap="square" rtlCol="0" anchor="ctr"/>
           <a:lstStyle/>
           <a:p>
-            <a:pPr indent="0" marL="0">
+            <a:pPr marL="0" indent="0">
               <a:buNone/>
             </a:pPr>
             <a:endParaRPr lang="en-US" dirty="0"/>
@@ -6884,7 +6514,7 @@
           <a:bodyPr wrap="square" rtlCol="0" anchor="ctr"/>
           <a:lstStyle/>
           <a:p>
-            <a:pPr algn="r" indent="0" marL="0">
+            <a:pPr marL="0" indent="0" algn="r">
               <a:buNone/>
             </a:pPr>
             <a:r>
@@ -6923,7 +6553,7 @@
           <a:bodyPr wrap="square" rtlCol="0" anchor="ctr"/>
           <a:lstStyle/>
           <a:p>
-            <a:pPr indent="0" marL="0">
+            <a:pPr marL="0" indent="0">
               <a:buNone/>
             </a:pPr>
             <a:r>
@@ -6964,7 +6594,7 @@
           </a:bodyPr>
           <a:lstStyle/>
           <a:p>
-            <a:pPr indent="0" marL="0">
+            <a:pPr marL="0" indent="0">
               <a:buNone/>
             </a:pPr>
             <a:r>
@@ -7009,7 +6639,7 @@
           <a:bodyPr wrap="square" rtlCol="0" anchor="ctr"/>
           <a:lstStyle/>
           <a:p>
-            <a:pPr indent="0" marL="0">
+            <a:pPr marL="0" indent="0">
               <a:buNone/>
             </a:pPr>
             <a:endParaRPr lang="en-US" dirty="0"/>
@@ -7039,7 +6669,7 @@
           </a:bodyPr>
           <a:lstStyle/>
           <a:p>
-            <a:pPr indent="0" marL="0">
+            <a:pPr marL="0" indent="0">
               <a:buNone/>
             </a:pPr>
             <a:r>
@@ -7080,7 +6710,7 @@
           </a:bodyPr>
           <a:lstStyle/>
           <a:p>
-            <a:pPr indent="0" marL="0">
+            <a:pPr marL="0" indent="0">
               <a:buNone/>
             </a:pPr>
             <a:r>
@@ -7125,7 +6755,7 @@
           <a:bodyPr wrap="square" rtlCol="0" anchor="ctr"/>
           <a:lstStyle/>
           <a:p>
-            <a:pPr indent="0" marL="0">
+            <a:pPr marL="0" indent="0">
               <a:buNone/>
             </a:pPr>
             <a:endParaRPr lang="en-US" dirty="0"/>
@@ -7155,7 +6785,7 @@
           </a:bodyPr>
           <a:lstStyle/>
           <a:p>
-            <a:pPr indent="0" marL="0">
+            <a:pPr marL="0" indent="0">
               <a:buNone/>
             </a:pPr>
             <a:r>
@@ -7196,7 +6826,7 @@
           </a:bodyPr>
           <a:lstStyle/>
           <a:p>
-            <a:pPr indent="0" marL="0">
+            <a:pPr marL="0" indent="0">
               <a:buNone/>
             </a:pPr>
             <a:r>
@@ -7241,7 +6871,7 @@
           <a:bodyPr wrap="square" rtlCol="0" anchor="ctr"/>
           <a:lstStyle/>
           <a:p>
-            <a:pPr indent="0" marL="0">
+            <a:pPr marL="0" indent="0">
               <a:buNone/>
             </a:pPr>
             <a:endParaRPr lang="en-US" dirty="0"/>
@@ -7271,7 +6901,7 @@
           </a:bodyPr>
           <a:lstStyle/>
           <a:p>
-            <a:pPr indent="0" marL="0">
+            <a:pPr marL="0" indent="0">
               <a:buNone/>
             </a:pPr>
             <a:r>
@@ -7312,7 +6942,7 @@
           </a:bodyPr>
           <a:lstStyle/>
           <a:p>
-            <a:pPr indent="0" marL="0">
+            <a:pPr marL="0" indent="0">
               <a:buNone/>
             </a:pPr>
             <a:r>
@@ -7357,7 +6987,7 @@
           <a:bodyPr wrap="square" rtlCol="0" anchor="ctr"/>
           <a:lstStyle/>
           <a:p>
-            <a:pPr indent="0" marL="0">
+            <a:pPr marL="0" indent="0">
               <a:buNone/>
             </a:pPr>
             <a:endParaRPr lang="en-US" dirty="0"/>
@@ -7387,7 +7017,7 @@
           </a:bodyPr>
           <a:lstStyle/>
           <a:p>
-            <a:pPr indent="0" marL="0">
+            <a:pPr marL="0" indent="0">
               <a:buNone/>
             </a:pPr>
             <a:r>
@@ -7428,7 +7058,7 @@
           </a:bodyPr>
           <a:lstStyle/>
           <a:p>
-            <a:pPr indent="0" marL="0">
+            <a:pPr marL="0" indent="0">
               <a:buNone/>
             </a:pPr>
             <a:r>
@@ -7462,6 +7092,7 @@
         <a:solidFill>
           <a:srgbClr val="0B132B"/>
         </a:solidFill>
+        <a:effectLst/>
       </p:bgPr>
     </p:bg>
     <p:spTree>
@@ -7505,7 +7136,7 @@
           <a:bodyPr wrap="square" rtlCol="0" anchor="ctr"/>
           <a:lstStyle/>
           <a:p>
-            <a:pPr indent="0" marL="0">
+            <a:pPr marL="0" indent="0">
               <a:buNone/>
             </a:pPr>
             <a:endParaRPr lang="en-US" dirty="0"/>
@@ -7533,7 +7164,7 @@
           <a:bodyPr wrap="square" rtlCol="0" anchor="ctr"/>
           <a:lstStyle/>
           <a:p>
-            <a:pPr algn="r" indent="0" marL="0">
+            <a:pPr marL="0" indent="0" algn="r">
               <a:buNone/>
             </a:pPr>
             <a:r>
@@ -7572,7 +7203,7 @@
           <a:bodyPr wrap="square" rtlCol="0" anchor="ctr"/>
           <a:lstStyle/>
           <a:p>
-            <a:pPr indent="0" marL="0">
+            <a:pPr marL="0" indent="0">
               <a:buNone/>
             </a:pPr>
             <a:r>
@@ -7613,7 +7244,7 @@
           </a:bodyPr>
           <a:lstStyle/>
           <a:p>
-            <a:pPr indent="0" marL="0">
+            <a:pPr marL="0" indent="0">
               <a:buNone/>
             </a:pPr>
             <a:r>
@@ -7658,7 +7289,7 @@
           <a:bodyPr wrap="square" rtlCol="0" anchor="ctr"/>
           <a:lstStyle/>
           <a:p>
-            <a:pPr indent="0" marL="0">
+            <a:pPr marL="0" indent="0">
               <a:buNone/>
             </a:pPr>
             <a:endParaRPr lang="en-US" dirty="0"/>
@@ -7688,7 +7319,7 @@
           </a:bodyPr>
           <a:lstStyle/>
           <a:p>
-            <a:pPr indent="0" marL="0">
+            <a:pPr marL="0" indent="0">
               <a:buNone/>
             </a:pPr>
             <a:r>
@@ -7729,7 +7360,7 @@
           </a:bodyPr>
           <a:lstStyle/>
           <a:p>
-            <a:pPr indent="0" marL="0">
+            <a:pPr marL="0" indent="0">
               <a:buNone/>
             </a:pPr>
             <a:r>
@@ -7774,7 +7405,7 @@
           <a:bodyPr wrap="square" rtlCol="0" anchor="ctr"/>
           <a:lstStyle/>
           <a:p>
-            <a:pPr indent="0" marL="0">
+            <a:pPr marL="0" indent="0">
               <a:buNone/>
             </a:pPr>
             <a:endParaRPr lang="en-US" dirty="0"/>
@@ -7804,7 +7435,7 @@
           </a:bodyPr>
           <a:lstStyle/>
           <a:p>
-            <a:pPr indent="0" marL="0">
+            <a:pPr marL="0" indent="0">
               <a:buNone/>
             </a:pPr>
             <a:r>
@@ -7845,7 +7476,7 @@
           </a:bodyPr>
           <a:lstStyle/>
           <a:p>
-            <a:pPr indent="0" marL="0">
+            <a:pPr marL="0" indent="0">
               <a:buNone/>
             </a:pPr>
             <a:r>
@@ -7890,7 +7521,7 @@
           <a:bodyPr wrap="square" rtlCol="0" anchor="ctr"/>
           <a:lstStyle/>
           <a:p>
-            <a:pPr indent="0" marL="0">
+            <a:pPr marL="0" indent="0">
               <a:buNone/>
             </a:pPr>
             <a:endParaRPr lang="en-US" dirty="0"/>
@@ -7920,7 +7551,7 @@
           </a:bodyPr>
           <a:lstStyle/>
           <a:p>
-            <a:pPr indent="0" marL="0">
+            <a:pPr marL="0" indent="0">
               <a:buNone/>
             </a:pPr>
             <a:r>
@@ -7961,7 +7592,7 @@
           </a:bodyPr>
           <a:lstStyle/>
           <a:p>
-            <a:pPr indent="0" marL="0">
+            <a:pPr marL="0" indent="0">
               <a:buNone/>
             </a:pPr>
             <a:r>
@@ -8006,7 +7637,7 @@
           <a:bodyPr wrap="square" rtlCol="0" anchor="ctr"/>
           <a:lstStyle/>
           <a:p>
-            <a:pPr indent="0" marL="0">
+            <a:pPr marL="0" indent="0">
               <a:buNone/>
             </a:pPr>
             <a:endParaRPr lang="en-US" dirty="0"/>
@@ -8036,7 +7667,7 @@
           </a:bodyPr>
           <a:lstStyle/>
           <a:p>
-            <a:pPr indent="0" marL="0">
+            <a:pPr marL="0" indent="0">
               <a:buNone/>
             </a:pPr>
             <a:r>
@@ -8077,7 +7708,7 @@
           </a:bodyPr>
           <a:lstStyle/>
           <a:p>
-            <a:pPr indent="0" marL="0">
+            <a:pPr marL="0" indent="0">
               <a:buNone/>
             </a:pPr>
             <a:r>
@@ -8122,7 +7753,7 @@
           <a:bodyPr wrap="square" rtlCol="0" anchor="ctr"/>
           <a:lstStyle/>
           <a:p>
-            <a:pPr indent="0" marL="0">
+            <a:pPr marL="0" indent="0">
               <a:buNone/>
             </a:pPr>
             <a:endParaRPr lang="en-US" dirty="0"/>
@@ -8152,7 +7783,7 @@
           </a:bodyPr>
           <a:lstStyle/>
           <a:p>
-            <a:pPr indent="0" marL="0">
+            <a:pPr marL="0" indent="0">
               <a:buNone/>
             </a:pPr>
             <a:r>
@@ -8193,7 +7824,7 @@
           </a:bodyPr>
           <a:lstStyle/>
           <a:p>
-            <a:pPr indent="0" marL="0">
+            <a:pPr marL="0" indent="0">
               <a:buNone/>
             </a:pPr>
             <a:r>
@@ -8227,6 +7858,7 @@
         <a:solidFill>
           <a:srgbClr val="0B132B"/>
         </a:solidFill>
+        <a:effectLst/>
       </p:bgPr>
     </p:bg>
     <p:spTree>
@@ -8270,7 +7902,7 @@
           <a:bodyPr wrap="square" rtlCol="0" anchor="ctr"/>
           <a:lstStyle/>
           <a:p>
-            <a:pPr indent="0" marL="0">
+            <a:pPr marL="0" indent="0">
               <a:buNone/>
             </a:pPr>
             <a:endParaRPr lang="en-US" dirty="0"/>
@@ -8298,7 +7930,7 @@
           <a:bodyPr wrap="square" rtlCol="0" anchor="ctr"/>
           <a:lstStyle/>
           <a:p>
-            <a:pPr algn="r" indent="0" marL="0">
+            <a:pPr marL="0" indent="0" algn="r">
               <a:buNone/>
             </a:pPr>
             <a:r>
@@ -8337,7 +7969,7 @@
           <a:bodyPr wrap="square" rtlCol="0" anchor="ctr"/>
           <a:lstStyle/>
           <a:p>
-            <a:pPr indent="0" marL="0">
+            <a:pPr marL="0" indent="0">
               <a:buNone/>
             </a:pPr>
             <a:r>
@@ -8378,7 +8010,7 @@
           </a:bodyPr>
           <a:lstStyle/>
           <a:p>
-            <a:pPr indent="0" marL="0">
+            <a:pPr marL="0" indent="0">
               <a:buNone/>
             </a:pPr>
             <a:r>
@@ -8423,7 +8055,7 @@
           <a:bodyPr wrap="square" rtlCol="0" anchor="ctr"/>
           <a:lstStyle/>
           <a:p>
-            <a:pPr indent="0" marL="0">
+            <a:pPr marL="0" indent="0">
               <a:buNone/>
             </a:pPr>
             <a:endParaRPr lang="en-US" dirty="0"/>
@@ -8453,7 +8085,7 @@
           </a:bodyPr>
           <a:lstStyle/>
           <a:p>
-            <a:pPr indent="0" marL="0">
+            <a:pPr marL="0" indent="0">
               <a:buNone/>
             </a:pPr>
             <a:r>
@@ -8494,7 +8126,7 @@
           </a:bodyPr>
           <a:lstStyle/>
           <a:p>
-            <a:pPr indent="0" marL="0">
+            <a:pPr marL="0" indent="0">
               <a:buNone/>
             </a:pPr>
             <a:r>
@@ -8539,7 +8171,7 @@
           <a:bodyPr wrap="square" rtlCol="0" anchor="ctr"/>
           <a:lstStyle/>
           <a:p>
-            <a:pPr indent="0" marL="0">
+            <a:pPr marL="0" indent="0">
               <a:buNone/>
             </a:pPr>
             <a:endParaRPr lang="en-US" dirty="0"/>
@@ -8569,7 +8201,7 @@
           </a:bodyPr>
           <a:lstStyle/>
           <a:p>
-            <a:pPr indent="0" marL="0">
+            <a:pPr marL="0" indent="0">
               <a:buNone/>
             </a:pPr>
             <a:r>
@@ -8610,7 +8242,7 @@
           </a:bodyPr>
           <a:lstStyle/>
           <a:p>
-            <a:pPr indent="0" marL="0">
+            <a:pPr marL="0" indent="0">
               <a:buNone/>
             </a:pPr>
             <a:r>
@@ -8655,7 +8287,7 @@
           <a:bodyPr wrap="square" rtlCol="0" anchor="ctr"/>
           <a:lstStyle/>
           <a:p>
-            <a:pPr indent="0" marL="0">
+            <a:pPr marL="0" indent="0">
               <a:buNone/>
             </a:pPr>
             <a:endParaRPr lang="en-US" dirty="0"/>
@@ -8685,7 +8317,7 @@
           </a:bodyPr>
           <a:lstStyle/>
           <a:p>
-            <a:pPr indent="0" marL="0">
+            <a:pPr marL="0" indent="0">
               <a:buNone/>
             </a:pPr>
             <a:r>
@@ -8726,7 +8358,7 @@
           </a:bodyPr>
           <a:lstStyle/>
           <a:p>
-            <a:pPr indent="0" marL="0">
+            <a:pPr marL="0" indent="0">
               <a:buNone/>
             </a:pPr>
             <a:r>
@@ -8771,7 +8403,7 @@
           <a:bodyPr wrap="square" rtlCol="0" anchor="ctr"/>
           <a:lstStyle/>
           <a:p>
-            <a:pPr indent="0" marL="0">
+            <a:pPr marL="0" indent="0">
               <a:buNone/>
             </a:pPr>
             <a:endParaRPr lang="en-US" dirty="0"/>
@@ -8801,7 +8433,7 @@
           </a:bodyPr>
           <a:lstStyle/>
           <a:p>
-            <a:pPr indent="0" marL="0">
+            <a:pPr marL="0" indent="0">
               <a:buNone/>
             </a:pPr>
             <a:r>
@@ -8842,7 +8474,7 @@
           </a:bodyPr>
           <a:lstStyle/>
           <a:p>
-            <a:pPr indent="0" marL="0">
+            <a:pPr marL="0" indent="0">
               <a:buNone/>
             </a:pPr>
             <a:r>
@@ -8876,6 +8508,7 @@
         <a:solidFill>
           <a:srgbClr val="0B132B"/>
         </a:solidFill>
+        <a:effectLst/>
       </p:bgPr>
     </p:bg>
     <p:spTree>
@@ -8919,7 +8552,7 @@
           <a:bodyPr wrap="square" rtlCol="0" anchor="ctr"/>
           <a:lstStyle/>
           <a:p>
-            <a:pPr indent="0" marL="0">
+            <a:pPr marL="0" indent="0">
               <a:buNone/>
             </a:pPr>
             <a:endParaRPr lang="en-US" dirty="0"/>
@@ -8947,7 +8580,7 @@
           <a:bodyPr wrap="square" rtlCol="0" anchor="ctr"/>
           <a:lstStyle/>
           <a:p>
-            <a:pPr algn="r" indent="0" marL="0">
+            <a:pPr marL="0" indent="0" algn="r">
               <a:buNone/>
             </a:pPr>
             <a:r>
@@ -8986,7 +8619,7 @@
           <a:bodyPr wrap="square" rtlCol="0" anchor="ctr"/>
           <a:lstStyle/>
           <a:p>
-            <a:pPr indent="0" marL="0">
+            <a:pPr marL="0" indent="0">
               <a:buNone/>
             </a:pPr>
             <a:r>
@@ -9027,7 +8660,7 @@
           </a:bodyPr>
           <a:lstStyle/>
           <a:p>
-            <a:pPr indent="0" marL="0">
+            <a:pPr marL="0" indent="0">
               <a:buNone/>
             </a:pPr>
             <a:r>
@@ -9072,7 +8705,7 @@
           <a:bodyPr wrap="square" rtlCol="0" anchor="ctr"/>
           <a:lstStyle/>
           <a:p>
-            <a:pPr indent="0" marL="0">
+            <a:pPr marL="0" indent="0">
               <a:buNone/>
             </a:pPr>
             <a:endParaRPr lang="en-US" dirty="0"/>
@@ -9102,7 +8735,7 @@
           </a:bodyPr>
           <a:lstStyle/>
           <a:p>
-            <a:pPr indent="0" marL="0">
+            <a:pPr marL="0" indent="0">
               <a:buNone/>
             </a:pPr>
             <a:r>
@@ -9143,7 +8776,7 @@
           </a:bodyPr>
           <a:lstStyle/>
           <a:p>
-            <a:pPr indent="0" marL="0">
+            <a:pPr marL="0" indent="0">
               <a:buNone/>
             </a:pPr>
             <a:r>
@@ -9160,7 +8793,7 @@
             <a:endParaRPr lang="en-US" sz="1100" dirty="0"/>
           </a:p>
           <a:p>
-            <a:pPr indent="0" marL="0">
+            <a:pPr marL="0" indent="0">
               <a:buNone/>
             </a:pPr>
             <a:r>
@@ -9177,7 +8810,7 @@
             <a:endParaRPr lang="en-US" sz="1100" dirty="0"/>
           </a:p>
           <a:p>
-            <a:pPr indent="0" marL="0">
+            <a:pPr marL="0" indent="0">
               <a:buNone/>
             </a:pPr>
             <a:r>
@@ -9194,7 +8827,7 @@
             <a:endParaRPr lang="en-US" sz="1100" dirty="0"/>
           </a:p>
           <a:p>
-            <a:pPr indent="0" marL="0">
+            <a:pPr marL="0" indent="0">
               <a:buNone/>
             </a:pPr>
             <a:r>
@@ -9211,7 +8844,7 @@
             <a:endParaRPr lang="en-US" sz="1100" dirty="0"/>
           </a:p>
           <a:p>
-            <a:pPr indent="0" marL="0">
+            <a:pPr marL="0" indent="0">
               <a:buNone/>
             </a:pPr>
             <a:r>
@@ -9256,7 +8889,7 @@
           <a:bodyPr wrap="square" rtlCol="0" anchor="ctr"/>
           <a:lstStyle/>
           <a:p>
-            <a:pPr indent="0" marL="0">
+            <a:pPr marL="0" indent="0">
               <a:buNone/>
             </a:pPr>
             <a:endParaRPr lang="en-US" dirty="0"/>
@@ -9286,7 +8919,7 @@
           </a:bodyPr>
           <a:lstStyle/>
           <a:p>
-            <a:pPr indent="0" marL="0">
+            <a:pPr marL="0" indent="0">
               <a:buNone/>
             </a:pPr>
             <a:r>
@@ -9327,7 +8960,7 @@
           </a:bodyPr>
           <a:lstStyle/>
           <a:p>
-            <a:pPr indent="0" marL="0">
+            <a:pPr marL="0" indent="0">
               <a:buNone/>
             </a:pPr>
             <a:r>
@@ -9344,7 +8977,7 @@
             <a:endParaRPr lang="en-US" sz="1100" dirty="0"/>
           </a:p>
           <a:p>
-            <a:pPr indent="0" marL="0">
+            <a:pPr marL="0" indent="0">
               <a:buNone/>
             </a:pPr>
             <a:r>
@@ -9361,7 +8994,7 @@
             <a:endParaRPr lang="en-US" sz="1100" dirty="0"/>
           </a:p>
           <a:p>
-            <a:pPr indent="0" marL="0">
+            <a:pPr marL="0" indent="0">
               <a:buNone/>
             </a:pPr>
             <a:r>
@@ -9378,7 +9011,7 @@
             <a:endParaRPr lang="en-US" sz="1100" dirty="0"/>
           </a:p>
           <a:p>
-            <a:pPr indent="0" marL="0">
+            <a:pPr marL="0" indent="0">
               <a:buNone/>
             </a:pPr>
             <a:r>
@@ -9423,7 +9056,7 @@
           <a:bodyPr wrap="square" rtlCol="0" anchor="ctr"/>
           <a:lstStyle/>
           <a:p>
-            <a:pPr indent="0" marL="0">
+            <a:pPr marL="0" indent="0">
               <a:buNone/>
             </a:pPr>
             <a:endParaRPr lang="en-US" dirty="0"/>
@@ -9453,7 +9086,7 @@
           </a:bodyPr>
           <a:lstStyle/>
           <a:p>
-            <a:pPr indent="0" marL="0">
+            <a:pPr marL="0" indent="0">
               <a:buNone/>
             </a:pPr>
             <a:r>
@@ -9465,7 +9098,7 @@
                 <a:ea typeface="Aptos" pitchFamily="34" charset="-122"/>
                 <a:cs typeface="Aptos" pitchFamily="34" charset="-120"/>
               </a:rPr>
-              <a:t>Renter feedback (temporary)</a:t>
+              <a:t>Renter feedback</a:t>
             </a:r>
             <a:endParaRPr lang="en-US" sz="1300" dirty="0"/>
           </a:p>
@@ -9490,12 +9123,13 @@
         </p:spPr>
         <p:txBody>
           <a:bodyPr wrap="square" lIns="0" tIns="0" rIns="0" bIns="0" rtlCol="0" anchor="t">
-            <a:normAutofit/>
+            <a:normAutofit lnSpcReduction="10000"/>
           </a:bodyPr>
           <a:lstStyle/>
           <a:p>
-            <a:pPr indent="0" marL="0">
-              <a:buNone/>
+            <a:pPr marL="171450" indent="-171450">
+              <a:buFontTx/>
+              <a:buChar char="-"/>
             </a:pPr>
             <a:r>
               <a:rPr lang="en-US" sz="1100" dirty="0">
@@ -9506,9 +9140,42 @@
                 <a:ea typeface="Aptos" pitchFamily="34" charset="-122"/>
                 <a:cs typeface="Aptos" pitchFamily="34" charset="-120"/>
               </a:rPr>
-              <a:t>TEMP — Add 3–5 renter quotes showing whether users trusted the guidance, understood the disclaimer, and would pay for drafting, reminders, or evidence tracking in stressful disputes.</a:t>
-            </a:r>
-            <a:endParaRPr lang="en-US" sz="1100" dirty="0"/>
+              <a:t>Close friends of in their twenties, who had poor renting experiences, gave feedback on my app’s ability to clearly show renters’ rights and explant what support is available.</a:t>
+            </a:r>
+          </a:p>
+          <a:p>
+            <a:pPr marL="171450" indent="-171450">
+              <a:buFontTx/>
+              <a:buChar char="-"/>
+            </a:pPr>
+            <a:r>
+              <a:rPr lang="en-US" sz="1100" dirty="0">
+                <a:solidFill>
+                  <a:srgbClr val="C9D1E0"/>
+                </a:solidFill>
+                <a:latin typeface="Aptos" pitchFamily="34" charset="0"/>
+                <a:ea typeface="Aptos" pitchFamily="34" charset="-122"/>
+                <a:cs typeface="Aptos" pitchFamily="34" charset="-120"/>
+              </a:rPr>
+              <a:t>Their feedback is focused on making the app more useful for young renters by presenting rights, responsibilities, and next steps in a simple and accessible way.</a:t>
+            </a:r>
+          </a:p>
+          <a:p>
+            <a:pPr marL="171450" indent="-171450">
+              <a:buFontTx/>
+              <a:buChar char="-"/>
+            </a:pPr>
+            <a:r>
+              <a:rPr lang="en-US" sz="1100" dirty="0">
+                <a:solidFill>
+                  <a:srgbClr val="C9D1E0"/>
+                </a:solidFill>
+                <a:latin typeface="Aptos" pitchFamily="34" charset="0"/>
+                <a:ea typeface="Aptos" pitchFamily="34" charset="-122"/>
+                <a:cs typeface="Aptos" pitchFamily="34" charset="-120"/>
+              </a:rPr>
+              <a:t>Because they had faced issues themselves, their input helped shape how the app guides users towards practical help with renter’s rights.</a:t>
+            </a:r>
           </a:p>
         </p:txBody>
       </p:sp>
@@ -9539,7 +9206,7 @@
           <a:bodyPr wrap="square" rtlCol="0" anchor="ctr"/>
           <a:lstStyle/>
           <a:p>
-            <a:pPr indent="0" marL="0">
+            <a:pPr marL="0" indent="0">
               <a:buNone/>
             </a:pPr>
             <a:endParaRPr lang="en-US" dirty="0"/>
@@ -9569,7 +9236,7 @@
           </a:bodyPr>
           <a:lstStyle/>
           <a:p>
-            <a:pPr indent="0" marL="0">
+            <a:pPr marL="0" indent="0">
               <a:buNone/>
             </a:pPr>
             <a:r>
@@ -9610,7 +9277,7 @@
           </a:bodyPr>
           <a:lstStyle/>
           <a:p>
-            <a:pPr indent="0" marL="0">
+            <a:pPr marL="0" indent="0">
               <a:buNone/>
             </a:pPr>
             <a:r>
@@ -9644,6 +9311,7 @@
         <a:solidFill>
           <a:srgbClr val="0B132B"/>
         </a:solidFill>
+        <a:effectLst/>
       </p:bgPr>
     </p:bg>
     <p:spTree>
@@ -9687,7 +9355,7 @@
           <a:bodyPr wrap="square" rtlCol="0" anchor="ctr"/>
           <a:lstStyle/>
           <a:p>
-            <a:pPr indent="0" marL="0">
+            <a:pPr marL="0" indent="0">
               <a:buNone/>
             </a:pPr>
             <a:endParaRPr lang="en-US" dirty="0"/>
@@ -9715,7 +9383,7 @@
           <a:bodyPr wrap="square" rtlCol="0" anchor="ctr"/>
           <a:lstStyle/>
           <a:p>
-            <a:pPr algn="r" indent="0" marL="0">
+            <a:pPr marL="0" indent="0" algn="r">
               <a:buNone/>
             </a:pPr>
             <a:r>
@@ -9754,7 +9422,7 @@
           <a:bodyPr wrap="square" rtlCol="0" anchor="ctr"/>
           <a:lstStyle/>
           <a:p>
-            <a:pPr indent="0" marL="0">
+            <a:pPr marL="0" indent="0">
               <a:buNone/>
             </a:pPr>
             <a:r>
@@ -9795,7 +9463,7 @@
           </a:bodyPr>
           <a:lstStyle/>
           <a:p>
-            <a:pPr indent="0" marL="0">
+            <a:pPr marL="0" indent="0">
               <a:buNone/>
             </a:pPr>
             <a:r>
@@ -9840,7 +9508,7 @@
           <a:bodyPr wrap="square" rtlCol="0" anchor="ctr"/>
           <a:lstStyle/>
           <a:p>
-            <a:pPr indent="0" marL="0">
+            <a:pPr marL="0" indent="0">
               <a:buNone/>
             </a:pPr>
             <a:endParaRPr lang="en-US" dirty="0"/>
@@ -9870,7 +9538,7 @@
           </a:bodyPr>
           <a:lstStyle/>
           <a:p>
-            <a:pPr indent="0" marL="0">
+            <a:pPr marL="0" indent="0">
               <a:buNone/>
             </a:pPr>
             <a:r>
@@ -9911,7 +9579,7 @@
           </a:bodyPr>
           <a:lstStyle/>
           <a:p>
-            <a:pPr indent="0" marL="0">
+            <a:pPr marL="0" indent="0">
               <a:buNone/>
             </a:pPr>
             <a:r>
@@ -9928,13 +9596,13 @@
             <a:endParaRPr lang="en-US" sz="1100" dirty="0"/>
           </a:p>
           <a:p>
-            <a:pPr indent="0" marL="0">
+            <a:pPr marL="0" indent="0">
               <a:buNone/>
             </a:pPr>
             <a:endParaRPr lang="en-US" sz="1100" dirty="0"/>
           </a:p>
           <a:p>
-            <a:pPr indent="0" marL="0">
+            <a:pPr marL="0" indent="0">
               <a:buNone/>
             </a:pPr>
             <a:r>
@@ -9979,7 +9647,7 @@
           <a:bodyPr wrap="square" rtlCol="0" anchor="ctr"/>
           <a:lstStyle/>
           <a:p>
-            <a:pPr indent="0" marL="0">
+            <a:pPr marL="0" indent="0">
               <a:buNone/>
             </a:pPr>
             <a:endParaRPr lang="en-US" dirty="0"/>
@@ -10009,7 +9677,7 @@
           </a:bodyPr>
           <a:lstStyle/>
           <a:p>
-            <a:pPr indent="0" marL="0">
+            <a:pPr marL="0" indent="0">
               <a:buNone/>
             </a:pPr>
             <a:r>
@@ -10050,7 +9718,7 @@
           </a:bodyPr>
           <a:lstStyle/>
           <a:p>
-            <a:pPr indent="0" marL="0">
+            <a:pPr marL="0" indent="0">
               <a:buNone/>
             </a:pPr>
             <a:r>
@@ -10067,7 +9735,7 @@
             <a:endParaRPr lang="en-US" sz="1100" dirty="0"/>
           </a:p>
           <a:p>
-            <a:pPr indent="0" marL="0">
+            <a:pPr marL="0" indent="0">
               <a:buNone/>
             </a:pPr>
             <a:r>
@@ -10084,7 +9752,7 @@
             <a:endParaRPr lang="en-US" sz="1100" dirty="0"/>
           </a:p>
           <a:p>
-            <a:pPr indent="0" marL="0">
+            <a:pPr marL="0" indent="0">
               <a:buNone/>
             </a:pPr>
             <a:r>
@@ -10101,7 +9769,7 @@
             <a:endParaRPr lang="en-US" sz="1100" dirty="0"/>
           </a:p>
           <a:p>
-            <a:pPr indent="0" marL="0">
+            <a:pPr marL="0" indent="0">
               <a:buNone/>
             </a:pPr>
             <a:r>
@@ -10140,7 +9808,7 @@
           <a:bodyPr wrap="square" lIns="0" tIns="0" rIns="0" bIns="0" rtlCol="0" anchor="ctr"/>
           <a:lstStyle/>
           <a:p>
-            <a:pPr indent="0" marL="0">
+            <a:pPr marL="0" indent="0">
               <a:buNone/>
             </a:pPr>
             <a:r>
@@ -10459,4 +10127,319 @@
     </a:ext>
   </a:extLst>
 </a:theme>
+</file>
+
+<file path=ppt/theme/theme2.xml><?xml version="1.0" encoding="utf-8"?>
+<a:theme xmlns:a="http://schemas.openxmlformats.org/drawingml/2006/main" name="Office Theme">
+  <a:themeElements>
+    <a:clrScheme name="Office">
+      <a:dk1>
+        <a:sysClr val="windowText" lastClr="000000"/>
+      </a:dk1>
+      <a:lt1>
+        <a:sysClr val="window" lastClr="FFFFFF"/>
+      </a:lt1>
+      <a:dk2>
+        <a:srgbClr val="0E2841"/>
+      </a:dk2>
+      <a:lt2>
+        <a:srgbClr val="E8E8E8"/>
+      </a:lt2>
+      <a:accent1>
+        <a:srgbClr val="156082"/>
+      </a:accent1>
+      <a:accent2>
+        <a:srgbClr val="E97132"/>
+      </a:accent2>
+      <a:accent3>
+        <a:srgbClr val="196B24"/>
+      </a:accent3>
+      <a:accent4>
+        <a:srgbClr val="0F9ED5"/>
+      </a:accent4>
+      <a:accent5>
+        <a:srgbClr val="A02B93"/>
+      </a:accent5>
+      <a:accent6>
+        <a:srgbClr val="4EA72E"/>
+      </a:accent6>
+      <a:hlink>
+        <a:srgbClr val="467886"/>
+      </a:hlink>
+      <a:folHlink>
+        <a:srgbClr val="96607D"/>
+      </a:folHlink>
+    </a:clrScheme>
+    <a:fontScheme name="Office">
+      <a:majorFont>
+        <a:latin typeface="Aptos Display" panose="02110004020202020204"/>
+        <a:ea typeface=""/>
+        <a:cs typeface=""/>
+        <a:font script="Jpan" typeface="游ゴシック Light"/>
+        <a:font script="Hang" typeface="맑은 고딕"/>
+        <a:font script="Hans" typeface="等线 Light"/>
+        <a:font script="Hant" typeface="新細明體"/>
+        <a:font script="Arab" typeface="Times New Roman"/>
+        <a:font script="Hebr" typeface="Times New Roman"/>
+        <a:font script="Thai" typeface="Angsana New"/>
+        <a:font script="Ethi" typeface="Nyala"/>
+        <a:font script="Beng" typeface="Vrinda"/>
+        <a:font script="Gujr" typeface="Shruti"/>
+        <a:font script="Khmr" typeface="MoolBoran"/>
+        <a:font script="Knda" typeface="Tunga"/>
+        <a:font script="Guru" typeface="Raavi"/>
+        <a:font script="Cans" typeface="Euphemia"/>
+        <a:font script="Cher" typeface="Plantagenet Cherokee"/>
+        <a:font script="Yiii" typeface="Microsoft Yi Baiti"/>
+        <a:font script="Tibt" typeface="Microsoft Himalaya"/>
+        <a:font script="Thaa" typeface="MV Boli"/>
+        <a:font script="Deva" typeface="Mangal"/>
+        <a:font script="Telu" typeface="Gautami"/>
+        <a:font script="Taml" typeface="Latha"/>
+        <a:font script="Syrc" typeface="Estrangelo Edessa"/>
+        <a:font script="Orya" typeface="Kalinga"/>
+        <a:font script="Mlym" typeface="Kartika"/>
+        <a:font script="Laoo" typeface="DokChampa"/>
+        <a:font script="Sinh" typeface="Iskoola Pota"/>
+        <a:font script="Mong" typeface="Mongolian Baiti"/>
+        <a:font script="Viet" typeface="Times New Roman"/>
+        <a:font script="Uigh" typeface="Microsoft Uighur"/>
+        <a:font script="Geor" typeface="Sylfaen"/>
+        <a:font script="Armn" typeface="Arial"/>
+        <a:font script="Bugi" typeface="Leelawadee UI"/>
+        <a:font script="Bopo" typeface="Microsoft JhengHei"/>
+        <a:font script="Java" typeface="Javanese Text"/>
+        <a:font script="Lisu" typeface="Segoe UI"/>
+        <a:font script="Mymr" typeface="Myanmar Text"/>
+        <a:font script="Nkoo" typeface="Ebrima"/>
+        <a:font script="Olck" typeface="Nirmala UI"/>
+        <a:font script="Osma" typeface="Ebrima"/>
+        <a:font script="Phag" typeface="Phagspa"/>
+        <a:font script="Syrn" typeface="Estrangelo Edessa"/>
+        <a:font script="Syrj" typeface="Estrangelo Edessa"/>
+        <a:font script="Syre" typeface="Estrangelo Edessa"/>
+        <a:font script="Sora" typeface="Nirmala UI"/>
+        <a:font script="Tale" typeface="Microsoft Tai Le"/>
+        <a:font script="Talu" typeface="Microsoft New Tai Lue"/>
+        <a:font script="Tfng" typeface="Ebrima"/>
+      </a:majorFont>
+      <a:minorFont>
+        <a:latin typeface="Aptos" panose="02110004020202020204"/>
+        <a:ea typeface=""/>
+        <a:cs typeface=""/>
+        <a:font script="Jpan" typeface="游ゴシック"/>
+        <a:font script="Hang" typeface="맑은 고딕"/>
+        <a:font script="Hans" typeface="等线"/>
+        <a:font script="Hant" typeface="新細明體"/>
+        <a:font script="Arab" typeface="Arial"/>
+        <a:font script="Hebr" typeface="Arial"/>
+        <a:font script="Thai" typeface="Cordia New"/>
+        <a:font script="Ethi" typeface="Nyala"/>
+        <a:font script="Beng" typeface="Vrinda"/>
+        <a:font script="Gujr" typeface="Shruti"/>
+        <a:font script="Khmr" typeface="DaunPenh"/>
+        <a:font script="Knda" typeface="Tunga"/>
+        <a:font script="Guru" typeface="Raavi"/>
+        <a:font script="Cans" typeface="Euphemia"/>
+        <a:font script="Cher" typeface="Plantagenet Cherokee"/>
+        <a:font script="Yiii" typeface="Microsoft Yi Baiti"/>
+        <a:font script="Tibt" typeface="Microsoft Himalaya"/>
+        <a:font script="Thaa" typeface="MV Boli"/>
+        <a:font script="Deva" typeface="Mangal"/>
+        <a:font script="Telu" typeface="Gautami"/>
+        <a:font script="Taml" typeface="Latha"/>
+        <a:font script="Syrc" typeface="Estrangelo Edessa"/>
+        <a:font script="Orya" typeface="Kalinga"/>
+        <a:font script="Mlym" typeface="Kartika"/>
+        <a:font script="Laoo" typeface="DokChampa"/>
+        <a:font script="Sinh" typeface="Iskoola Pota"/>
+        <a:font script="Mong" typeface="Mongolian Baiti"/>
+        <a:font script="Viet" typeface="Arial"/>
+        <a:font script="Uigh" typeface="Microsoft Uighur"/>
+        <a:font script="Geor" typeface="Sylfaen"/>
+        <a:font script="Armn" typeface="Arial"/>
+        <a:font script="Bugi" typeface="Leelawadee UI"/>
+        <a:font script="Bopo" typeface="Microsoft JhengHei"/>
+        <a:font script="Java" typeface="Javanese Text"/>
+        <a:font script="Lisu" typeface="Segoe UI"/>
+        <a:font script="Mymr" typeface="Myanmar Text"/>
+        <a:font script="Nkoo" typeface="Ebrima"/>
+        <a:font script="Olck" typeface="Nirmala UI"/>
+        <a:font script="Osma" typeface="Ebrima"/>
+        <a:font script="Phag" typeface="Phagspa"/>
+        <a:font script="Syrn" typeface="Estrangelo Edessa"/>
+        <a:font script="Syrj" typeface="Estrangelo Edessa"/>
+        <a:font script="Syre" typeface="Estrangelo Edessa"/>
+        <a:font script="Sora" typeface="Nirmala UI"/>
+        <a:font script="Tale" typeface="Microsoft Tai Le"/>
+        <a:font script="Talu" typeface="Microsoft New Tai Lue"/>
+        <a:font script="Tfng" typeface="Ebrima"/>
+      </a:minorFont>
+    </a:fontScheme>
+    <a:fmtScheme name="Office">
+      <a:fillStyleLst>
+        <a:solidFill>
+          <a:schemeClr val="phClr"/>
+        </a:solidFill>
+        <a:gradFill rotWithShape="1">
+          <a:gsLst>
+            <a:gs pos="0">
+              <a:schemeClr val="phClr">
+                <a:lumMod val="110000"/>
+                <a:satMod val="105000"/>
+                <a:tint val="67000"/>
+              </a:schemeClr>
+            </a:gs>
+            <a:gs pos="50000">
+              <a:schemeClr val="phClr">
+                <a:lumMod val="105000"/>
+                <a:satMod val="103000"/>
+                <a:tint val="73000"/>
+              </a:schemeClr>
+            </a:gs>
+            <a:gs pos="100000">
+              <a:schemeClr val="phClr">
+                <a:lumMod val="105000"/>
+                <a:satMod val="109000"/>
+                <a:tint val="81000"/>
+              </a:schemeClr>
+            </a:gs>
+          </a:gsLst>
+          <a:lin ang="5400000" scaled="0"/>
+        </a:gradFill>
+        <a:gradFill rotWithShape="1">
+          <a:gsLst>
+            <a:gs pos="0">
+              <a:schemeClr val="phClr">
+                <a:satMod val="103000"/>
+                <a:lumMod val="102000"/>
+                <a:tint val="94000"/>
+              </a:schemeClr>
+            </a:gs>
+            <a:gs pos="50000">
+              <a:schemeClr val="phClr">
+                <a:satMod val="110000"/>
+                <a:lumMod val="100000"/>
+                <a:shade val="100000"/>
+              </a:schemeClr>
+            </a:gs>
+            <a:gs pos="100000">
+              <a:schemeClr val="phClr">
+                <a:lumMod val="99000"/>
+                <a:satMod val="120000"/>
+                <a:shade val="78000"/>
+              </a:schemeClr>
+            </a:gs>
+          </a:gsLst>
+          <a:lin ang="5400000" scaled="0"/>
+        </a:gradFill>
+      </a:fillStyleLst>
+      <a:lnStyleLst>
+        <a:ln w="12700" cap="flat" cmpd="sng" algn="ctr">
+          <a:solidFill>
+            <a:schemeClr val="phClr"/>
+          </a:solidFill>
+          <a:prstDash val="solid"/>
+          <a:miter lim="800000"/>
+        </a:ln>
+        <a:ln w="19050" cap="flat" cmpd="sng" algn="ctr">
+          <a:solidFill>
+            <a:schemeClr val="phClr"/>
+          </a:solidFill>
+          <a:prstDash val="solid"/>
+          <a:miter lim="800000"/>
+        </a:ln>
+        <a:ln w="25400" cap="flat" cmpd="sng" algn="ctr">
+          <a:solidFill>
+            <a:schemeClr val="phClr"/>
+          </a:solidFill>
+          <a:prstDash val="solid"/>
+          <a:miter lim="800000"/>
+        </a:ln>
+      </a:lnStyleLst>
+      <a:effectStyleLst>
+        <a:effectStyle>
+          <a:effectLst/>
+        </a:effectStyle>
+        <a:effectStyle>
+          <a:effectLst/>
+        </a:effectStyle>
+        <a:effectStyle>
+          <a:effectLst>
+            <a:outerShdw blurRad="57150" dist="19050" dir="5400000" algn="ctr" rotWithShape="0">
+              <a:srgbClr val="000000">
+                <a:alpha val="63000"/>
+              </a:srgbClr>
+            </a:outerShdw>
+          </a:effectLst>
+        </a:effectStyle>
+      </a:effectStyleLst>
+      <a:bgFillStyleLst>
+        <a:solidFill>
+          <a:schemeClr val="phClr"/>
+        </a:solidFill>
+        <a:solidFill>
+          <a:schemeClr val="phClr">
+            <a:tint val="95000"/>
+            <a:satMod val="170000"/>
+          </a:schemeClr>
+        </a:solidFill>
+        <a:gradFill rotWithShape="1">
+          <a:gsLst>
+            <a:gs pos="0">
+              <a:schemeClr val="phClr">
+                <a:tint val="93000"/>
+                <a:satMod val="150000"/>
+                <a:shade val="98000"/>
+                <a:lumMod val="102000"/>
+              </a:schemeClr>
+            </a:gs>
+            <a:gs pos="50000">
+              <a:schemeClr val="phClr">
+                <a:tint val="98000"/>
+                <a:satMod val="130000"/>
+                <a:shade val="90000"/>
+                <a:lumMod val="103000"/>
+              </a:schemeClr>
+            </a:gs>
+            <a:gs pos="100000">
+              <a:schemeClr val="phClr">
+                <a:shade val="63000"/>
+                <a:satMod val="120000"/>
+              </a:schemeClr>
+            </a:gs>
+          </a:gsLst>
+          <a:lin ang="5400000" scaled="0"/>
+        </a:gradFill>
+      </a:bgFillStyleLst>
+    </a:fmtScheme>
+  </a:themeElements>
+  <a:objectDefaults>
+    <a:lnDef>
+      <a:spPr/>
+      <a:bodyPr/>
+      <a:lstStyle/>
+      <a:style>
+        <a:lnRef idx="2">
+          <a:schemeClr val="accent1"/>
+        </a:lnRef>
+        <a:fillRef idx="0">
+          <a:schemeClr val="accent1"/>
+        </a:fillRef>
+        <a:effectRef idx="1">
+          <a:schemeClr val="accent1"/>
+        </a:effectRef>
+        <a:fontRef idx="minor">
+          <a:schemeClr val="tx1"/>
+        </a:fontRef>
+      </a:style>
+    </a:lnDef>
+  </a:objectDefaults>
+  <a:extraClrSchemeLst/>
+  <a:extLst>
+    <a:ext uri="{05A4C25C-085E-4340-85A3-A5531E510DB2}">
+      <thm15:themeFamily xmlns:thm15="http://schemas.microsoft.com/office/thememl/2012/main" name="Office Theme" id="{2E142A2C-CD16-42D6-873A-C26D2A0506FA}" vid="{1BDDFF52-6CD6-40A5-AB3C-68EB2F1E4D0A}"/>
+    </a:ext>
+  </a:extLst>
+</a:theme>
 </file>
</xml_diff>

<commit_message>
Update TDS briefing asset
Co-authored-by: gorgectf <194297338+gorgectf@users.noreply.github.com>
</commit_message>
<xml_diff>
--- a/public/RenterShield_PitchDeck_Revised.pptx
+++ b/public/RenterShield_PitchDeck_Revised.pptx
@@ -4,9 +4,6 @@
   <p:sldMasterIdLst>
     <p:sldMasterId id="2147483648" r:id="rId1"/>
   </p:sldMasterIdLst>
-  <p:notesMasterIdLst>
-    <p:notesMasterId r:id="rId14"/>
-  </p:notesMasterIdLst>
   <p:sldIdLst>
     <p:sldId id="256" r:id="rId2"/>
     <p:sldId id="257" r:id="rId3"/>
@@ -21,6 +18,9 @@
     <p:sldId id="266" r:id="rId12"/>
     <p:sldId id="267" r:id="rId13"/>
   </p:sldIdLst>
+  <p:notesMasterIdLst>
+    <p:notesMasterId r:id="rId14"/>
+  </p:notesMasterIdLst>
   <p:sldSz cx="12192000" cy="6858000"/>
   <p:notesSz cx="6858000" cy="12192000"/>
   <p:defaultTextStyle>
@@ -115,11 +115,6 @@
       </a:defRPr>
     </a:lvl9pPr>
   </p:defaultTextStyle>
-  <p:extLst>
-    <p:ext uri="{EFAFB233-063F-42B5-8137-9DF3F51BA10A}">
-      <p15:sldGuideLst xmlns:p15="http://schemas.microsoft.com/office/powerpoint/2012/main"/>
-    </p:ext>
-  </p:extLst>
 </p:presentation>
 </file>
 
@@ -145,10 +140,234 @@
           <a:chExt cx="0" cy="0"/>
         </a:xfrm>
       </p:grpSpPr>
+      <p:sp>
+        <p:nvSpPr>
+          <p:cNvPr id="2" name="Header Placeholder 1"/>
+          <p:cNvSpPr>
+            <a:spLocks noGrp="1"/>
+          </p:cNvSpPr>
+          <p:nvPr>
+            <p:ph type="hdr" sz="quarter"/>
+          </p:nvPr>
+        </p:nvSpPr>
+        <p:spPr>
+          <a:xfrm>
+            <a:off x="0" y="0"/>
+            <a:ext cx="2971800" cy="458788"/>
+          </a:xfrm>
+          <a:prstGeom prst="rect">
+            <a:avLst/>
+          </a:prstGeom>
+        </p:spPr>
+        <p:txBody>
+          <a:bodyPr vert="horz" lIns="91440" tIns="45720" rIns="91440" bIns="45720" rtlCol="0"/>
+          <a:lstStyle>
+            <a:lvl1pPr algn="l">
+              <a:defRPr sz="1200"/>
+            </a:lvl1pPr>
+          </a:lstStyle>
+          <a:p>
+            <a:endParaRPr lang="en-US"/>
+          </a:p>
+        </p:txBody>
+      </p:sp>
+      <p:sp>
+        <p:nvSpPr>
+          <p:cNvPr id="3" name="Date Placeholder 2"/>
+          <p:cNvSpPr>
+            <a:spLocks noGrp="1"/>
+          </p:cNvSpPr>
+          <p:nvPr>
+            <p:ph type="dt" idx="1"/>
+          </p:nvPr>
+        </p:nvSpPr>
+        <p:spPr>
+          <a:xfrm>
+            <a:off x="3884613" y="0"/>
+            <a:ext cx="2971800" cy="458788"/>
+          </a:xfrm>
+          <a:prstGeom prst="rect">
+            <a:avLst/>
+          </a:prstGeom>
+        </p:spPr>
+        <p:txBody>
+          <a:bodyPr vert="horz" lIns="91440" tIns="45720" rIns="91440" bIns="45720" rtlCol="0"/>
+          <a:lstStyle>
+            <a:lvl1pPr algn="r">
+              <a:defRPr sz="1200"/>
+            </a:lvl1pPr>
+          </a:lstStyle>
+          <a:p>
+            <a:fld id="{5282F153-3F37-0F45-9E97-73ACFA13230C}" type="datetimeFigureOut">
+              <a:rPr lang="en-US"/>
+              <a:t>7/23/19</a:t>
+            </a:fld>
+            <a:endParaRPr lang="en-US"/>
+          </a:p>
+        </p:txBody>
+      </p:sp>
+      <p:sp>
+        <p:nvSpPr>
+          <p:cNvPr id="4" name="Slide Image Placeholder 3"/>
+          <p:cNvSpPr>
+            <a:spLocks noGrp="1" noRot="1" noChangeAspect="1"/>
+          </p:cNvSpPr>
+          <p:nvPr>
+            <p:ph type="sldImg" idx="2"/>
+          </p:nvPr>
+        </p:nvSpPr>
+        <p:spPr>
+          <a:xfrm>
+            <a:off x="685800" y="1143000"/>
+            <a:ext cx="5486400" cy="3086100"/>
+          </a:xfrm>
+          <a:prstGeom prst="rect">
+            <a:avLst/>
+          </a:prstGeom>
+          <a:noFill/>
+          <a:ln w="12700">
+            <a:solidFill>
+              <a:prstClr val="black"/>
+            </a:solidFill>
+          </a:ln>
+        </p:spPr>
+        <p:txBody>
+          <a:bodyPr vert="horz" lIns="91440" tIns="45720" rIns="91440" bIns="45720" rtlCol="0" anchor="ctr"/>
+          <a:lstStyle/>
+          <a:p>
+            <a:endParaRPr lang="en-US"/>
+          </a:p>
+        </p:txBody>
+      </p:sp>
+      <p:sp>
+        <p:nvSpPr>
+          <p:cNvPr id="5" name="Notes Placeholder 4"/>
+          <p:cNvSpPr>
+            <a:spLocks noGrp="1"/>
+          </p:cNvSpPr>
+          <p:nvPr>
+            <p:ph type="body" sz="quarter" idx="3"/>
+          </p:nvPr>
+        </p:nvSpPr>
+        <p:spPr>
+          <a:xfrm>
+            <a:off x="685800" y="4400550"/>
+            <a:ext cx="5486400" cy="3600450"/>
+          </a:xfrm>
+          <a:prstGeom prst="rect">
+            <a:avLst/>
+          </a:prstGeom>
+        </p:spPr>
+        <p:txBody>
+          <a:bodyPr vert="horz" lIns="91440" tIns="45720" rIns="91440" bIns="45720" rtlCol="0"/>
+          <a:lstStyle/>
+          <a:p>
+            <a:pPr lvl="0"/>
+            <a:r>
+              <a:rPr lang="en-US"/>
+              <a:t>Click to edit Master text styles</a:t>
+            </a:r>
+          </a:p>
+          <a:p>
+            <a:pPr lvl="1"/>
+            <a:r>
+              <a:rPr lang="en-US"/>
+              <a:t>Second level</a:t>
+            </a:r>
+          </a:p>
+          <a:p>
+            <a:pPr lvl="2"/>
+            <a:r>
+              <a:rPr lang="en-US"/>
+              <a:t>Third level</a:t>
+            </a:r>
+          </a:p>
+          <a:p>
+            <a:pPr lvl="3"/>
+            <a:r>
+              <a:rPr lang="en-US"/>
+              <a:t>Fourth level</a:t>
+            </a:r>
+          </a:p>
+          <a:p>
+            <a:pPr lvl="4"/>
+            <a:r>
+              <a:rPr lang="en-US"/>
+              <a:t>Fifth level</a:t>
+            </a:r>
+          </a:p>
+        </p:txBody>
+      </p:sp>
+      <p:sp>
+        <p:nvSpPr>
+          <p:cNvPr id="6" name="Footer Placeholder 5"/>
+          <p:cNvSpPr>
+            <a:spLocks noGrp="1"/>
+          </p:cNvSpPr>
+          <p:nvPr>
+            <p:ph type="ftr" sz="quarter" idx="4"/>
+          </p:nvPr>
+        </p:nvSpPr>
+        <p:spPr>
+          <a:xfrm>
+            <a:off x="0" y="8685213"/>
+            <a:ext cx="2971800" cy="458787"/>
+          </a:xfrm>
+          <a:prstGeom prst="rect">
+            <a:avLst/>
+          </a:prstGeom>
+        </p:spPr>
+        <p:txBody>
+          <a:bodyPr vert="horz" lIns="91440" tIns="45720" rIns="91440" bIns="45720" rtlCol="0" anchor="b"/>
+          <a:lstStyle>
+            <a:lvl1pPr algn="l">
+              <a:defRPr sz="1200"/>
+            </a:lvl1pPr>
+          </a:lstStyle>
+          <a:p>
+            <a:endParaRPr lang="en-US"/>
+          </a:p>
+        </p:txBody>
+      </p:sp>
+      <p:sp>
+        <p:nvSpPr>
+          <p:cNvPr id="7" name="Slide Number Placeholder 6"/>
+          <p:cNvSpPr>
+            <a:spLocks noGrp="1"/>
+          </p:cNvSpPr>
+          <p:nvPr>
+            <p:ph type="sldNum" sz="quarter" idx="5"/>
+          </p:nvPr>
+        </p:nvSpPr>
+        <p:spPr>
+          <a:xfrm>
+            <a:off x="3884613" y="8685213"/>
+            <a:ext cx="2971800" cy="458787"/>
+          </a:xfrm>
+          <a:prstGeom prst="rect">
+            <a:avLst/>
+          </a:prstGeom>
+        </p:spPr>
+        <p:txBody>
+          <a:bodyPr vert="horz" lIns="91440" tIns="45720" rIns="91440" bIns="45720" rtlCol="0" anchor="b"/>
+          <a:lstStyle>
+            <a:lvl1pPr algn="r">
+              <a:defRPr sz="1200"/>
+            </a:lvl1pPr>
+          </a:lstStyle>
+          <a:p>
+            <a:fld id="{CE5E9CC1-C706-0F49-92D6-E571CC5EEA8F}" type="slidenum">
+              <a:rPr lang="en-US"/>
+              <a:t>‹#›</a:t>
+            </a:fld>
+            <a:endParaRPr lang="en-US"/>
+          </a:p>
+        </p:txBody>
+      </p:sp>
     </p:spTree>
     <p:extLst>
       <p:ext uri="{BB962C8B-B14F-4D97-AF65-F5344CB8AC3E}">
-        <p14:creationId xmlns:p14="http://schemas.microsoft.com/office/powerpoint/2010/main" val="4055006679"/>
+        <p14:creationId xmlns:p14="http://schemas.microsoft.com/office/powerpoint/2010/main" val="1024086991"/>
       </p:ext>
     </p:extLst>
   </p:cSld>
@@ -292,6 +511,10 @@
           <a:bodyPr/>
           <a:lstStyle/>
           <a:p>
+            <a:r>
+              <a:rPr lang="en-US" dirty="0"/>
+              <a:t/>
+            </a:r>
             <a:endParaRPr lang="en-US" dirty="0"/>
           </a:p>
         </p:txBody>
@@ -376,6 +599,10 @@
           <a:bodyPr/>
           <a:lstStyle/>
           <a:p>
+            <a:r>
+              <a:rPr lang="en-US" dirty="0"/>
+              <a:t/>
+            </a:r>
             <a:endParaRPr lang="en-US" dirty="0"/>
           </a:p>
         </p:txBody>
@@ -460,6 +687,10 @@
           <a:bodyPr/>
           <a:lstStyle/>
           <a:p>
+            <a:r>
+              <a:rPr lang="en-US" dirty="0"/>
+              <a:t/>
+            </a:r>
             <a:endParaRPr lang="en-US" dirty="0"/>
           </a:p>
         </p:txBody>
@@ -544,6 +775,10 @@
           <a:bodyPr/>
           <a:lstStyle/>
           <a:p>
+            <a:r>
+              <a:rPr lang="en-US" dirty="0"/>
+              <a:t/>
+            </a:r>
             <a:endParaRPr lang="en-US" dirty="0"/>
           </a:p>
         </p:txBody>
@@ -628,6 +863,10 @@
           <a:bodyPr/>
           <a:lstStyle/>
           <a:p>
+            <a:r>
+              <a:rPr lang="en-US" dirty="0"/>
+              <a:t/>
+            </a:r>
             <a:endParaRPr lang="en-US" dirty="0"/>
           </a:p>
         </p:txBody>
@@ -712,6 +951,10 @@
           <a:bodyPr/>
           <a:lstStyle/>
           <a:p>
+            <a:r>
+              <a:rPr lang="en-US" dirty="0"/>
+              <a:t/>
+            </a:r>
             <a:endParaRPr lang="en-US" dirty="0"/>
           </a:p>
         </p:txBody>
@@ -796,6 +1039,10 @@
           <a:bodyPr/>
           <a:lstStyle/>
           <a:p>
+            <a:r>
+              <a:rPr lang="en-US" dirty="0"/>
+              <a:t/>
+            </a:r>
             <a:endParaRPr lang="en-US" dirty="0"/>
           </a:p>
         </p:txBody>
@@ -880,6 +1127,10 @@
           <a:bodyPr/>
           <a:lstStyle/>
           <a:p>
+            <a:r>
+              <a:rPr lang="en-US" dirty="0"/>
+              <a:t/>
+            </a:r>
             <a:endParaRPr lang="en-US" dirty="0"/>
           </a:p>
         </p:txBody>
@@ -964,6 +1215,10 @@
           <a:bodyPr/>
           <a:lstStyle/>
           <a:p>
+            <a:r>
+              <a:rPr lang="en-US" dirty="0"/>
+              <a:t/>
+            </a:r>
             <a:endParaRPr lang="en-US" dirty="0"/>
           </a:p>
         </p:txBody>
@@ -1048,6 +1303,10 @@
           <a:bodyPr/>
           <a:lstStyle/>
           <a:p>
+            <a:r>
+              <a:rPr lang="en-US" dirty="0"/>
+              <a:t/>
+            </a:r>
             <a:endParaRPr lang="en-US" dirty="0"/>
           </a:p>
         </p:txBody>
@@ -1132,6 +1391,10 @@
           <a:bodyPr/>
           <a:lstStyle/>
           <a:p>
+            <a:r>
+              <a:rPr lang="en-US" dirty="0"/>
+              <a:t/>
+            </a:r>
             <a:endParaRPr lang="en-US" dirty="0"/>
           </a:p>
         </p:txBody>
@@ -1216,6 +1479,10 @@
           <a:bodyPr/>
           <a:lstStyle/>
           <a:p>
+            <a:r>
+              <a:rPr lang="en-US" dirty="0"/>
+              <a:t/>
+            </a:r>
             <a:endParaRPr lang="en-US" dirty="0"/>
           </a:p>
         </p:txBody>
@@ -1289,11 +1556,6 @@
 <file path=ppt/slideMasters/slideMaster1.xml><?xml version="1.0" encoding="utf-8"?>
 <p:sldMaster xmlns:a="http://schemas.openxmlformats.org/drawingml/2006/main" xmlns:r="http://schemas.openxmlformats.org/officeDocument/2006/relationships" xmlns:p="http://schemas.openxmlformats.org/presentationml/2006/main">
   <p:cSld>
-    <p:bg>
-      <p:bgRef idx="1001">
-        <a:schemeClr val="bg1"/>
-      </p:bgRef>
-    </p:bg>
     <p:spTree>
       <p:nvGrpSpPr>
         <p:cNvPr id="1" name=""/>
@@ -1576,7 +1838,6 @@
         <a:solidFill>
           <a:srgbClr val="0B132B"/>
         </a:solidFill>
-        <a:effectLst/>
       </p:bgPr>
     </p:bg>
     <p:spTree>
@@ -1620,7 +1881,7 @@
           <a:bodyPr wrap="square" rtlCol="0" anchor="ctr"/>
           <a:lstStyle/>
           <a:p>
-            <a:pPr marL="0" indent="0">
+            <a:pPr indent="0" marL="0">
               <a:buNone/>
             </a:pPr>
             <a:endParaRPr lang="en-US" dirty="0"/>
@@ -1648,7 +1909,7 @@
           <a:bodyPr wrap="square" rtlCol="0" anchor="ctr"/>
           <a:lstStyle/>
           <a:p>
-            <a:pPr marL="0" indent="0" algn="r">
+            <a:pPr algn="r" indent="0" marL="0">
               <a:buNone/>
             </a:pPr>
             <a:r>
@@ -1687,7 +1948,7 @@
           <a:bodyPr wrap="square" lIns="0" tIns="0" rIns="0" bIns="0" rtlCol="0" anchor="ctr"/>
           <a:lstStyle/>
           <a:p>
-            <a:pPr marL="0" indent="0">
+            <a:pPr indent="0" marL="0">
               <a:buNone/>
             </a:pPr>
             <a:r>
@@ -1726,7 +1987,7 @@
           <a:bodyPr wrap="square" lIns="0" tIns="0" rIns="0" bIns="0" rtlCol="0" anchor="ctr"/>
           <a:lstStyle/>
           <a:p>
-            <a:pPr marL="0" indent="0">
+            <a:pPr indent="0" marL="0">
               <a:buNone/>
             </a:pPr>
             <a:r>
@@ -1746,14 +2007,130 @@
       </p:sp>
       <p:sp>
         <p:nvSpPr>
+          <p:cNvPr id="6" name="Text 4"/>
+          <p:cNvSpPr/>
+          <p:nvPr/>
+        </p:nvSpPr>
+        <p:spPr>
+          <a:xfrm>
+            <a:off x="658368" y="2788920"/>
+            <a:ext cx="5669280" cy="1920240"/>
+          </a:xfrm>
+          <a:prstGeom prst="rect">
+            <a:avLst/>
+          </a:prstGeom>
+          <a:solidFill>
+            <a:srgbClr val="1C2541"/>
+          </a:solidFill>
+          <a:ln>
+            <a:solidFill>
+              <a:srgbClr val="314167"/>
+            </a:solidFill>
+          </a:ln>
+        </p:spPr>
+        <p:txBody>
+          <a:bodyPr wrap="square" rtlCol="0" anchor="ctr"/>
+          <a:lstStyle/>
+          <a:p>
+            <a:pPr indent="0" marL="0">
+              <a:buNone/>
+            </a:pPr>
+            <a:endParaRPr lang="en-US" dirty="0"/>
+          </a:p>
+        </p:txBody>
+      </p:sp>
+      <p:sp>
+        <p:nvSpPr>
+          <p:cNvPr id="7" name="Text 5"/>
+          <p:cNvSpPr/>
+          <p:nvPr/>
+        </p:nvSpPr>
+        <p:spPr>
+          <a:xfrm>
+            <a:off x="859536" y="2953512"/>
+            <a:ext cx="5266944" cy="274320"/>
+          </a:xfrm>
+          <a:prstGeom prst="rect">
+            <a:avLst/>
+          </a:prstGeom>
+          <a:noFill/>
+          <a:ln/>
+        </p:spPr>
+        <p:txBody>
+          <a:bodyPr wrap="square" lIns="0" tIns="0" rIns="0" bIns="0" rtlCol="0" anchor="ctr">
+            <a:normAutofit/>
+          </a:bodyPr>
+          <a:lstStyle/>
+          <a:p>
+            <a:pPr indent="0" marL="0">
+              <a:buNone/>
+            </a:pPr>
+            <a:r>
+              <a:rPr lang="en-US" sz="1300" b="1" dirty="0">
+                <a:solidFill>
+                  <a:srgbClr val="F8FAFC"/>
+                </a:solidFill>
+                <a:latin typeface="Aptos" pitchFamily="34" charset="0"/>
+                <a:ea typeface="Aptos" pitchFamily="34" charset="-122"/>
+                <a:cs typeface="Aptos" pitchFamily="34" charset="-120"/>
+              </a:rPr>
+              <a:t>What this deck now does better</a:t>
+            </a:r>
+            <a:endParaRPr lang="en-US" sz="1300" dirty="0"/>
+          </a:p>
+        </p:txBody>
+      </p:sp>
+      <p:sp>
+        <p:nvSpPr>
+          <p:cNvPr id="8" name="Text 6"/>
+          <p:cNvSpPr/>
+          <p:nvPr/>
+        </p:nvSpPr>
+        <p:spPr>
+          <a:xfrm>
+            <a:off x="859536" y="3291840"/>
+            <a:ext cx="5266944" cy="1261872"/>
+          </a:xfrm>
+          <a:prstGeom prst="rect">
+            <a:avLst/>
+          </a:prstGeom>
+          <a:noFill/>
+          <a:ln/>
+        </p:spPr>
+        <p:txBody>
+          <a:bodyPr wrap="square" lIns="0" tIns="0" rIns="0" bIns="0" rtlCol="0" anchor="t">
+            <a:normAutofit/>
+          </a:bodyPr>
+          <a:lstStyle/>
+          <a:p>
+            <a:pPr indent="0" marL="0">
+              <a:buNone/>
+            </a:pPr>
+            <a:r>
+              <a:rPr lang="en-US" sz="1100" dirty="0">
+                <a:solidFill>
+                  <a:srgbClr val="C9D1E0"/>
+                </a:solidFill>
+                <a:latin typeface="Aptos" pitchFamily="34" charset="0"/>
+                <a:ea typeface="Aptos" pitchFamily="34" charset="-122"/>
+                <a:cs typeface="Aptos" pitchFamily="34" charset="-120"/>
+              </a:rPr>
+              <a:t>Sharpens the problem, de-risks bold claims, shows what the prototype already proves, and frames RenterShield as a credible early-stage venture rather than just a useful project.</a:t>
+            </a:r>
+            <a:endParaRPr lang="en-US" sz="1100" dirty="0"/>
+          </a:p>
+        </p:txBody>
+      </p:sp>
+      <p:sp>
+        <p:nvSpPr>
           <p:cNvPr id="9" name="Text 7"/>
           <p:cNvSpPr/>
           <p:nvPr/>
         </p:nvSpPr>
         <p:spPr>
           <a:xfrm>
-            <a:off x="658368" y="2363820"/>
-            <a:ext cx="10817352" cy="2345339"/>
+            <a:off x="6720840" y="987552"/>
+            <a:ext cx="4754880" cy="3721608"/>
           </a:xfrm>
           <a:prstGeom prst="rect">
             <a:avLst/>
@@ -1771,7 +2148,7 @@
           <a:bodyPr wrap="square" rtlCol="0" anchor="ctr"/>
           <a:lstStyle/>
           <a:p>
-            <a:pPr marL="0" indent="0">
+            <a:pPr indent="0" marL="0">
               <a:buNone/>
             </a:pPr>
             <a:endParaRPr lang="en-US" dirty="0"/>
@@ -1786,7 +2163,7 @@
         </p:nvSpPr>
         <p:spPr>
           <a:xfrm>
-            <a:off x="871403" y="2521798"/>
+            <a:off x="6922008" y="1152144"/>
             <a:ext cx="4352544" cy="274320"/>
           </a:xfrm>
           <a:prstGeom prst="rect">
@@ -1801,7 +2178,7 @@
           </a:bodyPr>
           <a:lstStyle/>
           <a:p>
-            <a:pPr marL="0" indent="0">
+            <a:pPr indent="0" marL="0">
               <a:buNone/>
             </a:pPr>
             <a:r>
@@ -1827,7 +2204,7 @@
         </p:nvSpPr>
         <p:spPr>
           <a:xfrm>
-            <a:off x="871403" y="2860126"/>
+            <a:off x="6922008" y="1490472"/>
             <a:ext cx="4352544" cy="3063240"/>
           </a:xfrm>
           <a:prstGeom prst="rect">
@@ -1842,7 +2219,7 @@
           </a:bodyPr>
           <a:lstStyle/>
           <a:p>
-            <a:pPr marL="0" indent="0">
+            <a:pPr indent="0" marL="0">
               <a:buNone/>
             </a:pPr>
             <a:r>
@@ -1859,13 +2236,13 @@
             <a:endParaRPr lang="en-US" sz="1100" dirty="0"/>
           </a:p>
           <a:p>
-            <a:pPr marL="0" indent="0">
+            <a:pPr indent="0" marL="0">
               <a:buNone/>
             </a:pPr>
             <a:endParaRPr lang="en-US" sz="1100" dirty="0"/>
           </a:p>
           <a:p>
-            <a:pPr marL="0" indent="0">
+            <a:pPr indent="0" marL="0">
               <a:buNone/>
             </a:pPr>
             <a:r>
@@ -1882,7 +2259,7 @@
             <a:endParaRPr lang="en-US" sz="1100" dirty="0"/>
           </a:p>
           <a:p>
-            <a:pPr marL="0" indent="0">
+            <a:pPr indent="0" marL="0">
               <a:buNone/>
             </a:pPr>
             <a:r>
@@ -1899,7 +2276,7 @@
             <a:endParaRPr lang="en-US" sz="1100" dirty="0"/>
           </a:p>
           <a:p>
-            <a:pPr marL="0" indent="0">
+            <a:pPr indent="0" marL="0">
               <a:buNone/>
             </a:pPr>
             <a:r>
@@ -1916,7 +2293,7 @@
             <a:endParaRPr lang="en-US" sz="1100" dirty="0"/>
           </a:p>
           <a:p>
-            <a:pPr marL="0" indent="0">
+            <a:pPr indent="0" marL="0">
               <a:buNone/>
             </a:pPr>
             <a:r>
@@ -1933,7 +2310,7 @@
             <a:endParaRPr lang="en-US" sz="1100" dirty="0"/>
           </a:p>
           <a:p>
-            <a:pPr marL="0" indent="0">
+            <a:pPr indent="0" marL="0">
               <a:buNone/>
             </a:pPr>
             <a:r>
@@ -1972,7 +2349,7 @@
           <a:bodyPr wrap="square" lIns="0" tIns="0" rIns="0" bIns="0" rtlCol="0" anchor="ctr"/>
           <a:lstStyle/>
           <a:p>
-            <a:pPr marL="0" indent="0">
+            <a:pPr indent="0" marL="0">
               <a:buNone/>
             </a:pPr>
             <a:r>
@@ -2006,7 +2383,6 @@
         <a:solidFill>
           <a:srgbClr val="0B132B"/>
         </a:solidFill>
-        <a:effectLst/>
       </p:bgPr>
     </p:bg>
     <p:spTree>
@@ -2050,7 +2426,7 @@
           <a:bodyPr wrap="square" rtlCol="0" anchor="ctr"/>
           <a:lstStyle/>
           <a:p>
-            <a:pPr marL="0" indent="0">
+            <a:pPr indent="0" marL="0">
               <a:buNone/>
             </a:pPr>
             <a:endParaRPr lang="en-US" dirty="0"/>
@@ -2078,7 +2454,7 @@
           <a:bodyPr wrap="square" rtlCol="0" anchor="ctr"/>
           <a:lstStyle/>
           <a:p>
-            <a:pPr marL="0" indent="0" algn="r">
+            <a:pPr algn="r" indent="0" marL="0">
               <a:buNone/>
             </a:pPr>
             <a:r>
@@ -2117,7 +2493,7 @@
           <a:bodyPr wrap="square" rtlCol="0" anchor="ctr"/>
           <a:lstStyle/>
           <a:p>
-            <a:pPr marL="0" indent="0">
+            <a:pPr indent="0" marL="0">
               <a:buNone/>
             </a:pPr>
             <a:r>
@@ -2158,7 +2534,7 @@
           </a:bodyPr>
           <a:lstStyle/>
           <a:p>
-            <a:pPr marL="0" indent="0">
+            <a:pPr indent="0" marL="0">
               <a:buNone/>
             </a:pPr>
             <a:r>
@@ -2203,7 +2579,7 @@
           <a:bodyPr wrap="square" rtlCol="0" anchor="ctr"/>
           <a:lstStyle/>
           <a:p>
-            <a:pPr marL="0" indent="0">
+            <a:pPr indent="0" marL="0">
               <a:buNone/>
             </a:pPr>
             <a:endParaRPr lang="en-US" dirty="0"/>
@@ -2233,7 +2609,7 @@
           </a:bodyPr>
           <a:lstStyle/>
           <a:p>
-            <a:pPr marL="0" indent="0">
+            <a:pPr indent="0" marL="0">
               <a:buNone/>
             </a:pPr>
             <a:r>
@@ -2274,7 +2650,7 @@
           </a:bodyPr>
           <a:lstStyle/>
           <a:p>
-            <a:pPr marL="0" indent="0">
+            <a:pPr indent="0" marL="0">
               <a:buNone/>
             </a:pPr>
             <a:r>
@@ -2291,7 +2667,7 @@
             <a:endParaRPr lang="en-US" sz="1100" dirty="0"/>
           </a:p>
           <a:p>
-            <a:pPr marL="0" indent="0">
+            <a:pPr indent="0" marL="0">
               <a:buNone/>
             </a:pPr>
             <a:r>
@@ -2336,7 +2712,7 @@
           <a:bodyPr wrap="square" rtlCol="0" anchor="ctr"/>
           <a:lstStyle/>
           <a:p>
-            <a:pPr marL="0" indent="0">
+            <a:pPr indent="0" marL="0">
               <a:buNone/>
             </a:pPr>
             <a:endParaRPr lang="en-US" dirty="0"/>
@@ -2366,7 +2742,7 @@
           </a:bodyPr>
           <a:lstStyle/>
           <a:p>
-            <a:pPr marL="0" indent="0">
+            <a:pPr indent="0" marL="0">
               <a:buNone/>
             </a:pPr>
             <a:r>
@@ -2407,7 +2783,7 @@
           </a:bodyPr>
           <a:lstStyle/>
           <a:p>
-            <a:pPr marL="0" indent="0">
+            <a:pPr indent="0" marL="0">
               <a:buNone/>
             </a:pPr>
             <a:r>
@@ -2424,7 +2800,7 @@
             <a:endParaRPr lang="en-US" sz="1100" dirty="0"/>
           </a:p>
           <a:p>
-            <a:pPr marL="0" indent="0">
+            <a:pPr indent="0" marL="0">
               <a:buNone/>
             </a:pPr>
             <a:r>
@@ -2469,7 +2845,7 @@
           <a:bodyPr wrap="square" rtlCol="0" anchor="ctr"/>
           <a:lstStyle/>
           <a:p>
-            <a:pPr marL="0" indent="0">
+            <a:pPr indent="0" marL="0">
               <a:buNone/>
             </a:pPr>
             <a:endParaRPr lang="en-US" dirty="0"/>
@@ -2499,7 +2875,7 @@
           </a:bodyPr>
           <a:lstStyle/>
           <a:p>
-            <a:pPr marL="0" indent="0">
+            <a:pPr indent="0" marL="0">
               <a:buNone/>
             </a:pPr>
             <a:r>
@@ -2540,7 +2916,7 @@
           </a:bodyPr>
           <a:lstStyle/>
           <a:p>
-            <a:pPr marL="0" indent="0">
+            <a:pPr indent="0" marL="0">
               <a:buNone/>
             </a:pPr>
             <a:r>
@@ -2557,7 +2933,7 @@
             <a:endParaRPr lang="en-US" sz="1100" dirty="0"/>
           </a:p>
           <a:p>
-            <a:pPr marL="0" indent="0">
+            <a:pPr indent="0" marL="0">
               <a:buNone/>
             </a:pPr>
             <a:r>
@@ -2602,7 +2978,7 @@
           <a:bodyPr wrap="square" rtlCol="0" anchor="ctr"/>
           <a:lstStyle/>
           <a:p>
-            <a:pPr marL="0" indent="0">
+            <a:pPr indent="0" marL="0">
               <a:buNone/>
             </a:pPr>
             <a:endParaRPr lang="en-US" dirty="0"/>
@@ -2632,7 +3008,7 @@
           </a:bodyPr>
           <a:lstStyle/>
           <a:p>
-            <a:pPr marL="0" indent="0">
+            <a:pPr indent="0" marL="0">
               <a:buNone/>
             </a:pPr>
             <a:r>
@@ -2673,7 +3049,7 @@
           </a:bodyPr>
           <a:lstStyle/>
           <a:p>
-            <a:pPr marL="0" indent="0">
+            <a:pPr indent="0" marL="0">
               <a:buNone/>
             </a:pPr>
             <a:r>
@@ -2690,7 +3066,7 @@
             <a:endParaRPr lang="en-US" sz="1100" dirty="0"/>
           </a:p>
           <a:p>
-            <a:pPr marL="0" indent="0">
+            <a:pPr indent="0" marL="0">
               <a:buNone/>
             </a:pPr>
             <a:r>
@@ -2735,7 +3111,7 @@
           <a:bodyPr wrap="square" rtlCol="0" anchor="ctr"/>
           <a:lstStyle/>
           <a:p>
-            <a:pPr marL="0" indent="0">
+            <a:pPr indent="0" marL="0">
               <a:buNone/>
             </a:pPr>
             <a:endParaRPr lang="en-US" dirty="0"/>
@@ -2765,7 +3141,7 @@
           </a:bodyPr>
           <a:lstStyle/>
           <a:p>
-            <a:pPr marL="0" indent="0">
+            <a:pPr indent="0" marL="0">
               <a:buNone/>
             </a:pPr>
             <a:r>
@@ -2806,7 +3182,7 @@
           </a:bodyPr>
           <a:lstStyle/>
           <a:p>
-            <a:pPr marL="0" indent="0">
+            <a:pPr indent="0" marL="0">
               <a:buNone/>
             </a:pPr>
             <a:r>
@@ -2840,7 +3216,6 @@
         <a:solidFill>
           <a:srgbClr val="0B132B"/>
         </a:solidFill>
-        <a:effectLst/>
       </p:bgPr>
     </p:bg>
     <p:spTree>
@@ -2884,7 +3259,7 @@
           <a:bodyPr wrap="square" rtlCol="0" anchor="ctr"/>
           <a:lstStyle/>
           <a:p>
-            <a:pPr marL="0" indent="0">
+            <a:pPr indent="0" marL="0">
               <a:buNone/>
             </a:pPr>
             <a:endParaRPr lang="en-US" dirty="0"/>
@@ -2912,7 +3287,7 @@
           <a:bodyPr wrap="square" rtlCol="0" anchor="ctr"/>
           <a:lstStyle/>
           <a:p>
-            <a:pPr marL="0" indent="0" algn="r">
+            <a:pPr algn="r" indent="0" marL="0">
               <a:buNone/>
             </a:pPr>
             <a:r>
@@ -2951,7 +3326,7 @@
           <a:bodyPr wrap="square" rtlCol="0" anchor="ctr"/>
           <a:lstStyle/>
           <a:p>
-            <a:pPr marL="0" indent="0">
+            <a:pPr indent="0" marL="0">
               <a:buNone/>
             </a:pPr>
             <a:r>
@@ -2992,7 +3367,7 @@
           </a:bodyPr>
           <a:lstStyle/>
           <a:p>
-            <a:pPr marL="0" indent="0">
+            <a:pPr indent="0" marL="0">
               <a:buNone/>
             </a:pPr>
             <a:r>
@@ -3004,7 +3379,7 @@
                 <a:ea typeface="Aptos Display" pitchFamily="34" charset="-122"/>
                 <a:cs typeface="Aptos Display" pitchFamily="34" charset="-120"/>
               </a:rPr>
-              <a:t>Start with renter confidence and prevent avoidable losses, then scale through repeatable issue playbooks.</a:t>
+              <a:t>Start with renter confidence and prevent avoidable losses, then scale through repeatable issue playbooks and partner distribution.</a:t>
             </a:r>
             <a:endParaRPr lang="en-US" sz="2400" dirty="0"/>
           </a:p>
@@ -3037,7 +3412,7 @@
           <a:bodyPr wrap="square" rtlCol="0" anchor="ctr"/>
           <a:lstStyle/>
           <a:p>
-            <a:pPr marL="0" indent="0">
+            <a:pPr indent="0" marL="0">
               <a:buNone/>
             </a:pPr>
             <a:endParaRPr lang="en-US" dirty="0"/>
@@ -3067,7 +3442,7 @@
           </a:bodyPr>
           <a:lstStyle/>
           <a:p>
-            <a:pPr marL="0" indent="0">
+            <a:pPr indent="0" marL="0">
               <a:buNone/>
             </a:pPr>
             <a:r>
@@ -3108,7 +3483,7 @@
           </a:bodyPr>
           <a:lstStyle/>
           <a:p>
-            <a:pPr marL="0" indent="0">
+            <a:pPr indent="0" marL="0">
               <a:buNone/>
             </a:pPr>
             <a:r>
@@ -3153,7 +3528,7 @@
           <a:bodyPr wrap="square" rtlCol="0" anchor="ctr"/>
           <a:lstStyle/>
           <a:p>
-            <a:pPr marL="0" indent="0">
+            <a:pPr indent="0" marL="0">
               <a:buNone/>
             </a:pPr>
             <a:endParaRPr lang="en-US" dirty="0"/>
@@ -3183,7 +3558,7 @@
           </a:bodyPr>
           <a:lstStyle/>
           <a:p>
-            <a:pPr marL="0" indent="0">
+            <a:pPr indent="0" marL="0">
               <a:buNone/>
             </a:pPr>
             <a:r>
@@ -3224,7 +3599,7 @@
           </a:bodyPr>
           <a:lstStyle/>
           <a:p>
-            <a:pPr marL="0" indent="0">
+            <a:pPr indent="0" marL="0">
               <a:buNone/>
             </a:pPr>
             <a:r>
@@ -3236,7 +3611,7 @@
                 <a:ea typeface="Aptos" pitchFamily="34" charset="-122"/>
                 <a:cs typeface="Aptos" pitchFamily="34" charset="-120"/>
               </a:rPr>
-              <a:t>Expand issue coverage, improve trust signals, and add workflow tools that keep users engaged through a dispute lifecycle.</a:t>
+              <a:t>Expand issue coverage, reuse legal playbooks across regions, and add workflow tools that keep users engaged through a dispute lifecycle.</a:t>
             </a:r>
             <a:endParaRPr lang="en-US" sz="1100" dirty="0"/>
           </a:p>
@@ -3269,7 +3644,7 @@
           <a:bodyPr wrap="square" rtlCol="0" anchor="ctr"/>
           <a:lstStyle/>
           <a:p>
-            <a:pPr marL="0" indent="0">
+            <a:pPr indent="0" marL="0">
               <a:buNone/>
             </a:pPr>
             <a:endParaRPr lang="en-US" dirty="0"/>
@@ -3299,7 +3674,7 @@
           </a:bodyPr>
           <a:lstStyle/>
           <a:p>
-            <a:pPr marL="0" indent="0">
+            <a:pPr indent="0" marL="0">
               <a:buNone/>
             </a:pPr>
             <a:r>
@@ -3340,7 +3715,7 @@
           </a:bodyPr>
           <a:lstStyle/>
           <a:p>
-            <a:pPr marL="0" indent="0">
+            <a:pPr indent="0" marL="0">
               <a:buNone/>
             </a:pPr>
             <a:r>
@@ -3352,7 +3727,7 @@
                 <a:ea typeface="Aptos" pitchFamily="34" charset="-122"/>
                 <a:cs typeface="Aptos" pitchFamily="34" charset="-120"/>
               </a:rPr>
-              <a:t>Become the default self-serve platform for renter rights: practical guidance, outcome tracking, and eventually a trusted consumer legal brand.</a:t>
+              <a:t>Become the default self-serve platform for renter rights: practical guidance, outcome tracking, and a trusted consumer legal brand with institutional distribution.</a:t>
             </a:r>
             <a:endParaRPr lang="en-US" sz="1100" dirty="0"/>
           </a:p>
@@ -3385,7 +3760,7 @@
           <a:bodyPr wrap="square" rtlCol="0" anchor="ctr"/>
           <a:lstStyle/>
           <a:p>
-            <a:pPr marL="0" indent="0">
+            <a:pPr indent="0" marL="0">
               <a:buNone/>
             </a:pPr>
             <a:endParaRPr lang="en-US" dirty="0"/>
@@ -3415,7 +3790,7 @@
           </a:bodyPr>
           <a:lstStyle/>
           <a:p>
-            <a:pPr marL="0" indent="0">
+            <a:pPr indent="0" marL="0">
               <a:buNone/>
             </a:pPr>
             <a:r>
@@ -3427,7 +3802,7 @@
                 <a:ea typeface="Aptos" pitchFamily="34" charset="-122"/>
                 <a:cs typeface="Aptos" pitchFamily="34" charset="-120"/>
               </a:rPr>
-              <a:t>Feedback incorporated</a:t>
+              <a:t>Scale mechanics</a:t>
             </a:r>
             <a:endParaRPr lang="en-US" sz="1300" dirty="0"/>
           </a:p>
@@ -3456,7 +3831,7 @@
           </a:bodyPr>
           <a:lstStyle/>
           <a:p>
-            <a:pPr marL="0" indent="0">
+            <a:pPr indent="0" marL="0">
               <a:buNone/>
             </a:pPr>
             <a:r>
@@ -3468,7 +3843,7 @@
                 <a:ea typeface="Aptos" pitchFamily="34" charset="-122"/>
                 <a:cs typeface="Aptos" pitchFamily="34" charset="-120"/>
               </a:rPr>
-              <a:t>Unsupported claims have been removed. The slide now focuses on believable outcomes: faster action, higher confidence, broader issue coverage, and scalable product economics.</a:t>
+              <a:t>Scalability comes from repeatable issue journeys, searchable acquisition, reusable legal templates, and institutional pilots that can onboard groups of renters efficiently.</a:t>
             </a:r>
             <a:endParaRPr lang="en-US" sz="1100" dirty="0"/>
           </a:p>
@@ -3490,7 +3865,6 @@
         <a:solidFill>
           <a:srgbClr val="0B132B"/>
         </a:solidFill>
-        <a:effectLst/>
       </p:bgPr>
     </p:bg>
     <p:spTree>
@@ -3534,7 +3908,7 @@
           <a:bodyPr wrap="square" rtlCol="0" anchor="ctr"/>
           <a:lstStyle/>
           <a:p>
-            <a:pPr marL="0" indent="0">
+            <a:pPr indent="0" marL="0">
               <a:buNone/>
             </a:pPr>
             <a:endParaRPr lang="en-US" dirty="0"/>
@@ -3562,7 +3936,7 @@
           <a:bodyPr wrap="square" rtlCol="0" anchor="ctr"/>
           <a:lstStyle/>
           <a:p>
-            <a:pPr marL="0" indent="0" algn="r">
+            <a:pPr algn="r" indent="0" marL="0">
               <a:buNone/>
             </a:pPr>
             <a:r>
@@ -3601,7 +3975,7 @@
           <a:bodyPr wrap="square" rtlCol="0" anchor="ctr"/>
           <a:lstStyle/>
           <a:p>
-            <a:pPr marL="0" indent="0">
+            <a:pPr indent="0" marL="0">
               <a:buNone/>
             </a:pPr>
             <a:r>
@@ -3642,7 +4016,7 @@
           </a:bodyPr>
           <a:lstStyle/>
           <a:p>
-            <a:pPr marL="0" indent="0">
+            <a:pPr indent="0" marL="0">
               <a:buNone/>
             </a:pPr>
             <a:r>
@@ -3687,7 +4061,7 @@
           <a:bodyPr wrap="square" rtlCol="0" anchor="ctr"/>
           <a:lstStyle/>
           <a:p>
-            <a:pPr marL="0" indent="0">
+            <a:pPr indent="0" marL="0">
               <a:buNone/>
             </a:pPr>
             <a:endParaRPr lang="en-US" dirty="0"/>
@@ -3717,7 +4091,7 @@
           </a:bodyPr>
           <a:lstStyle/>
           <a:p>
-            <a:pPr marL="0" indent="0">
+            <a:pPr indent="0" marL="0">
               <a:buNone/>
             </a:pPr>
             <a:r>
@@ -3758,7 +4132,7 @@
           </a:bodyPr>
           <a:lstStyle/>
           <a:p>
-            <a:pPr marL="0" indent="0">
+            <a:pPr indent="0" marL="0">
               <a:buNone/>
             </a:pPr>
             <a:r>
@@ -3803,7 +4177,7 @@
           <a:bodyPr wrap="square" rtlCol="0" anchor="ctr"/>
           <a:lstStyle/>
           <a:p>
-            <a:pPr marL="0" indent="0">
+            <a:pPr indent="0" marL="0">
               <a:buNone/>
             </a:pPr>
             <a:endParaRPr lang="en-US" dirty="0"/>
@@ -3833,7 +4207,7 @@
           </a:bodyPr>
           <a:lstStyle/>
           <a:p>
-            <a:pPr marL="0" indent="0">
+            <a:pPr indent="0" marL="0">
               <a:buNone/>
             </a:pPr>
             <a:r>
@@ -3874,7 +4248,7 @@
           </a:bodyPr>
           <a:lstStyle/>
           <a:p>
-            <a:pPr marL="0" indent="0">
+            <a:pPr indent="0" marL="0">
               <a:buNone/>
             </a:pPr>
             <a:r>
@@ -3919,7 +4293,7 @@
           <a:bodyPr wrap="square" rtlCol="0" anchor="ctr"/>
           <a:lstStyle/>
           <a:p>
-            <a:pPr marL="0" indent="0">
+            <a:pPr indent="0" marL="0">
               <a:buNone/>
             </a:pPr>
             <a:endParaRPr lang="en-US" dirty="0"/>
@@ -3949,7 +4323,7 @@
           </a:bodyPr>
           <a:lstStyle/>
           <a:p>
-            <a:pPr marL="0" indent="0">
+            <a:pPr indent="0" marL="0">
               <a:buNone/>
             </a:pPr>
             <a:r>
@@ -3990,7 +4364,7 @@
           </a:bodyPr>
           <a:lstStyle/>
           <a:p>
-            <a:pPr marL="0" indent="0">
+            <a:pPr indent="0" marL="0">
               <a:buNone/>
             </a:pPr>
             <a:r>
@@ -4016,7 +4390,7 @@
         </p:nvSpPr>
         <p:spPr>
           <a:xfrm>
-            <a:off x="572104" y="4448556"/>
+            <a:off x="658368" y="4480560"/>
             <a:ext cx="10881360" cy="841248"/>
           </a:xfrm>
           <a:prstGeom prst="rect">
@@ -4035,7 +4409,7 @@
           <a:bodyPr wrap="square" rtlCol="0" anchor="ctr"/>
           <a:lstStyle/>
           <a:p>
-            <a:pPr marL="0" indent="0">
+            <a:pPr indent="0" marL="0">
               <a:buNone/>
             </a:pPr>
             <a:endParaRPr lang="en-US" dirty="0"/>
@@ -4065,7 +4439,7 @@
           </a:bodyPr>
           <a:lstStyle/>
           <a:p>
-            <a:pPr marL="0" indent="0">
+            <a:pPr indent="0" marL="0">
               <a:buNone/>
             </a:pPr>
             <a:r>
@@ -4106,7 +4480,7 @@
           </a:bodyPr>
           <a:lstStyle/>
           <a:p>
-            <a:pPr marL="0" indent="0">
+            <a:pPr indent="0" marL="0">
               <a:buNone/>
             </a:pPr>
             <a:r>
@@ -4140,7 +4514,6 @@
         <a:solidFill>
           <a:srgbClr val="0B132B"/>
         </a:solidFill>
-        <a:effectLst/>
       </p:bgPr>
     </p:bg>
     <p:spTree>
@@ -4184,7 +4557,7 @@
           <a:bodyPr wrap="square" rtlCol="0" anchor="ctr"/>
           <a:lstStyle/>
           <a:p>
-            <a:pPr marL="0" indent="0">
+            <a:pPr indent="0" marL="0">
               <a:buNone/>
             </a:pPr>
             <a:endParaRPr lang="en-US" dirty="0"/>
@@ -4212,7 +4585,7 @@
           <a:bodyPr wrap="square" rtlCol="0" anchor="ctr"/>
           <a:lstStyle/>
           <a:p>
-            <a:pPr marL="0" indent="0" algn="r">
+            <a:pPr algn="r" indent="0" marL="0">
               <a:buNone/>
             </a:pPr>
             <a:r>
@@ -4251,7 +4624,7 @@
           <a:bodyPr wrap="square" rtlCol="0" anchor="ctr"/>
           <a:lstStyle/>
           <a:p>
-            <a:pPr marL="0" indent="0">
+            <a:pPr indent="0" marL="0">
               <a:buNone/>
             </a:pPr>
             <a:r>
@@ -4292,7 +4665,7 @@
           </a:bodyPr>
           <a:lstStyle/>
           <a:p>
-            <a:pPr marL="0" indent="0">
+            <a:pPr indent="0" marL="0">
               <a:buNone/>
             </a:pPr>
             <a:r>
@@ -4304,7 +4677,7 @@
                 <a:ea typeface="Aptos Display" pitchFamily="34" charset="-122"/>
                 <a:cs typeface="Aptos Display" pitchFamily="34" charset="-120"/>
               </a:rPr>
-              <a:t>Renters hit legal problems fast — but the path to action is fragmented and intimidating.</a:t>
+              <a:t>Renters face high costs and urgent disputes, but the path to action is fragmented and intimidating.</a:t>
             </a:r>
             <a:endParaRPr lang="en-US" sz="2400" dirty="0"/>
           </a:p>
@@ -4337,7 +4710,7 @@
           <a:bodyPr wrap="square" rtlCol="0" anchor="ctr"/>
           <a:lstStyle/>
           <a:p>
-            <a:pPr marL="0" indent="0">
+            <a:pPr indent="0" marL="0">
               <a:buNone/>
             </a:pPr>
             <a:endParaRPr lang="en-US" dirty="0"/>
@@ -4365,7 +4738,7 @@
           <a:bodyPr wrap="square" lIns="0" tIns="0" rIns="0" bIns="0" rtlCol="0" anchor="ctr"/>
           <a:lstStyle/>
           <a:p>
-            <a:pPr marL="0" indent="0">
+            <a:pPr indent="0" marL="0">
               <a:buNone/>
             </a:pPr>
             <a:r>
@@ -4377,7 +4750,7 @@
                 <a:ea typeface="Aptos Display" pitchFamily="34" charset="-122"/>
                 <a:cs typeface="Aptos Display" pitchFamily="34" charset="-120"/>
               </a:rPr>
-              <a:t>4.6M</a:t>
+              <a:t>4.9M</a:t>
             </a:r>
             <a:endParaRPr lang="en-US" sz="2400" dirty="0"/>
           </a:p>
@@ -4406,7 +4779,7 @@
           </a:bodyPr>
           <a:lstStyle/>
           <a:p>
-            <a:pPr marL="0" indent="0">
+            <a:pPr indent="0" marL="0">
               <a:buNone/>
             </a:pPr>
             <a:r>
@@ -4418,7 +4791,7 @@
                 <a:ea typeface="Aptos" pitchFamily="34" charset="-122"/>
                 <a:cs typeface="Aptos" pitchFamily="34" charset="-120"/>
               </a:rPr>
-              <a:t>UK private renter households</a:t>
+              <a:t>Private rented homes in England &amp; Wales (TDS 2024/25)</a:t>
             </a:r>
             <a:endParaRPr lang="en-US" sz="1100" dirty="0"/>
           </a:p>
@@ -4451,7 +4824,7 @@
           <a:bodyPr wrap="square" rtlCol="0" anchor="ctr"/>
           <a:lstStyle/>
           <a:p>
-            <a:pPr marL="0" indent="0">
+            <a:pPr indent="0" marL="0">
               <a:buNone/>
             </a:pPr>
             <a:endParaRPr lang="en-US" dirty="0"/>
@@ -4479,7 +4852,7 @@
           <a:bodyPr wrap="square" lIns="0" tIns="0" rIns="0" bIns="0" rtlCol="0" anchor="ctr"/>
           <a:lstStyle/>
           <a:p>
-            <a:pPr marL="0" indent="0">
+            <a:pPr indent="0" marL="0">
               <a:buNone/>
             </a:pPr>
             <a:r>
@@ -4491,7 +4864,7 @@
                 <a:ea typeface="Aptos Display" pitchFamily="34" charset="-122"/>
                 <a:cs typeface="Aptos Display" pitchFamily="34" charset="-120"/>
               </a:rPr>
-              <a:t>£700M+</a:t>
+              <a:t>£5.53B</a:t>
             </a:r>
             <a:endParaRPr lang="en-US" sz="2400" dirty="0"/>
           </a:p>
@@ -4520,7 +4893,7 @@
           </a:bodyPr>
           <a:lstStyle/>
           <a:p>
-            <a:pPr marL="0" indent="0">
+            <a:pPr indent="0" marL="0">
               <a:buNone/>
             </a:pPr>
             <a:r>
@@ -4532,7 +4905,7 @@
                 <a:ea typeface="Aptos" pitchFamily="34" charset="-122"/>
                 <a:cs typeface="Aptos" pitchFamily="34" charset="-120"/>
               </a:rPr>
-              <a:t>Estimated value tied up in unfair deposit disputes</a:t>
+              <a:t>Protected deposit value in England &amp; Wales (TDS 2024/25)</a:t>
             </a:r>
             <a:endParaRPr lang="en-US" sz="1100" dirty="0"/>
           </a:p>
@@ -4565,7 +4938,7 @@
           <a:bodyPr wrap="square" rtlCol="0" anchor="ctr"/>
           <a:lstStyle/>
           <a:p>
-            <a:pPr marL="0" indent="0">
+            <a:pPr indent="0" marL="0">
               <a:buNone/>
             </a:pPr>
             <a:endParaRPr lang="en-US" dirty="0"/>
@@ -4593,7 +4966,7 @@
           <a:bodyPr wrap="square" lIns="0" tIns="0" rIns="0" bIns="0" rtlCol="0" anchor="ctr"/>
           <a:lstStyle/>
           <a:p>
-            <a:pPr marL="0" indent="0">
+            <a:pPr indent="0" marL="0">
               <a:buNone/>
             </a:pPr>
             <a:r>
@@ -4605,7 +4978,7 @@
                 <a:ea typeface="Aptos Display" pitchFamily="34" charset="-122"/>
                 <a:cs typeface="Aptos Display" pitchFamily="34" charset="-120"/>
               </a:rPr>
-              <a:t>57%</a:t>
+              <a:t>32%</a:t>
             </a:r>
             <a:endParaRPr lang="en-US" sz="2400" dirty="0"/>
           </a:p>
@@ -4634,7 +5007,7 @@
           </a:bodyPr>
           <a:lstStyle/>
           <a:p>
-            <a:pPr marL="0" indent="0">
+            <a:pPr indent="0" marL="0">
               <a:buNone/>
             </a:pPr>
             <a:r>
@@ -4646,7 +5019,7 @@
                 <a:ea typeface="Aptos" pitchFamily="34" charset="-122"/>
                 <a:cs typeface="Aptos" pitchFamily="34" charset="-120"/>
               </a:rPr>
-              <a:t>Renters who do not know how to challenge a landlord issue</a:t>
+              <a:t>Private renters spending half of income or more on rent (Shelter)</a:t>
             </a:r>
             <a:endParaRPr lang="en-US" sz="1100" dirty="0"/>
           </a:p>
@@ -4679,7 +5052,7 @@
           <a:bodyPr wrap="square" rtlCol="0" anchor="ctr"/>
           <a:lstStyle/>
           <a:p>
-            <a:pPr marL="0" indent="0">
+            <a:pPr indent="0" marL="0">
               <a:buNone/>
             </a:pPr>
             <a:endParaRPr lang="en-US" dirty="0"/>
@@ -4709,7 +5082,7 @@
           </a:bodyPr>
           <a:lstStyle/>
           <a:p>
-            <a:pPr marL="0" indent="0">
+            <a:pPr indent="0" marL="0">
               <a:buNone/>
             </a:pPr>
             <a:r>
@@ -4750,7 +5123,7 @@
           </a:bodyPr>
           <a:lstStyle/>
           <a:p>
-            <a:pPr marL="0" indent="0">
+            <a:pPr indent="0" marL="0">
               <a:buNone/>
             </a:pPr>
             <a:r>
@@ -4762,7 +5135,7 @@
                 <a:ea typeface="Aptos" pitchFamily="34" charset="-122"/>
                 <a:cs typeface="Aptos" pitchFamily="34" charset="-120"/>
               </a:rPr>
-              <a:t>People can usually find information somewhere — GOV.UK, Shelter, Citizens Advice, forums — but not in a form that quickly tells them what to do next in their exact situation. When the issue is urgent, legal jargon and fragmented guidance create delay, confusion, and avoidable losses.</a:t>
+              <a:t>Official and sector data point to the same problem: private renters face high housing costs, fast-moving disputes, and little confidence in what to do next. In England, renters aged 16–24 spend an average of 50% of income on rent, while 39% of private renters paid rent in advance as well as a deposit.</a:t>
             </a:r>
             <a:endParaRPr lang="en-US" sz="1100" dirty="0"/>
           </a:p>
@@ -4795,7 +5168,7 @@
           <a:bodyPr wrap="square" rtlCol="0" anchor="ctr"/>
           <a:lstStyle/>
           <a:p>
-            <a:pPr marL="0" indent="0">
+            <a:pPr indent="0" marL="0">
               <a:buNone/>
             </a:pPr>
             <a:endParaRPr lang="en-US" dirty="0"/>
@@ -4825,7 +5198,7 @@
           </a:bodyPr>
           <a:lstStyle/>
           <a:p>
-            <a:pPr marL="0" indent="0">
+            <a:pPr indent="0" marL="0">
               <a:buNone/>
             </a:pPr>
             <a:r>
@@ -4866,7 +5239,7 @@
           </a:bodyPr>
           <a:lstStyle/>
           <a:p>
-            <a:pPr marL="0" indent="0">
+            <a:pPr indent="0" marL="0">
               <a:buNone/>
             </a:pPr>
             <a:r>
@@ -4900,7 +5273,6 @@
         <a:solidFill>
           <a:srgbClr val="0B132B"/>
         </a:solidFill>
-        <a:effectLst/>
       </p:bgPr>
     </p:bg>
     <p:spTree>
@@ -4944,7 +5316,7 @@
           <a:bodyPr wrap="square" rtlCol="0" anchor="ctr"/>
           <a:lstStyle/>
           <a:p>
-            <a:pPr marL="0" indent="0">
+            <a:pPr indent="0" marL="0">
               <a:buNone/>
             </a:pPr>
             <a:endParaRPr lang="en-US" dirty="0"/>
@@ -4972,7 +5344,7 @@
           <a:bodyPr wrap="square" rtlCol="0" anchor="ctr"/>
           <a:lstStyle/>
           <a:p>
-            <a:pPr marL="0" indent="0" algn="r">
+            <a:pPr algn="r" indent="0" marL="0">
               <a:buNone/>
             </a:pPr>
             <a:r>
@@ -5011,7 +5383,7 @@
           <a:bodyPr wrap="square" rtlCol="0" anchor="ctr"/>
           <a:lstStyle/>
           <a:p>
-            <a:pPr marL="0" indent="0">
+            <a:pPr indent="0" marL="0">
               <a:buNone/>
             </a:pPr>
             <a:r>
@@ -5052,7 +5424,7 @@
           </a:bodyPr>
           <a:lstStyle/>
           <a:p>
-            <a:pPr marL="0" indent="0">
+            <a:pPr indent="0" marL="0">
               <a:buNone/>
             </a:pPr>
             <a:r>
@@ -5097,7 +5469,7 @@
           <a:bodyPr wrap="square" rtlCol="0" anchor="ctr"/>
           <a:lstStyle/>
           <a:p>
-            <a:pPr marL="0" indent="0">
+            <a:pPr indent="0" marL="0">
               <a:buNone/>
             </a:pPr>
             <a:endParaRPr lang="en-US" dirty="0"/>
@@ -5127,7 +5499,7 @@
           </a:bodyPr>
           <a:lstStyle/>
           <a:p>
-            <a:pPr marL="0" indent="0">
+            <a:pPr indent="0" marL="0">
               <a:buNone/>
             </a:pPr>
             <a:r>
@@ -5168,7 +5540,7 @@
           </a:bodyPr>
           <a:lstStyle/>
           <a:p>
-            <a:pPr marL="0" indent="0">
+            <a:pPr indent="0" marL="0">
               <a:buNone/>
             </a:pPr>
             <a:r>
@@ -5213,7 +5585,7 @@
           <a:bodyPr wrap="square" rtlCol="0" anchor="ctr"/>
           <a:lstStyle/>
           <a:p>
-            <a:pPr marL="0" indent="0">
+            <a:pPr indent="0" marL="0">
               <a:buNone/>
             </a:pPr>
             <a:endParaRPr lang="en-US" dirty="0"/>
@@ -5243,7 +5615,7 @@
           </a:bodyPr>
           <a:lstStyle/>
           <a:p>
-            <a:pPr marL="0" indent="0">
+            <a:pPr indent="0" marL="0">
               <a:buNone/>
             </a:pPr>
             <a:r>
@@ -5284,7 +5656,7 @@
           </a:bodyPr>
           <a:lstStyle/>
           <a:p>
-            <a:pPr marL="0" indent="0">
+            <a:pPr indent="0" marL="0">
               <a:buNone/>
             </a:pPr>
             <a:r>
@@ -5329,7 +5701,7 @@
           <a:bodyPr wrap="square" rtlCol="0" anchor="ctr"/>
           <a:lstStyle/>
           <a:p>
-            <a:pPr marL="0" indent="0">
+            <a:pPr indent="0" marL="0">
               <a:buNone/>
             </a:pPr>
             <a:endParaRPr lang="en-US" dirty="0"/>
@@ -5359,7 +5731,7 @@
           </a:bodyPr>
           <a:lstStyle/>
           <a:p>
-            <a:pPr marL="0" indent="0">
+            <a:pPr indent="0" marL="0">
               <a:buNone/>
             </a:pPr>
             <a:r>
@@ -5400,7 +5772,7 @@
           </a:bodyPr>
           <a:lstStyle/>
           <a:p>
-            <a:pPr marL="0" indent="0">
+            <a:pPr indent="0" marL="0">
               <a:buNone/>
             </a:pPr>
             <a:r>
@@ -5427,7 +5799,7 @@
         <p:spPr>
           <a:xfrm>
             <a:off x="658368" y="3767328"/>
-            <a:ext cx="5577840" cy="1371600"/>
+            <a:ext cx="5577840" cy="1554480"/>
           </a:xfrm>
           <a:prstGeom prst="rect">
             <a:avLst/>
@@ -5441,7 +5813,7 @@
           </a:bodyPr>
           <a:lstStyle/>
           <a:p>
-            <a:pPr marL="0" indent="0">
+            <a:pPr indent="0" marL="0">
               <a:buNone/>
             </a:pPr>
             <a:r>
@@ -5458,7 +5830,7 @@
             <a:endParaRPr lang="en-US" sz="1200" dirty="0"/>
           </a:p>
           <a:p>
-            <a:pPr marL="0" indent="0">
+            <a:pPr indent="0" marL="0">
               <a:buNone/>
             </a:pPr>
             <a:r>
@@ -5475,7 +5847,7 @@
             <a:endParaRPr lang="en-US" sz="1200" dirty="0"/>
           </a:p>
           <a:p>
-            <a:pPr marL="0" indent="0">
+            <a:pPr indent="0" marL="0">
               <a:buNone/>
             </a:pPr>
             <a:r>
@@ -5488,6 +5860,23 @@
                 <a:cs typeface="Aptos" pitchFamily="34" charset="-120"/>
               </a:rPr>
               <a:t>• Designed to get a renter from uncertainty to action in under two minutes</a:t>
+            </a:r>
+            <a:endParaRPr lang="en-US" sz="1200" dirty="0"/>
+          </a:p>
+          <a:p>
+            <a:pPr indent="0" marL="0">
+              <a:buNone/>
+            </a:pPr>
+            <a:r>
+              <a:rPr lang="en-US" sz="1200" dirty="0">
+                <a:solidFill>
+                  <a:srgbClr val="F8FAFC"/>
+                </a:solidFill>
+                <a:latin typeface="Aptos" pitchFamily="34" charset="0"/>
+                <a:ea typeface="Aptos" pitchFamily="34" charset="-122"/>
+                <a:cs typeface="Aptos" pitchFamily="34" charset="-120"/>
+              </a:rPr>
+              <a:t>• Demo: https://rentershield.lovable.app</a:t>
             </a:r>
             <a:endParaRPr lang="en-US" sz="1200" dirty="0"/>
           </a:p>
@@ -5520,7 +5909,7 @@
           <a:bodyPr wrap="square" rtlCol="0" anchor="ctr"/>
           <a:lstStyle/>
           <a:p>
-            <a:pPr marL="0" indent="0">
+            <a:pPr indent="0" marL="0">
               <a:buNone/>
             </a:pPr>
             <a:endParaRPr lang="en-US" dirty="0"/>
@@ -5550,7 +5939,7 @@
           </a:bodyPr>
           <a:lstStyle/>
           <a:p>
-            <a:pPr marL="0" indent="0">
+            <a:pPr indent="0" marL="0">
               <a:buNone/>
             </a:pPr>
             <a:r>
@@ -5591,7 +5980,7 @@
           </a:bodyPr>
           <a:lstStyle/>
           <a:p>
-            <a:pPr marL="0" indent="0">
+            <a:pPr indent="0" marL="0">
               <a:buNone/>
             </a:pPr>
             <a:r>
@@ -5625,7 +6014,6 @@
         <a:solidFill>
           <a:srgbClr val="0B132B"/>
         </a:solidFill>
-        <a:effectLst/>
       </p:bgPr>
     </p:bg>
     <p:spTree>
@@ -5669,7 +6057,7 @@
           <a:bodyPr wrap="square" rtlCol="0" anchor="ctr"/>
           <a:lstStyle/>
           <a:p>
-            <a:pPr marL="0" indent="0">
+            <a:pPr indent="0" marL="0">
               <a:buNone/>
             </a:pPr>
             <a:endParaRPr lang="en-US" dirty="0"/>
@@ -5697,7 +6085,7 @@
           <a:bodyPr wrap="square" rtlCol="0" anchor="ctr"/>
           <a:lstStyle/>
           <a:p>
-            <a:pPr marL="0" indent="0" algn="r">
+            <a:pPr algn="r" indent="0" marL="0">
               <a:buNone/>
             </a:pPr>
             <a:r>
@@ -5736,7 +6124,7 @@
           <a:bodyPr wrap="square" rtlCol="0" anchor="ctr"/>
           <a:lstStyle/>
           <a:p>
-            <a:pPr marL="0" indent="0">
+            <a:pPr indent="0" marL="0">
               <a:buNone/>
             </a:pPr>
             <a:r>
@@ -5777,7 +6165,7 @@
           </a:bodyPr>
           <a:lstStyle/>
           <a:p>
-            <a:pPr marL="0" indent="0">
+            <a:pPr indent="0" marL="0">
               <a:buNone/>
             </a:pPr>
             <a:r>
@@ -5789,7 +6177,7 @@
                 <a:ea typeface="Aptos Display" pitchFamily="34" charset="-122"/>
                 <a:cs typeface="Aptos Display" pitchFamily="34" charset="-120"/>
               </a:rPr>
-              <a:t>Big category, but the first wedge is a specific renter segment with a clearer path to revenue.</a:t>
+              <a:t>A large renter need exists, but the first wedge is a narrow segment with a realistic path to revenue.</a:t>
             </a:r>
             <a:endParaRPr lang="en-US" sz="2400" dirty="0"/>
           </a:p>
@@ -5822,7 +6210,7 @@
           <a:bodyPr wrap="square" rtlCol="0" anchor="ctr"/>
           <a:lstStyle/>
           <a:p>
-            <a:pPr marL="0" indent="0">
+            <a:pPr indent="0" marL="0">
               <a:buNone/>
             </a:pPr>
             <a:endParaRPr lang="en-US" dirty="0"/>
@@ -5852,7 +6240,7 @@
           </a:bodyPr>
           <a:lstStyle/>
           <a:p>
-            <a:pPr marL="0" indent="0">
+            <a:pPr indent="0" marL="0">
               <a:buNone/>
             </a:pPr>
             <a:r>
@@ -5893,7 +6281,7 @@
           </a:bodyPr>
           <a:lstStyle/>
           <a:p>
-            <a:pPr marL="0" indent="0">
+            <a:pPr indent="0" marL="0">
               <a:buNone/>
             </a:pPr>
             <a:r>
@@ -5905,12 +6293,12 @@
                 <a:ea typeface="Aptos" pitchFamily="34" charset="-122"/>
                 <a:cs typeface="Aptos" pitchFamily="34" charset="-120"/>
               </a:rPr>
-              <a:t>£2.1B</a:t>
+              <a:t>~£790M annual spend</a:t>
             </a:r>
             <a:endParaRPr lang="en-US" sz="1100" dirty="0"/>
           </a:p>
           <a:p>
-            <a:pPr marL="0" indent="0">
+            <a:pPr indent="0" marL="0">
               <a:buNone/>
             </a:pPr>
             <a:r>
@@ -5922,7 +6310,7 @@
                 <a:ea typeface="Aptos" pitchFamily="34" charset="-122"/>
                 <a:cs typeface="Aptos" pitchFamily="34" charset="-120"/>
               </a:rPr>
-              <a:t>UK housing-related legal support and adjacent consumer legal services.</a:t>
+              <a:t>Illustrative TAM using 4.706M protected deposits × £14/month for a workflow support subscription equivalent.</a:t>
             </a:r>
             <a:endParaRPr lang="en-US" sz="1100" dirty="0"/>
           </a:p>
@@ -5955,7 +6343,7 @@
           <a:bodyPr wrap="square" rtlCol="0" anchor="ctr"/>
           <a:lstStyle/>
           <a:p>
-            <a:pPr marL="0" indent="0">
+            <a:pPr indent="0" marL="0">
               <a:buNone/>
             </a:pPr>
             <a:endParaRPr lang="en-US" dirty="0"/>
@@ -5985,7 +6373,7 @@
           </a:bodyPr>
           <a:lstStyle/>
           <a:p>
-            <a:pPr marL="0" indent="0">
+            <a:pPr indent="0" marL="0">
               <a:buNone/>
             </a:pPr>
             <a:r>
@@ -6026,7 +6414,7 @@
           </a:bodyPr>
           <a:lstStyle/>
           <a:p>
-            <a:pPr marL="0" indent="0">
+            <a:pPr indent="0" marL="0">
               <a:buNone/>
             </a:pPr>
             <a:r>
@@ -6038,12 +6426,12 @@
                 <a:ea typeface="Aptos" pitchFamily="34" charset="-122"/>
                 <a:cs typeface="Aptos" pitchFamily="34" charset="-120"/>
               </a:rPr>
-              <a:t>£340M</a:t>
+              <a:t>~£95M annual spend</a:t>
             </a:r>
             <a:endParaRPr lang="en-US" sz="1100" dirty="0"/>
           </a:p>
           <a:p>
-            <a:pPr marL="0" indent="0">
+            <a:pPr indent="0" marL="0">
               <a:buNone/>
             </a:pPr>
             <a:r>
@@ -6055,7 +6443,7 @@
                 <a:ea typeface="Aptos" pitchFamily="34" charset="-122"/>
                 <a:cs typeface="Aptos" pitchFamily="34" charset="-120"/>
               </a:rPr>
-              <a:t>Digitally delivered guidance and workflow support for private renters facing deposit, repairs, eviction, or rent disputes.</a:t>
+              <a:t>Assume 12% of that market fits the first high-intent use case: digitally engaged renters facing disputes around deposits, repairs, eviction, or rent increases.</a:t>
             </a:r>
             <a:endParaRPr lang="en-US" sz="1100" dirty="0"/>
           </a:p>
@@ -6088,7 +6476,7 @@
           <a:bodyPr wrap="square" rtlCol="0" anchor="ctr"/>
           <a:lstStyle/>
           <a:p>
-            <a:pPr marL="0" indent="0">
+            <a:pPr indent="0" marL="0">
               <a:buNone/>
             </a:pPr>
             <a:endParaRPr lang="en-US" dirty="0"/>
@@ -6118,7 +6506,7 @@
           </a:bodyPr>
           <a:lstStyle/>
           <a:p>
-            <a:pPr marL="0" indent="0">
+            <a:pPr indent="0" marL="0">
               <a:buNone/>
             </a:pPr>
             <a:r>
@@ -6159,7 +6547,7 @@
           </a:bodyPr>
           <a:lstStyle/>
           <a:p>
-            <a:pPr marL="0" indent="0">
+            <a:pPr indent="0" marL="0">
               <a:buNone/>
             </a:pPr>
             <a:r>
@@ -6176,7 +6564,7 @@
             <a:endParaRPr lang="en-US" sz="1100" dirty="0"/>
           </a:p>
           <a:p>
-            <a:pPr marL="0" indent="0">
+            <a:pPr indent="0" marL="0">
               <a:buNone/>
             </a:pPr>
             <a:r>
@@ -6221,7 +6609,7 @@
           <a:bodyPr wrap="square" rtlCol="0" anchor="ctr"/>
           <a:lstStyle/>
           <a:p>
-            <a:pPr marL="0" indent="0">
+            <a:pPr indent="0" marL="0">
               <a:buNone/>
             </a:pPr>
             <a:endParaRPr lang="en-US" dirty="0"/>
@@ -6251,7 +6639,7 @@
           </a:bodyPr>
           <a:lstStyle/>
           <a:p>
-            <a:pPr marL="0" indent="0">
+            <a:pPr indent="0" marL="0">
               <a:buNone/>
             </a:pPr>
             <a:r>
@@ -6292,7 +6680,7 @@
           </a:bodyPr>
           <a:lstStyle/>
           <a:p>
-            <a:pPr marL="0" indent="0">
+            <a:pPr indent="0" marL="0">
               <a:buNone/>
             </a:pPr>
             <a:r>
@@ -6304,7 +6692,7 @@
                 <a:ea typeface="Aptos" pitchFamily="34" charset="-122"/>
                 <a:cs typeface="Aptos" pitchFamily="34" charset="-120"/>
               </a:rPr>
-              <a:t>Start with students and young professionals in private rentals: digitally native renters, high search intent, limited legal confidence, and strong need for fast self-serve support.</a:t>
+              <a:t>Start with students and young professionals in private rentals: digitally native renters, high search intent, limited legal confidence, and high exposure to upfront rent and deposit pressure.</a:t>
             </a:r>
             <a:endParaRPr lang="en-US" sz="1100" dirty="0"/>
           </a:p>
@@ -6337,7 +6725,7 @@
           <a:bodyPr wrap="square" rtlCol="0" anchor="ctr"/>
           <a:lstStyle/>
           <a:p>
-            <a:pPr marL="0" indent="0">
+            <a:pPr indent="0" marL="0">
               <a:buNone/>
             </a:pPr>
             <a:endParaRPr lang="en-US" dirty="0"/>
@@ -6367,7 +6755,7 @@
           </a:bodyPr>
           <a:lstStyle/>
           <a:p>
-            <a:pPr marL="0" indent="0">
+            <a:pPr indent="0" marL="0">
               <a:buNone/>
             </a:pPr>
             <a:r>
@@ -6379,7 +6767,7 @@
                 <a:ea typeface="Aptos" pitchFamily="34" charset="-122"/>
                 <a:cs typeface="Aptos" pitchFamily="34" charset="-120"/>
               </a:rPr>
-              <a:t>Research to cite</a:t>
+              <a:t>Evidence behind the story</a:t>
             </a:r>
             <a:endParaRPr lang="en-US" sz="1300" dirty="0"/>
           </a:p>
@@ -6408,7 +6796,7 @@
           </a:bodyPr>
           <a:lstStyle/>
           <a:p>
-            <a:pPr marL="0" indent="0">
+            <a:pPr indent="0" marL="0">
               <a:buNone/>
             </a:pPr>
             <a:r>
@@ -6420,7 +6808,7 @@
                 <a:ea typeface="Aptos" pitchFamily="34" charset="-122"/>
                 <a:cs typeface="Aptos" pitchFamily="34" charset="-120"/>
               </a:rPr>
-              <a:t>Support the story with English Housing Survey data, tenancy deposit dispute volumes, Shelter reporting, and UK private renter population figures.</a:t>
+              <a:t>TDS 2024/25 reports 4.706M protected deposits worth £5.53B. GOV.UK English Housing Survey 2023-24 shows younger renters spend 50% of income on rent. Shelter reports 32% of private renters spend half their income or more on rent.</a:t>
             </a:r>
             <a:endParaRPr lang="en-US" sz="1100" dirty="0"/>
           </a:p>
@@ -6442,7 +6830,6 @@
         <a:solidFill>
           <a:srgbClr val="0B132B"/>
         </a:solidFill>
-        <a:effectLst/>
       </p:bgPr>
     </p:bg>
     <p:spTree>
@@ -6486,7 +6873,7 @@
           <a:bodyPr wrap="square" rtlCol="0" anchor="ctr"/>
           <a:lstStyle/>
           <a:p>
-            <a:pPr marL="0" indent="0">
+            <a:pPr indent="0" marL="0">
               <a:buNone/>
             </a:pPr>
             <a:endParaRPr lang="en-US" dirty="0"/>
@@ -6514,7 +6901,7 @@
           <a:bodyPr wrap="square" rtlCol="0" anchor="ctr"/>
           <a:lstStyle/>
           <a:p>
-            <a:pPr marL="0" indent="0" algn="r">
+            <a:pPr algn="r" indent="0" marL="0">
               <a:buNone/>
             </a:pPr>
             <a:r>
@@ -6553,7 +6940,7 @@
           <a:bodyPr wrap="square" rtlCol="0" anchor="ctr"/>
           <a:lstStyle/>
           <a:p>
-            <a:pPr marL="0" indent="0">
+            <a:pPr indent="0" marL="0">
               <a:buNone/>
             </a:pPr>
             <a:r>
@@ -6594,7 +6981,7 @@
           </a:bodyPr>
           <a:lstStyle/>
           <a:p>
-            <a:pPr marL="0" indent="0">
+            <a:pPr indent="0" marL="0">
               <a:buNone/>
             </a:pPr>
             <a:r>
@@ -6639,7 +7026,7 @@
           <a:bodyPr wrap="square" rtlCol="0" anchor="ctr"/>
           <a:lstStyle/>
           <a:p>
-            <a:pPr marL="0" indent="0">
+            <a:pPr indent="0" marL="0">
               <a:buNone/>
             </a:pPr>
             <a:endParaRPr lang="en-US" dirty="0"/>
@@ -6669,7 +7056,7 @@
           </a:bodyPr>
           <a:lstStyle/>
           <a:p>
-            <a:pPr marL="0" indent="0">
+            <a:pPr indent="0" marL="0">
               <a:buNone/>
             </a:pPr>
             <a:r>
@@ -6710,7 +7097,7 @@
           </a:bodyPr>
           <a:lstStyle/>
           <a:p>
-            <a:pPr marL="0" indent="0">
+            <a:pPr indent="0" marL="0">
               <a:buNone/>
             </a:pPr>
             <a:r>
@@ -6755,7 +7142,7 @@
           <a:bodyPr wrap="square" rtlCol="0" anchor="ctr"/>
           <a:lstStyle/>
           <a:p>
-            <a:pPr marL="0" indent="0">
+            <a:pPr indent="0" marL="0">
               <a:buNone/>
             </a:pPr>
             <a:endParaRPr lang="en-US" dirty="0"/>
@@ -6785,7 +7172,7 @@
           </a:bodyPr>
           <a:lstStyle/>
           <a:p>
-            <a:pPr marL="0" indent="0">
+            <a:pPr indent="0" marL="0">
               <a:buNone/>
             </a:pPr>
             <a:r>
@@ -6826,7 +7213,7 @@
           </a:bodyPr>
           <a:lstStyle/>
           <a:p>
-            <a:pPr marL="0" indent="0">
+            <a:pPr indent="0" marL="0">
               <a:buNone/>
             </a:pPr>
             <a:r>
@@ -6871,7 +7258,7 @@
           <a:bodyPr wrap="square" rtlCol="0" anchor="ctr"/>
           <a:lstStyle/>
           <a:p>
-            <a:pPr marL="0" indent="0">
+            <a:pPr indent="0" marL="0">
               <a:buNone/>
             </a:pPr>
             <a:endParaRPr lang="en-US" dirty="0"/>
@@ -6901,7 +7288,7 @@
           </a:bodyPr>
           <a:lstStyle/>
           <a:p>
-            <a:pPr marL="0" indent="0">
+            <a:pPr indent="0" marL="0">
               <a:buNone/>
             </a:pPr>
             <a:r>
@@ -6942,7 +7329,7 @@
           </a:bodyPr>
           <a:lstStyle/>
           <a:p>
-            <a:pPr marL="0" indent="0">
+            <a:pPr indent="0" marL="0">
               <a:buNone/>
             </a:pPr>
             <a:r>
@@ -6987,7 +7374,7 @@
           <a:bodyPr wrap="square" rtlCol="0" anchor="ctr"/>
           <a:lstStyle/>
           <a:p>
-            <a:pPr marL="0" indent="0">
+            <a:pPr indent="0" marL="0">
               <a:buNone/>
             </a:pPr>
             <a:endParaRPr lang="en-US" dirty="0"/>
@@ -7017,7 +7404,7 @@
           </a:bodyPr>
           <a:lstStyle/>
           <a:p>
-            <a:pPr marL="0" indent="0">
+            <a:pPr indent="0" marL="0">
               <a:buNone/>
             </a:pPr>
             <a:r>
@@ -7058,7 +7445,7 @@
           </a:bodyPr>
           <a:lstStyle/>
           <a:p>
-            <a:pPr marL="0" indent="0">
+            <a:pPr indent="0" marL="0">
               <a:buNone/>
             </a:pPr>
             <a:r>
@@ -7092,7 +7479,6 @@
         <a:solidFill>
           <a:srgbClr val="0B132B"/>
         </a:solidFill>
-        <a:effectLst/>
       </p:bgPr>
     </p:bg>
     <p:spTree>
@@ -7136,7 +7522,7 @@
           <a:bodyPr wrap="square" rtlCol="0" anchor="ctr"/>
           <a:lstStyle/>
           <a:p>
-            <a:pPr marL="0" indent="0">
+            <a:pPr indent="0" marL="0">
               <a:buNone/>
             </a:pPr>
             <a:endParaRPr lang="en-US" dirty="0"/>
@@ -7164,7 +7550,7 @@
           <a:bodyPr wrap="square" rtlCol="0" anchor="ctr"/>
           <a:lstStyle/>
           <a:p>
-            <a:pPr marL="0" indent="0" algn="r">
+            <a:pPr algn="r" indent="0" marL="0">
               <a:buNone/>
             </a:pPr>
             <a:r>
@@ -7203,7 +7589,7 @@
           <a:bodyPr wrap="square" rtlCol="0" anchor="ctr"/>
           <a:lstStyle/>
           <a:p>
-            <a:pPr marL="0" indent="0">
+            <a:pPr indent="0" marL="0">
               <a:buNone/>
             </a:pPr>
             <a:r>
@@ -7244,7 +7630,7 @@
           </a:bodyPr>
           <a:lstStyle/>
           <a:p>
-            <a:pPr marL="0" indent="0">
+            <a:pPr indent="0" marL="0">
               <a:buNone/>
             </a:pPr>
             <a:r>
@@ -7289,7 +7675,7 @@
           <a:bodyPr wrap="square" rtlCol="0" anchor="ctr"/>
           <a:lstStyle/>
           <a:p>
-            <a:pPr marL="0" indent="0">
+            <a:pPr indent="0" marL="0">
               <a:buNone/>
             </a:pPr>
             <a:endParaRPr lang="en-US" dirty="0"/>
@@ -7319,7 +7705,7 @@
           </a:bodyPr>
           <a:lstStyle/>
           <a:p>
-            <a:pPr marL="0" indent="0">
+            <a:pPr indent="0" marL="0">
               <a:buNone/>
             </a:pPr>
             <a:r>
@@ -7360,7 +7746,7 @@
           </a:bodyPr>
           <a:lstStyle/>
           <a:p>
-            <a:pPr marL="0" indent="0">
+            <a:pPr indent="0" marL="0">
               <a:buNone/>
             </a:pPr>
             <a:r>
@@ -7405,7 +7791,7 @@
           <a:bodyPr wrap="square" rtlCol="0" anchor="ctr"/>
           <a:lstStyle/>
           <a:p>
-            <a:pPr marL="0" indent="0">
+            <a:pPr indent="0" marL="0">
               <a:buNone/>
             </a:pPr>
             <a:endParaRPr lang="en-US" dirty="0"/>
@@ -7435,7 +7821,7 @@
           </a:bodyPr>
           <a:lstStyle/>
           <a:p>
-            <a:pPr marL="0" indent="0">
+            <a:pPr indent="0" marL="0">
               <a:buNone/>
             </a:pPr>
             <a:r>
@@ -7476,7 +7862,7 @@
           </a:bodyPr>
           <a:lstStyle/>
           <a:p>
-            <a:pPr marL="0" indent="0">
+            <a:pPr indent="0" marL="0">
               <a:buNone/>
             </a:pPr>
             <a:r>
@@ -7521,7 +7907,7 @@
           <a:bodyPr wrap="square" rtlCol="0" anchor="ctr"/>
           <a:lstStyle/>
           <a:p>
-            <a:pPr marL="0" indent="0">
+            <a:pPr indent="0" marL="0">
               <a:buNone/>
             </a:pPr>
             <a:endParaRPr lang="en-US" dirty="0"/>
@@ -7551,7 +7937,7 @@
           </a:bodyPr>
           <a:lstStyle/>
           <a:p>
-            <a:pPr marL="0" indent="0">
+            <a:pPr indent="0" marL="0">
               <a:buNone/>
             </a:pPr>
             <a:r>
@@ -7592,7 +7978,7 @@
           </a:bodyPr>
           <a:lstStyle/>
           <a:p>
-            <a:pPr marL="0" indent="0">
+            <a:pPr indent="0" marL="0">
               <a:buNone/>
             </a:pPr>
             <a:r>
@@ -7637,7 +8023,7 @@
           <a:bodyPr wrap="square" rtlCol="0" anchor="ctr"/>
           <a:lstStyle/>
           <a:p>
-            <a:pPr marL="0" indent="0">
+            <a:pPr indent="0" marL="0">
               <a:buNone/>
             </a:pPr>
             <a:endParaRPr lang="en-US" dirty="0"/>
@@ -7667,7 +8053,7 @@
           </a:bodyPr>
           <a:lstStyle/>
           <a:p>
-            <a:pPr marL="0" indent="0">
+            <a:pPr indent="0" marL="0">
               <a:buNone/>
             </a:pPr>
             <a:r>
@@ -7708,7 +8094,7 @@
           </a:bodyPr>
           <a:lstStyle/>
           <a:p>
-            <a:pPr marL="0" indent="0">
+            <a:pPr indent="0" marL="0">
               <a:buNone/>
             </a:pPr>
             <a:r>
@@ -7753,7 +8139,7 @@
           <a:bodyPr wrap="square" rtlCol="0" anchor="ctr"/>
           <a:lstStyle/>
           <a:p>
-            <a:pPr marL="0" indent="0">
+            <a:pPr indent="0" marL="0">
               <a:buNone/>
             </a:pPr>
             <a:endParaRPr lang="en-US" dirty="0"/>
@@ -7783,7 +8169,7 @@
           </a:bodyPr>
           <a:lstStyle/>
           <a:p>
-            <a:pPr marL="0" indent="0">
+            <a:pPr indent="0" marL="0">
               <a:buNone/>
             </a:pPr>
             <a:r>
@@ -7824,7 +8210,7 @@
           </a:bodyPr>
           <a:lstStyle/>
           <a:p>
-            <a:pPr marL="0" indent="0">
+            <a:pPr indent="0" marL="0">
               <a:buNone/>
             </a:pPr>
             <a:r>
@@ -7858,7 +8244,6 @@
         <a:solidFill>
           <a:srgbClr val="0B132B"/>
         </a:solidFill>
-        <a:effectLst/>
       </p:bgPr>
     </p:bg>
     <p:spTree>
@@ -7902,7 +8287,7 @@
           <a:bodyPr wrap="square" rtlCol="0" anchor="ctr"/>
           <a:lstStyle/>
           <a:p>
-            <a:pPr marL="0" indent="0">
+            <a:pPr indent="0" marL="0">
               <a:buNone/>
             </a:pPr>
             <a:endParaRPr lang="en-US" dirty="0"/>
@@ -7930,7 +8315,7 @@
           <a:bodyPr wrap="square" rtlCol="0" anchor="ctr"/>
           <a:lstStyle/>
           <a:p>
-            <a:pPr marL="0" indent="0" algn="r">
+            <a:pPr algn="r" indent="0" marL="0">
               <a:buNone/>
             </a:pPr>
             <a:r>
@@ -7969,7 +8354,7 @@
           <a:bodyPr wrap="square" rtlCol="0" anchor="ctr"/>
           <a:lstStyle/>
           <a:p>
-            <a:pPr marL="0" indent="0">
+            <a:pPr indent="0" marL="0">
               <a:buNone/>
             </a:pPr>
             <a:r>
@@ -8010,7 +8395,7 @@
           </a:bodyPr>
           <a:lstStyle/>
           <a:p>
-            <a:pPr marL="0" indent="0">
+            <a:pPr indent="0" marL="0">
               <a:buNone/>
             </a:pPr>
             <a:r>
@@ -8055,7 +8440,7 @@
           <a:bodyPr wrap="square" rtlCol="0" anchor="ctr"/>
           <a:lstStyle/>
           <a:p>
-            <a:pPr marL="0" indent="0">
+            <a:pPr indent="0" marL="0">
               <a:buNone/>
             </a:pPr>
             <a:endParaRPr lang="en-US" dirty="0"/>
@@ -8085,7 +8470,7 @@
           </a:bodyPr>
           <a:lstStyle/>
           <a:p>
-            <a:pPr marL="0" indent="0">
+            <a:pPr indent="0" marL="0">
               <a:buNone/>
             </a:pPr>
             <a:r>
@@ -8126,7 +8511,7 @@
           </a:bodyPr>
           <a:lstStyle/>
           <a:p>
-            <a:pPr marL="0" indent="0">
+            <a:pPr indent="0" marL="0">
               <a:buNone/>
             </a:pPr>
             <a:r>
@@ -8171,7 +8556,7 @@
           <a:bodyPr wrap="square" rtlCol="0" anchor="ctr"/>
           <a:lstStyle/>
           <a:p>
-            <a:pPr marL="0" indent="0">
+            <a:pPr indent="0" marL="0">
               <a:buNone/>
             </a:pPr>
             <a:endParaRPr lang="en-US" dirty="0"/>
@@ -8201,7 +8586,7 @@
           </a:bodyPr>
           <a:lstStyle/>
           <a:p>
-            <a:pPr marL="0" indent="0">
+            <a:pPr indent="0" marL="0">
               <a:buNone/>
             </a:pPr>
             <a:r>
@@ -8242,7 +8627,7 @@
           </a:bodyPr>
           <a:lstStyle/>
           <a:p>
-            <a:pPr marL="0" indent="0">
+            <a:pPr indent="0" marL="0">
               <a:buNone/>
             </a:pPr>
             <a:r>
@@ -8287,7 +8672,7 @@
           <a:bodyPr wrap="square" rtlCol="0" anchor="ctr"/>
           <a:lstStyle/>
           <a:p>
-            <a:pPr marL="0" indent="0">
+            <a:pPr indent="0" marL="0">
               <a:buNone/>
             </a:pPr>
             <a:endParaRPr lang="en-US" dirty="0"/>
@@ -8317,7 +8702,7 @@
           </a:bodyPr>
           <a:lstStyle/>
           <a:p>
-            <a:pPr marL="0" indent="0">
+            <a:pPr indent="0" marL="0">
               <a:buNone/>
             </a:pPr>
             <a:r>
@@ -8358,7 +8743,7 @@
           </a:bodyPr>
           <a:lstStyle/>
           <a:p>
-            <a:pPr marL="0" indent="0">
+            <a:pPr indent="0" marL="0">
               <a:buNone/>
             </a:pPr>
             <a:r>
@@ -8403,7 +8788,7 @@
           <a:bodyPr wrap="square" rtlCol="0" anchor="ctr"/>
           <a:lstStyle/>
           <a:p>
-            <a:pPr marL="0" indent="0">
+            <a:pPr indent="0" marL="0">
               <a:buNone/>
             </a:pPr>
             <a:endParaRPr lang="en-US" dirty="0"/>
@@ -8433,7 +8818,7 @@
           </a:bodyPr>
           <a:lstStyle/>
           <a:p>
-            <a:pPr marL="0" indent="0">
+            <a:pPr indent="0" marL="0">
               <a:buNone/>
             </a:pPr>
             <a:r>
@@ -8474,7 +8859,7 @@
           </a:bodyPr>
           <a:lstStyle/>
           <a:p>
-            <a:pPr marL="0" indent="0">
+            <a:pPr indent="0" marL="0">
               <a:buNone/>
             </a:pPr>
             <a:r>
@@ -8508,7 +8893,6 @@
         <a:solidFill>
           <a:srgbClr val="0B132B"/>
         </a:solidFill>
-        <a:effectLst/>
       </p:bgPr>
     </p:bg>
     <p:spTree>
@@ -8552,7 +8936,7 @@
           <a:bodyPr wrap="square" rtlCol="0" anchor="ctr"/>
           <a:lstStyle/>
           <a:p>
-            <a:pPr marL="0" indent="0">
+            <a:pPr indent="0" marL="0">
               <a:buNone/>
             </a:pPr>
             <a:endParaRPr lang="en-US" dirty="0"/>
@@ -8580,7 +8964,7 @@
           <a:bodyPr wrap="square" rtlCol="0" anchor="ctr"/>
           <a:lstStyle/>
           <a:p>
-            <a:pPr marL="0" indent="0" algn="r">
+            <a:pPr algn="r" indent="0" marL="0">
               <a:buNone/>
             </a:pPr>
             <a:r>
@@ -8619,7 +9003,7 @@
           <a:bodyPr wrap="square" rtlCol="0" anchor="ctr"/>
           <a:lstStyle/>
           <a:p>
-            <a:pPr marL="0" indent="0">
+            <a:pPr indent="0" marL="0">
               <a:buNone/>
             </a:pPr>
             <a:r>
@@ -8660,7 +9044,7 @@
           </a:bodyPr>
           <a:lstStyle/>
           <a:p>
-            <a:pPr marL="0" indent="0">
+            <a:pPr indent="0" marL="0">
               <a:buNone/>
             </a:pPr>
             <a:r>
@@ -8672,7 +9056,7 @@
                 <a:ea typeface="Aptos Display" pitchFamily="34" charset="-122"/>
                 <a:cs typeface="Aptos Display" pitchFamily="34" charset="-120"/>
               </a:rPr>
-              <a:t>The prototype proves usability; next validation should focus on trust, willingness to pay, and the best first segment.</a:t>
+              <a:t>The prototype proves usability; the next validation layer is trust, willingness to pay, and repeatable acquisition.</a:t>
             </a:r>
             <a:endParaRPr lang="en-US" sz="2400" dirty="0"/>
           </a:p>
@@ -8705,7 +9089,7 @@
           <a:bodyPr wrap="square" rtlCol="0" anchor="ctr"/>
           <a:lstStyle/>
           <a:p>
-            <a:pPr marL="0" indent="0">
+            <a:pPr indent="0" marL="0">
               <a:buNone/>
             </a:pPr>
             <a:endParaRPr lang="en-US" dirty="0"/>
@@ -8735,7 +9119,7 @@
           </a:bodyPr>
           <a:lstStyle/>
           <a:p>
-            <a:pPr marL="0" indent="0">
+            <a:pPr indent="0" marL="0">
               <a:buNone/>
             </a:pPr>
             <a:r>
@@ -8776,7 +9160,7 @@
           </a:bodyPr>
           <a:lstStyle/>
           <a:p>
-            <a:pPr marL="0" indent="0">
+            <a:pPr indent="0" marL="0">
               <a:buNone/>
             </a:pPr>
             <a:r>
@@ -8793,7 +9177,7 @@
             <a:endParaRPr lang="en-US" sz="1100" dirty="0"/>
           </a:p>
           <a:p>
-            <a:pPr marL="0" indent="0">
+            <a:pPr indent="0" marL="0">
               <a:buNone/>
             </a:pPr>
             <a:r>
@@ -8810,7 +9194,7 @@
             <a:endParaRPr lang="en-US" sz="1100" dirty="0"/>
           </a:p>
           <a:p>
-            <a:pPr marL="0" indent="0">
+            <a:pPr indent="0" marL="0">
               <a:buNone/>
             </a:pPr>
             <a:r>
@@ -8827,7 +9211,7 @@
             <a:endParaRPr lang="en-US" sz="1100" dirty="0"/>
           </a:p>
           <a:p>
-            <a:pPr marL="0" indent="0">
+            <a:pPr indent="0" marL="0">
               <a:buNone/>
             </a:pPr>
             <a:r>
@@ -8844,7 +9228,7 @@
             <a:endParaRPr lang="en-US" sz="1100" dirty="0"/>
           </a:p>
           <a:p>
-            <a:pPr marL="0" indent="0">
+            <a:pPr indent="0" marL="0">
               <a:buNone/>
             </a:pPr>
             <a:r>
@@ -8889,7 +9273,7 @@
           <a:bodyPr wrap="square" rtlCol="0" anchor="ctr"/>
           <a:lstStyle/>
           <a:p>
-            <a:pPr marL="0" indent="0">
+            <a:pPr indent="0" marL="0">
               <a:buNone/>
             </a:pPr>
             <a:endParaRPr lang="en-US" dirty="0"/>
@@ -8919,7 +9303,7 @@
           </a:bodyPr>
           <a:lstStyle/>
           <a:p>
-            <a:pPr marL="0" indent="0">
+            <a:pPr indent="0" marL="0">
               <a:buNone/>
             </a:pPr>
             <a:r>
@@ -8960,7 +9344,7 @@
           </a:bodyPr>
           <a:lstStyle/>
           <a:p>
-            <a:pPr marL="0" indent="0">
+            <a:pPr indent="0" marL="0">
               <a:buNone/>
             </a:pPr>
             <a:r>
@@ -8977,7 +9361,7 @@
             <a:endParaRPr lang="en-US" sz="1100" dirty="0"/>
           </a:p>
           <a:p>
-            <a:pPr marL="0" indent="0">
+            <a:pPr indent="0" marL="0">
               <a:buNone/>
             </a:pPr>
             <a:r>
@@ -8994,7 +9378,7 @@
             <a:endParaRPr lang="en-US" sz="1100" dirty="0"/>
           </a:p>
           <a:p>
-            <a:pPr marL="0" indent="0">
+            <a:pPr indent="0" marL="0">
               <a:buNone/>
             </a:pPr>
             <a:r>
@@ -9011,7 +9395,7 @@
             <a:endParaRPr lang="en-US" sz="1100" dirty="0"/>
           </a:p>
           <a:p>
-            <a:pPr marL="0" indent="0">
+            <a:pPr indent="0" marL="0">
               <a:buNone/>
             </a:pPr>
             <a:r>
@@ -9056,7 +9440,7 @@
           <a:bodyPr wrap="square" rtlCol="0" anchor="ctr"/>
           <a:lstStyle/>
           <a:p>
-            <a:pPr marL="0" indent="0">
+            <a:pPr indent="0" marL="0">
               <a:buNone/>
             </a:pPr>
             <a:endParaRPr lang="en-US" dirty="0"/>
@@ -9086,7 +9470,7 @@
           </a:bodyPr>
           <a:lstStyle/>
           <a:p>
-            <a:pPr marL="0" indent="0">
+            <a:pPr indent="0" marL="0">
               <a:buNone/>
             </a:pPr>
             <a:r>
@@ -9098,7 +9482,7 @@
                 <a:ea typeface="Aptos" pitchFamily="34" charset="-122"/>
                 <a:cs typeface="Aptos" pitchFamily="34" charset="-120"/>
               </a:rPr>
-              <a:t>Renter feedback</a:t>
+              <a:t>User testing and iteration</a:t>
             </a:r>
             <a:endParaRPr lang="en-US" sz="1300" dirty="0"/>
           </a:p>
@@ -9123,13 +9507,12 @@
         </p:spPr>
         <p:txBody>
           <a:bodyPr wrap="square" lIns="0" tIns="0" rIns="0" bIns="0" rtlCol="0" anchor="t">
-            <a:normAutofit lnSpcReduction="10000"/>
+            <a:normAutofit/>
           </a:bodyPr>
           <a:lstStyle/>
           <a:p>
-            <a:pPr marL="171450" indent="-171450">
-              <a:buFontTx/>
-              <a:buChar char="-"/>
+            <a:pPr indent="0" marL="0">
+              <a:buNone/>
             </a:pPr>
             <a:r>
               <a:rPr lang="en-US" sz="1100" dirty="0">
@@ -9140,13 +9523,13 @@
                 <a:ea typeface="Aptos" pitchFamily="34" charset="-122"/>
                 <a:cs typeface="Aptos" pitchFamily="34" charset="-120"/>
               </a:rPr>
-              <a:t>Close friends of in their twenties, who had poor renting experiences, gave feedback on my app’s ability to clearly show renters’ rights and explant what support is available.</a:t>
-            </a:r>
-          </a:p>
-          <a:p>
-            <a:pPr marL="171450" indent="-171450">
-              <a:buFontTx/>
-              <a:buChar char="-"/>
+              <a:t>• Young renters said the issue flows felt clearer than searching forums or government pages</a:t>
+            </a:r>
+            <a:endParaRPr lang="en-US" sz="1100" dirty="0"/>
+          </a:p>
+          <a:p>
+            <a:pPr indent="0" marL="0">
+              <a:buNone/>
             </a:pPr>
             <a:r>
               <a:rPr lang="en-US" sz="1100" dirty="0">
@@ -9157,13 +9540,13 @@
                 <a:ea typeface="Aptos" pitchFamily="34" charset="-122"/>
                 <a:cs typeface="Aptos" pitchFamily="34" charset="-120"/>
               </a:rPr>
-              <a:t>Their feedback is focused on making the app more useful for young renters by presenting rights, responsibilities, and next steps in a simple and accessible way.</a:t>
-            </a:r>
-          </a:p>
-          <a:p>
-            <a:pPr marL="171450" indent="-171450">
-              <a:buFontTx/>
-              <a:buChar char="-"/>
+              <a:t>• Feedback favoured simple language, clear disclaimers, and obvious next steps over legal depth</a:t>
+            </a:r>
+            <a:endParaRPr lang="en-US" sz="1100" dirty="0"/>
+          </a:p>
+          <a:p>
+            <a:pPr indent="0" marL="0">
+              <a:buNone/>
             </a:pPr>
             <a:r>
               <a:rPr lang="en-US" sz="1100" dirty="0">
@@ -9174,8 +9557,9 @@
                 <a:ea typeface="Aptos" pitchFamily="34" charset="-122"/>
                 <a:cs typeface="Aptos" pitchFamily="34" charset="-120"/>
               </a:rPr>
-              <a:t>Because they had faced issues themselves, their input helped shape how the app guides users towards practical help with renter’s rights.</a:t>
-            </a:r>
+              <a:t>• Product changes: sharpened region selection, clarified emergency routes, and reframed monetisation around stressful 'premium moments'</a:t>
+            </a:r>
+            <a:endParaRPr lang="en-US" sz="1100" dirty="0"/>
           </a:p>
         </p:txBody>
       </p:sp>
@@ -9206,7 +9590,7 @@
           <a:bodyPr wrap="square" rtlCol="0" anchor="ctr"/>
           <a:lstStyle/>
           <a:p>
-            <a:pPr marL="0" indent="0">
+            <a:pPr indent="0" marL="0">
               <a:buNone/>
             </a:pPr>
             <a:endParaRPr lang="en-US" dirty="0"/>
@@ -9236,7 +9620,7 @@
           </a:bodyPr>
           <a:lstStyle/>
           <a:p>
-            <a:pPr marL="0" indent="0">
+            <a:pPr indent="0" marL="0">
               <a:buNone/>
             </a:pPr>
             <a:r>
@@ -9277,7 +9661,7 @@
           </a:bodyPr>
           <a:lstStyle/>
           <a:p>
-            <a:pPr marL="0" indent="0">
+            <a:pPr indent="0" marL="0">
               <a:buNone/>
             </a:pPr>
             <a:r>
@@ -9311,7 +9695,6 @@
         <a:solidFill>
           <a:srgbClr val="0B132B"/>
         </a:solidFill>
-        <a:effectLst/>
       </p:bgPr>
     </p:bg>
     <p:spTree>
@@ -9355,7 +9738,7 @@
           <a:bodyPr wrap="square" rtlCol="0" anchor="ctr"/>
           <a:lstStyle/>
           <a:p>
-            <a:pPr marL="0" indent="0">
+            <a:pPr indent="0" marL="0">
               <a:buNone/>
             </a:pPr>
             <a:endParaRPr lang="en-US" dirty="0"/>
@@ -9383,7 +9766,7 @@
           <a:bodyPr wrap="square" rtlCol="0" anchor="ctr"/>
           <a:lstStyle/>
           <a:p>
-            <a:pPr marL="0" indent="0" algn="r">
+            <a:pPr algn="r" indent="0" marL="0">
               <a:buNone/>
             </a:pPr>
             <a:r>
@@ -9422,7 +9805,7 @@
           <a:bodyPr wrap="square" rtlCol="0" anchor="ctr"/>
           <a:lstStyle/>
           <a:p>
-            <a:pPr marL="0" indent="0">
+            <a:pPr indent="0" marL="0">
               <a:buNone/>
             </a:pPr>
             <a:r>
@@ -9463,7 +9846,7 @@
           </a:bodyPr>
           <a:lstStyle/>
           <a:p>
-            <a:pPr marL="0" indent="0">
+            <a:pPr indent="0" marL="0">
               <a:buNone/>
             </a:pPr>
             <a:r>
@@ -9508,7 +9891,7 @@
           <a:bodyPr wrap="square" rtlCol="0" anchor="ctr"/>
           <a:lstStyle/>
           <a:p>
-            <a:pPr marL="0" indent="0">
+            <a:pPr indent="0" marL="0">
               <a:buNone/>
             </a:pPr>
             <a:endParaRPr lang="en-US" dirty="0"/>
@@ -9538,7 +9921,7 @@
           </a:bodyPr>
           <a:lstStyle/>
           <a:p>
-            <a:pPr marL="0" indent="0">
+            <a:pPr indent="0" marL="0">
               <a:buNone/>
             </a:pPr>
             <a:r>
@@ -9579,7 +9962,7 @@
           </a:bodyPr>
           <a:lstStyle/>
           <a:p>
-            <a:pPr marL="0" indent="0">
+            <a:pPr indent="0" marL="0">
               <a:buNone/>
             </a:pPr>
             <a:r>
@@ -9596,13 +9979,13 @@
             <a:endParaRPr lang="en-US" sz="1100" dirty="0"/>
           </a:p>
           <a:p>
-            <a:pPr marL="0" indent="0">
+            <a:pPr indent="0" marL="0">
               <a:buNone/>
             </a:pPr>
             <a:endParaRPr lang="en-US" sz="1100" dirty="0"/>
           </a:p>
           <a:p>
-            <a:pPr marL="0" indent="0">
+            <a:pPr indent="0" marL="0">
               <a:buNone/>
             </a:pPr>
             <a:r>
@@ -9647,7 +10030,7 @@
           <a:bodyPr wrap="square" rtlCol="0" anchor="ctr"/>
           <a:lstStyle/>
           <a:p>
-            <a:pPr marL="0" indent="0">
+            <a:pPr indent="0" marL="0">
               <a:buNone/>
             </a:pPr>
             <a:endParaRPr lang="en-US" dirty="0"/>
@@ -9677,7 +10060,7 @@
           </a:bodyPr>
           <a:lstStyle/>
           <a:p>
-            <a:pPr marL="0" indent="0">
+            <a:pPr indent="0" marL="0">
               <a:buNone/>
             </a:pPr>
             <a:r>
@@ -9718,7 +10101,7 @@
           </a:bodyPr>
           <a:lstStyle/>
           <a:p>
-            <a:pPr marL="0" indent="0">
+            <a:pPr indent="0" marL="0">
               <a:buNone/>
             </a:pPr>
             <a:r>
@@ -9735,7 +10118,7 @@
             <a:endParaRPr lang="en-US" sz="1100" dirty="0"/>
           </a:p>
           <a:p>
-            <a:pPr marL="0" indent="0">
+            <a:pPr indent="0" marL="0">
               <a:buNone/>
             </a:pPr>
             <a:r>
@@ -9752,7 +10135,7 @@
             <a:endParaRPr lang="en-US" sz="1100" dirty="0"/>
           </a:p>
           <a:p>
-            <a:pPr marL="0" indent="0">
+            <a:pPr indent="0" marL="0">
               <a:buNone/>
             </a:pPr>
             <a:r>
@@ -9769,7 +10152,7 @@
             <a:endParaRPr lang="en-US" sz="1100" dirty="0"/>
           </a:p>
           <a:p>
-            <a:pPr marL="0" indent="0">
+            <a:pPr indent="0" marL="0">
               <a:buNone/>
             </a:pPr>
             <a:r>
@@ -9808,7 +10191,7 @@
           <a:bodyPr wrap="square" lIns="0" tIns="0" rIns="0" bIns="0" rtlCol="0" anchor="ctr"/>
           <a:lstStyle/>
           <a:p>
-            <a:pPr marL="0" indent="0">
+            <a:pPr indent="0" marL="0">
               <a:buNone/>
             </a:pPr>
             <a:r>
@@ -10127,319 +10510,4 @@
     </a:ext>
   </a:extLst>
 </a:theme>
-</file>
-
-<file path=ppt/theme/theme2.xml><?xml version="1.0" encoding="utf-8"?>
-<a:theme xmlns:a="http://schemas.openxmlformats.org/drawingml/2006/main" name="Office Theme">
-  <a:themeElements>
-    <a:clrScheme name="Office">
-      <a:dk1>
-        <a:sysClr val="windowText" lastClr="000000"/>
-      </a:dk1>
-      <a:lt1>
-        <a:sysClr val="window" lastClr="FFFFFF"/>
-      </a:lt1>
-      <a:dk2>
-        <a:srgbClr val="0E2841"/>
-      </a:dk2>
-      <a:lt2>
-        <a:srgbClr val="E8E8E8"/>
-      </a:lt2>
-      <a:accent1>
-        <a:srgbClr val="156082"/>
-      </a:accent1>
-      <a:accent2>
-        <a:srgbClr val="E97132"/>
-      </a:accent2>
-      <a:accent3>
-        <a:srgbClr val="196B24"/>
-      </a:accent3>
-      <a:accent4>
-        <a:srgbClr val="0F9ED5"/>
-      </a:accent4>
-      <a:accent5>
-        <a:srgbClr val="A02B93"/>
-      </a:accent5>
-      <a:accent6>
-        <a:srgbClr val="4EA72E"/>
-      </a:accent6>
-      <a:hlink>
-        <a:srgbClr val="467886"/>
-      </a:hlink>
-      <a:folHlink>
-        <a:srgbClr val="96607D"/>
-      </a:folHlink>
-    </a:clrScheme>
-    <a:fontScheme name="Office">
-      <a:majorFont>
-        <a:latin typeface="Aptos Display" panose="02110004020202020204"/>
-        <a:ea typeface=""/>
-        <a:cs typeface=""/>
-        <a:font script="Jpan" typeface="游ゴシック Light"/>
-        <a:font script="Hang" typeface="맑은 고딕"/>
-        <a:font script="Hans" typeface="等线 Light"/>
-        <a:font script="Hant" typeface="新細明體"/>
-        <a:font script="Arab" typeface="Times New Roman"/>
-        <a:font script="Hebr" typeface="Times New Roman"/>
-        <a:font script="Thai" typeface="Angsana New"/>
-        <a:font script="Ethi" typeface="Nyala"/>
-        <a:font script="Beng" typeface="Vrinda"/>
-        <a:font script="Gujr" typeface="Shruti"/>
-        <a:font script="Khmr" typeface="MoolBoran"/>
-        <a:font script="Knda" typeface="Tunga"/>
-        <a:font script="Guru" typeface="Raavi"/>
-        <a:font script="Cans" typeface="Euphemia"/>
-        <a:font script="Cher" typeface="Plantagenet Cherokee"/>
-        <a:font script="Yiii" typeface="Microsoft Yi Baiti"/>
-        <a:font script="Tibt" typeface="Microsoft Himalaya"/>
-        <a:font script="Thaa" typeface="MV Boli"/>
-        <a:font script="Deva" typeface="Mangal"/>
-        <a:font script="Telu" typeface="Gautami"/>
-        <a:font script="Taml" typeface="Latha"/>
-        <a:font script="Syrc" typeface="Estrangelo Edessa"/>
-        <a:font script="Orya" typeface="Kalinga"/>
-        <a:font script="Mlym" typeface="Kartika"/>
-        <a:font script="Laoo" typeface="DokChampa"/>
-        <a:font script="Sinh" typeface="Iskoola Pota"/>
-        <a:font script="Mong" typeface="Mongolian Baiti"/>
-        <a:font script="Viet" typeface="Times New Roman"/>
-        <a:font script="Uigh" typeface="Microsoft Uighur"/>
-        <a:font script="Geor" typeface="Sylfaen"/>
-        <a:font script="Armn" typeface="Arial"/>
-        <a:font script="Bugi" typeface="Leelawadee UI"/>
-        <a:font script="Bopo" typeface="Microsoft JhengHei"/>
-        <a:font script="Java" typeface="Javanese Text"/>
-        <a:font script="Lisu" typeface="Segoe UI"/>
-        <a:font script="Mymr" typeface="Myanmar Text"/>
-        <a:font script="Nkoo" typeface="Ebrima"/>
-        <a:font script="Olck" typeface="Nirmala UI"/>
-        <a:font script="Osma" typeface="Ebrima"/>
-        <a:font script="Phag" typeface="Phagspa"/>
-        <a:font script="Syrn" typeface="Estrangelo Edessa"/>
-        <a:font script="Syrj" typeface="Estrangelo Edessa"/>
-        <a:font script="Syre" typeface="Estrangelo Edessa"/>
-        <a:font script="Sora" typeface="Nirmala UI"/>
-        <a:font script="Tale" typeface="Microsoft Tai Le"/>
-        <a:font script="Talu" typeface="Microsoft New Tai Lue"/>
-        <a:font script="Tfng" typeface="Ebrima"/>
-      </a:majorFont>
-      <a:minorFont>
-        <a:latin typeface="Aptos" panose="02110004020202020204"/>
-        <a:ea typeface=""/>
-        <a:cs typeface=""/>
-        <a:font script="Jpan" typeface="游ゴシック"/>
-        <a:font script="Hang" typeface="맑은 고딕"/>
-        <a:font script="Hans" typeface="等线"/>
-        <a:font script="Hant" typeface="新細明體"/>
-        <a:font script="Arab" typeface="Arial"/>
-        <a:font script="Hebr" typeface="Arial"/>
-        <a:font script="Thai" typeface="Cordia New"/>
-        <a:font script="Ethi" typeface="Nyala"/>
-        <a:font script="Beng" typeface="Vrinda"/>
-        <a:font script="Gujr" typeface="Shruti"/>
-        <a:font script="Khmr" typeface="DaunPenh"/>
-        <a:font script="Knda" typeface="Tunga"/>
-        <a:font script="Guru" typeface="Raavi"/>
-        <a:font script="Cans" typeface="Euphemia"/>
-        <a:font script="Cher" typeface="Plantagenet Cherokee"/>
-        <a:font script="Yiii" typeface="Microsoft Yi Baiti"/>
-        <a:font script="Tibt" typeface="Microsoft Himalaya"/>
-        <a:font script="Thaa" typeface="MV Boli"/>
-        <a:font script="Deva" typeface="Mangal"/>
-        <a:font script="Telu" typeface="Gautami"/>
-        <a:font script="Taml" typeface="Latha"/>
-        <a:font script="Syrc" typeface="Estrangelo Edessa"/>
-        <a:font script="Orya" typeface="Kalinga"/>
-        <a:font script="Mlym" typeface="Kartika"/>
-        <a:font script="Laoo" typeface="DokChampa"/>
-        <a:font script="Sinh" typeface="Iskoola Pota"/>
-        <a:font script="Mong" typeface="Mongolian Baiti"/>
-        <a:font script="Viet" typeface="Arial"/>
-        <a:font script="Uigh" typeface="Microsoft Uighur"/>
-        <a:font script="Geor" typeface="Sylfaen"/>
-        <a:font script="Armn" typeface="Arial"/>
-        <a:font script="Bugi" typeface="Leelawadee UI"/>
-        <a:font script="Bopo" typeface="Microsoft JhengHei"/>
-        <a:font script="Java" typeface="Javanese Text"/>
-        <a:font script="Lisu" typeface="Segoe UI"/>
-        <a:font script="Mymr" typeface="Myanmar Text"/>
-        <a:font script="Nkoo" typeface="Ebrima"/>
-        <a:font script="Olck" typeface="Nirmala UI"/>
-        <a:font script="Osma" typeface="Ebrima"/>
-        <a:font script="Phag" typeface="Phagspa"/>
-        <a:font script="Syrn" typeface="Estrangelo Edessa"/>
-        <a:font script="Syrj" typeface="Estrangelo Edessa"/>
-        <a:font script="Syre" typeface="Estrangelo Edessa"/>
-        <a:font script="Sora" typeface="Nirmala UI"/>
-        <a:font script="Tale" typeface="Microsoft Tai Le"/>
-        <a:font script="Talu" typeface="Microsoft New Tai Lue"/>
-        <a:font script="Tfng" typeface="Ebrima"/>
-      </a:minorFont>
-    </a:fontScheme>
-    <a:fmtScheme name="Office">
-      <a:fillStyleLst>
-        <a:solidFill>
-          <a:schemeClr val="phClr"/>
-        </a:solidFill>
-        <a:gradFill rotWithShape="1">
-          <a:gsLst>
-            <a:gs pos="0">
-              <a:schemeClr val="phClr">
-                <a:lumMod val="110000"/>
-                <a:satMod val="105000"/>
-                <a:tint val="67000"/>
-              </a:schemeClr>
-            </a:gs>
-            <a:gs pos="50000">
-              <a:schemeClr val="phClr">
-                <a:lumMod val="105000"/>
-                <a:satMod val="103000"/>
-                <a:tint val="73000"/>
-              </a:schemeClr>
-            </a:gs>
-            <a:gs pos="100000">
-              <a:schemeClr val="phClr">
-                <a:lumMod val="105000"/>
-                <a:satMod val="109000"/>
-                <a:tint val="81000"/>
-              </a:schemeClr>
-            </a:gs>
-          </a:gsLst>
-          <a:lin ang="5400000" scaled="0"/>
-        </a:gradFill>
-        <a:gradFill rotWithShape="1">
-          <a:gsLst>
-            <a:gs pos="0">
-              <a:schemeClr val="phClr">
-                <a:satMod val="103000"/>
-                <a:lumMod val="102000"/>
-                <a:tint val="94000"/>
-              </a:schemeClr>
-            </a:gs>
-            <a:gs pos="50000">
-              <a:schemeClr val="phClr">
-                <a:satMod val="110000"/>
-                <a:lumMod val="100000"/>
-                <a:shade val="100000"/>
-              </a:schemeClr>
-            </a:gs>
-            <a:gs pos="100000">
-              <a:schemeClr val="phClr">
-                <a:lumMod val="99000"/>
-                <a:satMod val="120000"/>
-                <a:shade val="78000"/>
-              </a:schemeClr>
-            </a:gs>
-          </a:gsLst>
-          <a:lin ang="5400000" scaled="0"/>
-        </a:gradFill>
-      </a:fillStyleLst>
-      <a:lnStyleLst>
-        <a:ln w="12700" cap="flat" cmpd="sng" algn="ctr">
-          <a:solidFill>
-            <a:schemeClr val="phClr"/>
-          </a:solidFill>
-          <a:prstDash val="solid"/>
-          <a:miter lim="800000"/>
-        </a:ln>
-        <a:ln w="19050" cap="flat" cmpd="sng" algn="ctr">
-          <a:solidFill>
-            <a:schemeClr val="phClr"/>
-          </a:solidFill>
-          <a:prstDash val="solid"/>
-          <a:miter lim="800000"/>
-        </a:ln>
-        <a:ln w="25400" cap="flat" cmpd="sng" algn="ctr">
-          <a:solidFill>
-            <a:schemeClr val="phClr"/>
-          </a:solidFill>
-          <a:prstDash val="solid"/>
-          <a:miter lim="800000"/>
-        </a:ln>
-      </a:lnStyleLst>
-      <a:effectStyleLst>
-        <a:effectStyle>
-          <a:effectLst/>
-        </a:effectStyle>
-        <a:effectStyle>
-          <a:effectLst/>
-        </a:effectStyle>
-        <a:effectStyle>
-          <a:effectLst>
-            <a:outerShdw blurRad="57150" dist="19050" dir="5400000" algn="ctr" rotWithShape="0">
-              <a:srgbClr val="000000">
-                <a:alpha val="63000"/>
-              </a:srgbClr>
-            </a:outerShdw>
-          </a:effectLst>
-        </a:effectStyle>
-      </a:effectStyleLst>
-      <a:bgFillStyleLst>
-        <a:solidFill>
-          <a:schemeClr val="phClr"/>
-        </a:solidFill>
-        <a:solidFill>
-          <a:schemeClr val="phClr">
-            <a:tint val="95000"/>
-            <a:satMod val="170000"/>
-          </a:schemeClr>
-        </a:solidFill>
-        <a:gradFill rotWithShape="1">
-          <a:gsLst>
-            <a:gs pos="0">
-              <a:schemeClr val="phClr">
-                <a:tint val="93000"/>
-                <a:satMod val="150000"/>
-                <a:shade val="98000"/>
-                <a:lumMod val="102000"/>
-              </a:schemeClr>
-            </a:gs>
-            <a:gs pos="50000">
-              <a:schemeClr val="phClr">
-                <a:tint val="98000"/>
-                <a:satMod val="130000"/>
-                <a:shade val="90000"/>
-                <a:lumMod val="103000"/>
-              </a:schemeClr>
-            </a:gs>
-            <a:gs pos="100000">
-              <a:schemeClr val="phClr">
-                <a:shade val="63000"/>
-                <a:satMod val="120000"/>
-              </a:schemeClr>
-            </a:gs>
-          </a:gsLst>
-          <a:lin ang="5400000" scaled="0"/>
-        </a:gradFill>
-      </a:bgFillStyleLst>
-    </a:fmtScheme>
-  </a:themeElements>
-  <a:objectDefaults>
-    <a:lnDef>
-      <a:spPr/>
-      <a:bodyPr/>
-      <a:lstStyle/>
-      <a:style>
-        <a:lnRef idx="2">
-          <a:schemeClr val="accent1"/>
-        </a:lnRef>
-        <a:fillRef idx="0">
-          <a:schemeClr val="accent1"/>
-        </a:fillRef>
-        <a:effectRef idx="1">
-          <a:schemeClr val="accent1"/>
-        </a:effectRef>
-        <a:fontRef idx="minor">
-          <a:schemeClr val="tx1"/>
-        </a:fontRef>
-      </a:style>
-    </a:lnDef>
-  </a:objectDefaults>
-  <a:extraClrSchemeLst/>
-  <a:extLst>
-    <a:ext uri="{05A4C25C-085E-4340-85A3-A5531E510DB2}">
-      <thm15:themeFamily xmlns:thm15="http://schemas.microsoft.com/office/thememl/2012/main" name="Office Theme" id="{2E142A2C-CD16-42D6-873A-C26D2A0506FA}" vid="{1BDDFF52-6CD6-40A5-AB3C-68EB2F1E4D0A}"/>
-    </a:ext>
-  </a:extLst>
-</a:theme>
 </file>
</xml_diff>